<commit_message>
Updating paper, poster, abstract, explainer, PPTX and evidence index with the verified P3 result (fold-local duplicate-view removal tested once on 41 synthetic tasks: 1 gain, 4 harmed, rejected; synthetic only)
</commit_message>
<xml_diff>
--- a/docs/summit_poster/poster.pptx
+++ b/docs/summit_poster/poster.pptx
@@ -8615,25 +8615,7 @@
                 </a:solidFill>
                 <a:latin typeface="Arial"/>
               </a:rPr>
-              <a:t>would</a:t>
-            </a:r>
-            <a:r>
-              <a:rPr sz="2460" b="0" i="0">
-                <a:solidFill>
-                  <a:srgbClr val="0B0B0B"/>
-                </a:solidFill>
-                <a:latin typeface="Arial"/>
-              </a:rPr>
-              <a:t> </a:t>
-            </a:r>
-            <a:r>
-              <a:rPr sz="2460" b="0" i="0">
-                <a:solidFill>
-                  <a:srgbClr val="0B0B0B"/>
-                </a:solidFill>
-                <a:latin typeface="Arial"/>
-              </a:rPr>
-              <a:t>reach</a:t>
+              <a:t>reaches</a:t>
             </a:r>
             <a:r>
               <a:rPr sz="2460" b="0" i="0">
@@ -8706,6 +8688,24 @@
                 <a:latin typeface="Arial"/>
               </a:rPr>
               <a:t>failing</a:t>
+            </a:r>
+            <a:r>
+              <a:rPr sz="2460" b="0" i="0">
+                <a:solidFill>
+                  <a:srgbClr val="0B0B0B"/>
+                </a:solidFill>
+                <a:latin typeface="Arial"/>
+              </a:rPr>
+              <a:t> </a:t>
+            </a:r>
+            <a:r>
+              <a:rPr sz="2460" b="0" i="0">
+                <a:solidFill>
+                  <a:srgbClr val="0B0B0B"/>
+                </a:solidFill>
+                <a:latin typeface="Arial"/>
+              </a:rPr>
+              <a:t>pairs,</a:t>
             </a:r>
           </a:p>
         </p:txBody>
@@ -8719,7 +8719,7 @@
         <p:spPr>
           <a:xfrm>
             <a:off x="21119517" y="23983782"/>
-            <a:ext cx="8276877" cy="312515"/>
+            <a:ext cx="3816010" cy="312515"/>
           </a:xfrm>
           <a:prstGeom prst="rect">
             <a:avLst/>
@@ -8739,24 +8739,6 @@
                 </a:solidFill>
                 <a:latin typeface="Arial"/>
               </a:rPr>
-              <a:t>pairs,</a:t>
-            </a:r>
-            <a:r>
-              <a:rPr sz="2460" b="0" i="0">
-                <a:solidFill>
-                  <a:srgbClr val="0B0B0B"/>
-                </a:solidFill>
-                <a:latin typeface="Arial"/>
-              </a:rPr>
-              <a:t> </a:t>
-            </a:r>
-            <a:r>
-              <a:rPr sz="2460" b="0" i="0">
-                <a:solidFill>
-                  <a:srgbClr val="0B0B0B"/>
-                </a:solidFill>
-                <a:latin typeface="Arial"/>
-              </a:rPr>
               <a:t>from</a:t>
             </a:r>
             <a:r>
@@ -8830,96 +8812,6 @@
                 <a:latin typeface="Arial"/>
               </a:rPr>
               <a:t>alone.</a:t>
-            </a:r>
-            <a:r>
-              <a:rPr sz="2460" b="0" i="0">
-                <a:solidFill>
-                  <a:srgbClr val="0B0B0B"/>
-                </a:solidFill>
-                <a:latin typeface="Arial"/>
-              </a:rPr>
-              <a:t> </a:t>
-            </a:r>
-            <a:r>
-              <a:rPr sz="2460" b="0" i="0">
-                <a:solidFill>
-                  <a:srgbClr val="0B0B0B"/>
-                </a:solidFill>
-                <a:latin typeface="Arial"/>
-              </a:rPr>
-              <a:t>But</a:t>
-            </a:r>
-            <a:r>
-              <a:rPr sz="2460" b="0" i="0">
-                <a:solidFill>
-                  <a:srgbClr val="0B0B0B"/>
-                </a:solidFill>
-                <a:latin typeface="Arial"/>
-              </a:rPr>
-              <a:t> </a:t>
-            </a:r>
-            <a:r>
-              <a:rPr sz="2460" b="0" i="0">
-                <a:solidFill>
-                  <a:srgbClr val="0B0B0B"/>
-                </a:solidFill>
-                <a:latin typeface="Arial"/>
-              </a:rPr>
-              <a:t>it</a:t>
-            </a:r>
-            <a:r>
-              <a:rPr sz="2460" b="0" i="0">
-                <a:solidFill>
-                  <a:srgbClr val="0B0B0B"/>
-                </a:solidFill>
-                <a:latin typeface="Arial"/>
-              </a:rPr>
-              <a:t> </a:t>
-            </a:r>
-            <a:r>
-              <a:rPr sz="2460" b="0" i="0">
-                <a:solidFill>
-                  <a:srgbClr val="0B0B0B"/>
-                </a:solidFill>
-                <a:latin typeface="Arial"/>
-              </a:rPr>
-              <a:t>changes</a:t>
-            </a:r>
-            <a:r>
-              <a:rPr sz="2460" b="0" i="0">
-                <a:solidFill>
-                  <a:srgbClr val="0B0B0B"/>
-                </a:solidFill>
-                <a:latin typeface="Arial"/>
-              </a:rPr>
-              <a:t> </a:t>
-            </a:r>
-            <a:r>
-              <a:rPr sz="2460" b="0" i="0">
-                <a:solidFill>
-                  <a:srgbClr val="0B0B0B"/>
-                </a:solidFill>
-                <a:latin typeface="Arial"/>
-              </a:rPr>
-              <a:t>the</a:t>
-            </a:r>
-            <a:r>
-              <a:rPr sz="2460" b="0" i="0">
-                <a:solidFill>
-                  <a:srgbClr val="0B0B0B"/>
-                </a:solidFill>
-                <a:latin typeface="Arial"/>
-              </a:rPr>
-              <a:t> </a:t>
-            </a:r>
-            <a:r>
-              <a:rPr sz="2460" b="0" i="0">
-                <a:solidFill>
-                  <a:srgbClr val="0B0B0B"/>
-                </a:solidFill>
-                <a:latin typeface="Arial"/>
-              </a:rPr>
-              <a:t>search</a:t>
             </a:r>
           </a:p>
         </p:txBody>
@@ -8932,8 +8824,8 @@
         </p:nvSpPr>
         <p:spPr>
           <a:xfrm>
-            <a:off x="21119517" y="24388671"/>
-            <a:ext cx="8276871" cy="312515"/>
+            <a:off x="25141304" y="23983782"/>
+            <a:ext cx="4255078" cy="312515"/>
           </a:xfrm>
           <a:prstGeom prst="rect">
             <a:avLst/>
@@ -8953,6 +8845,24 @@
                 </a:solidFill>
                 <a:latin typeface="Arial"/>
               </a:rPr>
+              <a:t>Tested</a:t>
+            </a:r>
+            <a:r>
+              <a:rPr sz="2460" b="0" i="0">
+                <a:solidFill>
+                  <a:srgbClr val="0B0B0B"/>
+                </a:solidFill>
+                <a:latin typeface="Arial"/>
+              </a:rPr>
+              <a:t> </a:t>
+            </a:r>
+            <a:r>
+              <a:rPr sz="2460" b="0" i="0">
+                <a:solidFill>
+                  <a:srgbClr val="0B0B0B"/>
+                </a:solidFill>
+                <a:latin typeface="Arial"/>
+              </a:rPr>
               <a:t>on</a:t>
             </a:r>
             <a:r>
@@ -8971,187 +8881,43 @@
                 </a:solidFill>
                 <a:latin typeface="Arial"/>
               </a:rPr>
-              <a:t>277</a:t>
-            </a:r>
-            <a:r>
-              <a:rPr sz="2460" b="0" i="0">
-                <a:solidFill>
-                  <a:srgbClr val="0B0B0B"/>
-                </a:solidFill>
-                <a:latin typeface="Arial"/>
-              </a:rPr>
-              <a:t> </a:t>
-            </a:r>
-            <a:r>
-              <a:rPr sz="2460" b="0" i="0">
-                <a:solidFill>
-                  <a:srgbClr val="0B0B0B"/>
-                </a:solidFill>
-                <a:latin typeface="Arial"/>
-              </a:rPr>
-              <a:t>of</a:t>
-            </a:r>
-            <a:r>
-              <a:rPr sz="2460" b="0" i="0">
-                <a:solidFill>
-                  <a:srgbClr val="0B0B0B"/>
-                </a:solidFill>
-                <a:latin typeface="Arial"/>
-              </a:rPr>
-              <a:t> </a:t>
-            </a:r>
-            <a:r>
-              <a:rPr sz="2460" b="0" i="0">
-                <a:solidFill>
-                  <a:srgbClr val="0B0B0B"/>
-                </a:solidFill>
-                <a:latin typeface="Arial"/>
-              </a:rPr>
-              <a:t>522</a:t>
-            </a:r>
-            <a:r>
-              <a:rPr sz="2460" b="0" i="0">
-                <a:solidFill>
-                  <a:srgbClr val="0B0B0B"/>
-                </a:solidFill>
-                <a:latin typeface="Arial"/>
-              </a:rPr>
-              <a:t> </a:t>
-            </a:r>
-            <a:r>
-              <a:rPr sz="2460" b="0" i="0">
-                <a:solidFill>
-                  <a:srgbClr val="0B0B0B"/>
-                </a:solidFill>
-                <a:latin typeface="Arial"/>
-              </a:rPr>
-              <a:t>development</a:t>
-            </a:r>
-            <a:r>
-              <a:rPr sz="2460" b="0" i="0">
-                <a:solidFill>
-                  <a:srgbClr val="0B0B0B"/>
-                </a:solidFill>
-                <a:latin typeface="Arial"/>
-              </a:rPr>
-              <a:t> </a:t>
-            </a:r>
-            <a:r>
-              <a:rPr sz="2460" b="0" i="0">
-                <a:solidFill>
-                  <a:srgbClr val="0B0B0B"/>
-                </a:solidFill>
-                <a:latin typeface="Arial"/>
-              </a:rPr>
-              <a:t>subsets</a:t>
-            </a:r>
-            <a:r>
-              <a:rPr sz="2460" b="0" i="0">
-                <a:solidFill>
-                  <a:srgbClr val="0B0B0B"/>
-                </a:solidFill>
-                <a:latin typeface="Arial"/>
-              </a:rPr>
-              <a:t> </a:t>
-            </a:r>
-            <a:r>
-              <a:rPr sz="2460" b="0" i="0">
-                <a:solidFill>
-                  <a:srgbClr val="0B0B0B"/>
-                </a:solidFill>
-                <a:latin typeface="Arial"/>
-              </a:rPr>
-              <a:t>and</a:t>
-            </a:r>
-            <a:r>
-              <a:rPr sz="2460" b="0" i="0">
-                <a:solidFill>
-                  <a:srgbClr val="0B0B0B"/>
-                </a:solidFill>
-                <a:latin typeface="Arial"/>
-              </a:rPr>
-              <a:t> </a:t>
-            </a:r>
-            <a:r>
-              <a:rPr sz="2460" b="0" i="0">
-                <a:solidFill>
-                  <a:srgbClr val="0B0B0B"/>
-                </a:solidFill>
-                <a:latin typeface="Arial"/>
-              </a:rPr>
-              <a:t>on</a:t>
-            </a:r>
-            <a:r>
-              <a:rPr sz="2460" b="0" i="0">
-                <a:solidFill>
-                  <a:srgbClr val="0B0B0B"/>
-                </a:solidFill>
-                <a:latin typeface="Arial"/>
-              </a:rPr>
-              <a:t> </a:t>
-            </a:r>
-            <a:r>
-              <a:rPr sz="2460" b="0" i="0">
-                <a:solidFill>
-                  <a:srgbClr val="0B0B0B"/>
-                </a:solidFill>
-                <a:latin typeface="Arial"/>
-              </a:rPr>
-              <a:t>4</a:t>
-            </a:r>
-            <a:r>
-              <a:rPr sz="2460" b="0" i="0">
-                <a:solidFill>
-                  <a:srgbClr val="0B0B0B"/>
-                </a:solidFill>
-                <a:latin typeface="Arial"/>
-              </a:rPr>
-              <a:t> </a:t>
-            </a:r>
-            <a:r>
-              <a:rPr sz="2460" b="0" i="0">
-                <a:solidFill>
-                  <a:srgbClr val="0B0B0B"/>
-                </a:solidFill>
-                <a:latin typeface="Arial"/>
-              </a:rPr>
-              <a:t>of</a:t>
-            </a:r>
-            <a:r>
-              <a:rPr sz="2460" b="0" i="0">
-                <a:solidFill>
-                  <a:srgbClr val="0B0B0B"/>
-                </a:solidFill>
-                <a:latin typeface="Arial"/>
-              </a:rPr>
-              <a:t> </a:t>
-            </a:r>
-            <a:r>
-              <a:rPr sz="2460" b="0" i="0">
-                <a:solidFill>
-                  <a:srgbClr val="0B0B0B"/>
-                </a:solidFill>
-                <a:latin typeface="Arial"/>
-              </a:rPr>
-              <a:t>6</a:t>
-            </a:r>
-            <a:r>
-              <a:rPr sz="2460" b="0" i="0">
-                <a:solidFill>
-                  <a:srgbClr val="0B0B0B"/>
-                </a:solidFill>
-                <a:latin typeface="Arial"/>
-              </a:rPr>
-              <a:t> </a:t>
-            </a:r>
-            <a:r>
-              <a:rPr sz="2460" b="0" i="0">
-                <a:solidFill>
-                  <a:srgbClr val="0B0B0B"/>
-                </a:solidFill>
-                <a:latin typeface="Arial"/>
-              </a:rPr>
-              <a:t>native</a:t>
+              <a:t>41</a:t>
+            </a:r>
+            <a:r>
+              <a:rPr sz="2460" b="0" i="0">
+                <a:solidFill>
+                  <a:srgbClr val="0B0B0B"/>
+                </a:solidFill>
+                <a:latin typeface="Arial"/>
+              </a:rPr>
+              <a:t> </a:t>
+            </a:r>
+            <a:r>
+              <a:rPr sz="2460" b="0" i="0">
+                <a:solidFill>
+                  <a:srgbClr val="0B0B0B"/>
+                </a:solidFill>
+                <a:latin typeface="Arial"/>
+              </a:rPr>
+              <a:t>synthetic</a:t>
+            </a:r>
+            <a:r>
+              <a:rPr sz="2460" b="0" i="0">
+                <a:solidFill>
+                  <a:srgbClr val="0B0B0B"/>
+                </a:solidFill>
+                <a:latin typeface="Arial"/>
+              </a:rPr>
+              <a:t> </a:t>
+            </a:r>
+            <a:r>
+              <a:rPr sz="2460" b="0" i="0">
+                <a:solidFill>
+                  <a:srgbClr val="0B0B0B"/>
+                </a:solidFill>
+                <a:latin typeface="Arial"/>
+              </a:rPr>
+              <a:t>tasks,</a:t>
             </a:r>
           </a:p>
         </p:txBody>
@@ -9164,8 +8930,8 @@
         </p:nvSpPr>
         <p:spPr>
           <a:xfrm>
-            <a:off x="21119517" y="24793547"/>
-            <a:ext cx="5422909" cy="312774"/>
+            <a:off x="21119517" y="24388671"/>
+            <a:ext cx="8276862" cy="312515"/>
           </a:xfrm>
           <a:prstGeom prst="rect">
             <a:avLst/>
@@ -9185,34 +8951,205 @@
                 </a:solidFill>
                 <a:latin typeface="Arial"/>
               </a:rPr>
-              <a:t>successes:</a:t>
-            </a:r>
-            <a:r>
-              <a:rPr sz="2460" b="1" i="0">
-                <a:solidFill>
-                  <a:srgbClr val="0B0B0B"/>
-                </a:solidFill>
-                <a:latin typeface="Arial"/>
-              </a:rPr>
-              <a:t> </a:t>
-            </a:r>
-            <a:r>
-              <a:rPr sz="2460" b="1" i="0">
-                <a:solidFill>
-                  <a:srgbClr val="0B0B0B"/>
-                </a:solidFill>
-                <a:latin typeface="Arial"/>
-              </a:rPr>
-              <a:t>untested, not authorized</a:t>
-            </a:r>
-            <a:r>
-              <a:rPr sz="2460" b="0" i="0">
-                <a:solidFill>
-                  <a:srgbClr val="0B0B0B"/>
-                </a:solidFill>
-                <a:latin typeface="Arial"/>
-              </a:rPr>
-              <a:t>.</a:t>
+              <a:t>it</a:t>
+            </a:r>
+            <a:r>
+              <a:rPr sz="2460" b="0" i="0">
+                <a:solidFill>
+                  <a:srgbClr val="0B0B0B"/>
+                </a:solidFill>
+                <a:latin typeface="Arial"/>
+              </a:rPr>
+              <a:t> </a:t>
+            </a:r>
+            <a:r>
+              <a:rPr sz="2460" b="0" i="0">
+                <a:solidFill>
+                  <a:srgbClr val="0B0B0B"/>
+                </a:solidFill>
+                <a:latin typeface="Arial"/>
+              </a:rPr>
+              <a:t>gained</a:t>
+            </a:r>
+            <a:r>
+              <a:rPr sz="2460" b="0" i="0">
+                <a:solidFill>
+                  <a:srgbClr val="0B0B0B"/>
+                </a:solidFill>
+                <a:latin typeface="Arial"/>
+              </a:rPr>
+              <a:t> </a:t>
+            </a:r>
+            <a:r>
+              <a:rPr sz="2460" b="0" i="0">
+                <a:solidFill>
+                  <a:srgbClr val="0B0B0B"/>
+                </a:solidFill>
+                <a:latin typeface="Arial"/>
+              </a:rPr>
+              <a:t>1</a:t>
+            </a:r>
+            <a:r>
+              <a:rPr sz="2460" b="0" i="0">
+                <a:solidFill>
+                  <a:srgbClr val="0B0B0B"/>
+                </a:solidFill>
+                <a:latin typeface="Arial"/>
+              </a:rPr>
+              <a:t> </a:t>
+            </a:r>
+            <a:r>
+              <a:rPr sz="2460" b="0" i="0">
+                <a:solidFill>
+                  <a:srgbClr val="0B0B0B"/>
+                </a:solidFill>
+                <a:latin typeface="Arial"/>
+              </a:rPr>
+              <a:t>and</a:t>
+            </a:r>
+            <a:r>
+              <a:rPr sz="2460" b="0" i="0">
+                <a:solidFill>
+                  <a:srgbClr val="0B0B0B"/>
+                </a:solidFill>
+                <a:latin typeface="Arial"/>
+              </a:rPr>
+              <a:t> </a:t>
+            </a:r>
+            <a:r>
+              <a:rPr sz="2460" b="0" i="0">
+                <a:solidFill>
+                  <a:srgbClr val="0B0B0B"/>
+                </a:solidFill>
+                <a:latin typeface="Arial"/>
+              </a:rPr>
+              <a:t>harmed</a:t>
+            </a:r>
+            <a:r>
+              <a:rPr sz="2460" b="0" i="0">
+                <a:solidFill>
+                  <a:srgbClr val="0B0B0B"/>
+                </a:solidFill>
+                <a:latin typeface="Arial"/>
+              </a:rPr>
+              <a:t> </a:t>
+            </a:r>
+            <a:r>
+              <a:rPr sz="2460" b="0" i="0">
+                <a:solidFill>
+                  <a:srgbClr val="0B0B0B"/>
+                </a:solidFill>
+                <a:latin typeface="Arial"/>
+              </a:rPr>
+              <a:t>4</a:t>
+            </a:r>
+            <a:r>
+              <a:rPr sz="2460" b="0" i="0">
+                <a:solidFill>
+                  <a:srgbClr val="0B0B0B"/>
+                </a:solidFill>
+                <a:latin typeface="Arial"/>
+              </a:rPr>
+              <a:t> </a:t>
+            </a:r>
+            <a:r>
+              <a:rPr sz="2460" b="0" i="0">
+                <a:solidFill>
+                  <a:srgbClr val="0B0B0B"/>
+                </a:solidFill>
+                <a:latin typeface="Arial"/>
+              </a:rPr>
+              <a:t>(2</a:t>
+            </a:r>
+            <a:r>
+              <a:rPr sz="2460" b="0" i="0">
+                <a:solidFill>
+                  <a:srgbClr val="0B0B0B"/>
+                </a:solidFill>
+                <a:latin typeface="Arial"/>
+              </a:rPr>
+              <a:t> </a:t>
+            </a:r>
+            <a:r>
+              <a:rPr sz="2460" b="0" i="0">
+                <a:solidFill>
+                  <a:srgbClr val="0B0B0B"/>
+                </a:solidFill>
+                <a:latin typeface="Arial"/>
+              </a:rPr>
+              <a:t>correct</a:t>
+            </a:r>
+            <a:r>
+              <a:rPr sz="2460" b="0" i="0">
+                <a:solidFill>
+                  <a:srgbClr val="0B0B0B"/>
+                </a:solidFill>
+                <a:latin typeface="Arial"/>
+              </a:rPr>
+              <a:t> </a:t>
+            </a:r>
+            <a:r>
+              <a:rPr sz="2460" b="0" i="0">
+                <a:solidFill>
+                  <a:srgbClr val="0B0B0B"/>
+                </a:solidFill>
+                <a:latin typeface="Arial"/>
+              </a:rPr>
+              <a:t>answers</a:t>
+            </a:r>
+            <a:r>
+              <a:rPr sz="2460" b="0" i="0">
+                <a:solidFill>
+                  <a:srgbClr val="0B0B0B"/>
+                </a:solidFill>
+                <a:latin typeface="Arial"/>
+              </a:rPr>
+              <a:t> </a:t>
+            </a:r>
+            <a:r>
+              <a:rPr sz="2460" b="0" i="0">
+                <a:solidFill>
+                  <a:srgbClr val="0B0B0B"/>
+                </a:solidFill>
+                <a:latin typeface="Arial"/>
+              </a:rPr>
+              <a:t>lost,</a:t>
+            </a:r>
+            <a:r>
+              <a:rPr sz="2460" b="0" i="0">
+                <a:solidFill>
+                  <a:srgbClr val="0B0B0B"/>
+                </a:solidFill>
+                <a:latin typeface="Arial"/>
+              </a:rPr>
+              <a:t> </a:t>
+            </a:r>
+            <a:r>
+              <a:rPr sz="2460" b="0" i="0">
+                <a:solidFill>
+                  <a:srgbClr val="0B0B0B"/>
+                </a:solidFill>
+                <a:latin typeface="Arial"/>
+              </a:rPr>
+              <a:t>2</a:t>
+            </a:r>
+            <a:r>
+              <a:rPr sz="2460" b="0" i="0">
+                <a:solidFill>
+                  <a:srgbClr val="0B0B0B"/>
+                </a:solidFill>
+                <a:latin typeface="Arial"/>
+              </a:rPr>
+              <a:t> </a:t>
+            </a:r>
+            <a:r>
+              <a:rPr sz="2460" b="0" i="0">
+                <a:solidFill>
+                  <a:srgbClr val="0B0B0B"/>
+                </a:solidFill>
+                <a:latin typeface="Arial"/>
+              </a:rPr>
+              <a:t>false</a:t>
             </a:r>
           </a:p>
         </p:txBody>
@@ -9225,8 +9162,8 @@
         </p:nvSpPr>
         <p:spPr>
           <a:xfrm>
-            <a:off x="20946885" y="25276565"/>
-            <a:ext cx="8449695" cy="312515"/>
+            <a:off x="21119517" y="24793547"/>
+            <a:ext cx="7933621" cy="312774"/>
           </a:xfrm>
           <a:prstGeom prst="rect">
             <a:avLst/>
@@ -9246,133 +9183,34 @@
                 </a:solidFill>
                 <a:latin typeface="Arial"/>
               </a:rPr>
-              <a:t>• Observed,</a:t>
-            </a:r>
-            <a:r>
-              <a:rPr sz="2460" b="0" i="0">
-                <a:solidFill>
-                  <a:srgbClr val="0B0B0B"/>
-                </a:solidFill>
-                <a:latin typeface="Arial"/>
-              </a:rPr>
-              <a:t> </a:t>
-            </a:r>
-            <a:r>
-              <a:rPr sz="2460" b="0" i="0">
-                <a:solidFill>
-                  <a:srgbClr val="0B0B0B"/>
-                </a:solidFill>
-                <a:latin typeface="Arial"/>
-              </a:rPr>
-              <a:t>not</a:t>
-            </a:r>
-            <a:r>
-              <a:rPr sz="2460" b="0" i="0">
-                <a:solidFill>
-                  <a:srgbClr val="0B0B0B"/>
-                </a:solidFill>
-                <a:latin typeface="Arial"/>
-              </a:rPr>
-              <a:t> </a:t>
-            </a:r>
-            <a:r>
-              <a:rPr sz="2460" b="0" i="0">
-                <a:solidFill>
-                  <a:srgbClr val="0B0B0B"/>
-                </a:solidFill>
-                <a:latin typeface="Arial"/>
-              </a:rPr>
-              <a:t>a</a:t>
-            </a:r>
-            <a:r>
-              <a:rPr sz="2460" b="0" i="0">
-                <a:solidFill>
-                  <a:srgbClr val="0B0B0B"/>
-                </a:solidFill>
-                <a:latin typeface="Arial"/>
-              </a:rPr>
-              <a:t> </a:t>
-            </a:r>
-            <a:r>
-              <a:rPr sz="2460" b="0" i="0">
-                <a:solidFill>
-                  <a:srgbClr val="0B0B0B"/>
-                </a:solidFill>
-                <a:latin typeface="Arial"/>
-              </a:rPr>
-              <a:t>theorem:</a:t>
-            </a:r>
-            <a:r>
-              <a:rPr sz="2460" b="0" i="0">
-                <a:solidFill>
-                  <a:srgbClr val="0B0B0B"/>
-                </a:solidFill>
-                <a:latin typeface="Arial"/>
-              </a:rPr>
-              <a:t> </a:t>
-            </a:r>
-            <a:r>
-              <a:rPr sz="2460" b="0" i="0">
-                <a:solidFill>
-                  <a:srgbClr val="0B0B0B"/>
-                </a:solidFill>
-                <a:latin typeface="Arial"/>
-              </a:rPr>
-              <a:t>removing</a:t>
-            </a:r>
-            <a:r>
-              <a:rPr sz="2460" b="0" i="0">
-                <a:solidFill>
-                  <a:srgbClr val="0B0B0B"/>
-                </a:solidFill>
-                <a:latin typeface="Arial"/>
-              </a:rPr>
-              <a:t> </a:t>
-            </a:r>
-            <a:r>
-              <a:rPr sz="2460" b="0" i="0">
-                <a:solidFill>
-                  <a:srgbClr val="0B0B0B"/>
-                </a:solidFill>
-                <a:latin typeface="Arial"/>
-              </a:rPr>
-              <a:t>a</a:t>
-            </a:r>
-            <a:r>
-              <a:rPr sz="2460" b="0" i="0">
-                <a:solidFill>
-                  <a:srgbClr val="0B0B0B"/>
-                </a:solidFill>
-                <a:latin typeface="Arial"/>
-              </a:rPr>
-              <a:t> </a:t>
-            </a:r>
-            <a:r>
-              <a:rPr sz="2460" b="0" i="0">
-                <a:solidFill>
-                  <a:srgbClr val="0B0B0B"/>
-                </a:solidFill>
-                <a:latin typeface="Arial"/>
-              </a:rPr>
-              <a:t>demonstration</a:t>
-            </a:r>
-            <a:r>
-              <a:rPr sz="2460" b="0" i="0">
-                <a:solidFill>
-                  <a:srgbClr val="0B0B0B"/>
-                </a:solidFill>
-                <a:latin typeface="Arial"/>
-              </a:rPr>
-              <a:t> </a:t>
-            </a:r>
-            <a:r>
-              <a:rPr sz="2460" b="0" i="0">
-                <a:solidFill>
-                  <a:srgbClr val="0B0B0B"/>
-                </a:solidFill>
-                <a:latin typeface="Arial"/>
-              </a:rPr>
-              <a:t>made</a:t>
+              <a:t>acceptances) through the coarse views it let in:</a:t>
+            </a:r>
+            <a:r>
+              <a:rPr sz="2460" b="1" i="0">
+                <a:solidFill>
+                  <a:srgbClr val="0B0B0B"/>
+                </a:solidFill>
+                <a:latin typeface="Arial"/>
+              </a:rPr>
+              <a:t> </a:t>
+            </a:r>
+            <a:r>
+              <a:rPr sz="2460" b="1" i="0">
+                <a:solidFill>
+                  <a:srgbClr val="0B0B0B"/>
+                </a:solidFill>
+                <a:latin typeface="Arial"/>
+              </a:rPr>
+              <a:t>rejected</a:t>
+            </a:r>
+            <a:r>
+              <a:rPr sz="2460" b="0" i="0">
+                <a:solidFill>
+                  <a:srgbClr val="0B0B0B"/>
+                </a:solidFill>
+                <a:latin typeface="Arial"/>
+              </a:rPr>
+              <a:t>.</a:t>
             </a:r>
           </a:p>
         </p:txBody>
@@ -9385,8 +9223,8 @@
         </p:nvSpPr>
         <p:spPr>
           <a:xfrm>
-            <a:off x="21119517" y="25681441"/>
-            <a:ext cx="8276871" cy="312515"/>
+            <a:off x="20946882" y="25276565"/>
+            <a:ext cx="8449695" cy="312515"/>
           </a:xfrm>
           <a:prstGeom prst="rect">
             <a:avLst/>
@@ -9406,169 +9244,133 @@
                 </a:solidFill>
                 <a:latin typeface="Arial"/>
               </a:rPr>
-              <a:t>an</a:t>
-            </a:r>
-            <a:r>
-              <a:rPr sz="2460" b="0" i="0">
-                <a:solidFill>
-                  <a:srgbClr val="0B0B0B"/>
-                </a:solidFill>
-                <a:latin typeface="Arial"/>
-              </a:rPr>
-              <a:t> </a:t>
-            </a:r>
-            <a:r>
-              <a:rPr sz="2460" b="0" i="0">
-                <a:solidFill>
-                  <a:srgbClr val="0B0B0B"/>
-                </a:solidFill>
-                <a:latin typeface="Arial"/>
-              </a:rPr>
-              <a:t>eligible</a:t>
-            </a:r>
-            <a:r>
-              <a:rPr sz="2460" b="0" i="0">
-                <a:solidFill>
-                  <a:srgbClr val="0B0B0B"/>
-                </a:solidFill>
-                <a:latin typeface="Arial"/>
-              </a:rPr>
-              <a:t> </a:t>
-            </a:r>
-            <a:r>
-              <a:rPr sz="2460" b="0" i="0">
-                <a:solidFill>
-                  <a:srgbClr val="0B0B0B"/>
-                </a:solidFill>
-                <a:latin typeface="Arial"/>
-              </a:rPr>
-              <a:t>view</a:t>
-            </a:r>
-            <a:r>
-              <a:rPr sz="2460" b="0" i="0">
-                <a:solidFill>
-                  <a:srgbClr val="0B0B0B"/>
-                </a:solidFill>
-                <a:latin typeface="Arial"/>
-              </a:rPr>
-              <a:t> </a:t>
-            </a:r>
-            <a:r>
-              <a:rPr sz="2460" b="0" i="0">
-                <a:solidFill>
-                  <a:srgbClr val="0B0B0B"/>
-                </a:solidFill>
-                <a:latin typeface="Arial"/>
-              </a:rPr>
-              <a:t>ineligible</a:t>
-            </a:r>
-            <a:r>
-              <a:rPr sz="2460" b="0" i="0">
-                <a:solidFill>
-                  <a:srgbClr val="0B0B0B"/>
-                </a:solidFill>
-                <a:latin typeface="Arial"/>
-              </a:rPr>
-              <a:t> </a:t>
-            </a:r>
-            <a:r>
-              <a:rPr sz="2460" b="0" i="0">
-                <a:solidFill>
-                  <a:srgbClr val="0B0B0B"/>
-                </a:solidFill>
-                <a:latin typeface="Arial"/>
-              </a:rPr>
-              <a:t>in</a:t>
-            </a:r>
-            <a:r>
-              <a:rPr sz="2460" b="0" i="0">
-                <a:solidFill>
-                  <a:srgbClr val="0B0B0B"/>
-                </a:solidFill>
-                <a:latin typeface="Arial"/>
-              </a:rPr>
-              <a:t> </a:t>
-            </a:r>
-            <a:r>
-              <a:rPr sz="2460" b="0" i="0">
-                <a:solidFill>
-                  <a:srgbClr val="0B0B0B"/>
-                </a:solidFill>
-                <a:latin typeface="Arial"/>
-              </a:rPr>
-              <a:t>7</a:t>
-            </a:r>
-            <a:r>
-              <a:rPr sz="2460" b="0" i="0">
-                <a:solidFill>
-                  <a:srgbClr val="0B0B0B"/>
-                </a:solidFill>
-                <a:latin typeface="Arial"/>
-              </a:rPr>
-              <a:t> </a:t>
-            </a:r>
-            <a:r>
-              <a:rPr sz="2460" b="0" i="0">
-                <a:solidFill>
-                  <a:srgbClr val="0B0B0B"/>
-                </a:solidFill>
-                <a:latin typeface="Arial"/>
-              </a:rPr>
-              <a:t>of</a:t>
-            </a:r>
-            <a:r>
-              <a:rPr sz="2460" b="0" i="0">
-                <a:solidFill>
-                  <a:srgbClr val="0B0B0B"/>
-                </a:solidFill>
-                <a:latin typeface="Arial"/>
-              </a:rPr>
-              <a:t> </a:t>
-            </a:r>
-            <a:r>
-              <a:rPr sz="2460" b="0" i="0">
-                <a:solidFill>
-                  <a:srgbClr val="0B0B0B"/>
-                </a:solidFill>
-                <a:latin typeface="Arial"/>
-              </a:rPr>
-              <a:t>724</a:t>
-            </a:r>
-            <a:r>
-              <a:rPr sz="2460" b="0" i="0">
-                <a:solidFill>
-                  <a:srgbClr val="0B0B0B"/>
-                </a:solidFill>
-                <a:latin typeface="Arial"/>
-              </a:rPr>
-              <a:t> </a:t>
-            </a:r>
-            <a:r>
-              <a:rPr sz="2460" b="0" i="0">
-                <a:solidFill>
-                  <a:srgbClr val="0B0B0B"/>
-                </a:solidFill>
-                <a:latin typeface="Arial"/>
-              </a:rPr>
-              <a:t>development</a:t>
-            </a:r>
-            <a:r>
-              <a:rPr sz="2460" b="0" i="0">
-                <a:solidFill>
-                  <a:srgbClr val="0B0B0B"/>
-                </a:solidFill>
-                <a:latin typeface="Arial"/>
-              </a:rPr>
-              <a:t> </a:t>
-            </a:r>
-            <a:r>
-              <a:rPr sz="2460" b="0" i="0">
-                <a:solidFill>
-                  <a:srgbClr val="0B0B0B"/>
-                </a:solidFill>
-                <a:latin typeface="Arial"/>
-              </a:rPr>
-              <a:t>compar-</a:t>
+              <a:t>• Observed,</a:t>
+            </a:r>
+            <a:r>
+              <a:rPr sz="2460" b="0" i="0">
+                <a:solidFill>
+                  <a:srgbClr val="0B0B0B"/>
+                </a:solidFill>
+                <a:latin typeface="Arial"/>
+              </a:rPr>
+              <a:t> </a:t>
+            </a:r>
+            <a:r>
+              <a:rPr sz="2460" b="0" i="0">
+                <a:solidFill>
+                  <a:srgbClr val="0B0B0B"/>
+                </a:solidFill>
+                <a:latin typeface="Arial"/>
+              </a:rPr>
+              <a:t>not</a:t>
+            </a:r>
+            <a:r>
+              <a:rPr sz="2460" b="0" i="0">
+                <a:solidFill>
+                  <a:srgbClr val="0B0B0B"/>
+                </a:solidFill>
+                <a:latin typeface="Arial"/>
+              </a:rPr>
+              <a:t> </a:t>
+            </a:r>
+            <a:r>
+              <a:rPr sz="2460" b="0" i="0">
+                <a:solidFill>
+                  <a:srgbClr val="0B0B0B"/>
+                </a:solidFill>
+                <a:latin typeface="Arial"/>
+              </a:rPr>
+              <a:t>a</a:t>
+            </a:r>
+            <a:r>
+              <a:rPr sz="2460" b="0" i="0">
+                <a:solidFill>
+                  <a:srgbClr val="0B0B0B"/>
+                </a:solidFill>
+                <a:latin typeface="Arial"/>
+              </a:rPr>
+              <a:t> </a:t>
+            </a:r>
+            <a:r>
+              <a:rPr sz="2460" b="0" i="0">
+                <a:solidFill>
+                  <a:srgbClr val="0B0B0B"/>
+                </a:solidFill>
+                <a:latin typeface="Arial"/>
+              </a:rPr>
+              <a:t>theorem:</a:t>
+            </a:r>
+            <a:r>
+              <a:rPr sz="2460" b="0" i="0">
+                <a:solidFill>
+                  <a:srgbClr val="0B0B0B"/>
+                </a:solidFill>
+                <a:latin typeface="Arial"/>
+              </a:rPr>
+              <a:t> </a:t>
+            </a:r>
+            <a:r>
+              <a:rPr sz="2460" b="0" i="0">
+                <a:solidFill>
+                  <a:srgbClr val="0B0B0B"/>
+                </a:solidFill>
+                <a:latin typeface="Arial"/>
+              </a:rPr>
+              <a:t>removing</a:t>
+            </a:r>
+            <a:r>
+              <a:rPr sz="2460" b="0" i="0">
+                <a:solidFill>
+                  <a:srgbClr val="0B0B0B"/>
+                </a:solidFill>
+                <a:latin typeface="Arial"/>
+              </a:rPr>
+              <a:t> </a:t>
+            </a:r>
+            <a:r>
+              <a:rPr sz="2460" b="0" i="0">
+                <a:solidFill>
+                  <a:srgbClr val="0B0B0B"/>
+                </a:solidFill>
+                <a:latin typeface="Arial"/>
+              </a:rPr>
+              <a:t>a</a:t>
+            </a:r>
+            <a:r>
+              <a:rPr sz="2460" b="0" i="0">
+                <a:solidFill>
+                  <a:srgbClr val="0B0B0B"/>
+                </a:solidFill>
+                <a:latin typeface="Arial"/>
+              </a:rPr>
+              <a:t> </a:t>
+            </a:r>
+            <a:r>
+              <a:rPr sz="2460" b="0" i="0">
+                <a:solidFill>
+                  <a:srgbClr val="0B0B0B"/>
+                </a:solidFill>
+                <a:latin typeface="Arial"/>
+              </a:rPr>
+              <a:t>demonstration</a:t>
+            </a:r>
+            <a:r>
+              <a:rPr sz="2460" b="0" i="0">
+                <a:solidFill>
+                  <a:srgbClr val="0B0B0B"/>
+                </a:solidFill>
+                <a:latin typeface="Arial"/>
+              </a:rPr>
+              <a:t> </a:t>
+            </a:r>
+            <a:r>
+              <a:rPr sz="2460" b="0" i="0">
+                <a:solidFill>
+                  <a:srgbClr val="0B0B0B"/>
+                </a:solidFill>
+                <a:latin typeface="Arial"/>
+              </a:rPr>
+              <a:t>made</a:t>
             </a:r>
           </a:p>
         </p:txBody>
@@ -9581,8 +9383,8 @@
         </p:nvSpPr>
         <p:spPr>
           <a:xfrm>
-            <a:off x="21119517" y="26086317"/>
-            <a:ext cx="3456928" cy="312517"/>
+            <a:off x="21119513" y="25681441"/>
+            <a:ext cx="8276871" cy="312515"/>
           </a:xfrm>
           <a:prstGeom prst="rect">
             <a:avLst/>
@@ -9602,7 +9404,169 @@
                 </a:solidFill>
                 <a:latin typeface="Arial"/>
               </a:rPr>
-              <a:t>isons (pooled coverage).</a:t>
+              <a:t>an</a:t>
+            </a:r>
+            <a:r>
+              <a:rPr sz="2460" b="0" i="0">
+                <a:solidFill>
+                  <a:srgbClr val="0B0B0B"/>
+                </a:solidFill>
+                <a:latin typeface="Arial"/>
+              </a:rPr>
+              <a:t> </a:t>
+            </a:r>
+            <a:r>
+              <a:rPr sz="2460" b="0" i="0">
+                <a:solidFill>
+                  <a:srgbClr val="0B0B0B"/>
+                </a:solidFill>
+                <a:latin typeface="Arial"/>
+              </a:rPr>
+              <a:t>eligible</a:t>
+            </a:r>
+            <a:r>
+              <a:rPr sz="2460" b="0" i="0">
+                <a:solidFill>
+                  <a:srgbClr val="0B0B0B"/>
+                </a:solidFill>
+                <a:latin typeface="Arial"/>
+              </a:rPr>
+              <a:t> </a:t>
+            </a:r>
+            <a:r>
+              <a:rPr sz="2460" b="0" i="0">
+                <a:solidFill>
+                  <a:srgbClr val="0B0B0B"/>
+                </a:solidFill>
+                <a:latin typeface="Arial"/>
+              </a:rPr>
+              <a:t>view</a:t>
+            </a:r>
+            <a:r>
+              <a:rPr sz="2460" b="0" i="0">
+                <a:solidFill>
+                  <a:srgbClr val="0B0B0B"/>
+                </a:solidFill>
+                <a:latin typeface="Arial"/>
+              </a:rPr>
+              <a:t> </a:t>
+            </a:r>
+            <a:r>
+              <a:rPr sz="2460" b="0" i="0">
+                <a:solidFill>
+                  <a:srgbClr val="0B0B0B"/>
+                </a:solidFill>
+                <a:latin typeface="Arial"/>
+              </a:rPr>
+              <a:t>ineligible</a:t>
+            </a:r>
+            <a:r>
+              <a:rPr sz="2460" b="0" i="0">
+                <a:solidFill>
+                  <a:srgbClr val="0B0B0B"/>
+                </a:solidFill>
+                <a:latin typeface="Arial"/>
+              </a:rPr>
+              <a:t> </a:t>
+            </a:r>
+            <a:r>
+              <a:rPr sz="2460" b="0" i="0">
+                <a:solidFill>
+                  <a:srgbClr val="0B0B0B"/>
+                </a:solidFill>
+                <a:latin typeface="Arial"/>
+              </a:rPr>
+              <a:t>in</a:t>
+            </a:r>
+            <a:r>
+              <a:rPr sz="2460" b="0" i="0">
+                <a:solidFill>
+                  <a:srgbClr val="0B0B0B"/>
+                </a:solidFill>
+                <a:latin typeface="Arial"/>
+              </a:rPr>
+              <a:t> </a:t>
+            </a:r>
+            <a:r>
+              <a:rPr sz="2460" b="0" i="0">
+                <a:solidFill>
+                  <a:srgbClr val="0B0B0B"/>
+                </a:solidFill>
+                <a:latin typeface="Arial"/>
+              </a:rPr>
+              <a:t>7</a:t>
+            </a:r>
+            <a:r>
+              <a:rPr sz="2460" b="0" i="0">
+                <a:solidFill>
+                  <a:srgbClr val="0B0B0B"/>
+                </a:solidFill>
+                <a:latin typeface="Arial"/>
+              </a:rPr>
+              <a:t> </a:t>
+            </a:r>
+            <a:r>
+              <a:rPr sz="2460" b="0" i="0">
+                <a:solidFill>
+                  <a:srgbClr val="0B0B0B"/>
+                </a:solidFill>
+                <a:latin typeface="Arial"/>
+              </a:rPr>
+              <a:t>of</a:t>
+            </a:r>
+            <a:r>
+              <a:rPr sz="2460" b="0" i="0">
+                <a:solidFill>
+                  <a:srgbClr val="0B0B0B"/>
+                </a:solidFill>
+                <a:latin typeface="Arial"/>
+              </a:rPr>
+              <a:t> </a:t>
+            </a:r>
+            <a:r>
+              <a:rPr sz="2460" b="0" i="0">
+                <a:solidFill>
+                  <a:srgbClr val="0B0B0B"/>
+                </a:solidFill>
+                <a:latin typeface="Arial"/>
+              </a:rPr>
+              <a:t>724</a:t>
+            </a:r>
+            <a:r>
+              <a:rPr sz="2460" b="0" i="0">
+                <a:solidFill>
+                  <a:srgbClr val="0B0B0B"/>
+                </a:solidFill>
+                <a:latin typeface="Arial"/>
+              </a:rPr>
+              <a:t> </a:t>
+            </a:r>
+            <a:r>
+              <a:rPr sz="2460" b="0" i="0">
+                <a:solidFill>
+                  <a:srgbClr val="0B0B0B"/>
+                </a:solidFill>
+                <a:latin typeface="Arial"/>
+              </a:rPr>
+              <a:t>development</a:t>
+            </a:r>
+            <a:r>
+              <a:rPr sz="2460" b="0" i="0">
+                <a:solidFill>
+                  <a:srgbClr val="0B0B0B"/>
+                </a:solidFill>
+                <a:latin typeface="Arial"/>
+              </a:rPr>
+              <a:t> </a:t>
+            </a:r>
+            <a:r>
+              <a:rPr sz="2460" b="0" i="0">
+                <a:solidFill>
+                  <a:srgbClr val="0B0B0B"/>
+                </a:solidFill>
+                <a:latin typeface="Arial"/>
+              </a:rPr>
+              <a:t>compar-</a:t>
             </a:r>
           </a:p>
         </p:txBody>
@@ -9615,8 +9579,8 @@
         </p:nvSpPr>
         <p:spPr>
           <a:xfrm>
-            <a:off x="20775739" y="27759062"/>
-            <a:ext cx="8385869" cy="480795"/>
+            <a:off x="21119513" y="26086317"/>
+            <a:ext cx="3456928" cy="312517"/>
           </a:xfrm>
           <a:prstGeom prst="rect">
             <a:avLst/>
@@ -9630,31 +9594,13 @@
           <a:lstStyle/>
           <a:p>
             <a:r>
-              <a:rPr sz="3790" b="1" i="0">
-                <a:solidFill>
-                  <a:srgbClr val="2A78D6"/>
-                </a:solidFill>
-                <a:latin typeface="Arial"/>
-              </a:rPr>
-              <a:t>A portable controller?</a:t>
-            </a:r>
-            <a:r>
-              <a:rPr sz="3790" b="1" i="0">
-                <a:solidFill>
-                  <a:srgbClr val="D03B3B"/>
-                </a:solidFill>
-                <a:latin typeface="Arial"/>
-              </a:rPr>
-              <a:t> </a:t>
-            </a:r>
-            <a:r>
-              <a:rPr sz="3790" b="1" i="0">
-                <a:solidFill>
-                  <a:srgbClr val="D03B3B"/>
-                </a:solidFill>
-                <a:latin typeface="Arial"/>
-              </a:rPr>
-              <a:t>BIOLOGICAL</a:t>
+              <a:rPr sz="2460" b="0" i="0">
+                <a:solidFill>
+                  <a:srgbClr val="0B0B0B"/>
+                </a:solidFill>
+                <a:latin typeface="Arial"/>
+              </a:rPr>
+              <a:t>isons (pooled coverage).</a:t>
             </a:r>
           </a:p>
         </p:txBody>
@@ -9667,8 +9613,8 @@
         </p:nvSpPr>
         <p:spPr>
           <a:xfrm>
-            <a:off x="20775739" y="28442298"/>
-            <a:ext cx="6151134" cy="480795"/>
+            <a:off x="20775739" y="27759062"/>
+            <a:ext cx="8385869" cy="480795"/>
           </a:xfrm>
           <a:prstGeom prst="rect">
             <a:avLst/>
@@ -9684,11 +9630,29 @@
             <a:r>
               <a:rPr sz="3790" b="1" i="0">
                 <a:solidFill>
+                  <a:srgbClr val="2A78D6"/>
+                </a:solidFill>
+                <a:latin typeface="Arial"/>
+              </a:rPr>
+              <a:t>A portable controller?</a:t>
+            </a:r>
+            <a:r>
+              <a:rPr sz="3790" b="1" i="0">
+                <a:solidFill>
                   <a:srgbClr val="D03B3B"/>
                 </a:solidFill>
                 <a:latin typeface="Arial"/>
               </a:rPr>
-              <a:t>APPLICATION: UNTESTED</a:t>
+              <a:t> </a:t>
+            </a:r>
+            <a:r>
+              <a:rPr sz="3790" b="1" i="0">
+                <a:solidFill>
+                  <a:srgbClr val="D03B3B"/>
+                </a:solidFill>
+                <a:latin typeface="Arial"/>
+              </a:rPr>
+              <a:t>BIOLOGICAL</a:t>
             </a:r>
           </a:p>
         </p:txBody>
@@ -9701,8 +9665,8 @@
         </p:nvSpPr>
         <p:spPr>
           <a:xfrm>
-            <a:off x="21438945" y="29900804"/>
-            <a:ext cx="1681853" cy="264436"/>
+            <a:off x="20775739" y="28442298"/>
+            <a:ext cx="6151134" cy="480795"/>
           </a:xfrm>
           <a:prstGeom prst="rect">
             <a:avLst/>
@@ -9716,13 +9680,13 @@
           <a:lstStyle/>
           <a:p>
             <a:r>
-              <a:rPr sz="2080" b="1" i="0">
-                <a:solidFill>
-                  <a:srgbClr val="2A78D6"/>
-                </a:solidFill>
-                <a:latin typeface="Arial"/>
-              </a:rPr>
-              <a:t>implemented</a:t>
+              <a:rPr sz="3790" b="1" i="0">
+                <a:solidFill>
+                  <a:srgbClr val="D03B3B"/>
+                </a:solidFill>
+                <a:latin typeface="Arial"/>
+              </a:rPr>
+              <a:t>APPLICATION: UNTESTED</a:t>
             </a:r>
           </a:p>
         </p:txBody>
@@ -9735,8 +9699,8 @@
         </p:nvSpPr>
         <p:spPr>
           <a:xfrm>
-            <a:off x="27315935" y="29952239"/>
-            <a:ext cx="1152707" cy="264436"/>
+            <a:off x="21438945" y="29900804"/>
+            <a:ext cx="1681853" cy="264436"/>
           </a:xfrm>
           <a:prstGeom prst="rect">
             <a:avLst/>
@@ -9752,11 +9716,11 @@
             <a:r>
               <a:rPr sz="2080" b="1" i="0">
                 <a:solidFill>
-                  <a:srgbClr val="D03B3B"/>
-                </a:solidFill>
-                <a:latin typeface="Arial"/>
-              </a:rPr>
-              <a:t>untested</a:t>
+                  <a:srgbClr val="2A78D6"/>
+                </a:solidFill>
+                <a:latin typeface="Arial"/>
+              </a:rPr>
+              <a:t>implemented</a:t>
             </a:r>
           </a:p>
         </p:txBody>
@@ -9769,8 +9733,8 @@
         </p:nvSpPr>
         <p:spPr>
           <a:xfrm>
-            <a:off x="20775739" y="31986280"/>
-            <a:ext cx="8620645" cy="312517"/>
+            <a:off x="27315935" y="29952239"/>
+            <a:ext cx="1152707" cy="264436"/>
           </a:xfrm>
           <a:prstGeom prst="rect">
             <a:avLst/>
@@ -9784,157 +9748,13 @@
           <a:lstStyle/>
           <a:p>
             <a:r>
-              <a:rPr sz="2460" b="0" i="0">
-                <a:solidFill>
-                  <a:srgbClr val="0B0B0B"/>
-                </a:solidFill>
-                <a:latin typeface="Arial"/>
-              </a:rPr>
-              <a:t>The</a:t>
-            </a:r>
-            <a:r>
-              <a:rPr sz="2460" b="0" i="0">
-                <a:solidFill>
-                  <a:srgbClr val="0B0B0B"/>
-                </a:solidFill>
-                <a:latin typeface="Arial"/>
-              </a:rPr>
-              <a:t> </a:t>
-            </a:r>
-            <a:r>
-              <a:rPr sz="2460" b="0" i="0">
-                <a:solidFill>
-                  <a:srgbClr val="0B0B0B"/>
-                </a:solidFill>
-                <a:latin typeface="Arial"/>
-              </a:rPr>
-              <a:t>hypothesis:</a:t>
-            </a:r>
-            <a:r>
-              <a:rPr sz="2460" b="0" i="0">
-                <a:solidFill>
-                  <a:srgbClr val="0B0B0B"/>
-                </a:solidFill>
-                <a:latin typeface="Arial"/>
-              </a:rPr>
-              <a:t> </a:t>
-            </a:r>
-            <a:r>
-              <a:rPr sz="2460" b="0" i="0">
-                <a:solidFill>
-                  <a:srgbClr val="0B0B0B"/>
-                </a:solidFill>
-                <a:latin typeface="Arial"/>
-              </a:rPr>
-              <a:t>the</a:t>
-            </a:r>
-            <a:r>
-              <a:rPr sz="2460" b="0" i="0">
-                <a:solidFill>
-                  <a:srgbClr val="0B0B0B"/>
-                </a:solidFill>
-                <a:latin typeface="Arial"/>
-              </a:rPr>
-              <a:t> </a:t>
-            </a:r>
-            <a:r>
-              <a:rPr sz="2460" b="0" i="0">
-                <a:solidFill>
-                  <a:srgbClr val="0B0B0B"/>
-                </a:solidFill>
-                <a:latin typeface="Arial"/>
-              </a:rPr>
-              <a:t>controller</a:t>
-            </a:r>
-            <a:r>
-              <a:rPr sz="2460" b="0" i="0">
-                <a:solidFill>
-                  <a:srgbClr val="0B0B0B"/>
-                </a:solidFill>
-                <a:latin typeface="Arial"/>
-              </a:rPr>
-              <a:t> </a:t>
-            </a:r>
-            <a:r>
-              <a:rPr sz="2460" b="0" i="0">
-                <a:solidFill>
-                  <a:srgbClr val="0B0B0B"/>
-                </a:solidFill>
-                <a:latin typeface="Arial"/>
-              </a:rPr>
-              <a:t>and</a:t>
-            </a:r>
-            <a:r>
-              <a:rPr sz="2460" b="0" i="0">
-                <a:solidFill>
-                  <a:srgbClr val="0B0B0B"/>
-                </a:solidFill>
-                <a:latin typeface="Arial"/>
-              </a:rPr>
-              <a:t> </a:t>
-            </a:r>
-            <a:r>
-              <a:rPr sz="2460" b="0" i="0">
-                <a:solidFill>
-                  <a:srgbClr val="0B0B0B"/>
-                </a:solidFill>
-                <a:latin typeface="Arial"/>
-              </a:rPr>
-              <a:t>its</a:t>
-            </a:r>
-            <a:r>
-              <a:rPr sz="2460" b="0" i="0">
-                <a:solidFill>
-                  <a:srgbClr val="0B0B0B"/>
-                </a:solidFill>
-                <a:latin typeface="Arial"/>
-              </a:rPr>
-              <a:t> </a:t>
-            </a:r>
-            <a:r>
-              <a:rPr sz="2460" b="0" i="0">
-                <a:solidFill>
-                  <a:srgbClr val="0B0B0B"/>
-                </a:solidFill>
-                <a:latin typeface="Arial"/>
-              </a:rPr>
-              <a:t>evidence</a:t>
-            </a:r>
-            <a:r>
-              <a:rPr sz="2460" b="0" i="0">
-                <a:solidFill>
-                  <a:srgbClr val="0B0B0B"/>
-                </a:solidFill>
-                <a:latin typeface="Arial"/>
-              </a:rPr>
-              <a:t> </a:t>
-            </a:r>
-            <a:r>
-              <a:rPr sz="2460" b="0" i="0">
-                <a:solidFill>
-                  <a:srgbClr val="0B0B0B"/>
-                </a:solidFill>
-                <a:latin typeface="Arial"/>
-              </a:rPr>
-              <a:t>and</a:t>
-            </a:r>
-            <a:r>
-              <a:rPr sz="2460" b="0" i="0">
-                <a:solidFill>
-                  <a:srgbClr val="0B0B0B"/>
-                </a:solidFill>
-                <a:latin typeface="Arial"/>
-              </a:rPr>
-              <a:t> </a:t>
-            </a:r>
-            <a:r>
-              <a:rPr sz="2460" b="0" i="0">
-                <a:solidFill>
-                  <a:srgbClr val="0B0B0B"/>
-                </a:solidFill>
-                <a:latin typeface="Arial"/>
-              </a:rPr>
-              <a:t>certificate</a:t>
+              <a:rPr sz="2080" b="1" i="0">
+                <a:solidFill>
+                  <a:srgbClr val="D03B3B"/>
+                </a:solidFill>
+                <a:latin typeface="Arial"/>
+              </a:rPr>
+              <a:t>untested</a:t>
             </a:r>
           </a:p>
         </p:txBody>
@@ -9947,8 +9767,8 @@
         </p:nvSpPr>
         <p:spPr>
           <a:xfrm>
-            <a:off x="20775739" y="32391157"/>
-            <a:ext cx="8620642" cy="312517"/>
+            <a:off x="20775739" y="31986280"/>
+            <a:ext cx="8620645" cy="312517"/>
           </a:xfrm>
           <a:prstGeom prst="rect">
             <a:avLst/>
@@ -9968,169 +9788,151 @@
                 </a:solidFill>
                 <a:latin typeface="Arial"/>
               </a:rPr>
-              <a:t>interfaces</a:t>
-            </a:r>
-            <a:r>
-              <a:rPr sz="2460" b="0" i="0">
-                <a:solidFill>
-                  <a:srgbClr val="0B0B0B"/>
-                </a:solidFill>
-                <a:latin typeface="Arial"/>
-              </a:rPr>
-              <a:t> </a:t>
-            </a:r>
-            <a:r>
-              <a:rPr sz="2460" b="0" i="0">
-                <a:solidFill>
-                  <a:srgbClr val="0B0B0B"/>
-                </a:solidFill>
-                <a:latin typeface="Arial"/>
-              </a:rPr>
-              <a:t>are</a:t>
-            </a:r>
-            <a:r>
-              <a:rPr sz="2460" b="0" i="0">
-                <a:solidFill>
-                  <a:srgbClr val="0B0B0B"/>
-                </a:solidFill>
-                <a:latin typeface="Arial"/>
-              </a:rPr>
-              <a:t> </a:t>
-            </a:r>
-            <a:r>
-              <a:rPr sz="2460" b="0" i="0">
-                <a:solidFill>
-                  <a:srgbClr val="0B0B0B"/>
-                </a:solidFill>
-                <a:latin typeface="Arial"/>
-              </a:rPr>
-              <a:t>portable;</a:t>
-            </a:r>
-            <a:r>
-              <a:rPr sz="2460" b="0" i="0">
-                <a:solidFill>
-                  <a:srgbClr val="0B0B0B"/>
-                </a:solidFill>
-                <a:latin typeface="Arial"/>
-              </a:rPr>
-              <a:t> </a:t>
-            </a:r>
-            <a:r>
-              <a:rPr sz="2460" b="0" i="0">
-                <a:solidFill>
-                  <a:srgbClr val="0B0B0B"/>
-                </a:solidFill>
-                <a:latin typeface="Arial"/>
-              </a:rPr>
-              <a:t>ARC</a:t>
-            </a:r>
-            <a:r>
-              <a:rPr sz="2460" b="0" i="0">
-                <a:solidFill>
-                  <a:srgbClr val="0B0B0B"/>
-                </a:solidFill>
-                <a:latin typeface="Arial"/>
-              </a:rPr>
-              <a:t> </a:t>
-            </a:r>
-            <a:r>
-              <a:rPr sz="2460" b="0" i="0">
-                <a:solidFill>
-                  <a:srgbClr val="0B0B0B"/>
-                </a:solidFill>
-                <a:latin typeface="Arial"/>
-              </a:rPr>
-              <a:t>operators</a:t>
-            </a:r>
-            <a:r>
-              <a:rPr sz="2460" b="0" i="0">
-                <a:solidFill>
-                  <a:srgbClr val="0B0B0B"/>
-                </a:solidFill>
-                <a:latin typeface="Arial"/>
-              </a:rPr>
-              <a:t> </a:t>
-            </a:r>
-            <a:r>
-              <a:rPr sz="2460" b="0" i="0">
-                <a:solidFill>
-                  <a:srgbClr val="0B0B0B"/>
-                </a:solidFill>
-                <a:latin typeface="Arial"/>
-              </a:rPr>
-              <a:t>are</a:t>
-            </a:r>
-            <a:r>
-              <a:rPr sz="2460" b="0" i="0">
-                <a:solidFill>
-                  <a:srgbClr val="0B0B0B"/>
-                </a:solidFill>
-                <a:latin typeface="Arial"/>
-              </a:rPr>
-              <a:t> </a:t>
-            </a:r>
-            <a:r>
-              <a:rPr sz="2460" b="0" i="0">
-                <a:solidFill>
-                  <a:srgbClr val="0B0B0B"/>
-                </a:solidFill>
-                <a:latin typeface="Arial"/>
-              </a:rPr>
-              <a:t>not.</a:t>
-            </a:r>
-            <a:r>
-              <a:rPr sz="2460" b="0" i="0">
-                <a:solidFill>
-                  <a:srgbClr val="0B0B0B"/>
-                </a:solidFill>
-                <a:latin typeface="Arial"/>
-              </a:rPr>
-              <a:t> </a:t>
-            </a:r>
-            <a:r>
-              <a:rPr sz="2460" b="0" i="0">
-                <a:solidFill>
-                  <a:srgbClr val="0B0B0B"/>
-                </a:solidFill>
-                <a:latin typeface="Arial"/>
-              </a:rPr>
-              <a:t>A</a:t>
-            </a:r>
-            <a:r>
-              <a:rPr sz="2460" b="0" i="0">
-                <a:solidFill>
-                  <a:srgbClr val="0B0B0B"/>
-                </a:solidFill>
-                <a:latin typeface="Arial"/>
-              </a:rPr>
-              <a:t> </a:t>
-            </a:r>
-            <a:r>
-              <a:rPr sz="2460" b="0" i="0">
-                <a:solidFill>
-                  <a:srgbClr val="0B0B0B"/>
-                </a:solidFill>
-                <a:latin typeface="Arial"/>
-              </a:rPr>
-              <a:t>test</a:t>
-            </a:r>
-            <a:r>
-              <a:rPr sz="2460" b="0" i="0">
-                <a:solidFill>
-                  <a:srgbClr val="0B0B0B"/>
-                </a:solidFill>
-                <a:latin typeface="Arial"/>
-              </a:rPr>
-              <a:t> </a:t>
-            </a:r>
-            <a:r>
-              <a:rPr sz="2460" b="0" i="0">
-                <a:solidFill>
-                  <a:srgbClr val="0B0B0B"/>
-                </a:solidFill>
-                <a:latin typeface="Arial"/>
-              </a:rPr>
-              <a:t>needs</a:t>
+              <a:t>The</a:t>
+            </a:r>
+            <a:r>
+              <a:rPr sz="2460" b="0" i="0">
+                <a:solidFill>
+                  <a:srgbClr val="0B0B0B"/>
+                </a:solidFill>
+                <a:latin typeface="Arial"/>
+              </a:rPr>
+              <a:t> </a:t>
+            </a:r>
+            <a:r>
+              <a:rPr sz="2460" b="0" i="0">
+                <a:solidFill>
+                  <a:srgbClr val="0B0B0B"/>
+                </a:solidFill>
+                <a:latin typeface="Arial"/>
+              </a:rPr>
+              <a:t>hypothesis:</a:t>
+            </a:r>
+            <a:r>
+              <a:rPr sz="2460" b="0" i="0">
+                <a:solidFill>
+                  <a:srgbClr val="0B0B0B"/>
+                </a:solidFill>
+                <a:latin typeface="Arial"/>
+              </a:rPr>
+              <a:t> </a:t>
+            </a:r>
+            <a:r>
+              <a:rPr sz="2460" b="0" i="0">
+                <a:solidFill>
+                  <a:srgbClr val="0B0B0B"/>
+                </a:solidFill>
+                <a:latin typeface="Arial"/>
+              </a:rPr>
+              <a:t>the</a:t>
+            </a:r>
+            <a:r>
+              <a:rPr sz="2460" b="0" i="0">
+                <a:solidFill>
+                  <a:srgbClr val="0B0B0B"/>
+                </a:solidFill>
+                <a:latin typeface="Arial"/>
+              </a:rPr>
+              <a:t> </a:t>
+            </a:r>
+            <a:r>
+              <a:rPr sz="2460" b="0" i="0">
+                <a:solidFill>
+                  <a:srgbClr val="0B0B0B"/>
+                </a:solidFill>
+                <a:latin typeface="Arial"/>
+              </a:rPr>
+              <a:t>controller</a:t>
+            </a:r>
+            <a:r>
+              <a:rPr sz="2460" b="0" i="0">
+                <a:solidFill>
+                  <a:srgbClr val="0B0B0B"/>
+                </a:solidFill>
+                <a:latin typeface="Arial"/>
+              </a:rPr>
+              <a:t> </a:t>
+            </a:r>
+            <a:r>
+              <a:rPr sz="2460" b="0" i="0">
+                <a:solidFill>
+                  <a:srgbClr val="0B0B0B"/>
+                </a:solidFill>
+                <a:latin typeface="Arial"/>
+              </a:rPr>
+              <a:t>and</a:t>
+            </a:r>
+            <a:r>
+              <a:rPr sz="2460" b="0" i="0">
+                <a:solidFill>
+                  <a:srgbClr val="0B0B0B"/>
+                </a:solidFill>
+                <a:latin typeface="Arial"/>
+              </a:rPr>
+              <a:t> </a:t>
+            </a:r>
+            <a:r>
+              <a:rPr sz="2460" b="0" i="0">
+                <a:solidFill>
+                  <a:srgbClr val="0B0B0B"/>
+                </a:solidFill>
+                <a:latin typeface="Arial"/>
+              </a:rPr>
+              <a:t>its</a:t>
+            </a:r>
+            <a:r>
+              <a:rPr sz="2460" b="0" i="0">
+                <a:solidFill>
+                  <a:srgbClr val="0B0B0B"/>
+                </a:solidFill>
+                <a:latin typeface="Arial"/>
+              </a:rPr>
+              <a:t> </a:t>
+            </a:r>
+            <a:r>
+              <a:rPr sz="2460" b="0" i="0">
+                <a:solidFill>
+                  <a:srgbClr val="0B0B0B"/>
+                </a:solidFill>
+                <a:latin typeface="Arial"/>
+              </a:rPr>
+              <a:t>evidence</a:t>
+            </a:r>
+            <a:r>
+              <a:rPr sz="2460" b="0" i="0">
+                <a:solidFill>
+                  <a:srgbClr val="0B0B0B"/>
+                </a:solidFill>
+                <a:latin typeface="Arial"/>
+              </a:rPr>
+              <a:t> </a:t>
+            </a:r>
+            <a:r>
+              <a:rPr sz="2460" b="0" i="0">
+                <a:solidFill>
+                  <a:srgbClr val="0B0B0B"/>
+                </a:solidFill>
+                <a:latin typeface="Arial"/>
+              </a:rPr>
+              <a:t>and</a:t>
+            </a:r>
+            <a:r>
+              <a:rPr sz="2460" b="0" i="0">
+                <a:solidFill>
+                  <a:srgbClr val="0B0B0B"/>
+                </a:solidFill>
+                <a:latin typeface="Arial"/>
+              </a:rPr>
+              <a:t> </a:t>
+            </a:r>
+            <a:r>
+              <a:rPr sz="2460" b="0" i="0">
+                <a:solidFill>
+                  <a:srgbClr val="0B0B0B"/>
+                </a:solidFill>
+                <a:latin typeface="Arial"/>
+              </a:rPr>
+              <a:t>certificate</a:t>
             </a:r>
           </a:p>
         </p:txBody>
@@ -10143,8 +9945,8 @@
         </p:nvSpPr>
         <p:spPr>
           <a:xfrm>
-            <a:off x="20775739" y="32796035"/>
-            <a:ext cx="8620648" cy="312517"/>
+            <a:off x="20775739" y="32391157"/>
+            <a:ext cx="8620642" cy="312517"/>
           </a:xfrm>
           <a:prstGeom prst="rect">
             <a:avLst/>
@@ -10164,7 +9966,169 @@
                 </a:solidFill>
                 <a:latin typeface="Arial"/>
               </a:rPr>
-              <a:t>typed adapters, training-only diagnosis, held-out perturbations</a:t>
+              <a:t>interfaces</a:t>
+            </a:r>
+            <a:r>
+              <a:rPr sz="2460" b="0" i="0">
+                <a:solidFill>
+                  <a:srgbClr val="0B0B0B"/>
+                </a:solidFill>
+                <a:latin typeface="Arial"/>
+              </a:rPr>
+              <a:t> </a:t>
+            </a:r>
+            <a:r>
+              <a:rPr sz="2460" b="0" i="0">
+                <a:solidFill>
+                  <a:srgbClr val="0B0B0B"/>
+                </a:solidFill>
+                <a:latin typeface="Arial"/>
+              </a:rPr>
+              <a:t>are</a:t>
+            </a:r>
+            <a:r>
+              <a:rPr sz="2460" b="0" i="0">
+                <a:solidFill>
+                  <a:srgbClr val="0B0B0B"/>
+                </a:solidFill>
+                <a:latin typeface="Arial"/>
+              </a:rPr>
+              <a:t> </a:t>
+            </a:r>
+            <a:r>
+              <a:rPr sz="2460" b="0" i="0">
+                <a:solidFill>
+                  <a:srgbClr val="0B0B0B"/>
+                </a:solidFill>
+                <a:latin typeface="Arial"/>
+              </a:rPr>
+              <a:t>portable;</a:t>
+            </a:r>
+            <a:r>
+              <a:rPr sz="2460" b="0" i="0">
+                <a:solidFill>
+                  <a:srgbClr val="0B0B0B"/>
+                </a:solidFill>
+                <a:latin typeface="Arial"/>
+              </a:rPr>
+              <a:t> </a:t>
+            </a:r>
+            <a:r>
+              <a:rPr sz="2460" b="0" i="0">
+                <a:solidFill>
+                  <a:srgbClr val="0B0B0B"/>
+                </a:solidFill>
+                <a:latin typeface="Arial"/>
+              </a:rPr>
+              <a:t>ARC</a:t>
+            </a:r>
+            <a:r>
+              <a:rPr sz="2460" b="0" i="0">
+                <a:solidFill>
+                  <a:srgbClr val="0B0B0B"/>
+                </a:solidFill>
+                <a:latin typeface="Arial"/>
+              </a:rPr>
+              <a:t> </a:t>
+            </a:r>
+            <a:r>
+              <a:rPr sz="2460" b="0" i="0">
+                <a:solidFill>
+                  <a:srgbClr val="0B0B0B"/>
+                </a:solidFill>
+                <a:latin typeface="Arial"/>
+              </a:rPr>
+              <a:t>operators</a:t>
+            </a:r>
+            <a:r>
+              <a:rPr sz="2460" b="0" i="0">
+                <a:solidFill>
+                  <a:srgbClr val="0B0B0B"/>
+                </a:solidFill>
+                <a:latin typeface="Arial"/>
+              </a:rPr>
+              <a:t> </a:t>
+            </a:r>
+            <a:r>
+              <a:rPr sz="2460" b="0" i="0">
+                <a:solidFill>
+                  <a:srgbClr val="0B0B0B"/>
+                </a:solidFill>
+                <a:latin typeface="Arial"/>
+              </a:rPr>
+              <a:t>are</a:t>
+            </a:r>
+            <a:r>
+              <a:rPr sz="2460" b="0" i="0">
+                <a:solidFill>
+                  <a:srgbClr val="0B0B0B"/>
+                </a:solidFill>
+                <a:latin typeface="Arial"/>
+              </a:rPr>
+              <a:t> </a:t>
+            </a:r>
+            <a:r>
+              <a:rPr sz="2460" b="0" i="0">
+                <a:solidFill>
+                  <a:srgbClr val="0B0B0B"/>
+                </a:solidFill>
+                <a:latin typeface="Arial"/>
+              </a:rPr>
+              <a:t>not.</a:t>
+            </a:r>
+            <a:r>
+              <a:rPr sz="2460" b="0" i="0">
+                <a:solidFill>
+                  <a:srgbClr val="0B0B0B"/>
+                </a:solidFill>
+                <a:latin typeface="Arial"/>
+              </a:rPr>
+              <a:t> </a:t>
+            </a:r>
+            <a:r>
+              <a:rPr sz="2460" b="0" i="0">
+                <a:solidFill>
+                  <a:srgbClr val="0B0B0B"/>
+                </a:solidFill>
+                <a:latin typeface="Arial"/>
+              </a:rPr>
+              <a:t>A</a:t>
+            </a:r>
+            <a:r>
+              <a:rPr sz="2460" b="0" i="0">
+                <a:solidFill>
+                  <a:srgbClr val="0B0B0B"/>
+                </a:solidFill>
+                <a:latin typeface="Arial"/>
+              </a:rPr>
+              <a:t> </a:t>
+            </a:r>
+            <a:r>
+              <a:rPr sz="2460" b="0" i="0">
+                <a:solidFill>
+                  <a:srgbClr val="0B0B0B"/>
+                </a:solidFill>
+                <a:latin typeface="Arial"/>
+              </a:rPr>
+              <a:t>test</a:t>
+            </a:r>
+            <a:r>
+              <a:rPr sz="2460" b="0" i="0">
+                <a:solidFill>
+                  <a:srgbClr val="0B0B0B"/>
+                </a:solidFill>
+                <a:latin typeface="Arial"/>
+              </a:rPr>
+              <a:t> </a:t>
+            </a:r>
+            <a:r>
+              <a:rPr sz="2460" b="0" i="0">
+                <a:solidFill>
+                  <a:srgbClr val="0B0B0B"/>
+                </a:solidFill>
+                <a:latin typeface="Arial"/>
+              </a:rPr>
+              <a:t>needs</a:t>
             </a:r>
           </a:p>
         </p:txBody>
@@ -10177,8 +10141,8 @@
         </p:nvSpPr>
         <p:spPr>
           <a:xfrm>
-            <a:off x="20775739" y="33200922"/>
-            <a:ext cx="8620642" cy="312517"/>
+            <a:off x="20775739" y="32796035"/>
+            <a:ext cx="8620648" cy="312517"/>
           </a:xfrm>
           <a:prstGeom prst="rect">
             <a:avLst/>
@@ -10198,25 +10162,7 @@
                 </a:solidFill>
                 <a:latin typeface="Arial"/>
               </a:rPr>
-              <a:t>and cell states, and confounder controls.</a:t>
-            </a:r>
-            <a:r>
-              <a:rPr sz="2460" b="0" i="0">
-                <a:solidFill>
-                  <a:srgbClr val="0B0B0B"/>
-                </a:solidFill>
-                <a:latin typeface="Arial"/>
-              </a:rPr>
-              <a:t> </a:t>
-            </a:r>
-            <a:r>
-              <a:rPr sz="2460" b="0" i="0">
-                <a:solidFill>
-                  <a:srgbClr val="0B0B0B"/>
-                </a:solidFill>
-                <a:latin typeface="Arial"/>
-              </a:rPr>
-              <a:t>No biological data or</a:t>
+              <a:t>typed adapters, training-only diagnosis, held-out perturbations</a:t>
             </a:r>
           </a:p>
         </p:txBody>
@@ -10229,8 +10175,8 @@
         </p:nvSpPr>
         <p:spPr>
           <a:xfrm>
-            <a:off x="20775739" y="33605796"/>
-            <a:ext cx="2485623" cy="312517"/>
+            <a:off x="20775739" y="33200922"/>
+            <a:ext cx="8620642" cy="312517"/>
           </a:xfrm>
           <a:prstGeom prst="rect">
             <a:avLst/>
@@ -10250,7 +10196,25 @@
                 </a:solidFill>
                 <a:latin typeface="Arial"/>
               </a:rPr>
-              <a:t>result exists here.</a:t>
+              <a:t>and cell states, and confounder controls.</a:t>
+            </a:r>
+            <a:r>
+              <a:rPr sz="2460" b="0" i="0">
+                <a:solidFill>
+                  <a:srgbClr val="0B0B0B"/>
+                </a:solidFill>
+                <a:latin typeface="Arial"/>
+              </a:rPr>
+              <a:t> </a:t>
+            </a:r>
+            <a:r>
+              <a:rPr sz="2460" b="0" i="0">
+                <a:solidFill>
+                  <a:srgbClr val="0B0B0B"/>
+                </a:solidFill>
+                <a:latin typeface="Arial"/>
+              </a:rPr>
+              <a:t>No biological data or</a:t>
             </a:r>
           </a:p>
         </p:txBody>
@@ -10263,8 +10227,8 @@
         </p:nvSpPr>
         <p:spPr>
           <a:xfrm>
-            <a:off x="20775739" y="35030959"/>
-            <a:ext cx="5395605" cy="544062"/>
+            <a:off x="20775739" y="33605796"/>
+            <a:ext cx="2485623" cy="312517"/>
           </a:xfrm>
           <a:prstGeom prst="rect">
             <a:avLst/>
@@ -10278,49 +10242,13 @@
           <a:lstStyle/>
           <a:p>
             <a:r>
-              <a:rPr sz="3790" b="1" i="0">
-                <a:solidFill>
-                  <a:srgbClr val="2A78D6"/>
-                </a:solidFill>
-                <a:latin typeface="Arial"/>
-              </a:rPr>
-              <a:t>Not claimed</a:t>
-            </a:r>
-            <a:r>
-              <a:rPr sz="4280" b="0" i="1">
-                <a:solidFill>
-                  <a:srgbClr val="2A78D6"/>
-                </a:solidFill>
-                <a:latin typeface="Arial"/>
-              </a:rPr>
-              <a:t> </a:t>
-            </a:r>
-            <a:r>
-              <a:rPr sz="4280" b="0" i="1">
-                <a:solidFill>
-                  <a:srgbClr val="2A78D6"/>
-                </a:solidFill>
-                <a:latin typeface="Arial"/>
-              </a:rPr>
-              <a:t>·</a:t>
-            </a:r>
-            <a:r>
-              <a:rPr sz="3790" b="1" i="0">
-                <a:solidFill>
-                  <a:srgbClr val="2A78D6"/>
-                </a:solidFill>
-                <a:latin typeface="Arial"/>
-              </a:rPr>
-              <a:t> </a:t>
-            </a:r>
-            <a:r>
-              <a:rPr sz="3790" b="1" i="0">
-                <a:solidFill>
-                  <a:srgbClr val="2A78D6"/>
-                </a:solidFill>
-                <a:latin typeface="Arial"/>
-              </a:rPr>
-              <a:t>evidence</a:t>
+              <a:rPr sz="2460" b="0" i="0">
+                <a:solidFill>
+                  <a:srgbClr val="0B0B0B"/>
+                </a:solidFill>
+                <a:latin typeface="Arial"/>
+              </a:rPr>
+              <a:t>result exists here.</a:t>
             </a:r>
           </a:p>
         </p:txBody>
@@ -10333,8 +10261,8 @@
         </p:nvSpPr>
         <p:spPr>
           <a:xfrm>
-            <a:off x="20775739" y="36178526"/>
-            <a:ext cx="8512819" cy="312517"/>
+            <a:off x="20775739" y="35030959"/>
+            <a:ext cx="5395605" cy="544062"/>
           </a:xfrm>
           <a:prstGeom prst="rect">
             <a:avLst/>
@@ -10348,13 +10276,49 @@
           <a:lstStyle/>
           <a:p>
             <a:r>
-              <a:rPr sz="2460" b="0" i="0">
-                <a:solidFill>
-                  <a:srgbClr val="0B0B0B"/>
-                </a:solidFill>
-                <a:latin typeface="Arial"/>
-              </a:rPr>
-              <a:t>No ARC-AGI-2 solve or score gain; no semantic invention; no</a:t>
+              <a:rPr sz="3790" b="1" i="0">
+                <a:solidFill>
+                  <a:srgbClr val="2A78D6"/>
+                </a:solidFill>
+                <a:latin typeface="Arial"/>
+              </a:rPr>
+              <a:t>Not claimed</a:t>
+            </a:r>
+            <a:r>
+              <a:rPr sz="4280" b="0" i="1">
+                <a:solidFill>
+                  <a:srgbClr val="2A78D6"/>
+                </a:solidFill>
+                <a:latin typeface="Arial"/>
+              </a:rPr>
+              <a:t> </a:t>
+            </a:r>
+            <a:r>
+              <a:rPr sz="4280" b="0" i="1">
+                <a:solidFill>
+                  <a:srgbClr val="2A78D6"/>
+                </a:solidFill>
+                <a:latin typeface="Arial"/>
+              </a:rPr>
+              <a:t>·</a:t>
+            </a:r>
+            <a:r>
+              <a:rPr sz="3790" b="1" i="0">
+                <a:solidFill>
+                  <a:srgbClr val="2A78D6"/>
+                </a:solidFill>
+                <a:latin typeface="Arial"/>
+              </a:rPr>
+              <a:t> </a:t>
+            </a:r>
+            <a:r>
+              <a:rPr sz="3790" b="1" i="0">
+                <a:solidFill>
+                  <a:srgbClr val="2A78D6"/>
+                </a:solidFill>
+                <a:latin typeface="Arial"/>
+              </a:rPr>
+              <a:t>evidence</a:t>
             </a:r>
           </a:p>
         </p:txBody>
@@ -10367,8 +10331,8 @@
         </p:nvSpPr>
         <p:spPr>
           <a:xfrm>
-            <a:off x="20775739" y="36583401"/>
-            <a:ext cx="8002801" cy="312517"/>
+            <a:off x="20775739" y="36178526"/>
+            <a:ext cx="8512819" cy="312517"/>
           </a:xfrm>
           <a:prstGeom prst="rect">
             <a:avLst/>
@@ -10388,7 +10352,7 @@
                 </a:solidFill>
                 <a:latin typeface="Arial"/>
               </a:rPr>
-              <a:t>automatic failure-type controller; no domain generality; no</a:t>
+              <a:t>No ARC-AGI-2 solve or score gain; no semantic invention; no</a:t>
             </a:r>
           </a:p>
         </p:txBody>
@@ -10401,8 +10365,8 @@
         </p:nvSpPr>
         <p:spPr>
           <a:xfrm>
-            <a:off x="20775739" y="36988291"/>
-            <a:ext cx="8509384" cy="312517"/>
+            <a:off x="20775739" y="36583401"/>
+            <a:ext cx="8002801" cy="312517"/>
           </a:xfrm>
           <a:prstGeom prst="rect">
             <a:avLst/>
@@ -10422,25 +10386,7 @@
                 </a:solidFill>
                 <a:latin typeface="Arial"/>
               </a:rPr>
-              <a:t>results from the separate VDCG project.</a:t>
-            </a:r>
-            <a:r>
-              <a:rPr sz="2460" b="0" i="0">
-                <a:solidFill>
-                  <a:srgbClr val="0B0B0B"/>
-                </a:solidFill>
-                <a:latin typeface="Arial"/>
-              </a:rPr>
-              <a:t> </a:t>
-            </a:r>
-            <a:r>
-              <a:rPr sz="2460" b="0" i="0">
-                <a:solidFill>
-                  <a:srgbClr val="0B0B0B"/>
-                </a:solidFill>
-                <a:latin typeface="Arial"/>
-              </a:rPr>
-              <a:t>The 120-task pilot is</a:t>
+              <a:t>automatic failure-type controller; no domain generality; no</a:t>
             </a:r>
           </a:p>
         </p:txBody>
@@ -10453,8 +10399,8 @@
         </p:nvSpPr>
         <p:spPr>
           <a:xfrm>
-            <a:off x="20775739" y="37393168"/>
-            <a:ext cx="4214429" cy="312774"/>
+            <a:off x="20775739" y="36988291"/>
+            <a:ext cx="8509384" cy="312517"/>
           </a:xfrm>
           <a:prstGeom prst="rect">
             <a:avLst/>
@@ -10474,25 +10420,25 @@
                 </a:solidFill>
                 <a:latin typeface="Arial"/>
               </a:rPr>
-              <a:t>frozen and</a:t>
-            </a:r>
-            <a:r>
-              <a:rPr sz="2460" b="1" i="0">
-                <a:solidFill>
-                  <a:srgbClr val="0B0B0B"/>
-                </a:solidFill>
-                <a:latin typeface="Arial"/>
-              </a:rPr>
-              <a:t> has not been run</a:t>
-            </a:r>
-            <a:r>
-              <a:rPr sz="2460" b="0" i="0">
-                <a:solidFill>
-                  <a:srgbClr val="0B0B0B"/>
-                </a:solidFill>
-                <a:latin typeface="Arial"/>
-              </a:rPr>
-              <a:t>.</a:t>
+              <a:t>results from the separate VDCG project.</a:t>
+            </a:r>
+            <a:r>
+              <a:rPr sz="2460" b="0" i="0">
+                <a:solidFill>
+                  <a:srgbClr val="0B0B0B"/>
+                </a:solidFill>
+                <a:latin typeface="Arial"/>
+              </a:rPr>
+              <a:t> </a:t>
+            </a:r>
+            <a:r>
+              <a:rPr sz="2460" b="0" i="0">
+                <a:solidFill>
+                  <a:srgbClr val="0B0B0B"/>
+                </a:solidFill>
+                <a:latin typeface="Arial"/>
+              </a:rPr>
+              <a:t>The 120-task pilot is</a:t>
             </a:r>
           </a:p>
         </p:txBody>
@@ -10505,8 +10451,8 @@
         </p:nvSpPr>
         <p:spPr>
           <a:xfrm>
-            <a:off x="20775738" y="37865555"/>
-            <a:ext cx="4459778" cy="264439"/>
+            <a:off x="20775739" y="37393168"/>
+            <a:ext cx="4214429" cy="312774"/>
           </a:xfrm>
           <a:prstGeom prst="rect">
             <a:avLst/>
@@ -10520,13 +10466,31 @@
           <a:lstStyle/>
           <a:p>
             <a:r>
-              <a:rPr sz="2080" b="0" i="0">
-                <a:solidFill>
-                  <a:srgbClr val="0B0B0B"/>
-                </a:solidFill>
-                <a:latin typeface="Arial"/>
-              </a:rPr>
-              <a:t>Every number, with commit and hash:</a:t>
+              <a:rPr sz="2460" b="0" i="0">
+                <a:solidFill>
+                  <a:srgbClr val="0B0B0B"/>
+                </a:solidFill>
+                <a:latin typeface="Arial"/>
+              </a:rPr>
+              <a:t>frozen and</a:t>
+            </a:r>
+            <a:r>
+              <a:rPr sz="2460" b="1" i="0">
+                <a:solidFill>
+                  <a:srgbClr val="0B0B0B"/>
+                </a:solidFill>
+                <a:latin typeface="Arial"/>
+              </a:rPr>
+              <a:t> has not been run</a:t>
+            </a:r>
+            <a:r>
+              <a:rPr sz="2460" b="0" i="0">
+                <a:solidFill>
+                  <a:srgbClr val="0B0B0B"/>
+                </a:solidFill>
+                <a:latin typeface="Arial"/>
+              </a:rPr>
+              <a:t>.</a:t>
             </a:r>
           </a:p>
         </p:txBody>
@@ -10539,8 +10503,8 @@
         </p:nvSpPr>
         <p:spPr>
           <a:xfrm>
-            <a:off x="20775738" y="38206545"/>
-            <a:ext cx="8583241" cy="278358"/>
+            <a:off x="20775738" y="37865555"/>
+            <a:ext cx="4459778" cy="264439"/>
           </a:xfrm>
           <a:prstGeom prst="rect">
             <a:avLst/>
@@ -10554,6 +10518,40 @@
           <a:lstStyle/>
           <a:p>
             <a:r>
+              <a:rPr sz="2080" b="0" i="0">
+                <a:solidFill>
+                  <a:srgbClr val="0B0B0B"/>
+                </a:solidFill>
+                <a:latin typeface="Arial"/>
+              </a:rPr>
+              <a:t>Every number, with commit and hash:</a:t>
+            </a:r>
+          </a:p>
+        </p:txBody>
+      </p:sp>
+      <p:sp>
+        <p:nvSpPr>
+          <p:cNvPr id="116" name="TextBox 115"/>
+          <p:cNvSpPr txBox="1"/>
+          <p:nvPr/>
+        </p:nvSpPr>
+        <p:spPr>
+          <a:xfrm>
+            <a:off x="20775738" y="38206545"/>
+            <a:ext cx="8583241" cy="278358"/>
+          </a:xfrm>
+          <a:prstGeom prst="rect">
+            <a:avLst/>
+          </a:prstGeom>
+          <a:noFill/>
+        </p:spPr>
+        <p:txBody>
+          <a:bodyPr wrap="none" lIns="0" rIns="0" tIns="0" bIns="0">
+            <a:spAutoFit/>
+          </a:bodyPr>
+          <a:lstStyle/>
+          <a:p>
+            <a:r>
               <a:rPr sz="2190" b="0" i="0">
                 <a:solidFill>
                   <a:srgbClr val="0B0B0B"/>
@@ -10576,7 +10574,7 @@
       </p:sp>
       <p:sp>
         <p:nvSpPr>
-          <p:cNvPr id="116" name="TextBox 115"/>
+          <p:cNvPr id="117" name="TextBox 116"/>
           <p:cNvSpPr txBox="1"/>
           <p:nvPr/>
         </p:nvSpPr>

</xml_diff>

<commit_message>
Summit deliverables updated with the verified CORA-NVG negative result (poster block, one abstract sentence, explainer Part 3) and the explainer's outdated diagnosis line corrected; PDFs rebuilt reproducibly (poster 1 page, abstract 1 page, explainer 6 pages), PPTX regenerated, evidence note section 13
</commit_message>
<xml_diff>
--- a/docs/summit_poster/poster.pptx
+++ b/docs/summit_poster/poster.pptx
@@ -7624,8 +7624,8 @@
         </p:nvSpPr>
         <p:spPr>
           <a:xfrm>
-            <a:off x="20775739" y="5987210"/>
-            <a:ext cx="8091143" cy="480795"/>
+            <a:off x="10873880" y="37530636"/>
+            <a:ext cx="5472028" cy="312517"/>
           </a:xfrm>
           <a:prstGeom prst="rect">
             <a:avLst/>
@@ -7639,13 +7639,121 @@
           <a:lstStyle/>
           <a:p>
             <a:r>
-              <a:rPr sz="3790" b="1" i="0">
-                <a:solidFill>
-                  <a:srgbClr val="2A78D6"/>
-                </a:solidFill>
-                <a:latin typeface="Arial"/>
-              </a:rPr>
-              <a:t>Negative controls before any repair</a:t>
+              <a:rPr sz="2460" b="1" i="0">
+                <a:solidFill>
+                  <a:srgbClr val="0B0B0B"/>
+                </a:solidFill>
+                <a:latin typeface="Arial"/>
+              </a:rPr>
+              <a:t>Can</a:t>
+            </a:r>
+            <a:r>
+              <a:rPr sz="2460" b="1" i="0">
+                <a:solidFill>
+                  <a:srgbClr val="0B0B0B"/>
+                </a:solidFill>
+                <a:latin typeface="Arial"/>
+              </a:rPr>
+              <a:t> </a:t>
+            </a:r>
+            <a:r>
+              <a:rPr sz="2460" b="1" i="0">
+                <a:solidFill>
+                  <a:srgbClr val="0B0B0B"/>
+                </a:solidFill>
+                <a:latin typeface="Arial"/>
+              </a:rPr>
+              <a:t>a</a:t>
+            </a:r>
+            <a:r>
+              <a:rPr sz="2460" b="1" i="0">
+                <a:solidFill>
+                  <a:srgbClr val="0B0B0B"/>
+                </a:solidFill>
+                <a:latin typeface="Arial"/>
+              </a:rPr>
+              <a:t> </a:t>
+            </a:r>
+            <a:r>
+              <a:rPr sz="2460" b="1" i="0">
+                <a:solidFill>
+                  <a:srgbClr val="0B0B0B"/>
+                </a:solidFill>
+                <a:latin typeface="Arial"/>
+              </a:rPr>
+              <a:t>neural</a:t>
+            </a:r>
+            <a:r>
+              <a:rPr sz="2460" b="1" i="0">
+                <a:solidFill>
+                  <a:srgbClr val="0B0B0B"/>
+                </a:solidFill>
+                <a:latin typeface="Arial"/>
+              </a:rPr>
+              <a:t> </a:t>
+            </a:r>
+            <a:r>
+              <a:rPr sz="2460" b="1" i="0">
+                <a:solidFill>
+                  <a:srgbClr val="0B0B0B"/>
+                </a:solidFill>
+                <a:latin typeface="Arial"/>
+              </a:rPr>
+              <a:t>model</a:t>
+            </a:r>
+            <a:r>
+              <a:rPr sz="2460" b="1" i="0">
+                <a:solidFill>
+                  <a:srgbClr val="0B0B0B"/>
+                </a:solidFill>
+                <a:latin typeface="Arial"/>
+              </a:rPr>
+              <a:t> </a:t>
+            </a:r>
+            <a:r>
+              <a:rPr sz="2460" b="1" i="0">
+                <a:solidFill>
+                  <a:srgbClr val="0B0B0B"/>
+                </a:solidFill>
+                <a:latin typeface="Arial"/>
+              </a:rPr>
+              <a:t>pick</a:t>
+            </a:r>
+            <a:r>
+              <a:rPr sz="2460" b="1" i="0">
+                <a:solidFill>
+                  <a:srgbClr val="0B0B0B"/>
+                </a:solidFill>
+                <a:latin typeface="Arial"/>
+              </a:rPr>
+              <a:t> </a:t>
+            </a:r>
+            <a:r>
+              <a:rPr sz="2460" b="1" i="0">
+                <a:solidFill>
+                  <a:srgbClr val="0B0B0B"/>
+                </a:solidFill>
+                <a:latin typeface="Arial"/>
+              </a:rPr>
+              <a:t>the</a:t>
+            </a:r>
+            <a:r>
+              <a:rPr sz="2460" b="1" i="0">
+                <a:solidFill>
+                  <a:srgbClr val="0B0B0B"/>
+                </a:solidFill>
+                <a:latin typeface="Arial"/>
+              </a:rPr>
+              <a:t> </a:t>
+            </a:r>
+            <a:r>
+              <a:rPr sz="2460" b="1" i="0">
+                <a:solidFill>
+                  <a:srgbClr val="0B0B0B"/>
+                </a:solidFill>
+                <a:latin typeface="Arial"/>
+              </a:rPr>
+              <a:t>view?</a:t>
             </a:r>
           </a:p>
         </p:txBody>
@@ -7658,8 +7766,8 @@
         </p:nvSpPr>
         <p:spPr>
           <a:xfrm>
-            <a:off x="20775739" y="17740983"/>
-            <a:ext cx="8620639" cy="312774"/>
+            <a:off x="16565702" y="37530378"/>
+            <a:ext cx="1385875" cy="312517"/>
           </a:xfrm>
           <a:prstGeom prst="rect">
             <a:avLst/>
@@ -7673,31 +7781,31 @@
           <a:lstStyle/>
           <a:p>
             <a:r>
-              <a:rPr sz="2460" b="1" i="0">
-                <a:solidFill>
-                  <a:srgbClr val="0B0B0B"/>
-                </a:solidFill>
-                <a:latin typeface="Arial"/>
-              </a:rPr>
-              <a:t>No task gained.</a:t>
-            </a:r>
-            <a:r>
-              <a:rPr sz="2460" b="0" i="0">
-                <a:solidFill>
-                  <a:srgbClr val="0B0B0B"/>
-                </a:solidFill>
-                <a:latin typeface="Arial"/>
-              </a:rPr>
-              <a:t> </a:t>
-            </a:r>
-            <a:r>
-              <a:rPr sz="2460" b="0" i="0">
-                <a:solidFill>
-                  <a:srgbClr val="0B0B0B"/>
-                </a:solidFill>
-                <a:latin typeface="Arial"/>
-              </a:rPr>
-              <a:t>Forcing one view to be searched first harmed</a:t>
+              <a:rPr sz="2460" b="0" i="0">
+                <a:solidFill>
+                  <a:srgbClr val="0B0B0B"/>
+                </a:solidFill>
+                <a:latin typeface="Arial"/>
+              </a:rPr>
+              <a:t>Not</a:t>
+            </a:r>
+            <a:r>
+              <a:rPr sz="2460" b="0" i="0">
+                <a:solidFill>
+                  <a:srgbClr val="0B0B0B"/>
+                </a:solidFill>
+                <a:latin typeface="Arial"/>
+              </a:rPr>
+              <a:t> </a:t>
+            </a:r>
+            <a:r>
+              <a:rPr sz="2460" b="0" i="0">
+                <a:solidFill>
+                  <a:srgbClr val="0B0B0B"/>
+                </a:solidFill>
+                <a:latin typeface="Arial"/>
+              </a:rPr>
+              <a:t>here.</a:t>
             </a:r>
           </a:p>
         </p:txBody>
@@ -7710,8 +7818,8 @@
         </p:nvSpPr>
         <p:spPr>
           <a:xfrm>
-            <a:off x="20775739" y="18145872"/>
-            <a:ext cx="8620636" cy="312515"/>
+            <a:off x="18171416" y="37530378"/>
+            <a:ext cx="1323058" cy="312517"/>
           </a:xfrm>
           <a:prstGeom prst="rect">
             <a:avLst/>
@@ -7731,25 +7839,43 @@
                 </a:solidFill>
                 <a:latin typeface="Arial"/>
               </a:rPr>
-              <a:t>5 of 24 tasks:</a:t>
-            </a:r>
-            <a:r>
-              <a:rPr sz="2460" b="0" i="0">
-                <a:solidFill>
-                  <a:srgbClr val="0B0B0B"/>
-                </a:solidFill>
-                <a:latin typeface="Arial"/>
-              </a:rPr>
-              <a:t> </a:t>
-            </a:r>
-            <a:r>
-              <a:rPr sz="2460" b="0" i="0">
-                <a:solidFill>
-                  <a:srgbClr val="0B0B0B"/>
-                </a:solidFill>
-                <a:latin typeface="Arial"/>
-              </a:rPr>
-              <a:t>4 of the 7 natively correct tasks lost their answer,</a:t>
+              <a:t>In</a:t>
+            </a:r>
+            <a:r>
+              <a:rPr sz="2460" b="0" i="0">
+                <a:solidFill>
+                  <a:srgbClr val="0B0B0B"/>
+                </a:solidFill>
+                <a:latin typeface="Arial"/>
+              </a:rPr>
+              <a:t> </a:t>
+            </a:r>
+            <a:r>
+              <a:rPr sz="2460" b="0" i="0">
+                <a:solidFill>
+                  <a:srgbClr val="0B0B0B"/>
+                </a:solidFill>
+                <a:latin typeface="Arial"/>
+              </a:rPr>
+              <a:t>a</a:t>
+            </a:r>
+            <a:r>
+              <a:rPr sz="2460" b="0" i="0">
+                <a:solidFill>
+                  <a:srgbClr val="0B0B0B"/>
+                </a:solidFill>
+                <a:latin typeface="Arial"/>
+              </a:rPr>
+              <a:t> </a:t>
+            </a:r>
+            <a:r>
+              <a:rPr sz="2460" b="0" i="0">
+                <a:solidFill>
+                  <a:srgbClr val="0B0B0B"/>
+                </a:solidFill>
+                <a:latin typeface="Arial"/>
+              </a:rPr>
+              <a:t>pre-</a:t>
             </a:r>
           </a:p>
         </p:txBody>
@@ -7762,8 +7888,8 @@
         </p:nvSpPr>
         <p:spPr>
           <a:xfrm>
-            <a:off x="20775739" y="18550748"/>
-            <a:ext cx="8620645" cy="312515"/>
+            <a:off x="10873879" y="37935253"/>
+            <a:ext cx="8620648" cy="312517"/>
           </a:xfrm>
           <a:prstGeom prst="rect">
             <a:avLst/>
@@ -7783,79 +7909,115 @@
                 </a:solidFill>
                 <a:latin typeface="Arial"/>
               </a:rPr>
-              <a:t>and</a:t>
-            </a:r>
-            <a:r>
-              <a:rPr sz="2460" b="0" i="0">
-                <a:solidFill>
-                  <a:srgbClr val="0B0B0B"/>
-                </a:solidFill>
-                <a:latin typeface="Arial"/>
-              </a:rPr>
-              <a:t> </a:t>
-            </a:r>
-            <a:r>
-              <a:rPr sz="2460" b="0" i="0">
-                <a:solidFill>
-                  <a:srgbClr val="0B0B0B"/>
-                </a:solidFill>
-                <a:latin typeface="Arial"/>
-              </a:rPr>
-              <a:t>1</a:t>
-            </a:r>
-            <a:r>
-              <a:rPr sz="2460" b="0" i="0">
-                <a:solidFill>
-                  <a:srgbClr val="0B0B0B"/>
-                </a:solidFill>
-                <a:latin typeface="Arial"/>
-              </a:rPr>
-              <a:t> </a:t>
-            </a:r>
-            <a:r>
-              <a:rPr sz="2460" b="0" i="0">
-                <a:solidFill>
-                  <a:srgbClr val="0B0B0B"/>
-                </a:solidFill>
-                <a:latin typeface="Arial"/>
-              </a:rPr>
-              <a:t>rejected</a:t>
-            </a:r>
-            <a:r>
-              <a:rPr sz="2460" b="0" i="0">
-                <a:solidFill>
-                  <a:srgbClr val="0B0B0B"/>
-                </a:solidFill>
-                <a:latin typeface="Arial"/>
-              </a:rPr>
-              <a:t> </a:t>
-            </a:r>
-            <a:r>
-              <a:rPr sz="2460" b="0" i="0">
-                <a:solidFill>
-                  <a:srgbClr val="0B0B0B"/>
-                </a:solidFill>
-                <a:latin typeface="Arial"/>
-              </a:rPr>
-              <a:t>task</a:t>
-            </a:r>
-            <a:r>
-              <a:rPr sz="2460" b="0" i="0">
-                <a:solidFill>
-                  <a:srgbClr val="0B0B0B"/>
-                </a:solidFill>
-                <a:latin typeface="Arial"/>
-              </a:rPr>
-              <a:t> </a:t>
-            </a:r>
-            <a:r>
-              <a:rPr sz="2460" b="0" i="0">
-                <a:solidFill>
-                  <a:srgbClr val="0B0B0B"/>
-                </a:solidFill>
-                <a:latin typeface="Arial"/>
-              </a:rPr>
-              <a:t>became</a:t>
+              <a:t>registered</a:t>
+            </a:r>
+            <a:r>
+              <a:rPr sz="2460" b="0" i="0">
+                <a:solidFill>
+                  <a:srgbClr val="0B0B0B"/>
+                </a:solidFill>
+                <a:latin typeface="Arial"/>
+              </a:rPr>
+              <a:t> </a:t>
+            </a:r>
+            <a:r>
+              <a:rPr sz="2460" b="0" i="0">
+                <a:solidFill>
+                  <a:srgbClr val="0B0B0B"/>
+                </a:solidFill>
+                <a:latin typeface="Arial"/>
+              </a:rPr>
+              <a:t>synthetic</a:t>
+            </a:r>
+            <a:r>
+              <a:rPr sz="2460" b="0" i="0">
+                <a:solidFill>
+                  <a:srgbClr val="0B0B0B"/>
+                </a:solidFill>
+                <a:latin typeface="Arial"/>
+              </a:rPr>
+              <a:t> </a:t>
+            </a:r>
+            <a:r>
+              <a:rPr sz="2460" b="0" i="0">
+                <a:solidFill>
+                  <a:srgbClr val="0B0B0B"/>
+                </a:solidFill>
+                <a:latin typeface="Arial"/>
+              </a:rPr>
+              <a:t>test</a:t>
+            </a:r>
+            <a:r>
+              <a:rPr sz="2460" b="0" i="0">
+                <a:solidFill>
+                  <a:srgbClr val="0B0B0B"/>
+                </a:solidFill>
+                <a:latin typeface="Arial"/>
+              </a:rPr>
+              <a:t> </a:t>
+            </a:r>
+            <a:r>
+              <a:rPr sz="2460" b="0" i="0">
+                <a:solidFill>
+                  <a:srgbClr val="0B0B0B"/>
+                </a:solidFill>
+                <a:latin typeface="Arial"/>
+              </a:rPr>
+              <a:t>(35</a:t>
+            </a:r>
+            <a:r>
+              <a:rPr sz="2460" b="0" i="0">
+                <a:solidFill>
+                  <a:srgbClr val="0B0B0B"/>
+                </a:solidFill>
+                <a:latin typeface="Arial"/>
+              </a:rPr>
+              <a:t> </a:t>
+            </a:r>
+            <a:r>
+              <a:rPr sz="2460" b="0" i="0">
+                <a:solidFill>
+                  <a:srgbClr val="0B0B0B"/>
+                </a:solidFill>
+                <a:latin typeface="Arial"/>
+              </a:rPr>
+              <a:t>cases</a:t>
+            </a:r>
+            <a:r>
+              <a:rPr sz="2460" b="0" i="0">
+                <a:solidFill>
+                  <a:srgbClr val="0B0B0B"/>
+                </a:solidFill>
+                <a:latin typeface="Arial"/>
+              </a:rPr>
+              <a:t> </a:t>
+            </a:r>
+            <a:r>
+              <a:rPr sz="2460" b="0" i="0">
+                <a:solidFill>
+                  <a:srgbClr val="0B0B0B"/>
+                </a:solidFill>
+                <a:latin typeface="Arial"/>
+              </a:rPr>
+              <a:t>that</a:t>
+            </a:r>
+            <a:r>
+              <a:rPr sz="2460" b="0" i="0">
+                <a:solidFill>
+                  <a:srgbClr val="0B0B0B"/>
+                </a:solidFill>
+                <a:latin typeface="Arial"/>
+              </a:rPr>
+              <a:t> </a:t>
+            </a:r>
+            <a:r>
+              <a:rPr sz="2460" b="0" i="0">
+                <a:solidFill>
+                  <a:srgbClr val="0B0B0B"/>
+                </a:solidFill>
+                <a:latin typeface="Arial"/>
+              </a:rPr>
+              <a:t>needed</a:t>
             </a:r>
             <a:r>
               <a:rPr sz="2460" b="0" i="0">
@@ -7891,61 +8053,7 @@
                 </a:solidFill>
                 <a:latin typeface="Arial"/>
               </a:rPr>
-              <a:t>false</a:t>
-            </a:r>
-            <a:r>
-              <a:rPr sz="2460" b="0" i="0">
-                <a:solidFill>
-                  <a:srgbClr val="0B0B0B"/>
-                </a:solidFill>
-                <a:latin typeface="Arial"/>
-              </a:rPr>
-              <a:t> </a:t>
-            </a:r>
-            <a:r>
-              <a:rPr sz="2460" b="0" i="0">
-                <a:solidFill>
-                  <a:srgbClr val="0B0B0B"/>
-                </a:solidFill>
-                <a:latin typeface="Arial"/>
-              </a:rPr>
-              <a:t>acceptance.</a:t>
-            </a:r>
-            <a:r>
-              <a:rPr sz="2460" b="0" i="0">
-                <a:solidFill>
-                  <a:srgbClr val="0B0B0B"/>
-                </a:solidFill>
-                <a:latin typeface="Arial"/>
-              </a:rPr>
-              <a:t> </a:t>
-            </a:r>
-            <a:r>
-              <a:rPr sz="2460" b="0" i="0">
-                <a:solidFill>
-                  <a:srgbClr val="0B0B0B"/>
-                </a:solidFill>
-                <a:latin typeface="Arial"/>
-              </a:rPr>
-              <a:t>The</a:t>
-            </a:r>
-            <a:r>
-              <a:rPr sz="2460" b="0" i="0">
-                <a:solidFill>
-                  <a:srgbClr val="0B0B0B"/>
-                </a:solidFill>
-                <a:latin typeface="Arial"/>
-              </a:rPr>
-              <a:t> </a:t>
-            </a:r>
-            <a:r>
-              <a:rPr sz="2460" b="0" i="0">
-                <a:solidFill>
-                  <a:srgbClr val="0B0B0B"/>
-                </a:solidFill>
-                <a:latin typeface="Arial"/>
-              </a:rPr>
-              <a:t>variant-</a:t>
+              <a:t>different</a:t>
             </a:r>
           </a:p>
         </p:txBody>
@@ -7958,8 +8066,8 @@
         </p:nvSpPr>
         <p:spPr>
           <a:xfrm>
-            <a:off x="20775739" y="18955624"/>
-            <a:ext cx="6401075" cy="312774"/>
+            <a:off x="10873879" y="38340143"/>
+            <a:ext cx="8620642" cy="312517"/>
           </a:xfrm>
           <a:prstGeom prst="rect">
             <a:avLst/>
@@ -7979,25 +8087,7 @@
                 </a:solidFill>
                 <a:latin typeface="Arial"/>
               </a:rPr>
-              <a:t>first repair we had built was therefore</a:t>
-            </a:r>
-            <a:r>
-              <a:rPr sz="2460" b="1" i="0">
-                <a:solidFill>
-                  <a:srgbClr val="0B0B0B"/>
-                </a:solidFill>
-                <a:latin typeface="Arial"/>
-              </a:rPr>
-              <a:t> not run</a:t>
-            </a:r>
-            <a:r>
-              <a:rPr sz="2460" b="0" i="0">
-                <a:solidFill>
-                  <a:srgbClr val="0B0B0B"/>
-                </a:solidFill>
-                <a:latin typeface="Arial"/>
-              </a:rPr>
-              <a:t>.</a:t>
+              <a:t>view), the fixed order picked right 35 times; a frozen Qwen2.5-</a:t>
             </a:r>
           </a:p>
         </p:txBody>
@@ -8010,8 +8100,8 @@
         </p:nvSpPr>
         <p:spPr>
           <a:xfrm>
-            <a:off x="20775739" y="20505546"/>
-            <a:ext cx="7432935" cy="480795"/>
+            <a:off x="10873879" y="38745017"/>
+            <a:ext cx="8620646" cy="312517"/>
           </a:xfrm>
           <a:prstGeom prst="rect">
             <a:avLst/>
@@ -8025,13 +8115,31 @@
           <a:lstStyle/>
           <a:p>
             <a:r>
-              <a:rPr sz="3790" b="1" i="0">
-                <a:solidFill>
-                  <a:srgbClr val="2A78D6"/>
-                </a:solidFill>
-                <a:latin typeface="Arial"/>
-              </a:rPr>
-              <a:t>What a valid repair must respect</a:t>
+              <a:rPr sz="2460" b="0" i="0">
+                <a:solidFill>
+                  <a:srgbClr val="0B0B0B"/>
+                </a:solidFill>
+                <a:latin typeface="Arial"/>
+              </a:rPr>
+              <a:t>1.5B 19 times,</a:t>
+            </a:r>
+            <a:r>
+              <a:rPr sz="2460" b="0" i="0">
+                <a:solidFill>
+                  <a:srgbClr val="0B0B0B"/>
+                </a:solidFill>
+                <a:latin typeface="Arial"/>
+              </a:rPr>
+              <a:t> </a:t>
+            </a:r>
+            <a:r>
+              <a:rPr sz="2460" b="0" i="0">
+                <a:solidFill>
+                  <a:srgbClr val="0B0B0B"/>
+                </a:solidFill>
+                <a:latin typeface="Arial"/>
+              </a:rPr>
+              <a:t>and only once when shown the reasoner’s real</a:t>
             </a:r>
           </a:p>
         </p:txBody>
@@ -8044,8 +8152,8 @@
         </p:nvSpPr>
         <p:spPr>
           <a:xfrm>
-            <a:off x="20946884" y="21803117"/>
-            <a:ext cx="8449696" cy="312515"/>
+            <a:off x="10873879" y="39149908"/>
+            <a:ext cx="8620645" cy="312517"/>
           </a:xfrm>
           <a:prstGeom prst="rect">
             <a:avLst/>
@@ -8065,151 +8173,7 @@
                 </a:solidFill>
                 <a:latin typeface="Arial"/>
               </a:rPr>
-              <a:t>• Every</a:t>
-            </a:r>
-            <a:r>
-              <a:rPr sz="2460" b="0" i="0">
-                <a:solidFill>
-                  <a:srgbClr val="0B0B0B"/>
-                </a:solidFill>
-                <a:latin typeface="Arial"/>
-              </a:rPr>
-              <a:t> </a:t>
-            </a:r>
-            <a:r>
-              <a:rPr sz="2460" b="0" i="0">
-                <a:solidFill>
-                  <a:srgbClr val="0B0B0B"/>
-                </a:solidFill>
-                <a:latin typeface="Arial"/>
-              </a:rPr>
-              <a:t>fold,</a:t>
-            </a:r>
-            <a:r>
-              <a:rPr sz="2460" b="0" i="0">
-                <a:solidFill>
-                  <a:srgbClr val="0B0B0B"/>
-                </a:solidFill>
-                <a:latin typeface="Arial"/>
-              </a:rPr>
-              <a:t> </a:t>
-            </a:r>
-            <a:r>
-              <a:rPr sz="2460" b="0" i="0">
-                <a:solidFill>
-                  <a:srgbClr val="0B0B0B"/>
-                </a:solidFill>
-                <a:latin typeface="Arial"/>
-              </a:rPr>
-              <a:t>inner</a:t>
-            </a:r>
-            <a:r>
-              <a:rPr sz="2460" b="0" i="0">
-                <a:solidFill>
-                  <a:srgbClr val="0B0B0B"/>
-                </a:solidFill>
-                <a:latin typeface="Arial"/>
-              </a:rPr>
-              <a:t> </a:t>
-            </a:r>
-            <a:r>
-              <a:rPr sz="2460" b="0" i="0">
-                <a:solidFill>
-                  <a:srgbClr val="0B0B0B"/>
-                </a:solidFill>
-                <a:latin typeface="Arial"/>
-              </a:rPr>
-              <a:t>and</a:t>
-            </a:r>
-            <a:r>
-              <a:rPr sz="2460" b="0" i="0">
-                <a:solidFill>
-                  <a:srgbClr val="0B0B0B"/>
-                </a:solidFill>
-                <a:latin typeface="Arial"/>
-              </a:rPr>
-              <a:t> </a:t>
-            </a:r>
-            <a:r>
-              <a:rPr sz="2460" b="0" i="0">
-                <a:solidFill>
-                  <a:srgbClr val="0B0B0B"/>
-                </a:solidFill>
-                <a:latin typeface="Arial"/>
-              </a:rPr>
-              <a:t>outer,</a:t>
-            </a:r>
-            <a:r>
-              <a:rPr sz="2460" b="0" i="0">
-                <a:solidFill>
-                  <a:srgbClr val="0B0B0B"/>
-                </a:solidFill>
-                <a:latin typeface="Arial"/>
-              </a:rPr>
-              <a:t> </a:t>
-            </a:r>
-            <a:r>
-              <a:rPr sz="2460" b="0" i="0">
-                <a:solidFill>
-                  <a:srgbClr val="0B0B0B"/>
-                </a:solidFill>
-                <a:latin typeface="Arial"/>
-              </a:rPr>
-              <a:t>selects</a:t>
-            </a:r>
-            <a:r>
-              <a:rPr sz="2460" b="0" i="0">
-                <a:solidFill>
-                  <a:srgbClr val="0B0B0B"/>
-                </a:solidFill>
-                <a:latin typeface="Arial"/>
-              </a:rPr>
-              <a:t> </a:t>
-            </a:r>
-            <a:r>
-              <a:rPr sz="2460" b="0" i="0">
-                <a:solidFill>
-                  <a:srgbClr val="0B0B0B"/>
-                </a:solidFill>
-                <a:latin typeface="Arial"/>
-              </a:rPr>
-              <a:t>its</a:t>
-            </a:r>
-            <a:r>
-              <a:rPr sz="2460" b="0" i="0">
-                <a:solidFill>
-                  <a:srgbClr val="0B0B0B"/>
-                </a:solidFill>
-                <a:latin typeface="Arial"/>
-              </a:rPr>
-              <a:t> </a:t>
-            </a:r>
-            <a:r>
-              <a:rPr sz="2460" b="0" i="0">
-                <a:solidFill>
-                  <a:srgbClr val="0B0B0B"/>
-                </a:solidFill>
-                <a:latin typeface="Arial"/>
-              </a:rPr>
-              <a:t>representation</a:t>
-            </a:r>
-            <a:r>
-              <a:rPr sz="2460" b="0" i="0">
-                <a:solidFill>
-                  <a:srgbClr val="0B0B0B"/>
-                </a:solidFill>
-                <a:latin typeface="Arial"/>
-              </a:rPr>
-              <a:t> </a:t>
-            </a:r>
-            <a:r>
-              <a:rPr sz="2460" b="0" i="0">
-                <a:solidFill>
-                  <a:srgbClr val="0B0B0B"/>
-                </a:solidFill>
-                <a:latin typeface="Arial"/>
-              </a:rPr>
-              <a:t>from</a:t>
+              <a:t>failure record (a shuffled record did the same); I-JEPA 3 times.</a:t>
             </a:r>
           </a:p>
         </p:txBody>
@@ -8222,8 +8186,8 @@
         </p:nvSpPr>
         <p:spPr>
           <a:xfrm>
-            <a:off x="21119515" y="22208005"/>
-            <a:ext cx="5598233" cy="312774"/>
+            <a:off x="20775739" y="5987210"/>
+            <a:ext cx="8091143" cy="480795"/>
           </a:xfrm>
           <a:prstGeom prst="rect">
             <a:avLst/>
@@ -8237,22 +8201,13 @@
           <a:lstStyle/>
           <a:p>
             <a:r>
-              <a:rPr sz="2460" b="1" i="0">
-                <a:solidFill>
-                  <a:srgbClr val="0B0B0B"/>
-                </a:solidFill>
-                <a:latin typeface="Arial"/>
-              </a:rPr>
-              <a:t>its own training demonstrations only</a:t>
-            </a:r>
-            <a:r>
-              <a:rPr sz="2460" b="0" i="0">
-                <a:solidFill>
-                  <a:srgbClr val="0B0B0B"/>
-                </a:solidFill>
-                <a:latin typeface="Arial"/>
-              </a:rPr>
-              <a:t>.</a:t>
+              <a:rPr sz="3790" b="1" i="0">
+                <a:solidFill>
+                  <a:srgbClr val="2A78D6"/>
+                </a:solidFill>
+                <a:latin typeface="Arial"/>
+              </a:rPr>
+              <a:t>Negative controls before any repair</a:t>
             </a:r>
           </a:p>
         </p:txBody>
@@ -8265,8 +8220,8 @@
         </p:nvSpPr>
         <p:spPr>
           <a:xfrm>
-            <a:off x="20946884" y="22691011"/>
-            <a:ext cx="8449693" cy="312515"/>
+            <a:off x="20775739" y="17740983"/>
+            <a:ext cx="8620639" cy="312774"/>
           </a:xfrm>
           <a:prstGeom prst="rect">
             <a:avLst/>
@@ -8280,193 +8235,31 @@
           <a:lstStyle/>
           <a:p>
             <a:r>
-              <a:rPr sz="2460" b="0" i="0">
-                <a:solidFill>
-                  <a:srgbClr val="0B0B0B"/>
-                </a:solidFill>
-                <a:latin typeface="Arial"/>
-              </a:rPr>
-              <a:t>• Anchoring</a:t>
-            </a:r>
-            <a:r>
-              <a:rPr sz="2460" b="0" i="0">
-                <a:solidFill>
-                  <a:srgbClr val="0B0B0B"/>
-                </a:solidFill>
-                <a:latin typeface="Arial"/>
-              </a:rPr>
-              <a:t> </a:t>
-            </a:r>
-            <a:r>
-              <a:rPr sz="2460" b="0" i="0">
-                <a:solidFill>
-                  <a:srgbClr val="0B0B0B"/>
-                </a:solidFill>
-                <a:latin typeface="Arial"/>
-              </a:rPr>
-              <a:t>a</a:t>
-            </a:r>
-            <a:r>
-              <a:rPr sz="2460" b="0" i="0">
-                <a:solidFill>
-                  <a:srgbClr val="0B0B0B"/>
-                </a:solidFill>
-                <a:latin typeface="Arial"/>
-              </a:rPr>
-              <a:t> </a:t>
-            </a:r>
-            <a:r>
-              <a:rPr sz="2460" b="0" i="0">
-                <a:solidFill>
-                  <a:srgbClr val="0B0B0B"/>
-                </a:solidFill>
-                <a:latin typeface="Arial"/>
-              </a:rPr>
-              <a:t>fold</a:t>
-            </a:r>
-            <a:r>
-              <a:rPr sz="2460" b="0" i="0">
-                <a:solidFill>
-                  <a:srgbClr val="0B0B0B"/>
-                </a:solidFill>
-                <a:latin typeface="Arial"/>
-              </a:rPr>
-              <a:t> </a:t>
-            </a:r>
-            <a:r>
-              <a:rPr sz="2460" b="0" i="0">
-                <a:solidFill>
-                  <a:srgbClr val="0B0B0B"/>
-                </a:solidFill>
-                <a:latin typeface="Arial"/>
-              </a:rPr>
-              <a:t>to</a:t>
-            </a:r>
-            <a:r>
-              <a:rPr sz="2460" b="0" i="0">
-                <a:solidFill>
-                  <a:srgbClr val="0B0B0B"/>
-                </a:solidFill>
-                <a:latin typeface="Arial"/>
-              </a:rPr>
-              <a:t> </a:t>
-            </a:r>
-            <a:r>
-              <a:rPr sz="2460" b="0" i="0">
-                <a:solidFill>
-                  <a:srgbClr val="0B0B0B"/>
-                </a:solidFill>
-                <a:latin typeface="Arial"/>
-              </a:rPr>
-              <a:t>the</a:t>
-            </a:r>
-            <a:r>
-              <a:rPr sz="2460" b="0" i="0">
-                <a:solidFill>
-                  <a:srgbClr val="0B0B0B"/>
-                </a:solidFill>
-                <a:latin typeface="Arial"/>
-              </a:rPr>
-              <a:t> </a:t>
-            </a:r>
-            <a:r>
-              <a:rPr sz="2460" b="0" i="0">
-                <a:solidFill>
-                  <a:srgbClr val="0B0B0B"/>
-                </a:solidFill>
-                <a:latin typeface="Arial"/>
-              </a:rPr>
-              <a:t>parent’s</a:t>
-            </a:r>
-            <a:r>
-              <a:rPr sz="2460" b="0" i="0">
-                <a:solidFill>
-                  <a:srgbClr val="0B0B0B"/>
-                </a:solidFill>
-                <a:latin typeface="Arial"/>
-              </a:rPr>
-              <a:t> </a:t>
-            </a:r>
-            <a:r>
-              <a:rPr sz="2460" b="0" i="0">
-                <a:solidFill>
-                  <a:srgbClr val="0B0B0B"/>
-                </a:solidFill>
-                <a:latin typeface="Arial"/>
-              </a:rPr>
-              <a:t>view</a:t>
-            </a:r>
-            <a:r>
-              <a:rPr sz="2460" b="0" i="0">
-                <a:solidFill>
-                  <a:srgbClr val="0B0B0B"/>
-                </a:solidFill>
-                <a:latin typeface="Arial"/>
-              </a:rPr>
-              <a:t> </a:t>
-            </a:r>
-            <a:r>
-              <a:rPr sz="2460" b="0" i="0">
-                <a:solidFill>
-                  <a:srgbClr val="0B0B0B"/>
-                </a:solidFill>
-                <a:latin typeface="Arial"/>
-              </a:rPr>
-              <a:t>would</a:t>
-            </a:r>
-            <a:r>
-              <a:rPr sz="2460" b="0" i="0">
-                <a:solidFill>
-                  <a:srgbClr val="0B0B0B"/>
-                </a:solidFill>
-                <a:latin typeface="Arial"/>
-              </a:rPr>
-              <a:t> </a:t>
-            </a:r>
-            <a:r>
-              <a:rPr sz="2460" b="0" i="0">
-                <a:solidFill>
-                  <a:srgbClr val="0B0B0B"/>
-                </a:solidFill>
-                <a:latin typeface="Arial"/>
-              </a:rPr>
-              <a:t>use</a:t>
-            </a:r>
-            <a:r>
-              <a:rPr sz="2460" b="0" i="0">
-                <a:solidFill>
-                  <a:srgbClr val="0B0B0B"/>
-                </a:solidFill>
-                <a:latin typeface="Arial"/>
-              </a:rPr>
-              <a:t> </a:t>
-            </a:r>
-            <a:r>
-              <a:rPr sz="2460" b="0" i="0">
-                <a:solidFill>
-                  <a:srgbClr val="0B0B0B"/>
-                </a:solidFill>
-                <a:latin typeface="Arial"/>
-              </a:rPr>
-              <a:t>the</a:t>
-            </a:r>
-            <a:r>
-              <a:rPr sz="2460" b="0" i="0">
-                <a:solidFill>
-                  <a:srgbClr val="0B0B0B"/>
-                </a:solidFill>
-                <a:latin typeface="Arial"/>
-              </a:rPr>
-              <a:t> </a:t>
-            </a:r>
-            <a:r>
-              <a:rPr sz="2460" b="0" i="0">
-                <a:solidFill>
-                  <a:srgbClr val="0B0B0B"/>
-                </a:solidFill>
-                <a:latin typeface="Arial"/>
-              </a:rPr>
-              <a:t>fold’s</a:t>
+              <a:rPr sz="2460" b="1" i="0">
+                <a:solidFill>
+                  <a:srgbClr val="0B0B0B"/>
+                </a:solidFill>
+                <a:latin typeface="Arial"/>
+              </a:rPr>
+              <a:t>No task gained.</a:t>
+            </a:r>
+            <a:r>
+              <a:rPr sz="2460" b="0" i="0">
+                <a:solidFill>
+                  <a:srgbClr val="0B0B0B"/>
+                </a:solidFill>
+                <a:latin typeface="Arial"/>
+              </a:rPr>
+              <a:t> </a:t>
+            </a:r>
+            <a:r>
+              <a:rPr sz="2460" b="0" i="0">
+                <a:solidFill>
+                  <a:srgbClr val="0B0B0B"/>
+                </a:solidFill>
+                <a:latin typeface="Arial"/>
+              </a:rPr>
+              <a:t>Forcing one view to be searched first harmed</a:t>
             </a:r>
           </a:p>
         </p:txBody>
@@ -8479,8 +8272,8 @@
         </p:nvSpPr>
         <p:spPr>
           <a:xfrm>
-            <a:off x="21119515" y="23095900"/>
-            <a:ext cx="8089901" cy="312774"/>
+            <a:off x="20775739" y="18145872"/>
+            <a:ext cx="8620636" cy="312515"/>
           </a:xfrm>
           <a:prstGeom prst="rect">
             <a:avLst/>
@@ -8500,34 +8293,25 @@
                 </a:solidFill>
                 <a:latin typeface="Arial"/>
               </a:rPr>
-              <a:t>held-out demonstration:</a:t>
-            </a:r>
-            <a:r>
-              <a:rPr sz="2460" b="1" i="0">
-                <a:solidFill>
-                  <a:srgbClr val="0B0B0B"/>
-                </a:solidFill>
-                <a:latin typeface="Arial"/>
-              </a:rPr>
-              <a:t> </a:t>
-            </a:r>
-            <a:r>
-              <a:rPr sz="2460" b="1" i="0">
-                <a:solidFill>
-                  <a:srgbClr val="0B0B0B"/>
-                </a:solidFill>
-                <a:latin typeface="Arial"/>
-              </a:rPr>
-              <a:t>forensic only</a:t>
-            </a:r>
-            <a:r>
-              <a:rPr sz="2460" b="0" i="0">
-                <a:solidFill>
-                  <a:srgbClr val="0B0B0B"/>
-                </a:solidFill>
-                <a:latin typeface="Arial"/>
-              </a:rPr>
-              <a:t>, never a certificate.</a:t>
+              <a:t>5 of 24 tasks:</a:t>
+            </a:r>
+            <a:r>
+              <a:rPr sz="2460" b="0" i="0">
+                <a:solidFill>
+                  <a:srgbClr val="0B0B0B"/>
+                </a:solidFill>
+                <a:latin typeface="Arial"/>
+              </a:rPr>
+              <a:t> </a:t>
+            </a:r>
+            <a:r>
+              <a:rPr sz="2460" b="0" i="0">
+                <a:solidFill>
+                  <a:srgbClr val="0B0B0B"/>
+                </a:solidFill>
+                <a:latin typeface="Arial"/>
+              </a:rPr>
+              <a:t>4 of the 7 natively correct tasks lost their answer,</a:t>
             </a:r>
           </a:p>
         </p:txBody>
@@ -8540,8 +8324,8 @@
         </p:nvSpPr>
         <p:spPr>
           <a:xfrm>
-            <a:off x="20946885" y="23578906"/>
-            <a:ext cx="8449698" cy="312515"/>
+            <a:off x="20775739" y="18550748"/>
+            <a:ext cx="8620645" cy="312515"/>
           </a:xfrm>
           <a:prstGeom prst="rect">
             <a:avLst/>
@@ -8561,151 +8345,169 @@
                 </a:solidFill>
                 <a:latin typeface="Arial"/>
               </a:rPr>
-              <a:t>• Removing</a:t>
-            </a:r>
-            <a:r>
-              <a:rPr sz="2460" b="0" i="0">
-                <a:solidFill>
-                  <a:srgbClr val="0B0B0B"/>
-                </a:solidFill>
-                <a:latin typeface="Arial"/>
-              </a:rPr>
-              <a:t> </a:t>
-            </a:r>
-            <a:r>
-              <a:rPr sz="2460" b="0" i="0">
-                <a:solidFill>
-                  <a:srgbClr val="0B0B0B"/>
-                </a:solidFill>
-                <a:latin typeface="Arial"/>
-              </a:rPr>
-              <a:t>duplicate</a:t>
-            </a:r>
-            <a:r>
-              <a:rPr sz="2460" b="0" i="0">
-                <a:solidFill>
-                  <a:srgbClr val="0B0B0B"/>
-                </a:solidFill>
-                <a:latin typeface="Arial"/>
-              </a:rPr>
-              <a:t> </a:t>
-            </a:r>
-            <a:r>
-              <a:rPr sz="2460" b="0" i="0">
-                <a:solidFill>
-                  <a:srgbClr val="0B0B0B"/>
-                </a:solidFill>
-                <a:latin typeface="Arial"/>
-              </a:rPr>
-              <a:t>views</a:t>
-            </a:r>
-            <a:r>
-              <a:rPr sz="2460" b="0" i="0">
-                <a:solidFill>
-                  <a:srgbClr val="0B0B0B"/>
-                </a:solidFill>
-                <a:latin typeface="Arial"/>
-              </a:rPr>
-              <a:t> </a:t>
-            </a:r>
-            <a:r>
-              <a:rPr sz="2460" b="0" i="0">
-                <a:solidFill>
-                  <a:srgbClr val="0B0B0B"/>
-                </a:solidFill>
-                <a:latin typeface="Arial"/>
-              </a:rPr>
-              <a:t>reaches</a:t>
-            </a:r>
-            <a:r>
-              <a:rPr sz="2460" b="0" i="0">
-                <a:solidFill>
-                  <a:srgbClr val="0B0B0B"/>
-                </a:solidFill>
-                <a:latin typeface="Arial"/>
-              </a:rPr>
-              <a:t> </a:t>
-            </a:r>
-            <a:r>
-              <a:rPr sz="2460" b="0" i="0">
-                <a:solidFill>
-                  <a:srgbClr val="0B0B0B"/>
-                </a:solidFill>
-                <a:latin typeface="Arial"/>
-              </a:rPr>
-              <a:t>S6</a:t>
-            </a:r>
-            <a:r>
-              <a:rPr sz="2460" b="0" i="0">
-                <a:solidFill>
-                  <a:srgbClr val="0B0B0B"/>
-                </a:solidFill>
-                <a:latin typeface="Arial"/>
-              </a:rPr>
-              <a:t> </a:t>
-            </a:r>
-            <a:r>
-              <a:rPr sz="2460" b="0" i="0">
-                <a:solidFill>
-                  <a:srgbClr val="0B0B0B"/>
-                </a:solidFill>
-                <a:latin typeface="Arial"/>
-              </a:rPr>
-              <a:t>on</a:t>
-            </a:r>
-            <a:r>
-              <a:rPr sz="2460" b="0" i="0">
-                <a:solidFill>
-                  <a:srgbClr val="0B0B0B"/>
-                </a:solidFill>
-                <a:latin typeface="Arial"/>
-              </a:rPr>
-              <a:t> </a:t>
-            </a:r>
-            <a:r>
-              <a:rPr sz="2460" b="0" i="0">
-                <a:solidFill>
-                  <a:srgbClr val="0B0B0B"/>
-                </a:solidFill>
-                <a:latin typeface="Arial"/>
-              </a:rPr>
-              <a:t>both</a:t>
-            </a:r>
-            <a:r>
-              <a:rPr sz="2460" b="0" i="0">
-                <a:solidFill>
-                  <a:srgbClr val="0B0B0B"/>
-                </a:solidFill>
-                <a:latin typeface="Arial"/>
-              </a:rPr>
-              <a:t> </a:t>
-            </a:r>
-            <a:r>
-              <a:rPr sz="2460" b="0" i="0">
-                <a:solidFill>
-                  <a:srgbClr val="0B0B0B"/>
-                </a:solidFill>
-                <a:latin typeface="Arial"/>
-              </a:rPr>
-              <a:t>failing</a:t>
-            </a:r>
-            <a:r>
-              <a:rPr sz="2460" b="0" i="0">
-                <a:solidFill>
-                  <a:srgbClr val="0B0B0B"/>
-                </a:solidFill>
-                <a:latin typeface="Arial"/>
-              </a:rPr>
-              <a:t> </a:t>
-            </a:r>
-            <a:r>
-              <a:rPr sz="2460" b="0" i="0">
-                <a:solidFill>
-                  <a:srgbClr val="0B0B0B"/>
-                </a:solidFill>
-                <a:latin typeface="Arial"/>
-              </a:rPr>
-              <a:t>pairs,</a:t>
+              <a:t>and</a:t>
+            </a:r>
+            <a:r>
+              <a:rPr sz="2460" b="0" i="0">
+                <a:solidFill>
+                  <a:srgbClr val="0B0B0B"/>
+                </a:solidFill>
+                <a:latin typeface="Arial"/>
+              </a:rPr>
+              <a:t> </a:t>
+            </a:r>
+            <a:r>
+              <a:rPr sz="2460" b="0" i="0">
+                <a:solidFill>
+                  <a:srgbClr val="0B0B0B"/>
+                </a:solidFill>
+                <a:latin typeface="Arial"/>
+              </a:rPr>
+              <a:t>1</a:t>
+            </a:r>
+            <a:r>
+              <a:rPr sz="2460" b="0" i="0">
+                <a:solidFill>
+                  <a:srgbClr val="0B0B0B"/>
+                </a:solidFill>
+                <a:latin typeface="Arial"/>
+              </a:rPr>
+              <a:t> </a:t>
+            </a:r>
+            <a:r>
+              <a:rPr sz="2460" b="0" i="0">
+                <a:solidFill>
+                  <a:srgbClr val="0B0B0B"/>
+                </a:solidFill>
+                <a:latin typeface="Arial"/>
+              </a:rPr>
+              <a:t>rejected</a:t>
+            </a:r>
+            <a:r>
+              <a:rPr sz="2460" b="0" i="0">
+                <a:solidFill>
+                  <a:srgbClr val="0B0B0B"/>
+                </a:solidFill>
+                <a:latin typeface="Arial"/>
+              </a:rPr>
+              <a:t> </a:t>
+            </a:r>
+            <a:r>
+              <a:rPr sz="2460" b="0" i="0">
+                <a:solidFill>
+                  <a:srgbClr val="0B0B0B"/>
+                </a:solidFill>
+                <a:latin typeface="Arial"/>
+              </a:rPr>
+              <a:t>task</a:t>
+            </a:r>
+            <a:r>
+              <a:rPr sz="2460" b="0" i="0">
+                <a:solidFill>
+                  <a:srgbClr val="0B0B0B"/>
+                </a:solidFill>
+                <a:latin typeface="Arial"/>
+              </a:rPr>
+              <a:t> </a:t>
+            </a:r>
+            <a:r>
+              <a:rPr sz="2460" b="0" i="0">
+                <a:solidFill>
+                  <a:srgbClr val="0B0B0B"/>
+                </a:solidFill>
+                <a:latin typeface="Arial"/>
+              </a:rPr>
+              <a:t>became</a:t>
+            </a:r>
+            <a:r>
+              <a:rPr sz="2460" b="0" i="0">
+                <a:solidFill>
+                  <a:srgbClr val="0B0B0B"/>
+                </a:solidFill>
+                <a:latin typeface="Arial"/>
+              </a:rPr>
+              <a:t> </a:t>
+            </a:r>
+            <a:r>
+              <a:rPr sz="2460" b="0" i="0">
+                <a:solidFill>
+                  <a:srgbClr val="0B0B0B"/>
+                </a:solidFill>
+                <a:latin typeface="Arial"/>
+              </a:rPr>
+              <a:t>a</a:t>
+            </a:r>
+            <a:r>
+              <a:rPr sz="2460" b="0" i="0">
+                <a:solidFill>
+                  <a:srgbClr val="0B0B0B"/>
+                </a:solidFill>
+                <a:latin typeface="Arial"/>
+              </a:rPr>
+              <a:t> </a:t>
+            </a:r>
+            <a:r>
+              <a:rPr sz="2460" b="0" i="0">
+                <a:solidFill>
+                  <a:srgbClr val="0B0B0B"/>
+                </a:solidFill>
+                <a:latin typeface="Arial"/>
+              </a:rPr>
+              <a:t>false</a:t>
+            </a:r>
+            <a:r>
+              <a:rPr sz="2460" b="0" i="0">
+                <a:solidFill>
+                  <a:srgbClr val="0B0B0B"/>
+                </a:solidFill>
+                <a:latin typeface="Arial"/>
+              </a:rPr>
+              <a:t> </a:t>
+            </a:r>
+            <a:r>
+              <a:rPr sz="2460" b="0" i="0">
+                <a:solidFill>
+                  <a:srgbClr val="0B0B0B"/>
+                </a:solidFill>
+                <a:latin typeface="Arial"/>
+              </a:rPr>
+              <a:t>acceptance.</a:t>
+            </a:r>
+            <a:r>
+              <a:rPr sz="2460" b="0" i="0">
+                <a:solidFill>
+                  <a:srgbClr val="0B0B0B"/>
+                </a:solidFill>
+                <a:latin typeface="Arial"/>
+              </a:rPr>
+              <a:t> </a:t>
+            </a:r>
+            <a:r>
+              <a:rPr sz="2460" b="0" i="0">
+                <a:solidFill>
+                  <a:srgbClr val="0B0B0B"/>
+                </a:solidFill>
+                <a:latin typeface="Arial"/>
+              </a:rPr>
+              <a:t>The</a:t>
+            </a:r>
+            <a:r>
+              <a:rPr sz="2460" b="0" i="0">
+                <a:solidFill>
+                  <a:srgbClr val="0B0B0B"/>
+                </a:solidFill>
+                <a:latin typeface="Arial"/>
+              </a:rPr>
+              <a:t> </a:t>
+            </a:r>
+            <a:r>
+              <a:rPr sz="2460" b="0" i="0">
+                <a:solidFill>
+                  <a:srgbClr val="0B0B0B"/>
+                </a:solidFill>
+                <a:latin typeface="Arial"/>
+              </a:rPr>
+              <a:t>variant-</a:t>
             </a:r>
           </a:p>
         </p:txBody>
@@ -8718,8 +8520,8 @@
         </p:nvSpPr>
         <p:spPr>
           <a:xfrm>
-            <a:off x="21119517" y="23983782"/>
-            <a:ext cx="3816010" cy="312515"/>
+            <a:off x="20775739" y="18955624"/>
+            <a:ext cx="6401075" cy="312774"/>
           </a:xfrm>
           <a:prstGeom prst="rect">
             <a:avLst/>
@@ -8739,79 +8541,25 @@
                 </a:solidFill>
                 <a:latin typeface="Arial"/>
               </a:rPr>
-              <a:t>from</a:t>
-            </a:r>
-            <a:r>
-              <a:rPr sz="2460" b="0" i="0">
-                <a:solidFill>
-                  <a:srgbClr val="0B0B0B"/>
-                </a:solidFill>
-                <a:latin typeface="Arial"/>
-              </a:rPr>
-              <a:t> </a:t>
-            </a:r>
-            <a:r>
-              <a:rPr sz="2460" b="0" i="0">
-                <a:solidFill>
-                  <a:srgbClr val="0B0B0B"/>
-                </a:solidFill>
-                <a:latin typeface="Arial"/>
-              </a:rPr>
-              <a:t>the</a:t>
-            </a:r>
-            <a:r>
-              <a:rPr sz="2460" b="0" i="0">
-                <a:solidFill>
-                  <a:srgbClr val="0B0B0B"/>
-                </a:solidFill>
-                <a:latin typeface="Arial"/>
-              </a:rPr>
-              <a:t> </a:t>
-            </a:r>
-            <a:r>
-              <a:rPr sz="2460" b="0" i="0">
-                <a:solidFill>
-                  <a:srgbClr val="0B0B0B"/>
-                </a:solidFill>
-                <a:latin typeface="Arial"/>
-              </a:rPr>
-              <a:t>fold’s</a:t>
-            </a:r>
-            <a:r>
-              <a:rPr sz="2460" b="0" i="0">
-                <a:solidFill>
-                  <a:srgbClr val="0B0B0B"/>
-                </a:solidFill>
-                <a:latin typeface="Arial"/>
-              </a:rPr>
-              <a:t> </a:t>
-            </a:r>
-            <a:r>
-              <a:rPr sz="2460" b="0" i="0">
-                <a:solidFill>
-                  <a:srgbClr val="0B0B0B"/>
-                </a:solidFill>
-                <a:latin typeface="Arial"/>
-              </a:rPr>
-              <a:t>data</a:t>
-            </a:r>
-            <a:r>
-              <a:rPr sz="2460" b="0" i="0">
-                <a:solidFill>
-                  <a:srgbClr val="0B0B0B"/>
-                </a:solidFill>
-                <a:latin typeface="Arial"/>
-              </a:rPr>
-              <a:t> </a:t>
-            </a:r>
-            <a:r>
-              <a:rPr sz="2460" b="0" i="0">
-                <a:solidFill>
-                  <a:srgbClr val="0B0B0B"/>
-                </a:solidFill>
-                <a:latin typeface="Arial"/>
-              </a:rPr>
-              <a:t>alone.</a:t>
+              <a:t>first repair we had built was therefore</a:t>
+            </a:r>
+            <a:r>
+              <a:rPr sz="2460" b="1" i="0">
+                <a:solidFill>
+                  <a:srgbClr val="0B0B0B"/>
+                </a:solidFill>
+                <a:latin typeface="Arial"/>
+              </a:rPr>
+              <a:t> not run</a:t>
+            </a:r>
+            <a:r>
+              <a:rPr sz="2460" b="0" i="0">
+                <a:solidFill>
+                  <a:srgbClr val="0B0B0B"/>
+                </a:solidFill>
+                <a:latin typeface="Arial"/>
+              </a:rPr>
+              <a:t>.</a:t>
             </a:r>
           </a:p>
         </p:txBody>
@@ -8824,8 +8572,8 @@
         </p:nvSpPr>
         <p:spPr>
           <a:xfrm>
-            <a:off x="25141304" y="23983782"/>
-            <a:ext cx="4255078" cy="312515"/>
+            <a:off x="20775739" y="20505546"/>
+            <a:ext cx="7432935" cy="480795"/>
           </a:xfrm>
           <a:prstGeom prst="rect">
             <a:avLst/>
@@ -8839,85 +8587,13 @@
           <a:lstStyle/>
           <a:p>
             <a:r>
-              <a:rPr sz="2460" b="0" i="0">
-                <a:solidFill>
-                  <a:srgbClr val="0B0B0B"/>
-                </a:solidFill>
-                <a:latin typeface="Arial"/>
-              </a:rPr>
-              <a:t>Tested</a:t>
-            </a:r>
-            <a:r>
-              <a:rPr sz="2460" b="0" i="0">
-                <a:solidFill>
-                  <a:srgbClr val="0B0B0B"/>
-                </a:solidFill>
-                <a:latin typeface="Arial"/>
-              </a:rPr>
-              <a:t> </a:t>
-            </a:r>
-            <a:r>
-              <a:rPr sz="2460" b="0" i="0">
-                <a:solidFill>
-                  <a:srgbClr val="0B0B0B"/>
-                </a:solidFill>
-                <a:latin typeface="Arial"/>
-              </a:rPr>
-              <a:t>on</a:t>
-            </a:r>
-            <a:r>
-              <a:rPr sz="2460" b="0" i="0">
-                <a:solidFill>
-                  <a:srgbClr val="0B0B0B"/>
-                </a:solidFill>
-                <a:latin typeface="Arial"/>
-              </a:rPr>
-              <a:t> </a:t>
-            </a:r>
-            <a:r>
-              <a:rPr sz="2460" b="0" i="0">
-                <a:solidFill>
-                  <a:srgbClr val="0B0B0B"/>
-                </a:solidFill>
-                <a:latin typeface="Arial"/>
-              </a:rPr>
-              <a:t>41</a:t>
-            </a:r>
-            <a:r>
-              <a:rPr sz="2460" b="0" i="0">
-                <a:solidFill>
-                  <a:srgbClr val="0B0B0B"/>
-                </a:solidFill>
-                <a:latin typeface="Arial"/>
-              </a:rPr>
-              <a:t> </a:t>
-            </a:r>
-            <a:r>
-              <a:rPr sz="2460" b="0" i="0">
-                <a:solidFill>
-                  <a:srgbClr val="0B0B0B"/>
-                </a:solidFill>
-                <a:latin typeface="Arial"/>
-              </a:rPr>
-              <a:t>synthetic</a:t>
-            </a:r>
-            <a:r>
-              <a:rPr sz="2460" b="0" i="0">
-                <a:solidFill>
-                  <a:srgbClr val="0B0B0B"/>
-                </a:solidFill>
-                <a:latin typeface="Arial"/>
-              </a:rPr>
-              <a:t> </a:t>
-            </a:r>
-            <a:r>
-              <a:rPr sz="2460" b="0" i="0">
-                <a:solidFill>
-                  <a:srgbClr val="0B0B0B"/>
-                </a:solidFill>
-                <a:latin typeface="Arial"/>
-              </a:rPr>
-              <a:t>tasks,</a:t>
+              <a:rPr sz="3790" b="1" i="0">
+                <a:solidFill>
+                  <a:srgbClr val="2A78D6"/>
+                </a:solidFill>
+                <a:latin typeface="Arial"/>
+              </a:rPr>
+              <a:t>What a valid repair must respect</a:t>
             </a:r>
           </a:p>
         </p:txBody>
@@ -8930,8 +8606,8 @@
         </p:nvSpPr>
         <p:spPr>
           <a:xfrm>
-            <a:off x="21119517" y="24388671"/>
-            <a:ext cx="8276862" cy="312515"/>
+            <a:off x="20946884" y="21803117"/>
+            <a:ext cx="8449696" cy="312515"/>
           </a:xfrm>
           <a:prstGeom prst="rect">
             <a:avLst/>
@@ -8951,43 +8627,43 @@
                 </a:solidFill>
                 <a:latin typeface="Arial"/>
               </a:rPr>
-              <a:t>it</a:t>
-            </a:r>
-            <a:r>
-              <a:rPr sz="2460" b="0" i="0">
-                <a:solidFill>
-                  <a:srgbClr val="0B0B0B"/>
-                </a:solidFill>
-                <a:latin typeface="Arial"/>
-              </a:rPr>
-              <a:t> </a:t>
-            </a:r>
-            <a:r>
-              <a:rPr sz="2460" b="0" i="0">
-                <a:solidFill>
-                  <a:srgbClr val="0B0B0B"/>
-                </a:solidFill>
-                <a:latin typeface="Arial"/>
-              </a:rPr>
-              <a:t>gained</a:t>
-            </a:r>
-            <a:r>
-              <a:rPr sz="2460" b="0" i="0">
-                <a:solidFill>
-                  <a:srgbClr val="0B0B0B"/>
-                </a:solidFill>
-                <a:latin typeface="Arial"/>
-              </a:rPr>
-              <a:t> </a:t>
-            </a:r>
-            <a:r>
-              <a:rPr sz="2460" b="0" i="0">
-                <a:solidFill>
-                  <a:srgbClr val="0B0B0B"/>
-                </a:solidFill>
-                <a:latin typeface="Arial"/>
-              </a:rPr>
-              <a:t>1</a:t>
+              <a:t>• Every</a:t>
+            </a:r>
+            <a:r>
+              <a:rPr sz="2460" b="0" i="0">
+                <a:solidFill>
+                  <a:srgbClr val="0B0B0B"/>
+                </a:solidFill>
+                <a:latin typeface="Arial"/>
+              </a:rPr>
+              <a:t> </a:t>
+            </a:r>
+            <a:r>
+              <a:rPr sz="2460" b="0" i="0">
+                <a:solidFill>
+                  <a:srgbClr val="0B0B0B"/>
+                </a:solidFill>
+                <a:latin typeface="Arial"/>
+              </a:rPr>
+              <a:t>fold,</a:t>
+            </a:r>
+            <a:r>
+              <a:rPr sz="2460" b="0" i="0">
+                <a:solidFill>
+                  <a:srgbClr val="0B0B0B"/>
+                </a:solidFill>
+                <a:latin typeface="Arial"/>
+              </a:rPr>
+              <a:t> </a:t>
+            </a:r>
+            <a:r>
+              <a:rPr sz="2460" b="0" i="0">
+                <a:solidFill>
+                  <a:srgbClr val="0B0B0B"/>
+                </a:solidFill>
+                <a:latin typeface="Arial"/>
+              </a:rPr>
+              <a:t>inner</a:t>
             </a:r>
             <a:r>
               <a:rPr sz="2460" b="0" i="0">
@@ -9023,133 +8699,79 @@
                 </a:solidFill>
                 <a:latin typeface="Arial"/>
               </a:rPr>
-              <a:t>harmed</a:t>
-            </a:r>
-            <a:r>
-              <a:rPr sz="2460" b="0" i="0">
-                <a:solidFill>
-                  <a:srgbClr val="0B0B0B"/>
-                </a:solidFill>
-                <a:latin typeface="Arial"/>
-              </a:rPr>
-              <a:t> </a:t>
-            </a:r>
-            <a:r>
-              <a:rPr sz="2460" b="0" i="0">
-                <a:solidFill>
-                  <a:srgbClr val="0B0B0B"/>
-                </a:solidFill>
-                <a:latin typeface="Arial"/>
-              </a:rPr>
-              <a:t>4</a:t>
-            </a:r>
-            <a:r>
-              <a:rPr sz="2460" b="0" i="0">
-                <a:solidFill>
-                  <a:srgbClr val="0B0B0B"/>
-                </a:solidFill>
-                <a:latin typeface="Arial"/>
-              </a:rPr>
-              <a:t> </a:t>
-            </a:r>
-            <a:r>
-              <a:rPr sz="2460" b="0" i="0">
-                <a:solidFill>
-                  <a:srgbClr val="0B0B0B"/>
-                </a:solidFill>
-                <a:latin typeface="Arial"/>
-              </a:rPr>
-              <a:t>(2</a:t>
-            </a:r>
-            <a:r>
-              <a:rPr sz="2460" b="0" i="0">
-                <a:solidFill>
-                  <a:srgbClr val="0B0B0B"/>
-                </a:solidFill>
-                <a:latin typeface="Arial"/>
-              </a:rPr>
-              <a:t> </a:t>
-            </a:r>
-            <a:r>
-              <a:rPr sz="2460" b="0" i="0">
-                <a:solidFill>
-                  <a:srgbClr val="0B0B0B"/>
-                </a:solidFill>
-                <a:latin typeface="Arial"/>
-              </a:rPr>
-              <a:t>correct</a:t>
-            </a:r>
-            <a:r>
-              <a:rPr sz="2460" b="0" i="0">
-                <a:solidFill>
-                  <a:srgbClr val="0B0B0B"/>
-                </a:solidFill>
-                <a:latin typeface="Arial"/>
-              </a:rPr>
-              <a:t> </a:t>
-            </a:r>
-            <a:r>
-              <a:rPr sz="2460" b="0" i="0">
-                <a:solidFill>
-                  <a:srgbClr val="0B0B0B"/>
-                </a:solidFill>
-                <a:latin typeface="Arial"/>
-              </a:rPr>
-              <a:t>answers</a:t>
-            </a:r>
-            <a:r>
-              <a:rPr sz="2460" b="0" i="0">
-                <a:solidFill>
-                  <a:srgbClr val="0B0B0B"/>
-                </a:solidFill>
-                <a:latin typeface="Arial"/>
-              </a:rPr>
-              <a:t> </a:t>
-            </a:r>
-            <a:r>
-              <a:rPr sz="2460" b="0" i="0">
-                <a:solidFill>
-                  <a:srgbClr val="0B0B0B"/>
-                </a:solidFill>
-                <a:latin typeface="Arial"/>
-              </a:rPr>
-              <a:t>lost,</a:t>
-            </a:r>
-            <a:r>
-              <a:rPr sz="2460" b="0" i="0">
-                <a:solidFill>
-                  <a:srgbClr val="0B0B0B"/>
-                </a:solidFill>
-                <a:latin typeface="Arial"/>
-              </a:rPr>
-              <a:t> </a:t>
-            </a:r>
-            <a:r>
-              <a:rPr sz="2460" b="0" i="0">
-                <a:solidFill>
-                  <a:srgbClr val="0B0B0B"/>
-                </a:solidFill>
-                <a:latin typeface="Arial"/>
-              </a:rPr>
-              <a:t>2</a:t>
-            </a:r>
-            <a:r>
-              <a:rPr sz="2460" b="0" i="0">
-                <a:solidFill>
-                  <a:srgbClr val="0B0B0B"/>
-                </a:solidFill>
-                <a:latin typeface="Arial"/>
-              </a:rPr>
-              <a:t> </a:t>
-            </a:r>
-            <a:r>
-              <a:rPr sz="2460" b="0" i="0">
-                <a:solidFill>
-                  <a:srgbClr val="0B0B0B"/>
-                </a:solidFill>
-                <a:latin typeface="Arial"/>
-              </a:rPr>
-              <a:t>false</a:t>
+              <a:t>outer,</a:t>
+            </a:r>
+            <a:r>
+              <a:rPr sz="2460" b="0" i="0">
+                <a:solidFill>
+                  <a:srgbClr val="0B0B0B"/>
+                </a:solidFill>
+                <a:latin typeface="Arial"/>
+              </a:rPr>
+              <a:t> </a:t>
+            </a:r>
+            <a:r>
+              <a:rPr sz="2460" b="0" i="0">
+                <a:solidFill>
+                  <a:srgbClr val="0B0B0B"/>
+                </a:solidFill>
+                <a:latin typeface="Arial"/>
+              </a:rPr>
+              <a:t>selects</a:t>
+            </a:r>
+            <a:r>
+              <a:rPr sz="2460" b="0" i="0">
+                <a:solidFill>
+                  <a:srgbClr val="0B0B0B"/>
+                </a:solidFill>
+                <a:latin typeface="Arial"/>
+              </a:rPr>
+              <a:t> </a:t>
+            </a:r>
+            <a:r>
+              <a:rPr sz="2460" b="0" i="0">
+                <a:solidFill>
+                  <a:srgbClr val="0B0B0B"/>
+                </a:solidFill>
+                <a:latin typeface="Arial"/>
+              </a:rPr>
+              <a:t>its</a:t>
+            </a:r>
+            <a:r>
+              <a:rPr sz="2460" b="0" i="0">
+                <a:solidFill>
+                  <a:srgbClr val="0B0B0B"/>
+                </a:solidFill>
+                <a:latin typeface="Arial"/>
+              </a:rPr>
+              <a:t> </a:t>
+            </a:r>
+            <a:r>
+              <a:rPr sz="2460" b="0" i="0">
+                <a:solidFill>
+                  <a:srgbClr val="0B0B0B"/>
+                </a:solidFill>
+                <a:latin typeface="Arial"/>
+              </a:rPr>
+              <a:t>representation</a:t>
+            </a:r>
+            <a:r>
+              <a:rPr sz="2460" b="0" i="0">
+                <a:solidFill>
+                  <a:srgbClr val="0B0B0B"/>
+                </a:solidFill>
+                <a:latin typeface="Arial"/>
+              </a:rPr>
+              <a:t> </a:t>
+            </a:r>
+            <a:r>
+              <a:rPr sz="2460" b="0" i="0">
+                <a:solidFill>
+                  <a:srgbClr val="0B0B0B"/>
+                </a:solidFill>
+                <a:latin typeface="Arial"/>
+              </a:rPr>
+              <a:t>from</a:t>
             </a:r>
           </a:p>
         </p:txBody>
@@ -9162,8 +8784,8 @@
         </p:nvSpPr>
         <p:spPr>
           <a:xfrm>
-            <a:off x="21119517" y="24793547"/>
-            <a:ext cx="7933621" cy="312774"/>
+            <a:off x="21119515" y="22208005"/>
+            <a:ext cx="5598233" cy="312774"/>
           </a:xfrm>
           <a:prstGeom prst="rect">
             <a:avLst/>
@@ -9177,31 +8799,13 @@
           <a:lstStyle/>
           <a:p>
             <a:r>
-              <a:rPr sz="2460" b="0" i="0">
-                <a:solidFill>
-                  <a:srgbClr val="0B0B0B"/>
-                </a:solidFill>
-                <a:latin typeface="Arial"/>
-              </a:rPr>
-              <a:t>acceptances) through the coarse views it let in:</a:t>
-            </a:r>
-            <a:r>
               <a:rPr sz="2460" b="1" i="0">
                 <a:solidFill>
                   <a:srgbClr val="0B0B0B"/>
                 </a:solidFill>
                 <a:latin typeface="Arial"/>
               </a:rPr>
-              <a:t> </a:t>
-            </a:r>
-            <a:r>
-              <a:rPr sz="2460" b="1" i="0">
-                <a:solidFill>
-                  <a:srgbClr val="0B0B0B"/>
-                </a:solidFill>
-                <a:latin typeface="Arial"/>
-              </a:rPr>
-              <a:t>rejected</a:t>
+              <a:t>its own training demonstrations only</a:t>
             </a:r>
             <a:r>
               <a:rPr sz="2460" b="0" i="0">
@@ -9223,8 +8827,8 @@
         </p:nvSpPr>
         <p:spPr>
           <a:xfrm>
-            <a:off x="20946882" y="25276565"/>
-            <a:ext cx="8449695" cy="312515"/>
+            <a:off x="20946884" y="22691011"/>
+            <a:ext cx="8449693" cy="312515"/>
           </a:xfrm>
           <a:prstGeom prst="rect">
             <a:avLst/>
@@ -9244,25 +8848,7 @@
                 </a:solidFill>
                 <a:latin typeface="Arial"/>
               </a:rPr>
-              <a:t>• Observed,</a:t>
-            </a:r>
-            <a:r>
-              <a:rPr sz="2460" b="0" i="0">
-                <a:solidFill>
-                  <a:srgbClr val="0B0B0B"/>
-                </a:solidFill>
-                <a:latin typeface="Arial"/>
-              </a:rPr>
-              <a:t> </a:t>
-            </a:r>
-            <a:r>
-              <a:rPr sz="2460" b="0" i="0">
-                <a:solidFill>
-                  <a:srgbClr val="0B0B0B"/>
-                </a:solidFill>
-                <a:latin typeface="Arial"/>
-              </a:rPr>
-              <a:t>not</a:t>
+              <a:t>• Anchoring</a:t>
             </a:r>
             <a:r>
               <a:rPr sz="2460" b="0" i="0">
@@ -9298,79 +8884,151 @@
                 </a:solidFill>
                 <a:latin typeface="Arial"/>
               </a:rPr>
-              <a:t>theorem:</a:t>
-            </a:r>
-            <a:r>
-              <a:rPr sz="2460" b="0" i="0">
-                <a:solidFill>
-                  <a:srgbClr val="0B0B0B"/>
-                </a:solidFill>
-                <a:latin typeface="Arial"/>
-              </a:rPr>
-              <a:t> </a:t>
-            </a:r>
-            <a:r>
-              <a:rPr sz="2460" b="0" i="0">
-                <a:solidFill>
-                  <a:srgbClr val="0B0B0B"/>
-                </a:solidFill>
-                <a:latin typeface="Arial"/>
-              </a:rPr>
-              <a:t>removing</a:t>
-            </a:r>
-            <a:r>
-              <a:rPr sz="2460" b="0" i="0">
-                <a:solidFill>
-                  <a:srgbClr val="0B0B0B"/>
-                </a:solidFill>
-                <a:latin typeface="Arial"/>
-              </a:rPr>
-              <a:t> </a:t>
-            </a:r>
-            <a:r>
-              <a:rPr sz="2460" b="0" i="0">
-                <a:solidFill>
-                  <a:srgbClr val="0B0B0B"/>
-                </a:solidFill>
-                <a:latin typeface="Arial"/>
-              </a:rPr>
-              <a:t>a</a:t>
-            </a:r>
-            <a:r>
-              <a:rPr sz="2460" b="0" i="0">
-                <a:solidFill>
-                  <a:srgbClr val="0B0B0B"/>
-                </a:solidFill>
-                <a:latin typeface="Arial"/>
-              </a:rPr>
-              <a:t> </a:t>
-            </a:r>
-            <a:r>
-              <a:rPr sz="2460" b="0" i="0">
-                <a:solidFill>
-                  <a:srgbClr val="0B0B0B"/>
-                </a:solidFill>
-                <a:latin typeface="Arial"/>
-              </a:rPr>
-              <a:t>demonstration</a:t>
-            </a:r>
-            <a:r>
-              <a:rPr sz="2460" b="0" i="0">
-                <a:solidFill>
-                  <a:srgbClr val="0B0B0B"/>
-                </a:solidFill>
-                <a:latin typeface="Arial"/>
-              </a:rPr>
-              <a:t> </a:t>
-            </a:r>
-            <a:r>
-              <a:rPr sz="2460" b="0" i="0">
-                <a:solidFill>
-                  <a:srgbClr val="0B0B0B"/>
-                </a:solidFill>
-                <a:latin typeface="Arial"/>
-              </a:rPr>
-              <a:t>made</a:t>
+              <a:t>fold</a:t>
+            </a:r>
+            <a:r>
+              <a:rPr sz="2460" b="0" i="0">
+                <a:solidFill>
+                  <a:srgbClr val="0B0B0B"/>
+                </a:solidFill>
+                <a:latin typeface="Arial"/>
+              </a:rPr>
+              <a:t> </a:t>
+            </a:r>
+            <a:r>
+              <a:rPr sz="2460" b="0" i="0">
+                <a:solidFill>
+                  <a:srgbClr val="0B0B0B"/>
+                </a:solidFill>
+                <a:latin typeface="Arial"/>
+              </a:rPr>
+              <a:t>to</a:t>
+            </a:r>
+            <a:r>
+              <a:rPr sz="2460" b="0" i="0">
+                <a:solidFill>
+                  <a:srgbClr val="0B0B0B"/>
+                </a:solidFill>
+                <a:latin typeface="Arial"/>
+              </a:rPr>
+              <a:t> </a:t>
+            </a:r>
+            <a:r>
+              <a:rPr sz="2460" b="0" i="0">
+                <a:solidFill>
+                  <a:srgbClr val="0B0B0B"/>
+                </a:solidFill>
+                <a:latin typeface="Arial"/>
+              </a:rPr>
+              <a:t>the</a:t>
+            </a:r>
+            <a:r>
+              <a:rPr sz="2460" b="0" i="0">
+                <a:solidFill>
+                  <a:srgbClr val="0B0B0B"/>
+                </a:solidFill>
+                <a:latin typeface="Arial"/>
+              </a:rPr>
+              <a:t> </a:t>
+            </a:r>
+            <a:r>
+              <a:rPr sz="2460" b="0" i="0">
+                <a:solidFill>
+                  <a:srgbClr val="0B0B0B"/>
+                </a:solidFill>
+                <a:latin typeface="Arial"/>
+              </a:rPr>
+              <a:t>parent’s</a:t>
+            </a:r>
+            <a:r>
+              <a:rPr sz="2460" b="0" i="0">
+                <a:solidFill>
+                  <a:srgbClr val="0B0B0B"/>
+                </a:solidFill>
+                <a:latin typeface="Arial"/>
+              </a:rPr>
+              <a:t> </a:t>
+            </a:r>
+            <a:r>
+              <a:rPr sz="2460" b="0" i="0">
+                <a:solidFill>
+                  <a:srgbClr val="0B0B0B"/>
+                </a:solidFill>
+                <a:latin typeface="Arial"/>
+              </a:rPr>
+              <a:t>view</a:t>
+            </a:r>
+            <a:r>
+              <a:rPr sz="2460" b="0" i="0">
+                <a:solidFill>
+                  <a:srgbClr val="0B0B0B"/>
+                </a:solidFill>
+                <a:latin typeface="Arial"/>
+              </a:rPr>
+              <a:t> </a:t>
+            </a:r>
+            <a:r>
+              <a:rPr sz="2460" b="0" i="0">
+                <a:solidFill>
+                  <a:srgbClr val="0B0B0B"/>
+                </a:solidFill>
+                <a:latin typeface="Arial"/>
+              </a:rPr>
+              <a:t>would</a:t>
+            </a:r>
+            <a:r>
+              <a:rPr sz="2460" b="0" i="0">
+                <a:solidFill>
+                  <a:srgbClr val="0B0B0B"/>
+                </a:solidFill>
+                <a:latin typeface="Arial"/>
+              </a:rPr>
+              <a:t> </a:t>
+            </a:r>
+            <a:r>
+              <a:rPr sz="2460" b="0" i="0">
+                <a:solidFill>
+                  <a:srgbClr val="0B0B0B"/>
+                </a:solidFill>
+                <a:latin typeface="Arial"/>
+              </a:rPr>
+              <a:t>use</a:t>
+            </a:r>
+            <a:r>
+              <a:rPr sz="2460" b="0" i="0">
+                <a:solidFill>
+                  <a:srgbClr val="0B0B0B"/>
+                </a:solidFill>
+                <a:latin typeface="Arial"/>
+              </a:rPr>
+              <a:t> </a:t>
+            </a:r>
+            <a:r>
+              <a:rPr sz="2460" b="0" i="0">
+                <a:solidFill>
+                  <a:srgbClr val="0B0B0B"/>
+                </a:solidFill>
+                <a:latin typeface="Arial"/>
+              </a:rPr>
+              <a:t>the</a:t>
+            </a:r>
+            <a:r>
+              <a:rPr sz="2460" b="0" i="0">
+                <a:solidFill>
+                  <a:srgbClr val="0B0B0B"/>
+                </a:solidFill>
+                <a:latin typeface="Arial"/>
+              </a:rPr>
+              <a:t> </a:t>
+            </a:r>
+            <a:r>
+              <a:rPr sz="2460" b="0" i="0">
+                <a:solidFill>
+                  <a:srgbClr val="0B0B0B"/>
+                </a:solidFill>
+                <a:latin typeface="Arial"/>
+              </a:rPr>
+              <a:t>fold’s</a:t>
             </a:r>
           </a:p>
         </p:txBody>
@@ -9383,8 +9041,8 @@
         </p:nvSpPr>
         <p:spPr>
           <a:xfrm>
-            <a:off x="21119513" y="25681441"/>
-            <a:ext cx="8276871" cy="312515"/>
+            <a:off x="21119515" y="23095900"/>
+            <a:ext cx="8089901" cy="312774"/>
           </a:xfrm>
           <a:prstGeom prst="rect">
             <a:avLst/>
@@ -9404,169 +9062,34 @@
                 </a:solidFill>
                 <a:latin typeface="Arial"/>
               </a:rPr>
-              <a:t>an</a:t>
-            </a:r>
-            <a:r>
-              <a:rPr sz="2460" b="0" i="0">
-                <a:solidFill>
-                  <a:srgbClr val="0B0B0B"/>
-                </a:solidFill>
-                <a:latin typeface="Arial"/>
-              </a:rPr>
-              <a:t> </a:t>
-            </a:r>
-            <a:r>
-              <a:rPr sz="2460" b="0" i="0">
-                <a:solidFill>
-                  <a:srgbClr val="0B0B0B"/>
-                </a:solidFill>
-                <a:latin typeface="Arial"/>
-              </a:rPr>
-              <a:t>eligible</a:t>
-            </a:r>
-            <a:r>
-              <a:rPr sz="2460" b="0" i="0">
-                <a:solidFill>
-                  <a:srgbClr val="0B0B0B"/>
-                </a:solidFill>
-                <a:latin typeface="Arial"/>
-              </a:rPr>
-              <a:t> </a:t>
-            </a:r>
-            <a:r>
-              <a:rPr sz="2460" b="0" i="0">
-                <a:solidFill>
-                  <a:srgbClr val="0B0B0B"/>
-                </a:solidFill>
-                <a:latin typeface="Arial"/>
-              </a:rPr>
-              <a:t>view</a:t>
-            </a:r>
-            <a:r>
-              <a:rPr sz="2460" b="0" i="0">
-                <a:solidFill>
-                  <a:srgbClr val="0B0B0B"/>
-                </a:solidFill>
-                <a:latin typeface="Arial"/>
-              </a:rPr>
-              <a:t> </a:t>
-            </a:r>
-            <a:r>
-              <a:rPr sz="2460" b="0" i="0">
-                <a:solidFill>
-                  <a:srgbClr val="0B0B0B"/>
-                </a:solidFill>
-                <a:latin typeface="Arial"/>
-              </a:rPr>
-              <a:t>ineligible</a:t>
-            </a:r>
-            <a:r>
-              <a:rPr sz="2460" b="0" i="0">
-                <a:solidFill>
-                  <a:srgbClr val="0B0B0B"/>
-                </a:solidFill>
-                <a:latin typeface="Arial"/>
-              </a:rPr>
-              <a:t> </a:t>
-            </a:r>
-            <a:r>
-              <a:rPr sz="2460" b="0" i="0">
-                <a:solidFill>
-                  <a:srgbClr val="0B0B0B"/>
-                </a:solidFill>
-                <a:latin typeface="Arial"/>
-              </a:rPr>
-              <a:t>in</a:t>
-            </a:r>
-            <a:r>
-              <a:rPr sz="2460" b="0" i="0">
-                <a:solidFill>
-                  <a:srgbClr val="0B0B0B"/>
-                </a:solidFill>
-                <a:latin typeface="Arial"/>
-              </a:rPr>
-              <a:t> </a:t>
-            </a:r>
-            <a:r>
-              <a:rPr sz="2460" b="0" i="0">
-                <a:solidFill>
-                  <a:srgbClr val="0B0B0B"/>
-                </a:solidFill>
-                <a:latin typeface="Arial"/>
-              </a:rPr>
-              <a:t>7</a:t>
-            </a:r>
-            <a:r>
-              <a:rPr sz="2460" b="0" i="0">
-                <a:solidFill>
-                  <a:srgbClr val="0B0B0B"/>
-                </a:solidFill>
-                <a:latin typeface="Arial"/>
-              </a:rPr>
-              <a:t> </a:t>
-            </a:r>
-            <a:r>
-              <a:rPr sz="2460" b="0" i="0">
-                <a:solidFill>
-                  <a:srgbClr val="0B0B0B"/>
-                </a:solidFill>
-                <a:latin typeface="Arial"/>
-              </a:rPr>
-              <a:t>of</a:t>
-            </a:r>
-            <a:r>
-              <a:rPr sz="2460" b="0" i="0">
-                <a:solidFill>
-                  <a:srgbClr val="0B0B0B"/>
-                </a:solidFill>
-                <a:latin typeface="Arial"/>
-              </a:rPr>
-              <a:t> </a:t>
-            </a:r>
-            <a:r>
-              <a:rPr sz="2460" b="0" i="0">
-                <a:solidFill>
-                  <a:srgbClr val="0B0B0B"/>
-                </a:solidFill>
-                <a:latin typeface="Arial"/>
-              </a:rPr>
-              <a:t>724</a:t>
-            </a:r>
-            <a:r>
-              <a:rPr sz="2460" b="0" i="0">
-                <a:solidFill>
-                  <a:srgbClr val="0B0B0B"/>
-                </a:solidFill>
-                <a:latin typeface="Arial"/>
-              </a:rPr>
-              <a:t> </a:t>
-            </a:r>
-            <a:r>
-              <a:rPr sz="2460" b="0" i="0">
-                <a:solidFill>
-                  <a:srgbClr val="0B0B0B"/>
-                </a:solidFill>
-                <a:latin typeface="Arial"/>
-              </a:rPr>
-              <a:t>development</a:t>
-            </a:r>
-            <a:r>
-              <a:rPr sz="2460" b="0" i="0">
-                <a:solidFill>
-                  <a:srgbClr val="0B0B0B"/>
-                </a:solidFill>
-                <a:latin typeface="Arial"/>
-              </a:rPr>
-              <a:t> </a:t>
-            </a:r>
-            <a:r>
-              <a:rPr sz="2460" b="0" i="0">
-                <a:solidFill>
-                  <a:srgbClr val="0B0B0B"/>
-                </a:solidFill>
-                <a:latin typeface="Arial"/>
-              </a:rPr>
-              <a:t>compar-</a:t>
+              <a:t>held-out demonstration:</a:t>
+            </a:r>
+            <a:r>
+              <a:rPr sz="2460" b="1" i="0">
+                <a:solidFill>
+                  <a:srgbClr val="0B0B0B"/>
+                </a:solidFill>
+                <a:latin typeface="Arial"/>
+              </a:rPr>
+              <a:t> </a:t>
+            </a:r>
+            <a:r>
+              <a:rPr sz="2460" b="1" i="0">
+                <a:solidFill>
+                  <a:srgbClr val="0B0B0B"/>
+                </a:solidFill>
+                <a:latin typeface="Arial"/>
+              </a:rPr>
+              <a:t>forensic only</a:t>
+            </a:r>
+            <a:r>
+              <a:rPr sz="2460" b="0" i="0">
+                <a:solidFill>
+                  <a:srgbClr val="0B0B0B"/>
+                </a:solidFill>
+                <a:latin typeface="Arial"/>
+              </a:rPr>
+              <a:t>, never a certificate.</a:t>
             </a:r>
           </a:p>
         </p:txBody>
@@ -9579,8 +9102,8 @@
         </p:nvSpPr>
         <p:spPr>
           <a:xfrm>
-            <a:off x="21119513" y="26086317"/>
-            <a:ext cx="3456928" cy="312517"/>
+            <a:off x="20946885" y="23578906"/>
+            <a:ext cx="8449698" cy="312515"/>
           </a:xfrm>
           <a:prstGeom prst="rect">
             <a:avLst/>
@@ -9600,7 +9123,151 @@
                 </a:solidFill>
                 <a:latin typeface="Arial"/>
               </a:rPr>
-              <a:t>isons (pooled coverage).</a:t>
+              <a:t>• Removing</a:t>
+            </a:r>
+            <a:r>
+              <a:rPr sz="2460" b="0" i="0">
+                <a:solidFill>
+                  <a:srgbClr val="0B0B0B"/>
+                </a:solidFill>
+                <a:latin typeface="Arial"/>
+              </a:rPr>
+              <a:t> </a:t>
+            </a:r>
+            <a:r>
+              <a:rPr sz="2460" b="0" i="0">
+                <a:solidFill>
+                  <a:srgbClr val="0B0B0B"/>
+                </a:solidFill>
+                <a:latin typeface="Arial"/>
+              </a:rPr>
+              <a:t>duplicate</a:t>
+            </a:r>
+            <a:r>
+              <a:rPr sz="2460" b="0" i="0">
+                <a:solidFill>
+                  <a:srgbClr val="0B0B0B"/>
+                </a:solidFill>
+                <a:latin typeface="Arial"/>
+              </a:rPr>
+              <a:t> </a:t>
+            </a:r>
+            <a:r>
+              <a:rPr sz="2460" b="0" i="0">
+                <a:solidFill>
+                  <a:srgbClr val="0B0B0B"/>
+                </a:solidFill>
+                <a:latin typeface="Arial"/>
+              </a:rPr>
+              <a:t>views</a:t>
+            </a:r>
+            <a:r>
+              <a:rPr sz="2460" b="0" i="0">
+                <a:solidFill>
+                  <a:srgbClr val="0B0B0B"/>
+                </a:solidFill>
+                <a:latin typeface="Arial"/>
+              </a:rPr>
+              <a:t> </a:t>
+            </a:r>
+            <a:r>
+              <a:rPr sz="2460" b="0" i="0">
+                <a:solidFill>
+                  <a:srgbClr val="0B0B0B"/>
+                </a:solidFill>
+                <a:latin typeface="Arial"/>
+              </a:rPr>
+              <a:t>reaches</a:t>
+            </a:r>
+            <a:r>
+              <a:rPr sz="2460" b="0" i="0">
+                <a:solidFill>
+                  <a:srgbClr val="0B0B0B"/>
+                </a:solidFill>
+                <a:latin typeface="Arial"/>
+              </a:rPr>
+              <a:t> </a:t>
+            </a:r>
+            <a:r>
+              <a:rPr sz="2460" b="0" i="0">
+                <a:solidFill>
+                  <a:srgbClr val="0B0B0B"/>
+                </a:solidFill>
+                <a:latin typeface="Arial"/>
+              </a:rPr>
+              <a:t>S6</a:t>
+            </a:r>
+            <a:r>
+              <a:rPr sz="2460" b="0" i="0">
+                <a:solidFill>
+                  <a:srgbClr val="0B0B0B"/>
+                </a:solidFill>
+                <a:latin typeface="Arial"/>
+              </a:rPr>
+              <a:t> </a:t>
+            </a:r>
+            <a:r>
+              <a:rPr sz="2460" b="0" i="0">
+                <a:solidFill>
+                  <a:srgbClr val="0B0B0B"/>
+                </a:solidFill>
+                <a:latin typeface="Arial"/>
+              </a:rPr>
+              <a:t>on</a:t>
+            </a:r>
+            <a:r>
+              <a:rPr sz="2460" b="0" i="0">
+                <a:solidFill>
+                  <a:srgbClr val="0B0B0B"/>
+                </a:solidFill>
+                <a:latin typeface="Arial"/>
+              </a:rPr>
+              <a:t> </a:t>
+            </a:r>
+            <a:r>
+              <a:rPr sz="2460" b="0" i="0">
+                <a:solidFill>
+                  <a:srgbClr val="0B0B0B"/>
+                </a:solidFill>
+                <a:latin typeface="Arial"/>
+              </a:rPr>
+              <a:t>both</a:t>
+            </a:r>
+            <a:r>
+              <a:rPr sz="2460" b="0" i="0">
+                <a:solidFill>
+                  <a:srgbClr val="0B0B0B"/>
+                </a:solidFill>
+                <a:latin typeface="Arial"/>
+              </a:rPr>
+              <a:t> </a:t>
+            </a:r>
+            <a:r>
+              <a:rPr sz="2460" b="0" i="0">
+                <a:solidFill>
+                  <a:srgbClr val="0B0B0B"/>
+                </a:solidFill>
+                <a:latin typeface="Arial"/>
+              </a:rPr>
+              <a:t>failing</a:t>
+            </a:r>
+            <a:r>
+              <a:rPr sz="2460" b="0" i="0">
+                <a:solidFill>
+                  <a:srgbClr val="0B0B0B"/>
+                </a:solidFill>
+                <a:latin typeface="Arial"/>
+              </a:rPr>
+              <a:t> </a:t>
+            </a:r>
+            <a:r>
+              <a:rPr sz="2460" b="0" i="0">
+                <a:solidFill>
+                  <a:srgbClr val="0B0B0B"/>
+                </a:solidFill>
+                <a:latin typeface="Arial"/>
+              </a:rPr>
+              <a:t>pairs,</a:t>
             </a:r>
           </a:p>
         </p:txBody>
@@ -9613,8 +9280,8 @@
         </p:nvSpPr>
         <p:spPr>
           <a:xfrm>
-            <a:off x="20775739" y="27759062"/>
-            <a:ext cx="8385869" cy="480795"/>
+            <a:off x="21119517" y="23983782"/>
+            <a:ext cx="3816010" cy="312515"/>
           </a:xfrm>
           <a:prstGeom prst="rect">
             <a:avLst/>
@@ -9628,31 +9295,85 @@
           <a:lstStyle/>
           <a:p>
             <a:r>
-              <a:rPr sz="3790" b="1" i="0">
-                <a:solidFill>
-                  <a:srgbClr val="2A78D6"/>
-                </a:solidFill>
-                <a:latin typeface="Arial"/>
-              </a:rPr>
-              <a:t>A portable controller?</a:t>
-            </a:r>
-            <a:r>
-              <a:rPr sz="3790" b="1" i="0">
-                <a:solidFill>
-                  <a:srgbClr val="D03B3B"/>
-                </a:solidFill>
-                <a:latin typeface="Arial"/>
-              </a:rPr>
-              <a:t> </a:t>
-            </a:r>
-            <a:r>
-              <a:rPr sz="3790" b="1" i="0">
-                <a:solidFill>
-                  <a:srgbClr val="D03B3B"/>
-                </a:solidFill>
-                <a:latin typeface="Arial"/>
-              </a:rPr>
-              <a:t>BIOLOGICAL</a:t>
+              <a:rPr sz="2460" b="0" i="0">
+                <a:solidFill>
+                  <a:srgbClr val="0B0B0B"/>
+                </a:solidFill>
+                <a:latin typeface="Arial"/>
+              </a:rPr>
+              <a:t>from</a:t>
+            </a:r>
+            <a:r>
+              <a:rPr sz="2460" b="0" i="0">
+                <a:solidFill>
+                  <a:srgbClr val="0B0B0B"/>
+                </a:solidFill>
+                <a:latin typeface="Arial"/>
+              </a:rPr>
+              <a:t> </a:t>
+            </a:r>
+            <a:r>
+              <a:rPr sz="2460" b="0" i="0">
+                <a:solidFill>
+                  <a:srgbClr val="0B0B0B"/>
+                </a:solidFill>
+                <a:latin typeface="Arial"/>
+              </a:rPr>
+              <a:t>the</a:t>
+            </a:r>
+            <a:r>
+              <a:rPr sz="2460" b="0" i="0">
+                <a:solidFill>
+                  <a:srgbClr val="0B0B0B"/>
+                </a:solidFill>
+                <a:latin typeface="Arial"/>
+              </a:rPr>
+              <a:t> </a:t>
+            </a:r>
+            <a:r>
+              <a:rPr sz="2460" b="0" i="0">
+                <a:solidFill>
+                  <a:srgbClr val="0B0B0B"/>
+                </a:solidFill>
+                <a:latin typeface="Arial"/>
+              </a:rPr>
+              <a:t>fold’s</a:t>
+            </a:r>
+            <a:r>
+              <a:rPr sz="2460" b="0" i="0">
+                <a:solidFill>
+                  <a:srgbClr val="0B0B0B"/>
+                </a:solidFill>
+                <a:latin typeface="Arial"/>
+              </a:rPr>
+              <a:t> </a:t>
+            </a:r>
+            <a:r>
+              <a:rPr sz="2460" b="0" i="0">
+                <a:solidFill>
+                  <a:srgbClr val="0B0B0B"/>
+                </a:solidFill>
+                <a:latin typeface="Arial"/>
+              </a:rPr>
+              <a:t>data</a:t>
+            </a:r>
+            <a:r>
+              <a:rPr sz="2460" b="0" i="0">
+                <a:solidFill>
+                  <a:srgbClr val="0B0B0B"/>
+                </a:solidFill>
+                <a:latin typeface="Arial"/>
+              </a:rPr>
+              <a:t> </a:t>
+            </a:r>
+            <a:r>
+              <a:rPr sz="2460" b="0" i="0">
+                <a:solidFill>
+                  <a:srgbClr val="0B0B0B"/>
+                </a:solidFill>
+                <a:latin typeface="Arial"/>
+              </a:rPr>
+              <a:t>alone.</a:t>
             </a:r>
           </a:p>
         </p:txBody>
@@ -9665,8 +9386,8 @@
         </p:nvSpPr>
         <p:spPr>
           <a:xfrm>
-            <a:off x="20775739" y="28442298"/>
-            <a:ext cx="6151134" cy="480795"/>
+            <a:off x="25141304" y="23983782"/>
+            <a:ext cx="4255078" cy="312515"/>
           </a:xfrm>
           <a:prstGeom prst="rect">
             <a:avLst/>
@@ -9680,13 +9401,85 @@
           <a:lstStyle/>
           <a:p>
             <a:r>
-              <a:rPr sz="3790" b="1" i="0">
-                <a:solidFill>
-                  <a:srgbClr val="D03B3B"/>
-                </a:solidFill>
-                <a:latin typeface="Arial"/>
-              </a:rPr>
-              <a:t>APPLICATION: UNTESTED</a:t>
+              <a:rPr sz="2460" b="0" i="0">
+                <a:solidFill>
+                  <a:srgbClr val="0B0B0B"/>
+                </a:solidFill>
+                <a:latin typeface="Arial"/>
+              </a:rPr>
+              <a:t>Tested</a:t>
+            </a:r>
+            <a:r>
+              <a:rPr sz="2460" b="0" i="0">
+                <a:solidFill>
+                  <a:srgbClr val="0B0B0B"/>
+                </a:solidFill>
+                <a:latin typeface="Arial"/>
+              </a:rPr>
+              <a:t> </a:t>
+            </a:r>
+            <a:r>
+              <a:rPr sz="2460" b="0" i="0">
+                <a:solidFill>
+                  <a:srgbClr val="0B0B0B"/>
+                </a:solidFill>
+                <a:latin typeface="Arial"/>
+              </a:rPr>
+              <a:t>on</a:t>
+            </a:r>
+            <a:r>
+              <a:rPr sz="2460" b="0" i="0">
+                <a:solidFill>
+                  <a:srgbClr val="0B0B0B"/>
+                </a:solidFill>
+                <a:latin typeface="Arial"/>
+              </a:rPr>
+              <a:t> </a:t>
+            </a:r>
+            <a:r>
+              <a:rPr sz="2460" b="0" i="0">
+                <a:solidFill>
+                  <a:srgbClr val="0B0B0B"/>
+                </a:solidFill>
+                <a:latin typeface="Arial"/>
+              </a:rPr>
+              <a:t>41</a:t>
+            </a:r>
+            <a:r>
+              <a:rPr sz="2460" b="0" i="0">
+                <a:solidFill>
+                  <a:srgbClr val="0B0B0B"/>
+                </a:solidFill>
+                <a:latin typeface="Arial"/>
+              </a:rPr>
+              <a:t> </a:t>
+            </a:r>
+            <a:r>
+              <a:rPr sz="2460" b="0" i="0">
+                <a:solidFill>
+                  <a:srgbClr val="0B0B0B"/>
+                </a:solidFill>
+                <a:latin typeface="Arial"/>
+              </a:rPr>
+              <a:t>synthetic</a:t>
+            </a:r>
+            <a:r>
+              <a:rPr sz="2460" b="0" i="0">
+                <a:solidFill>
+                  <a:srgbClr val="0B0B0B"/>
+                </a:solidFill>
+                <a:latin typeface="Arial"/>
+              </a:rPr>
+              <a:t> </a:t>
+            </a:r>
+            <a:r>
+              <a:rPr sz="2460" b="0" i="0">
+                <a:solidFill>
+                  <a:srgbClr val="0B0B0B"/>
+                </a:solidFill>
+                <a:latin typeface="Arial"/>
+              </a:rPr>
+              <a:t>tasks,</a:t>
             </a:r>
           </a:p>
         </p:txBody>
@@ -9699,8 +9492,8 @@
         </p:nvSpPr>
         <p:spPr>
           <a:xfrm>
-            <a:off x="21438945" y="29900804"/>
-            <a:ext cx="1681853" cy="264436"/>
+            <a:off x="21119517" y="24388671"/>
+            <a:ext cx="8276862" cy="312515"/>
           </a:xfrm>
           <a:prstGeom prst="rect">
             <a:avLst/>
@@ -9714,13 +9507,211 @@
           <a:lstStyle/>
           <a:p>
             <a:r>
-              <a:rPr sz="2080" b="1" i="0">
-                <a:solidFill>
-                  <a:srgbClr val="2A78D6"/>
-                </a:solidFill>
-                <a:latin typeface="Arial"/>
-              </a:rPr>
-              <a:t>implemented</a:t>
+              <a:rPr sz="2460" b="0" i="0">
+                <a:solidFill>
+                  <a:srgbClr val="0B0B0B"/>
+                </a:solidFill>
+                <a:latin typeface="Arial"/>
+              </a:rPr>
+              <a:t>it</a:t>
+            </a:r>
+            <a:r>
+              <a:rPr sz="2460" b="0" i="0">
+                <a:solidFill>
+                  <a:srgbClr val="0B0B0B"/>
+                </a:solidFill>
+                <a:latin typeface="Arial"/>
+              </a:rPr>
+              <a:t> </a:t>
+            </a:r>
+            <a:r>
+              <a:rPr sz="2460" b="0" i="0">
+                <a:solidFill>
+                  <a:srgbClr val="0B0B0B"/>
+                </a:solidFill>
+                <a:latin typeface="Arial"/>
+              </a:rPr>
+              <a:t>gained</a:t>
+            </a:r>
+            <a:r>
+              <a:rPr sz="2460" b="0" i="0">
+                <a:solidFill>
+                  <a:srgbClr val="0B0B0B"/>
+                </a:solidFill>
+                <a:latin typeface="Arial"/>
+              </a:rPr>
+              <a:t> </a:t>
+            </a:r>
+            <a:r>
+              <a:rPr sz="2460" b="0" i="0">
+                <a:solidFill>
+                  <a:srgbClr val="0B0B0B"/>
+                </a:solidFill>
+                <a:latin typeface="Arial"/>
+              </a:rPr>
+              <a:t>1</a:t>
+            </a:r>
+            <a:r>
+              <a:rPr sz="2460" b="0" i="0">
+                <a:solidFill>
+                  <a:srgbClr val="0B0B0B"/>
+                </a:solidFill>
+                <a:latin typeface="Arial"/>
+              </a:rPr>
+              <a:t> </a:t>
+            </a:r>
+            <a:r>
+              <a:rPr sz="2460" b="0" i="0">
+                <a:solidFill>
+                  <a:srgbClr val="0B0B0B"/>
+                </a:solidFill>
+                <a:latin typeface="Arial"/>
+              </a:rPr>
+              <a:t>and</a:t>
+            </a:r>
+            <a:r>
+              <a:rPr sz="2460" b="0" i="0">
+                <a:solidFill>
+                  <a:srgbClr val="0B0B0B"/>
+                </a:solidFill>
+                <a:latin typeface="Arial"/>
+              </a:rPr>
+              <a:t> </a:t>
+            </a:r>
+            <a:r>
+              <a:rPr sz="2460" b="0" i="0">
+                <a:solidFill>
+                  <a:srgbClr val="0B0B0B"/>
+                </a:solidFill>
+                <a:latin typeface="Arial"/>
+              </a:rPr>
+              <a:t>harmed</a:t>
+            </a:r>
+            <a:r>
+              <a:rPr sz="2460" b="0" i="0">
+                <a:solidFill>
+                  <a:srgbClr val="0B0B0B"/>
+                </a:solidFill>
+                <a:latin typeface="Arial"/>
+              </a:rPr>
+              <a:t> </a:t>
+            </a:r>
+            <a:r>
+              <a:rPr sz="2460" b="0" i="0">
+                <a:solidFill>
+                  <a:srgbClr val="0B0B0B"/>
+                </a:solidFill>
+                <a:latin typeface="Arial"/>
+              </a:rPr>
+              <a:t>4</a:t>
+            </a:r>
+            <a:r>
+              <a:rPr sz="2460" b="0" i="0">
+                <a:solidFill>
+                  <a:srgbClr val="0B0B0B"/>
+                </a:solidFill>
+                <a:latin typeface="Arial"/>
+              </a:rPr>
+              <a:t> </a:t>
+            </a:r>
+            <a:r>
+              <a:rPr sz="2460" b="0" i="0">
+                <a:solidFill>
+                  <a:srgbClr val="0B0B0B"/>
+                </a:solidFill>
+                <a:latin typeface="Arial"/>
+              </a:rPr>
+              <a:t>(2</a:t>
+            </a:r>
+            <a:r>
+              <a:rPr sz="2460" b="0" i="0">
+                <a:solidFill>
+                  <a:srgbClr val="0B0B0B"/>
+                </a:solidFill>
+                <a:latin typeface="Arial"/>
+              </a:rPr>
+              <a:t> </a:t>
+            </a:r>
+            <a:r>
+              <a:rPr sz="2460" b="0" i="0">
+                <a:solidFill>
+                  <a:srgbClr val="0B0B0B"/>
+                </a:solidFill>
+                <a:latin typeface="Arial"/>
+              </a:rPr>
+              <a:t>correct</a:t>
+            </a:r>
+            <a:r>
+              <a:rPr sz="2460" b="0" i="0">
+                <a:solidFill>
+                  <a:srgbClr val="0B0B0B"/>
+                </a:solidFill>
+                <a:latin typeface="Arial"/>
+              </a:rPr>
+              <a:t> </a:t>
+            </a:r>
+            <a:r>
+              <a:rPr sz="2460" b="0" i="0">
+                <a:solidFill>
+                  <a:srgbClr val="0B0B0B"/>
+                </a:solidFill>
+                <a:latin typeface="Arial"/>
+              </a:rPr>
+              <a:t>answers</a:t>
+            </a:r>
+            <a:r>
+              <a:rPr sz="2460" b="0" i="0">
+                <a:solidFill>
+                  <a:srgbClr val="0B0B0B"/>
+                </a:solidFill>
+                <a:latin typeface="Arial"/>
+              </a:rPr>
+              <a:t> </a:t>
+            </a:r>
+            <a:r>
+              <a:rPr sz="2460" b="0" i="0">
+                <a:solidFill>
+                  <a:srgbClr val="0B0B0B"/>
+                </a:solidFill>
+                <a:latin typeface="Arial"/>
+              </a:rPr>
+              <a:t>lost,</a:t>
+            </a:r>
+            <a:r>
+              <a:rPr sz="2460" b="0" i="0">
+                <a:solidFill>
+                  <a:srgbClr val="0B0B0B"/>
+                </a:solidFill>
+                <a:latin typeface="Arial"/>
+              </a:rPr>
+              <a:t> </a:t>
+            </a:r>
+            <a:r>
+              <a:rPr sz="2460" b="0" i="0">
+                <a:solidFill>
+                  <a:srgbClr val="0B0B0B"/>
+                </a:solidFill>
+                <a:latin typeface="Arial"/>
+              </a:rPr>
+              <a:t>2</a:t>
+            </a:r>
+            <a:r>
+              <a:rPr sz="2460" b="0" i="0">
+                <a:solidFill>
+                  <a:srgbClr val="0B0B0B"/>
+                </a:solidFill>
+                <a:latin typeface="Arial"/>
+              </a:rPr>
+              <a:t> </a:t>
+            </a:r>
+            <a:r>
+              <a:rPr sz="2460" b="0" i="0">
+                <a:solidFill>
+                  <a:srgbClr val="0B0B0B"/>
+                </a:solidFill>
+                <a:latin typeface="Arial"/>
+              </a:rPr>
+              <a:t>false</a:t>
             </a:r>
           </a:p>
         </p:txBody>
@@ -9733,8 +9724,8 @@
         </p:nvSpPr>
         <p:spPr>
           <a:xfrm>
-            <a:off x="27315935" y="29952239"/>
-            <a:ext cx="1152707" cy="264436"/>
+            <a:off x="21119517" y="24793547"/>
+            <a:ext cx="7933621" cy="312774"/>
           </a:xfrm>
           <a:prstGeom prst="rect">
             <a:avLst/>
@@ -9748,13 +9739,40 @@
           <a:lstStyle/>
           <a:p>
             <a:r>
-              <a:rPr sz="2080" b="1" i="0">
-                <a:solidFill>
-                  <a:srgbClr val="D03B3B"/>
-                </a:solidFill>
-                <a:latin typeface="Arial"/>
-              </a:rPr>
-              <a:t>untested</a:t>
+              <a:rPr sz="2460" b="0" i="0">
+                <a:solidFill>
+                  <a:srgbClr val="0B0B0B"/>
+                </a:solidFill>
+                <a:latin typeface="Arial"/>
+              </a:rPr>
+              <a:t>acceptances) through the coarse views it let in:</a:t>
+            </a:r>
+            <a:r>
+              <a:rPr sz="2460" b="1" i="0">
+                <a:solidFill>
+                  <a:srgbClr val="0B0B0B"/>
+                </a:solidFill>
+                <a:latin typeface="Arial"/>
+              </a:rPr>
+              <a:t> </a:t>
+            </a:r>
+            <a:r>
+              <a:rPr sz="2460" b="1" i="0">
+                <a:solidFill>
+                  <a:srgbClr val="0B0B0B"/>
+                </a:solidFill>
+                <a:latin typeface="Arial"/>
+              </a:rPr>
+              <a:t>rejected</a:t>
+            </a:r>
+            <a:r>
+              <a:rPr sz="2460" b="0" i="0">
+                <a:solidFill>
+                  <a:srgbClr val="0B0B0B"/>
+                </a:solidFill>
+                <a:latin typeface="Arial"/>
+              </a:rPr>
+              <a:t>.</a:t>
             </a:r>
           </a:p>
         </p:txBody>
@@ -9767,8 +9785,8 @@
         </p:nvSpPr>
         <p:spPr>
           <a:xfrm>
-            <a:off x="20775739" y="31986280"/>
-            <a:ext cx="8620645" cy="312517"/>
+            <a:off x="20946882" y="25276565"/>
+            <a:ext cx="8449695" cy="312515"/>
           </a:xfrm>
           <a:prstGeom prst="rect">
             <a:avLst/>
@@ -9788,151 +9806,133 @@
                 </a:solidFill>
                 <a:latin typeface="Arial"/>
               </a:rPr>
-              <a:t>The</a:t>
-            </a:r>
-            <a:r>
-              <a:rPr sz="2460" b="0" i="0">
-                <a:solidFill>
-                  <a:srgbClr val="0B0B0B"/>
-                </a:solidFill>
-                <a:latin typeface="Arial"/>
-              </a:rPr>
-              <a:t> </a:t>
-            </a:r>
-            <a:r>
-              <a:rPr sz="2460" b="0" i="0">
-                <a:solidFill>
-                  <a:srgbClr val="0B0B0B"/>
-                </a:solidFill>
-                <a:latin typeface="Arial"/>
-              </a:rPr>
-              <a:t>hypothesis:</a:t>
-            </a:r>
-            <a:r>
-              <a:rPr sz="2460" b="0" i="0">
-                <a:solidFill>
-                  <a:srgbClr val="0B0B0B"/>
-                </a:solidFill>
-                <a:latin typeface="Arial"/>
-              </a:rPr>
-              <a:t> </a:t>
-            </a:r>
-            <a:r>
-              <a:rPr sz="2460" b="0" i="0">
-                <a:solidFill>
-                  <a:srgbClr val="0B0B0B"/>
-                </a:solidFill>
-                <a:latin typeface="Arial"/>
-              </a:rPr>
-              <a:t>the</a:t>
-            </a:r>
-            <a:r>
-              <a:rPr sz="2460" b="0" i="0">
-                <a:solidFill>
-                  <a:srgbClr val="0B0B0B"/>
-                </a:solidFill>
-                <a:latin typeface="Arial"/>
-              </a:rPr>
-              <a:t> </a:t>
-            </a:r>
-            <a:r>
-              <a:rPr sz="2460" b="0" i="0">
-                <a:solidFill>
-                  <a:srgbClr val="0B0B0B"/>
-                </a:solidFill>
-                <a:latin typeface="Arial"/>
-              </a:rPr>
-              <a:t>controller</a:t>
-            </a:r>
-            <a:r>
-              <a:rPr sz="2460" b="0" i="0">
-                <a:solidFill>
-                  <a:srgbClr val="0B0B0B"/>
-                </a:solidFill>
-                <a:latin typeface="Arial"/>
-              </a:rPr>
-              <a:t> </a:t>
-            </a:r>
-            <a:r>
-              <a:rPr sz="2460" b="0" i="0">
-                <a:solidFill>
-                  <a:srgbClr val="0B0B0B"/>
-                </a:solidFill>
-                <a:latin typeface="Arial"/>
-              </a:rPr>
-              <a:t>and</a:t>
-            </a:r>
-            <a:r>
-              <a:rPr sz="2460" b="0" i="0">
-                <a:solidFill>
-                  <a:srgbClr val="0B0B0B"/>
-                </a:solidFill>
-                <a:latin typeface="Arial"/>
-              </a:rPr>
-              <a:t> </a:t>
-            </a:r>
-            <a:r>
-              <a:rPr sz="2460" b="0" i="0">
-                <a:solidFill>
-                  <a:srgbClr val="0B0B0B"/>
-                </a:solidFill>
-                <a:latin typeface="Arial"/>
-              </a:rPr>
-              <a:t>its</a:t>
-            </a:r>
-            <a:r>
-              <a:rPr sz="2460" b="0" i="0">
-                <a:solidFill>
-                  <a:srgbClr val="0B0B0B"/>
-                </a:solidFill>
-                <a:latin typeface="Arial"/>
-              </a:rPr>
-              <a:t> </a:t>
-            </a:r>
-            <a:r>
-              <a:rPr sz="2460" b="0" i="0">
-                <a:solidFill>
-                  <a:srgbClr val="0B0B0B"/>
-                </a:solidFill>
-                <a:latin typeface="Arial"/>
-              </a:rPr>
-              <a:t>evidence</a:t>
-            </a:r>
-            <a:r>
-              <a:rPr sz="2460" b="0" i="0">
-                <a:solidFill>
-                  <a:srgbClr val="0B0B0B"/>
-                </a:solidFill>
-                <a:latin typeface="Arial"/>
-              </a:rPr>
-              <a:t> </a:t>
-            </a:r>
-            <a:r>
-              <a:rPr sz="2460" b="0" i="0">
-                <a:solidFill>
-                  <a:srgbClr val="0B0B0B"/>
-                </a:solidFill>
-                <a:latin typeface="Arial"/>
-              </a:rPr>
-              <a:t>and</a:t>
-            </a:r>
-            <a:r>
-              <a:rPr sz="2460" b="0" i="0">
-                <a:solidFill>
-                  <a:srgbClr val="0B0B0B"/>
-                </a:solidFill>
-                <a:latin typeface="Arial"/>
-              </a:rPr>
-              <a:t> </a:t>
-            </a:r>
-            <a:r>
-              <a:rPr sz="2460" b="0" i="0">
-                <a:solidFill>
-                  <a:srgbClr val="0B0B0B"/>
-                </a:solidFill>
-                <a:latin typeface="Arial"/>
-              </a:rPr>
-              <a:t>certificate</a:t>
+              <a:t>• Observed,</a:t>
+            </a:r>
+            <a:r>
+              <a:rPr sz="2460" b="0" i="0">
+                <a:solidFill>
+                  <a:srgbClr val="0B0B0B"/>
+                </a:solidFill>
+                <a:latin typeface="Arial"/>
+              </a:rPr>
+              <a:t> </a:t>
+            </a:r>
+            <a:r>
+              <a:rPr sz="2460" b="0" i="0">
+                <a:solidFill>
+                  <a:srgbClr val="0B0B0B"/>
+                </a:solidFill>
+                <a:latin typeface="Arial"/>
+              </a:rPr>
+              <a:t>not</a:t>
+            </a:r>
+            <a:r>
+              <a:rPr sz="2460" b="0" i="0">
+                <a:solidFill>
+                  <a:srgbClr val="0B0B0B"/>
+                </a:solidFill>
+                <a:latin typeface="Arial"/>
+              </a:rPr>
+              <a:t> </a:t>
+            </a:r>
+            <a:r>
+              <a:rPr sz="2460" b="0" i="0">
+                <a:solidFill>
+                  <a:srgbClr val="0B0B0B"/>
+                </a:solidFill>
+                <a:latin typeface="Arial"/>
+              </a:rPr>
+              <a:t>a</a:t>
+            </a:r>
+            <a:r>
+              <a:rPr sz="2460" b="0" i="0">
+                <a:solidFill>
+                  <a:srgbClr val="0B0B0B"/>
+                </a:solidFill>
+                <a:latin typeface="Arial"/>
+              </a:rPr>
+              <a:t> </a:t>
+            </a:r>
+            <a:r>
+              <a:rPr sz="2460" b="0" i="0">
+                <a:solidFill>
+                  <a:srgbClr val="0B0B0B"/>
+                </a:solidFill>
+                <a:latin typeface="Arial"/>
+              </a:rPr>
+              <a:t>theorem:</a:t>
+            </a:r>
+            <a:r>
+              <a:rPr sz="2460" b="0" i="0">
+                <a:solidFill>
+                  <a:srgbClr val="0B0B0B"/>
+                </a:solidFill>
+                <a:latin typeface="Arial"/>
+              </a:rPr>
+              <a:t> </a:t>
+            </a:r>
+            <a:r>
+              <a:rPr sz="2460" b="0" i="0">
+                <a:solidFill>
+                  <a:srgbClr val="0B0B0B"/>
+                </a:solidFill>
+                <a:latin typeface="Arial"/>
+              </a:rPr>
+              <a:t>removing</a:t>
+            </a:r>
+            <a:r>
+              <a:rPr sz="2460" b="0" i="0">
+                <a:solidFill>
+                  <a:srgbClr val="0B0B0B"/>
+                </a:solidFill>
+                <a:latin typeface="Arial"/>
+              </a:rPr>
+              <a:t> </a:t>
+            </a:r>
+            <a:r>
+              <a:rPr sz="2460" b="0" i="0">
+                <a:solidFill>
+                  <a:srgbClr val="0B0B0B"/>
+                </a:solidFill>
+                <a:latin typeface="Arial"/>
+              </a:rPr>
+              <a:t>a</a:t>
+            </a:r>
+            <a:r>
+              <a:rPr sz="2460" b="0" i="0">
+                <a:solidFill>
+                  <a:srgbClr val="0B0B0B"/>
+                </a:solidFill>
+                <a:latin typeface="Arial"/>
+              </a:rPr>
+              <a:t> </a:t>
+            </a:r>
+            <a:r>
+              <a:rPr sz="2460" b="0" i="0">
+                <a:solidFill>
+                  <a:srgbClr val="0B0B0B"/>
+                </a:solidFill>
+                <a:latin typeface="Arial"/>
+              </a:rPr>
+              <a:t>demonstration</a:t>
+            </a:r>
+            <a:r>
+              <a:rPr sz="2460" b="0" i="0">
+                <a:solidFill>
+                  <a:srgbClr val="0B0B0B"/>
+                </a:solidFill>
+                <a:latin typeface="Arial"/>
+              </a:rPr>
+              <a:t> </a:t>
+            </a:r>
+            <a:r>
+              <a:rPr sz="2460" b="0" i="0">
+                <a:solidFill>
+                  <a:srgbClr val="0B0B0B"/>
+                </a:solidFill>
+                <a:latin typeface="Arial"/>
+              </a:rPr>
+              <a:t>made</a:t>
             </a:r>
           </a:p>
         </p:txBody>
@@ -9945,8 +9945,8 @@
         </p:nvSpPr>
         <p:spPr>
           <a:xfrm>
-            <a:off x="20775739" y="32391157"/>
-            <a:ext cx="8620642" cy="312517"/>
+            <a:off x="21119513" y="25681441"/>
+            <a:ext cx="8276871" cy="312515"/>
           </a:xfrm>
           <a:prstGeom prst="rect">
             <a:avLst/>
@@ -9966,169 +9966,169 @@
                 </a:solidFill>
                 <a:latin typeface="Arial"/>
               </a:rPr>
-              <a:t>interfaces</a:t>
-            </a:r>
-            <a:r>
-              <a:rPr sz="2460" b="0" i="0">
-                <a:solidFill>
-                  <a:srgbClr val="0B0B0B"/>
-                </a:solidFill>
-                <a:latin typeface="Arial"/>
-              </a:rPr>
-              <a:t> </a:t>
-            </a:r>
-            <a:r>
-              <a:rPr sz="2460" b="0" i="0">
-                <a:solidFill>
-                  <a:srgbClr val="0B0B0B"/>
-                </a:solidFill>
-                <a:latin typeface="Arial"/>
-              </a:rPr>
-              <a:t>are</a:t>
-            </a:r>
-            <a:r>
-              <a:rPr sz="2460" b="0" i="0">
-                <a:solidFill>
-                  <a:srgbClr val="0B0B0B"/>
-                </a:solidFill>
-                <a:latin typeface="Arial"/>
-              </a:rPr>
-              <a:t> </a:t>
-            </a:r>
-            <a:r>
-              <a:rPr sz="2460" b="0" i="0">
-                <a:solidFill>
-                  <a:srgbClr val="0B0B0B"/>
-                </a:solidFill>
-                <a:latin typeface="Arial"/>
-              </a:rPr>
-              <a:t>portable;</a:t>
-            </a:r>
-            <a:r>
-              <a:rPr sz="2460" b="0" i="0">
-                <a:solidFill>
-                  <a:srgbClr val="0B0B0B"/>
-                </a:solidFill>
-                <a:latin typeface="Arial"/>
-              </a:rPr>
-              <a:t> </a:t>
-            </a:r>
-            <a:r>
-              <a:rPr sz="2460" b="0" i="0">
-                <a:solidFill>
-                  <a:srgbClr val="0B0B0B"/>
-                </a:solidFill>
-                <a:latin typeface="Arial"/>
-              </a:rPr>
-              <a:t>ARC</a:t>
-            </a:r>
-            <a:r>
-              <a:rPr sz="2460" b="0" i="0">
-                <a:solidFill>
-                  <a:srgbClr val="0B0B0B"/>
-                </a:solidFill>
-                <a:latin typeface="Arial"/>
-              </a:rPr>
-              <a:t> </a:t>
-            </a:r>
-            <a:r>
-              <a:rPr sz="2460" b="0" i="0">
-                <a:solidFill>
-                  <a:srgbClr val="0B0B0B"/>
-                </a:solidFill>
-                <a:latin typeface="Arial"/>
-              </a:rPr>
-              <a:t>operators</a:t>
-            </a:r>
-            <a:r>
-              <a:rPr sz="2460" b="0" i="0">
-                <a:solidFill>
-                  <a:srgbClr val="0B0B0B"/>
-                </a:solidFill>
-                <a:latin typeface="Arial"/>
-              </a:rPr>
-              <a:t> </a:t>
-            </a:r>
-            <a:r>
-              <a:rPr sz="2460" b="0" i="0">
-                <a:solidFill>
-                  <a:srgbClr val="0B0B0B"/>
-                </a:solidFill>
-                <a:latin typeface="Arial"/>
-              </a:rPr>
-              <a:t>are</a:t>
-            </a:r>
-            <a:r>
-              <a:rPr sz="2460" b="0" i="0">
-                <a:solidFill>
-                  <a:srgbClr val="0B0B0B"/>
-                </a:solidFill>
-                <a:latin typeface="Arial"/>
-              </a:rPr>
-              <a:t> </a:t>
-            </a:r>
-            <a:r>
-              <a:rPr sz="2460" b="0" i="0">
-                <a:solidFill>
-                  <a:srgbClr val="0B0B0B"/>
-                </a:solidFill>
-                <a:latin typeface="Arial"/>
-              </a:rPr>
-              <a:t>not.</a:t>
-            </a:r>
-            <a:r>
-              <a:rPr sz="2460" b="0" i="0">
-                <a:solidFill>
-                  <a:srgbClr val="0B0B0B"/>
-                </a:solidFill>
-                <a:latin typeface="Arial"/>
-              </a:rPr>
-              <a:t> </a:t>
-            </a:r>
-            <a:r>
-              <a:rPr sz="2460" b="0" i="0">
-                <a:solidFill>
-                  <a:srgbClr val="0B0B0B"/>
-                </a:solidFill>
-                <a:latin typeface="Arial"/>
-              </a:rPr>
-              <a:t>A</a:t>
-            </a:r>
-            <a:r>
-              <a:rPr sz="2460" b="0" i="0">
-                <a:solidFill>
-                  <a:srgbClr val="0B0B0B"/>
-                </a:solidFill>
-                <a:latin typeface="Arial"/>
-              </a:rPr>
-              <a:t> </a:t>
-            </a:r>
-            <a:r>
-              <a:rPr sz="2460" b="0" i="0">
-                <a:solidFill>
-                  <a:srgbClr val="0B0B0B"/>
-                </a:solidFill>
-                <a:latin typeface="Arial"/>
-              </a:rPr>
-              <a:t>test</a:t>
-            </a:r>
-            <a:r>
-              <a:rPr sz="2460" b="0" i="0">
-                <a:solidFill>
-                  <a:srgbClr val="0B0B0B"/>
-                </a:solidFill>
-                <a:latin typeface="Arial"/>
-              </a:rPr>
-              <a:t> </a:t>
-            </a:r>
-            <a:r>
-              <a:rPr sz="2460" b="0" i="0">
-                <a:solidFill>
-                  <a:srgbClr val="0B0B0B"/>
-                </a:solidFill>
-                <a:latin typeface="Arial"/>
-              </a:rPr>
-              <a:t>needs</a:t>
+              <a:t>an</a:t>
+            </a:r>
+            <a:r>
+              <a:rPr sz="2460" b="0" i="0">
+                <a:solidFill>
+                  <a:srgbClr val="0B0B0B"/>
+                </a:solidFill>
+                <a:latin typeface="Arial"/>
+              </a:rPr>
+              <a:t> </a:t>
+            </a:r>
+            <a:r>
+              <a:rPr sz="2460" b="0" i="0">
+                <a:solidFill>
+                  <a:srgbClr val="0B0B0B"/>
+                </a:solidFill>
+                <a:latin typeface="Arial"/>
+              </a:rPr>
+              <a:t>eligible</a:t>
+            </a:r>
+            <a:r>
+              <a:rPr sz="2460" b="0" i="0">
+                <a:solidFill>
+                  <a:srgbClr val="0B0B0B"/>
+                </a:solidFill>
+                <a:latin typeface="Arial"/>
+              </a:rPr>
+              <a:t> </a:t>
+            </a:r>
+            <a:r>
+              <a:rPr sz="2460" b="0" i="0">
+                <a:solidFill>
+                  <a:srgbClr val="0B0B0B"/>
+                </a:solidFill>
+                <a:latin typeface="Arial"/>
+              </a:rPr>
+              <a:t>view</a:t>
+            </a:r>
+            <a:r>
+              <a:rPr sz="2460" b="0" i="0">
+                <a:solidFill>
+                  <a:srgbClr val="0B0B0B"/>
+                </a:solidFill>
+                <a:latin typeface="Arial"/>
+              </a:rPr>
+              <a:t> </a:t>
+            </a:r>
+            <a:r>
+              <a:rPr sz="2460" b="0" i="0">
+                <a:solidFill>
+                  <a:srgbClr val="0B0B0B"/>
+                </a:solidFill>
+                <a:latin typeface="Arial"/>
+              </a:rPr>
+              <a:t>ineligible</a:t>
+            </a:r>
+            <a:r>
+              <a:rPr sz="2460" b="0" i="0">
+                <a:solidFill>
+                  <a:srgbClr val="0B0B0B"/>
+                </a:solidFill>
+                <a:latin typeface="Arial"/>
+              </a:rPr>
+              <a:t> </a:t>
+            </a:r>
+            <a:r>
+              <a:rPr sz="2460" b="0" i="0">
+                <a:solidFill>
+                  <a:srgbClr val="0B0B0B"/>
+                </a:solidFill>
+                <a:latin typeface="Arial"/>
+              </a:rPr>
+              <a:t>in</a:t>
+            </a:r>
+            <a:r>
+              <a:rPr sz="2460" b="0" i="0">
+                <a:solidFill>
+                  <a:srgbClr val="0B0B0B"/>
+                </a:solidFill>
+                <a:latin typeface="Arial"/>
+              </a:rPr>
+              <a:t> </a:t>
+            </a:r>
+            <a:r>
+              <a:rPr sz="2460" b="0" i="0">
+                <a:solidFill>
+                  <a:srgbClr val="0B0B0B"/>
+                </a:solidFill>
+                <a:latin typeface="Arial"/>
+              </a:rPr>
+              <a:t>7</a:t>
+            </a:r>
+            <a:r>
+              <a:rPr sz="2460" b="0" i="0">
+                <a:solidFill>
+                  <a:srgbClr val="0B0B0B"/>
+                </a:solidFill>
+                <a:latin typeface="Arial"/>
+              </a:rPr>
+              <a:t> </a:t>
+            </a:r>
+            <a:r>
+              <a:rPr sz="2460" b="0" i="0">
+                <a:solidFill>
+                  <a:srgbClr val="0B0B0B"/>
+                </a:solidFill>
+                <a:latin typeface="Arial"/>
+              </a:rPr>
+              <a:t>of</a:t>
+            </a:r>
+            <a:r>
+              <a:rPr sz="2460" b="0" i="0">
+                <a:solidFill>
+                  <a:srgbClr val="0B0B0B"/>
+                </a:solidFill>
+                <a:latin typeface="Arial"/>
+              </a:rPr>
+              <a:t> </a:t>
+            </a:r>
+            <a:r>
+              <a:rPr sz="2460" b="0" i="0">
+                <a:solidFill>
+                  <a:srgbClr val="0B0B0B"/>
+                </a:solidFill>
+                <a:latin typeface="Arial"/>
+              </a:rPr>
+              <a:t>724</a:t>
+            </a:r>
+            <a:r>
+              <a:rPr sz="2460" b="0" i="0">
+                <a:solidFill>
+                  <a:srgbClr val="0B0B0B"/>
+                </a:solidFill>
+                <a:latin typeface="Arial"/>
+              </a:rPr>
+              <a:t> </a:t>
+            </a:r>
+            <a:r>
+              <a:rPr sz="2460" b="0" i="0">
+                <a:solidFill>
+                  <a:srgbClr val="0B0B0B"/>
+                </a:solidFill>
+                <a:latin typeface="Arial"/>
+              </a:rPr>
+              <a:t>development</a:t>
+            </a:r>
+            <a:r>
+              <a:rPr sz="2460" b="0" i="0">
+                <a:solidFill>
+                  <a:srgbClr val="0B0B0B"/>
+                </a:solidFill>
+                <a:latin typeface="Arial"/>
+              </a:rPr>
+              <a:t> </a:t>
+            </a:r>
+            <a:r>
+              <a:rPr sz="2460" b="0" i="0">
+                <a:solidFill>
+                  <a:srgbClr val="0B0B0B"/>
+                </a:solidFill>
+                <a:latin typeface="Arial"/>
+              </a:rPr>
+              <a:t>compar-</a:t>
             </a:r>
           </a:p>
         </p:txBody>
@@ -10141,8 +10141,8 @@
         </p:nvSpPr>
         <p:spPr>
           <a:xfrm>
-            <a:off x="20775739" y="32796035"/>
-            <a:ext cx="8620648" cy="312517"/>
+            <a:off x="21119513" y="26086317"/>
+            <a:ext cx="3456928" cy="312517"/>
           </a:xfrm>
           <a:prstGeom prst="rect">
             <a:avLst/>
@@ -10162,7 +10162,7 @@
                 </a:solidFill>
                 <a:latin typeface="Arial"/>
               </a:rPr>
-              <a:t>typed adapters, training-only diagnosis, held-out perturbations</a:t>
+              <a:t>isons (pooled coverage).</a:t>
             </a:r>
           </a:p>
         </p:txBody>
@@ -10175,8 +10175,8 @@
         </p:nvSpPr>
         <p:spPr>
           <a:xfrm>
-            <a:off x="20775739" y="33200922"/>
-            <a:ext cx="8620642" cy="312517"/>
+            <a:off x="20775739" y="27759062"/>
+            <a:ext cx="8385869" cy="480795"/>
           </a:xfrm>
           <a:prstGeom prst="rect">
             <a:avLst/>
@@ -10190,31 +10190,31 @@
           <a:lstStyle/>
           <a:p>
             <a:r>
-              <a:rPr sz="2460" b="0" i="0">
-                <a:solidFill>
-                  <a:srgbClr val="0B0B0B"/>
-                </a:solidFill>
-                <a:latin typeface="Arial"/>
-              </a:rPr>
-              <a:t>and cell states, and confounder controls.</a:t>
-            </a:r>
-            <a:r>
-              <a:rPr sz="2460" b="0" i="0">
-                <a:solidFill>
-                  <a:srgbClr val="0B0B0B"/>
-                </a:solidFill>
-                <a:latin typeface="Arial"/>
-              </a:rPr>
-              <a:t> </a:t>
-            </a:r>
-            <a:r>
-              <a:rPr sz="2460" b="0" i="0">
-                <a:solidFill>
-                  <a:srgbClr val="0B0B0B"/>
-                </a:solidFill>
-                <a:latin typeface="Arial"/>
-              </a:rPr>
-              <a:t>No biological data or</a:t>
+              <a:rPr sz="3790" b="1" i="0">
+                <a:solidFill>
+                  <a:srgbClr val="2A78D6"/>
+                </a:solidFill>
+                <a:latin typeface="Arial"/>
+              </a:rPr>
+              <a:t>A portable controller?</a:t>
+            </a:r>
+            <a:r>
+              <a:rPr sz="3790" b="1" i="0">
+                <a:solidFill>
+                  <a:srgbClr val="D03B3B"/>
+                </a:solidFill>
+                <a:latin typeface="Arial"/>
+              </a:rPr>
+              <a:t> </a:t>
+            </a:r>
+            <a:r>
+              <a:rPr sz="3790" b="1" i="0">
+                <a:solidFill>
+                  <a:srgbClr val="D03B3B"/>
+                </a:solidFill>
+                <a:latin typeface="Arial"/>
+              </a:rPr>
+              <a:t>BIOLOGICAL</a:t>
             </a:r>
           </a:p>
         </p:txBody>
@@ -10227,8 +10227,8 @@
         </p:nvSpPr>
         <p:spPr>
           <a:xfrm>
-            <a:off x="20775739" y="33605796"/>
-            <a:ext cx="2485623" cy="312517"/>
+            <a:off x="20775739" y="28442298"/>
+            <a:ext cx="6151134" cy="480795"/>
           </a:xfrm>
           <a:prstGeom prst="rect">
             <a:avLst/>
@@ -10242,13 +10242,13 @@
           <a:lstStyle/>
           <a:p>
             <a:r>
-              <a:rPr sz="2460" b="0" i="0">
-                <a:solidFill>
-                  <a:srgbClr val="0B0B0B"/>
-                </a:solidFill>
-                <a:latin typeface="Arial"/>
-              </a:rPr>
-              <a:t>result exists here.</a:t>
+              <a:rPr sz="3790" b="1" i="0">
+                <a:solidFill>
+                  <a:srgbClr val="D03B3B"/>
+                </a:solidFill>
+                <a:latin typeface="Arial"/>
+              </a:rPr>
+              <a:t>APPLICATION: UNTESTED</a:t>
             </a:r>
           </a:p>
         </p:txBody>
@@ -10261,8 +10261,8 @@
         </p:nvSpPr>
         <p:spPr>
           <a:xfrm>
-            <a:off x="20775739" y="35030959"/>
-            <a:ext cx="5395605" cy="544062"/>
+            <a:off x="21438945" y="29900804"/>
+            <a:ext cx="1681853" cy="264436"/>
           </a:xfrm>
           <a:prstGeom prst="rect">
             <a:avLst/>
@@ -10276,49 +10276,13 @@
           <a:lstStyle/>
           <a:p>
             <a:r>
-              <a:rPr sz="3790" b="1" i="0">
+              <a:rPr sz="2080" b="1" i="0">
                 <a:solidFill>
                   <a:srgbClr val="2A78D6"/>
                 </a:solidFill>
                 <a:latin typeface="Arial"/>
               </a:rPr>
-              <a:t>Not claimed</a:t>
-            </a:r>
-            <a:r>
-              <a:rPr sz="4280" b="0" i="1">
-                <a:solidFill>
-                  <a:srgbClr val="2A78D6"/>
-                </a:solidFill>
-                <a:latin typeface="Arial"/>
-              </a:rPr>
-              <a:t> </a:t>
-            </a:r>
-            <a:r>
-              <a:rPr sz="4280" b="0" i="1">
-                <a:solidFill>
-                  <a:srgbClr val="2A78D6"/>
-                </a:solidFill>
-                <a:latin typeface="Arial"/>
-              </a:rPr>
-              <a:t>·</a:t>
-            </a:r>
-            <a:r>
-              <a:rPr sz="3790" b="1" i="0">
-                <a:solidFill>
-                  <a:srgbClr val="2A78D6"/>
-                </a:solidFill>
-                <a:latin typeface="Arial"/>
-              </a:rPr>
-              <a:t> </a:t>
-            </a:r>
-            <a:r>
-              <a:rPr sz="3790" b="1" i="0">
-                <a:solidFill>
-                  <a:srgbClr val="2A78D6"/>
-                </a:solidFill>
-                <a:latin typeface="Arial"/>
-              </a:rPr>
-              <a:t>evidence</a:t>
+              <a:t>implemented</a:t>
             </a:r>
           </a:p>
         </p:txBody>
@@ -10331,8 +10295,8 @@
         </p:nvSpPr>
         <p:spPr>
           <a:xfrm>
-            <a:off x="20775739" y="36178526"/>
-            <a:ext cx="8512819" cy="312517"/>
+            <a:off x="27315935" y="29952239"/>
+            <a:ext cx="1152707" cy="264436"/>
           </a:xfrm>
           <a:prstGeom prst="rect">
             <a:avLst/>
@@ -10346,13 +10310,13 @@
           <a:lstStyle/>
           <a:p>
             <a:r>
-              <a:rPr sz="2460" b="0" i="0">
-                <a:solidFill>
-                  <a:srgbClr val="0B0B0B"/>
-                </a:solidFill>
-                <a:latin typeface="Arial"/>
-              </a:rPr>
-              <a:t>No ARC-AGI-2 solve or score gain; no semantic invention; no</a:t>
+              <a:rPr sz="2080" b="1" i="0">
+                <a:solidFill>
+                  <a:srgbClr val="D03B3B"/>
+                </a:solidFill>
+                <a:latin typeface="Arial"/>
+              </a:rPr>
+              <a:t>untested</a:t>
             </a:r>
           </a:p>
         </p:txBody>
@@ -10365,8 +10329,8 @@
         </p:nvSpPr>
         <p:spPr>
           <a:xfrm>
-            <a:off x="20775739" y="36583401"/>
-            <a:ext cx="8002801" cy="312517"/>
+            <a:off x="20775739" y="31986280"/>
+            <a:ext cx="8620645" cy="312517"/>
           </a:xfrm>
           <a:prstGeom prst="rect">
             <a:avLst/>
@@ -10386,7 +10350,151 @@
                 </a:solidFill>
                 <a:latin typeface="Arial"/>
               </a:rPr>
-              <a:t>automatic failure-type controller; no domain generality; no</a:t>
+              <a:t>The</a:t>
+            </a:r>
+            <a:r>
+              <a:rPr sz="2460" b="0" i="0">
+                <a:solidFill>
+                  <a:srgbClr val="0B0B0B"/>
+                </a:solidFill>
+                <a:latin typeface="Arial"/>
+              </a:rPr>
+              <a:t> </a:t>
+            </a:r>
+            <a:r>
+              <a:rPr sz="2460" b="0" i="0">
+                <a:solidFill>
+                  <a:srgbClr val="0B0B0B"/>
+                </a:solidFill>
+                <a:latin typeface="Arial"/>
+              </a:rPr>
+              <a:t>hypothesis:</a:t>
+            </a:r>
+            <a:r>
+              <a:rPr sz="2460" b="0" i="0">
+                <a:solidFill>
+                  <a:srgbClr val="0B0B0B"/>
+                </a:solidFill>
+                <a:latin typeface="Arial"/>
+              </a:rPr>
+              <a:t> </a:t>
+            </a:r>
+            <a:r>
+              <a:rPr sz="2460" b="0" i="0">
+                <a:solidFill>
+                  <a:srgbClr val="0B0B0B"/>
+                </a:solidFill>
+                <a:latin typeface="Arial"/>
+              </a:rPr>
+              <a:t>the</a:t>
+            </a:r>
+            <a:r>
+              <a:rPr sz="2460" b="0" i="0">
+                <a:solidFill>
+                  <a:srgbClr val="0B0B0B"/>
+                </a:solidFill>
+                <a:latin typeface="Arial"/>
+              </a:rPr>
+              <a:t> </a:t>
+            </a:r>
+            <a:r>
+              <a:rPr sz="2460" b="0" i="0">
+                <a:solidFill>
+                  <a:srgbClr val="0B0B0B"/>
+                </a:solidFill>
+                <a:latin typeface="Arial"/>
+              </a:rPr>
+              <a:t>controller</a:t>
+            </a:r>
+            <a:r>
+              <a:rPr sz="2460" b="0" i="0">
+                <a:solidFill>
+                  <a:srgbClr val="0B0B0B"/>
+                </a:solidFill>
+                <a:latin typeface="Arial"/>
+              </a:rPr>
+              <a:t> </a:t>
+            </a:r>
+            <a:r>
+              <a:rPr sz="2460" b="0" i="0">
+                <a:solidFill>
+                  <a:srgbClr val="0B0B0B"/>
+                </a:solidFill>
+                <a:latin typeface="Arial"/>
+              </a:rPr>
+              <a:t>and</a:t>
+            </a:r>
+            <a:r>
+              <a:rPr sz="2460" b="0" i="0">
+                <a:solidFill>
+                  <a:srgbClr val="0B0B0B"/>
+                </a:solidFill>
+                <a:latin typeface="Arial"/>
+              </a:rPr>
+              <a:t> </a:t>
+            </a:r>
+            <a:r>
+              <a:rPr sz="2460" b="0" i="0">
+                <a:solidFill>
+                  <a:srgbClr val="0B0B0B"/>
+                </a:solidFill>
+                <a:latin typeface="Arial"/>
+              </a:rPr>
+              <a:t>its</a:t>
+            </a:r>
+            <a:r>
+              <a:rPr sz="2460" b="0" i="0">
+                <a:solidFill>
+                  <a:srgbClr val="0B0B0B"/>
+                </a:solidFill>
+                <a:latin typeface="Arial"/>
+              </a:rPr>
+              <a:t> </a:t>
+            </a:r>
+            <a:r>
+              <a:rPr sz="2460" b="0" i="0">
+                <a:solidFill>
+                  <a:srgbClr val="0B0B0B"/>
+                </a:solidFill>
+                <a:latin typeface="Arial"/>
+              </a:rPr>
+              <a:t>evidence</a:t>
+            </a:r>
+            <a:r>
+              <a:rPr sz="2460" b="0" i="0">
+                <a:solidFill>
+                  <a:srgbClr val="0B0B0B"/>
+                </a:solidFill>
+                <a:latin typeface="Arial"/>
+              </a:rPr>
+              <a:t> </a:t>
+            </a:r>
+            <a:r>
+              <a:rPr sz="2460" b="0" i="0">
+                <a:solidFill>
+                  <a:srgbClr val="0B0B0B"/>
+                </a:solidFill>
+                <a:latin typeface="Arial"/>
+              </a:rPr>
+              <a:t>and</a:t>
+            </a:r>
+            <a:r>
+              <a:rPr sz="2460" b="0" i="0">
+                <a:solidFill>
+                  <a:srgbClr val="0B0B0B"/>
+                </a:solidFill>
+                <a:latin typeface="Arial"/>
+              </a:rPr>
+              <a:t> </a:t>
+            </a:r>
+            <a:r>
+              <a:rPr sz="2460" b="0" i="0">
+                <a:solidFill>
+                  <a:srgbClr val="0B0B0B"/>
+                </a:solidFill>
+                <a:latin typeface="Arial"/>
+              </a:rPr>
+              <a:t>certificate</a:t>
             </a:r>
           </a:p>
         </p:txBody>
@@ -10399,8 +10507,8 @@
         </p:nvSpPr>
         <p:spPr>
           <a:xfrm>
-            <a:off x="20775739" y="36988291"/>
-            <a:ext cx="8509384" cy="312517"/>
+            <a:off x="20775739" y="32391157"/>
+            <a:ext cx="8620642" cy="312517"/>
           </a:xfrm>
           <a:prstGeom prst="rect">
             <a:avLst/>
@@ -10420,25 +10528,169 @@
                 </a:solidFill>
                 <a:latin typeface="Arial"/>
               </a:rPr>
-              <a:t>results from the separate VDCG project.</a:t>
-            </a:r>
-            <a:r>
-              <a:rPr sz="2460" b="0" i="0">
-                <a:solidFill>
-                  <a:srgbClr val="0B0B0B"/>
-                </a:solidFill>
-                <a:latin typeface="Arial"/>
-              </a:rPr>
-              <a:t> </a:t>
-            </a:r>
-            <a:r>
-              <a:rPr sz="2460" b="0" i="0">
-                <a:solidFill>
-                  <a:srgbClr val="0B0B0B"/>
-                </a:solidFill>
-                <a:latin typeface="Arial"/>
-              </a:rPr>
-              <a:t>The 120-task pilot is</a:t>
+              <a:t>interfaces</a:t>
+            </a:r>
+            <a:r>
+              <a:rPr sz="2460" b="0" i="0">
+                <a:solidFill>
+                  <a:srgbClr val="0B0B0B"/>
+                </a:solidFill>
+                <a:latin typeface="Arial"/>
+              </a:rPr>
+              <a:t> </a:t>
+            </a:r>
+            <a:r>
+              <a:rPr sz="2460" b="0" i="0">
+                <a:solidFill>
+                  <a:srgbClr val="0B0B0B"/>
+                </a:solidFill>
+                <a:latin typeface="Arial"/>
+              </a:rPr>
+              <a:t>are</a:t>
+            </a:r>
+            <a:r>
+              <a:rPr sz="2460" b="0" i="0">
+                <a:solidFill>
+                  <a:srgbClr val="0B0B0B"/>
+                </a:solidFill>
+                <a:latin typeface="Arial"/>
+              </a:rPr>
+              <a:t> </a:t>
+            </a:r>
+            <a:r>
+              <a:rPr sz="2460" b="0" i="0">
+                <a:solidFill>
+                  <a:srgbClr val="0B0B0B"/>
+                </a:solidFill>
+                <a:latin typeface="Arial"/>
+              </a:rPr>
+              <a:t>portable;</a:t>
+            </a:r>
+            <a:r>
+              <a:rPr sz="2460" b="0" i="0">
+                <a:solidFill>
+                  <a:srgbClr val="0B0B0B"/>
+                </a:solidFill>
+                <a:latin typeface="Arial"/>
+              </a:rPr>
+              <a:t> </a:t>
+            </a:r>
+            <a:r>
+              <a:rPr sz="2460" b="0" i="0">
+                <a:solidFill>
+                  <a:srgbClr val="0B0B0B"/>
+                </a:solidFill>
+                <a:latin typeface="Arial"/>
+              </a:rPr>
+              <a:t>ARC</a:t>
+            </a:r>
+            <a:r>
+              <a:rPr sz="2460" b="0" i="0">
+                <a:solidFill>
+                  <a:srgbClr val="0B0B0B"/>
+                </a:solidFill>
+                <a:latin typeface="Arial"/>
+              </a:rPr>
+              <a:t> </a:t>
+            </a:r>
+            <a:r>
+              <a:rPr sz="2460" b="0" i="0">
+                <a:solidFill>
+                  <a:srgbClr val="0B0B0B"/>
+                </a:solidFill>
+                <a:latin typeface="Arial"/>
+              </a:rPr>
+              <a:t>operators</a:t>
+            </a:r>
+            <a:r>
+              <a:rPr sz="2460" b="0" i="0">
+                <a:solidFill>
+                  <a:srgbClr val="0B0B0B"/>
+                </a:solidFill>
+                <a:latin typeface="Arial"/>
+              </a:rPr>
+              <a:t> </a:t>
+            </a:r>
+            <a:r>
+              <a:rPr sz="2460" b="0" i="0">
+                <a:solidFill>
+                  <a:srgbClr val="0B0B0B"/>
+                </a:solidFill>
+                <a:latin typeface="Arial"/>
+              </a:rPr>
+              <a:t>are</a:t>
+            </a:r>
+            <a:r>
+              <a:rPr sz="2460" b="0" i="0">
+                <a:solidFill>
+                  <a:srgbClr val="0B0B0B"/>
+                </a:solidFill>
+                <a:latin typeface="Arial"/>
+              </a:rPr>
+              <a:t> </a:t>
+            </a:r>
+            <a:r>
+              <a:rPr sz="2460" b="0" i="0">
+                <a:solidFill>
+                  <a:srgbClr val="0B0B0B"/>
+                </a:solidFill>
+                <a:latin typeface="Arial"/>
+              </a:rPr>
+              <a:t>not.</a:t>
+            </a:r>
+            <a:r>
+              <a:rPr sz="2460" b="0" i="0">
+                <a:solidFill>
+                  <a:srgbClr val="0B0B0B"/>
+                </a:solidFill>
+                <a:latin typeface="Arial"/>
+              </a:rPr>
+              <a:t> </a:t>
+            </a:r>
+            <a:r>
+              <a:rPr sz="2460" b="0" i="0">
+                <a:solidFill>
+                  <a:srgbClr val="0B0B0B"/>
+                </a:solidFill>
+                <a:latin typeface="Arial"/>
+              </a:rPr>
+              <a:t>A</a:t>
+            </a:r>
+            <a:r>
+              <a:rPr sz="2460" b="0" i="0">
+                <a:solidFill>
+                  <a:srgbClr val="0B0B0B"/>
+                </a:solidFill>
+                <a:latin typeface="Arial"/>
+              </a:rPr>
+              <a:t> </a:t>
+            </a:r>
+            <a:r>
+              <a:rPr sz="2460" b="0" i="0">
+                <a:solidFill>
+                  <a:srgbClr val="0B0B0B"/>
+                </a:solidFill>
+                <a:latin typeface="Arial"/>
+              </a:rPr>
+              <a:t>test</a:t>
+            </a:r>
+            <a:r>
+              <a:rPr sz="2460" b="0" i="0">
+                <a:solidFill>
+                  <a:srgbClr val="0B0B0B"/>
+                </a:solidFill>
+                <a:latin typeface="Arial"/>
+              </a:rPr>
+              <a:t> </a:t>
+            </a:r>
+            <a:r>
+              <a:rPr sz="2460" b="0" i="0">
+                <a:solidFill>
+                  <a:srgbClr val="0B0B0B"/>
+                </a:solidFill>
+                <a:latin typeface="Arial"/>
+              </a:rPr>
+              <a:t>needs</a:t>
             </a:r>
           </a:p>
         </p:txBody>
@@ -10451,8 +10703,8 @@
         </p:nvSpPr>
         <p:spPr>
           <a:xfrm>
-            <a:off x="20775739" y="37393168"/>
-            <a:ext cx="4214429" cy="312774"/>
+            <a:off x="20775739" y="32796035"/>
+            <a:ext cx="8620648" cy="312517"/>
           </a:xfrm>
           <a:prstGeom prst="rect">
             <a:avLst/>
@@ -10472,25 +10724,7 @@
                 </a:solidFill>
                 <a:latin typeface="Arial"/>
               </a:rPr>
-              <a:t>frozen and</a:t>
-            </a:r>
-            <a:r>
-              <a:rPr sz="2460" b="1" i="0">
-                <a:solidFill>
-                  <a:srgbClr val="0B0B0B"/>
-                </a:solidFill>
-                <a:latin typeface="Arial"/>
-              </a:rPr>
-              <a:t> has not been run</a:t>
-            </a:r>
-            <a:r>
-              <a:rPr sz="2460" b="0" i="0">
-                <a:solidFill>
-                  <a:srgbClr val="0B0B0B"/>
-                </a:solidFill>
-                <a:latin typeface="Arial"/>
-              </a:rPr>
-              <a:t>.</a:t>
+              <a:t>typed adapters, training-only diagnosis, held-out perturbations</a:t>
             </a:r>
           </a:p>
         </p:txBody>
@@ -10503,8 +10737,8 @@
         </p:nvSpPr>
         <p:spPr>
           <a:xfrm>
-            <a:off x="20775738" y="37865555"/>
-            <a:ext cx="4459778" cy="264439"/>
+            <a:off x="20775739" y="33200922"/>
+            <a:ext cx="8620642" cy="312517"/>
           </a:xfrm>
           <a:prstGeom prst="rect">
             <a:avLst/>
@@ -10518,13 +10752,31 @@
           <a:lstStyle/>
           <a:p>
             <a:r>
-              <a:rPr sz="2080" b="0" i="0">
-                <a:solidFill>
-                  <a:srgbClr val="0B0B0B"/>
-                </a:solidFill>
-                <a:latin typeface="Arial"/>
-              </a:rPr>
-              <a:t>Every number, with commit and hash:</a:t>
+              <a:rPr sz="2460" b="0" i="0">
+                <a:solidFill>
+                  <a:srgbClr val="0B0B0B"/>
+                </a:solidFill>
+                <a:latin typeface="Arial"/>
+              </a:rPr>
+              <a:t>and cell states, and confounder controls.</a:t>
+            </a:r>
+            <a:r>
+              <a:rPr sz="2460" b="0" i="0">
+                <a:solidFill>
+                  <a:srgbClr val="0B0B0B"/>
+                </a:solidFill>
+                <a:latin typeface="Arial"/>
+              </a:rPr>
+              <a:t> </a:t>
+            </a:r>
+            <a:r>
+              <a:rPr sz="2460" b="0" i="0">
+                <a:solidFill>
+                  <a:srgbClr val="0B0B0B"/>
+                </a:solidFill>
+                <a:latin typeface="Arial"/>
+              </a:rPr>
+              <a:t>No biological data or</a:t>
             </a:r>
           </a:p>
         </p:txBody>
@@ -10537,8 +10789,8 @@
         </p:nvSpPr>
         <p:spPr>
           <a:xfrm>
-            <a:off x="20775738" y="38206545"/>
-            <a:ext cx="8583241" cy="278358"/>
+            <a:off x="20775739" y="33605796"/>
+            <a:ext cx="2485623" cy="312517"/>
           </a:xfrm>
           <a:prstGeom prst="rect">
             <a:avLst/>
@@ -10552,6 +10804,316 @@
           <a:lstStyle/>
           <a:p>
             <a:r>
+              <a:rPr sz="2460" b="0" i="0">
+                <a:solidFill>
+                  <a:srgbClr val="0B0B0B"/>
+                </a:solidFill>
+                <a:latin typeface="Arial"/>
+              </a:rPr>
+              <a:t>result exists here.</a:t>
+            </a:r>
+          </a:p>
+        </p:txBody>
+      </p:sp>
+      <p:sp>
+        <p:nvSpPr>
+          <p:cNvPr id="117" name="TextBox 116"/>
+          <p:cNvSpPr txBox="1"/>
+          <p:nvPr/>
+        </p:nvSpPr>
+        <p:spPr>
+          <a:xfrm>
+            <a:off x="20775739" y="35030959"/>
+            <a:ext cx="5395605" cy="544062"/>
+          </a:xfrm>
+          <a:prstGeom prst="rect">
+            <a:avLst/>
+          </a:prstGeom>
+          <a:noFill/>
+        </p:spPr>
+        <p:txBody>
+          <a:bodyPr wrap="none" lIns="0" rIns="0" tIns="0" bIns="0">
+            <a:spAutoFit/>
+          </a:bodyPr>
+          <a:lstStyle/>
+          <a:p>
+            <a:r>
+              <a:rPr sz="3790" b="1" i="0">
+                <a:solidFill>
+                  <a:srgbClr val="2A78D6"/>
+                </a:solidFill>
+                <a:latin typeface="Arial"/>
+              </a:rPr>
+              <a:t>Not claimed</a:t>
+            </a:r>
+            <a:r>
+              <a:rPr sz="4280" b="0" i="1">
+                <a:solidFill>
+                  <a:srgbClr val="2A78D6"/>
+                </a:solidFill>
+                <a:latin typeface="Arial"/>
+              </a:rPr>
+              <a:t> </a:t>
+            </a:r>
+            <a:r>
+              <a:rPr sz="4280" b="0" i="1">
+                <a:solidFill>
+                  <a:srgbClr val="2A78D6"/>
+                </a:solidFill>
+                <a:latin typeface="Arial"/>
+              </a:rPr>
+              <a:t>·</a:t>
+            </a:r>
+            <a:r>
+              <a:rPr sz="3790" b="1" i="0">
+                <a:solidFill>
+                  <a:srgbClr val="2A78D6"/>
+                </a:solidFill>
+                <a:latin typeface="Arial"/>
+              </a:rPr>
+              <a:t> </a:t>
+            </a:r>
+            <a:r>
+              <a:rPr sz="3790" b="1" i="0">
+                <a:solidFill>
+                  <a:srgbClr val="2A78D6"/>
+                </a:solidFill>
+                <a:latin typeface="Arial"/>
+              </a:rPr>
+              <a:t>evidence</a:t>
+            </a:r>
+          </a:p>
+        </p:txBody>
+      </p:sp>
+      <p:sp>
+        <p:nvSpPr>
+          <p:cNvPr id="118" name="TextBox 117"/>
+          <p:cNvSpPr txBox="1"/>
+          <p:nvPr/>
+        </p:nvSpPr>
+        <p:spPr>
+          <a:xfrm>
+            <a:off x="20775739" y="36178526"/>
+            <a:ext cx="8512819" cy="312517"/>
+          </a:xfrm>
+          <a:prstGeom prst="rect">
+            <a:avLst/>
+          </a:prstGeom>
+          <a:noFill/>
+        </p:spPr>
+        <p:txBody>
+          <a:bodyPr wrap="none" lIns="0" rIns="0" tIns="0" bIns="0">
+            <a:spAutoFit/>
+          </a:bodyPr>
+          <a:lstStyle/>
+          <a:p>
+            <a:r>
+              <a:rPr sz="2460" b="0" i="0">
+                <a:solidFill>
+                  <a:srgbClr val="0B0B0B"/>
+                </a:solidFill>
+                <a:latin typeface="Arial"/>
+              </a:rPr>
+              <a:t>No ARC-AGI-2 solve or score gain; no semantic invention; no</a:t>
+            </a:r>
+          </a:p>
+        </p:txBody>
+      </p:sp>
+      <p:sp>
+        <p:nvSpPr>
+          <p:cNvPr id="119" name="TextBox 118"/>
+          <p:cNvSpPr txBox="1"/>
+          <p:nvPr/>
+        </p:nvSpPr>
+        <p:spPr>
+          <a:xfrm>
+            <a:off x="20775739" y="36583401"/>
+            <a:ext cx="8002801" cy="312517"/>
+          </a:xfrm>
+          <a:prstGeom prst="rect">
+            <a:avLst/>
+          </a:prstGeom>
+          <a:noFill/>
+        </p:spPr>
+        <p:txBody>
+          <a:bodyPr wrap="none" lIns="0" rIns="0" tIns="0" bIns="0">
+            <a:spAutoFit/>
+          </a:bodyPr>
+          <a:lstStyle/>
+          <a:p>
+            <a:r>
+              <a:rPr sz="2460" b="0" i="0">
+                <a:solidFill>
+                  <a:srgbClr val="0B0B0B"/>
+                </a:solidFill>
+                <a:latin typeface="Arial"/>
+              </a:rPr>
+              <a:t>automatic failure-type controller; no domain generality; no</a:t>
+            </a:r>
+          </a:p>
+        </p:txBody>
+      </p:sp>
+      <p:sp>
+        <p:nvSpPr>
+          <p:cNvPr id="120" name="TextBox 119"/>
+          <p:cNvSpPr txBox="1"/>
+          <p:nvPr/>
+        </p:nvSpPr>
+        <p:spPr>
+          <a:xfrm>
+            <a:off x="20775739" y="36988291"/>
+            <a:ext cx="8509384" cy="312517"/>
+          </a:xfrm>
+          <a:prstGeom prst="rect">
+            <a:avLst/>
+          </a:prstGeom>
+          <a:noFill/>
+        </p:spPr>
+        <p:txBody>
+          <a:bodyPr wrap="none" lIns="0" rIns="0" tIns="0" bIns="0">
+            <a:spAutoFit/>
+          </a:bodyPr>
+          <a:lstStyle/>
+          <a:p>
+            <a:r>
+              <a:rPr sz="2460" b="0" i="0">
+                <a:solidFill>
+                  <a:srgbClr val="0B0B0B"/>
+                </a:solidFill>
+                <a:latin typeface="Arial"/>
+              </a:rPr>
+              <a:t>results from the separate VDCG project.</a:t>
+            </a:r>
+            <a:r>
+              <a:rPr sz="2460" b="0" i="0">
+                <a:solidFill>
+                  <a:srgbClr val="0B0B0B"/>
+                </a:solidFill>
+                <a:latin typeface="Arial"/>
+              </a:rPr>
+              <a:t> </a:t>
+            </a:r>
+            <a:r>
+              <a:rPr sz="2460" b="0" i="0">
+                <a:solidFill>
+                  <a:srgbClr val="0B0B0B"/>
+                </a:solidFill>
+                <a:latin typeface="Arial"/>
+              </a:rPr>
+              <a:t>The 120-task pilot is</a:t>
+            </a:r>
+          </a:p>
+        </p:txBody>
+      </p:sp>
+      <p:sp>
+        <p:nvSpPr>
+          <p:cNvPr id="121" name="TextBox 120"/>
+          <p:cNvSpPr txBox="1"/>
+          <p:nvPr/>
+        </p:nvSpPr>
+        <p:spPr>
+          <a:xfrm>
+            <a:off x="20775739" y="37393168"/>
+            <a:ext cx="4214429" cy="312774"/>
+          </a:xfrm>
+          <a:prstGeom prst="rect">
+            <a:avLst/>
+          </a:prstGeom>
+          <a:noFill/>
+        </p:spPr>
+        <p:txBody>
+          <a:bodyPr wrap="none" lIns="0" rIns="0" tIns="0" bIns="0">
+            <a:spAutoFit/>
+          </a:bodyPr>
+          <a:lstStyle/>
+          <a:p>
+            <a:r>
+              <a:rPr sz="2460" b="0" i="0">
+                <a:solidFill>
+                  <a:srgbClr val="0B0B0B"/>
+                </a:solidFill>
+                <a:latin typeface="Arial"/>
+              </a:rPr>
+              <a:t>frozen and</a:t>
+            </a:r>
+            <a:r>
+              <a:rPr sz="2460" b="1" i="0">
+                <a:solidFill>
+                  <a:srgbClr val="0B0B0B"/>
+                </a:solidFill>
+                <a:latin typeface="Arial"/>
+              </a:rPr>
+              <a:t> has not been run</a:t>
+            </a:r>
+            <a:r>
+              <a:rPr sz="2460" b="0" i="0">
+                <a:solidFill>
+                  <a:srgbClr val="0B0B0B"/>
+                </a:solidFill>
+                <a:latin typeface="Arial"/>
+              </a:rPr>
+              <a:t>.</a:t>
+            </a:r>
+          </a:p>
+        </p:txBody>
+      </p:sp>
+      <p:sp>
+        <p:nvSpPr>
+          <p:cNvPr id="122" name="TextBox 121"/>
+          <p:cNvSpPr txBox="1"/>
+          <p:nvPr/>
+        </p:nvSpPr>
+        <p:spPr>
+          <a:xfrm>
+            <a:off x="20775738" y="37865555"/>
+            <a:ext cx="4459778" cy="264439"/>
+          </a:xfrm>
+          <a:prstGeom prst="rect">
+            <a:avLst/>
+          </a:prstGeom>
+          <a:noFill/>
+        </p:spPr>
+        <p:txBody>
+          <a:bodyPr wrap="none" lIns="0" rIns="0" tIns="0" bIns="0">
+            <a:spAutoFit/>
+          </a:bodyPr>
+          <a:lstStyle/>
+          <a:p>
+            <a:r>
+              <a:rPr sz="2080" b="0" i="0">
+                <a:solidFill>
+                  <a:srgbClr val="0B0B0B"/>
+                </a:solidFill>
+                <a:latin typeface="Arial"/>
+              </a:rPr>
+              <a:t>Every number, with commit and hash:</a:t>
+            </a:r>
+          </a:p>
+        </p:txBody>
+      </p:sp>
+      <p:sp>
+        <p:nvSpPr>
+          <p:cNvPr id="123" name="TextBox 122"/>
+          <p:cNvSpPr txBox="1"/>
+          <p:nvPr/>
+        </p:nvSpPr>
+        <p:spPr>
+          <a:xfrm>
+            <a:off x="20775738" y="38206545"/>
+            <a:ext cx="8583241" cy="278358"/>
+          </a:xfrm>
+          <a:prstGeom prst="rect">
+            <a:avLst/>
+          </a:prstGeom>
+          <a:noFill/>
+        </p:spPr>
+        <p:txBody>
+          <a:bodyPr wrap="none" lIns="0" rIns="0" tIns="0" bIns="0">
+            <a:spAutoFit/>
+          </a:bodyPr>
+          <a:lstStyle/>
+          <a:p>
+            <a:r>
               <a:rPr sz="2190" b="0" i="0">
                 <a:solidFill>
                   <a:srgbClr val="0B0B0B"/>
@@ -10574,7 +11136,7 @@
       </p:sp>
       <p:sp>
         <p:nvSpPr>
-          <p:cNvPr id="117" name="TextBox 116"/>
+          <p:cNvPr id="124" name="TextBox 123"/>
           <p:cNvSpPr txBox="1"/>
           <p:nvPr/>
         </p:nvSpPr>

</xml_diff>

<commit_message>
Summit poster and abstract state the official Kaggle ARC-AGI-2 native result (public 0.00, October 2026); PDFs rebuilt reproducibly, PPTX regenerated, evidence note section 14
</commit_message>
<xml_diff>
--- a/docs/summit_poster/poster.pptx
+++ b/docs/summit_poster/poster.pptx
@@ -10893,8 +10893,8 @@
         </p:nvSpPr>
         <p:spPr>
           <a:xfrm>
-            <a:off x="20775739" y="36178526"/>
-            <a:ext cx="8512819" cy="312517"/>
+            <a:off x="20775739" y="36178523"/>
+            <a:ext cx="8570949" cy="312517"/>
           </a:xfrm>
           <a:prstGeom prst="rect">
             <a:avLst/>
@@ -10914,7 +10914,7 @@
                 </a:solidFill>
                 <a:latin typeface="Arial"/>
               </a:rPr>
-              <a:t>No ARC-AGI-2 solve or score gain; no semantic invention; no</a:t>
+              <a:t>Official Kaggle ARC-AGI-2 score of the native solver (October</a:t>
             </a:r>
           </a:p>
         </p:txBody>
@@ -10928,7 +10928,7 @@
         <p:spPr>
           <a:xfrm>
             <a:off x="20775739" y="36583401"/>
-            <a:ext cx="8002801" cy="312517"/>
+            <a:ext cx="8464035" cy="312774"/>
           </a:xfrm>
           <a:prstGeom prst="rect">
             <a:avLst/>
@@ -10948,7 +10948,52 @@
                 </a:solidFill>
                 <a:latin typeface="Arial"/>
               </a:rPr>
-              <a:t>automatic failure-type controller; no domain generality; no</a:t>
+              <a:t>2026):</a:t>
+            </a:r>
+            <a:r>
+              <a:rPr sz="2460" b="1" i="0">
+                <a:solidFill>
+                  <a:srgbClr val="0B0B0B"/>
+                </a:solidFill>
+                <a:latin typeface="Arial"/>
+              </a:rPr>
+              <a:t> </a:t>
+            </a:r>
+            <a:r>
+              <a:rPr sz="2460" b="1" i="0">
+                <a:solidFill>
+                  <a:srgbClr val="0B0B0B"/>
+                </a:solidFill>
+                <a:latin typeface="Arial"/>
+              </a:rPr>
+              <a:t>0.00</a:t>
+            </a:r>
+            <a:r>
+              <a:rPr sz="2460" b="0" i="0">
+                <a:solidFill>
+                  <a:srgbClr val="0B0B0B"/>
+                </a:solidFill>
+                <a:latin typeface="Arial"/>
+              </a:rPr>
+              <a:t>.</a:t>
+            </a:r>
+            <a:r>
+              <a:rPr sz="2460" b="0" i="0">
+                <a:solidFill>
+                  <a:srgbClr val="0B0B0B"/>
+                </a:solidFill>
+                <a:latin typeface="Arial"/>
+              </a:rPr>
+              <a:t> </a:t>
+            </a:r>
+            <a:r>
+              <a:rPr sz="2460" b="0" i="0">
+                <a:solidFill>
+                  <a:srgbClr val="0B0B0B"/>
+                </a:solidFill>
+                <a:latin typeface="Arial"/>
+              </a:rPr>
+              <a:t>No ARC-AGI-2 solve or score gain; no semantic</a:t>
             </a:r>
           </a:p>
         </p:txBody>
@@ -10961,8 +11006,8 @@
         </p:nvSpPr>
         <p:spPr>
           <a:xfrm>
-            <a:off x="20775739" y="36988291"/>
-            <a:ext cx="8509384" cy="312517"/>
+            <a:off x="20775739" y="36988288"/>
+            <a:ext cx="7887794" cy="312517"/>
           </a:xfrm>
           <a:prstGeom prst="rect">
             <a:avLst/>
@@ -10982,25 +11027,7 @@
                 </a:solidFill>
                 <a:latin typeface="Arial"/>
               </a:rPr>
-              <a:t>results from the separate VDCG project.</a:t>
-            </a:r>
-            <a:r>
-              <a:rPr sz="2460" b="0" i="0">
-                <a:solidFill>
-                  <a:srgbClr val="0B0B0B"/>
-                </a:solidFill>
-                <a:latin typeface="Arial"/>
-              </a:rPr>
-              <a:t> </a:t>
-            </a:r>
-            <a:r>
-              <a:rPr sz="2460" b="0" i="0">
-                <a:solidFill>
-                  <a:srgbClr val="0B0B0B"/>
-                </a:solidFill>
-                <a:latin typeface="Arial"/>
-              </a:rPr>
-              <a:t>The 120-task pilot is</a:t>
+              <a:t>invention; no automatic failure-type controller; no domain</a:t>
             </a:r>
           </a:p>
         </p:txBody>
@@ -11013,8 +11040,8 @@
         </p:nvSpPr>
         <p:spPr>
           <a:xfrm>
-            <a:off x="20775739" y="37393168"/>
-            <a:ext cx="4214429" cy="312774"/>
+            <a:off x="20775739" y="37393165"/>
+            <a:ext cx="8211247" cy="312517"/>
           </a:xfrm>
           <a:prstGeom prst="rect">
             <a:avLst/>
@@ -11034,25 +11061,25 @@
                 </a:solidFill>
                 <a:latin typeface="Arial"/>
               </a:rPr>
-              <a:t>frozen and</a:t>
-            </a:r>
-            <a:r>
-              <a:rPr sz="2460" b="1" i="0">
-                <a:solidFill>
-                  <a:srgbClr val="0B0B0B"/>
-                </a:solidFill>
-                <a:latin typeface="Arial"/>
-              </a:rPr>
-              <a:t> has not been run</a:t>
-            </a:r>
-            <a:r>
-              <a:rPr sz="2460" b="0" i="0">
-                <a:solidFill>
-                  <a:srgbClr val="0B0B0B"/>
-                </a:solidFill>
-                <a:latin typeface="Arial"/>
-              </a:rPr>
-              <a:t>.</a:t>
+              <a:t>generality; no results from the separate VDCG project.</a:t>
+            </a:r>
+            <a:r>
+              <a:rPr sz="2460" b="0" i="0">
+                <a:solidFill>
+                  <a:srgbClr val="0B0B0B"/>
+                </a:solidFill>
+                <a:latin typeface="Arial"/>
+              </a:rPr>
+              <a:t> </a:t>
+            </a:r>
+            <a:r>
+              <a:rPr sz="2460" b="0" i="0">
+                <a:solidFill>
+                  <a:srgbClr val="0B0B0B"/>
+                </a:solidFill>
+                <a:latin typeface="Arial"/>
+              </a:rPr>
+              <a:t>The</a:t>
             </a:r>
           </a:p>
         </p:txBody>
@@ -11065,8 +11092,8 @@
         </p:nvSpPr>
         <p:spPr>
           <a:xfrm>
-            <a:off x="20775738" y="37865555"/>
-            <a:ext cx="4459778" cy="264439"/>
+            <a:off x="20775739" y="37798052"/>
+            <a:ext cx="6472324" cy="312774"/>
           </a:xfrm>
           <a:prstGeom prst="rect">
             <a:avLst/>
@@ -11080,13 +11107,31 @@
           <a:lstStyle/>
           <a:p>
             <a:r>
-              <a:rPr sz="2080" b="0" i="0">
-                <a:solidFill>
-                  <a:srgbClr val="0B0B0B"/>
-                </a:solidFill>
-                <a:latin typeface="Arial"/>
-              </a:rPr>
-              <a:t>Every number, with commit and hash:</a:t>
+              <a:rPr sz="2460" b="0" i="0">
+                <a:solidFill>
+                  <a:srgbClr val="0B0B0B"/>
+                </a:solidFill>
+                <a:latin typeface="Arial"/>
+              </a:rPr>
+              <a:t>120-task pilot is frozen and</a:t>
+            </a:r>
+            <a:r>
+              <a:rPr sz="2460" b="1" i="0">
+                <a:solidFill>
+                  <a:srgbClr val="0B0B0B"/>
+                </a:solidFill>
+                <a:latin typeface="Arial"/>
+              </a:rPr>
+              <a:t> has not been run</a:t>
+            </a:r>
+            <a:r>
+              <a:rPr sz="2460" b="0" i="0">
+                <a:solidFill>
+                  <a:srgbClr val="0B0B0B"/>
+                </a:solidFill>
+                <a:latin typeface="Arial"/>
+              </a:rPr>
+              <a:t>.</a:t>
             </a:r>
           </a:p>
         </p:txBody>
@@ -11099,8 +11144,8 @@
         </p:nvSpPr>
         <p:spPr>
           <a:xfrm>
-            <a:off x="20775738" y="38206545"/>
-            <a:ext cx="8583241" cy="278358"/>
+            <a:off x="20775739" y="38270426"/>
+            <a:ext cx="4459777" cy="264439"/>
           </a:xfrm>
           <a:prstGeom prst="rect">
             <a:avLst/>
@@ -11114,22 +11159,13 @@
           <a:lstStyle/>
           <a:p>
             <a:r>
-              <a:rPr sz="2190" b="0" i="0">
-                <a:solidFill>
-                  <a:srgbClr val="0B0B0B"/>
-                </a:solidFill>
-                <a:latin typeface="Courier New"/>
-              </a:rPr>
-              <a:t>records/CORA_SUMMIT_POSTER_EVIDENCE_20261012.md</a:t>
-            </a:r>
-            <a:r>
               <a:rPr sz="2080" b="0" i="0">
                 <a:solidFill>
                   <a:srgbClr val="0B0B0B"/>
                 </a:solidFill>
                 <a:latin typeface="Arial"/>
               </a:rPr>
-              <a:t>; figure hashes:</a:t>
+              <a:t>Every number, with commit and hash:</a:t>
             </a:r>
           </a:p>
         </p:txBody>
@@ -11142,7 +11178,50 @@
         </p:nvSpPr>
         <p:spPr>
           <a:xfrm>
-            <a:off x="20775736" y="38548161"/>
+            <a:off x="20775739" y="38611416"/>
+            <a:ext cx="8583243" cy="278358"/>
+          </a:xfrm>
+          <a:prstGeom prst="rect">
+            <a:avLst/>
+          </a:prstGeom>
+          <a:noFill/>
+        </p:spPr>
+        <p:txBody>
+          <a:bodyPr wrap="none" lIns="0" rIns="0" tIns="0" bIns="0">
+            <a:spAutoFit/>
+          </a:bodyPr>
+          <a:lstStyle/>
+          <a:p>
+            <a:r>
+              <a:rPr sz="2190" b="0" i="0">
+                <a:solidFill>
+                  <a:srgbClr val="0B0B0B"/>
+                </a:solidFill>
+                <a:latin typeface="Courier New"/>
+              </a:rPr>
+              <a:t>records/CORA_SUMMIT_POSTER_EVIDENCE_20261012.md</a:t>
+            </a:r>
+            <a:r>
+              <a:rPr sz="2080" b="0" i="0">
+                <a:solidFill>
+                  <a:srgbClr val="0B0B0B"/>
+                </a:solidFill>
+                <a:latin typeface="Arial"/>
+              </a:rPr>
+              <a:t>; figure hashes:</a:t>
+            </a:r>
+          </a:p>
+        </p:txBody>
+      </p:sp>
+      <p:sp>
+        <p:nvSpPr>
+          <p:cNvPr id="125" name="TextBox 124"/>
+          <p:cNvSpPr txBox="1"/>
+          <p:nvPr/>
+        </p:nvSpPr>
+        <p:spPr>
+          <a:xfrm>
+            <a:off x="20775739" y="38953048"/>
             <a:ext cx="3415022" cy="278358"/>
           </a:xfrm>
           <a:prstGeom prst="rect">

</xml_diff>

<commit_message>
Kaggle 57160429 scored: public 27.64 (NEURAL_TTT_BASELINE, NVARC reproduction); recorded in log 11.2, paper, poster, abstract, explainer, evidence record, ledger
</commit_message>
<xml_diff>
--- a/docs/summit_poster/poster.pptx
+++ b/docs/summit_poster/poster.pptx
@@ -9875,7 +9875,7 @@
         <p:spPr>
           <a:xfrm>
             <a:off x="20775741" y="9334483"/>
-            <a:ext cx="8620523" cy="312775"/>
+            <a:ext cx="8620666" cy="312775"/>
           </a:xfrm>
           <a:prstGeom prst="rect">
             <a:avLst/>
@@ -9895,7 +9895,61 @@
                 </a:solidFill>
                 <a:latin typeface="Arial"/>
               </a:rPr>
-              <a:t>NVARC Qwen3-4B test-time-training pipeline,</a:t>
+              <a:t>NVARC</a:t>
+            </a:r>
+            <a:r>
+              <a:rPr sz="2460" b="0" i="0">
+                <a:solidFill>
+                  <a:srgbClr val="0B0B0B"/>
+                </a:solidFill>
+                <a:latin typeface="Arial"/>
+              </a:rPr>
+              <a:t> </a:t>
+            </a:r>
+            <a:r>
+              <a:rPr sz="2460" b="0" i="0">
+                <a:solidFill>
+                  <a:srgbClr val="0B0B0B"/>
+                </a:solidFill>
+                <a:latin typeface="Arial"/>
+              </a:rPr>
+              <a:t>Qwen3-4B</a:t>
+            </a:r>
+            <a:r>
+              <a:rPr sz="2460" b="0" i="0">
+                <a:solidFill>
+                  <a:srgbClr val="0B0B0B"/>
+                </a:solidFill>
+                <a:latin typeface="Arial"/>
+              </a:rPr>
+              <a:t> </a:t>
+            </a:r>
+            <a:r>
+              <a:rPr sz="2460" b="0" i="0">
+                <a:solidFill>
+                  <a:srgbClr val="0B0B0B"/>
+                </a:solidFill>
+                <a:latin typeface="Arial"/>
+              </a:rPr>
+              <a:t>test-time-training</a:t>
+            </a:r>
+            <a:r>
+              <a:rPr sz="2460" b="0" i="0">
+                <a:solidFill>
+                  <a:srgbClr val="0B0B0B"/>
+                </a:solidFill>
+                <a:latin typeface="Arial"/>
+              </a:rPr>
+              <a:t> </a:t>
+            </a:r>
+            <a:r>
+              <a:rPr sz="2460" b="0" i="0">
+                <a:solidFill>
+                  <a:srgbClr val="0B0B0B"/>
+                </a:solidFill>
+                <a:latin typeface="Arial"/>
+              </a:rPr>
+              <a:t>pipeline,</a:t>
             </a:r>
             <a:r>
               <a:rPr sz="2460" b="1" i="0">
@@ -9904,16 +9958,61 @@
                 </a:solidFill>
                 <a:latin typeface="Arial"/>
               </a:rPr>
-              <a:t> not CORA</a:t>
-            </a:r>
-            <a:r>
-              <a:rPr sz="2460" b="0" i="0">
-                <a:solidFill>
-                  <a:srgbClr val="0B0B0B"/>
-                </a:solidFill>
-                <a:latin typeface="Arial"/>
-              </a:rPr>
-              <a:t>: sub-</a:t>
+              <a:t> </a:t>
+            </a:r>
+            <a:r>
+              <a:rPr sz="2460" b="1" i="0">
+                <a:solidFill>
+                  <a:srgbClr val="0B0B0B"/>
+                </a:solidFill>
+                <a:latin typeface="Arial"/>
+              </a:rPr>
+              <a:t>not</a:t>
+            </a:r>
+            <a:r>
+              <a:rPr sz="2460" b="1" i="0">
+                <a:solidFill>
+                  <a:srgbClr val="0B0B0B"/>
+                </a:solidFill>
+                <a:latin typeface="Arial"/>
+              </a:rPr>
+              <a:t> </a:t>
+            </a:r>
+            <a:r>
+              <a:rPr sz="2460" b="1" i="0">
+                <a:solidFill>
+                  <a:srgbClr val="0B0B0B"/>
+                </a:solidFill>
+                <a:latin typeface="Arial"/>
+              </a:rPr>
+              <a:t>CORA</a:t>
+            </a:r>
+            <a:r>
+              <a:rPr sz="2460" b="0" i="0">
+                <a:solidFill>
+                  <a:srgbClr val="0B0B0B"/>
+                </a:solidFill>
+                <a:latin typeface="Arial"/>
+              </a:rPr>
+              <a:t>:</a:t>
+            </a:r>
+            <a:r>
+              <a:rPr sz="2460" b="0" i="0">
+                <a:solidFill>
+                  <a:srgbClr val="0B0B0B"/>
+                </a:solidFill>
+                <a:latin typeface="Arial"/>
+              </a:rPr>
+              <a:t> </a:t>
+            </a:r>
+            <a:r>
+              <a:rPr sz="2460" b="0" i="0">
+                <a:solidFill>
+                  <a:srgbClr val="0B0B0B"/>
+                </a:solidFill>
+                <a:latin typeface="Arial"/>
+              </a:rPr>
+              <a:t>of-</a:t>
             </a:r>
           </a:p>
         </p:txBody>
@@ -9926,8 +10025,8 @@
         </p:nvSpPr>
         <p:spPr>
           <a:xfrm>
-            <a:off x="20775741" y="9739373"/>
-            <a:ext cx="8620827" cy="312775"/>
+            <a:off x="20775742" y="9739373"/>
+            <a:ext cx="8620797" cy="312775"/>
           </a:xfrm>
           <a:prstGeom prst="rect">
             <a:avLst/>
@@ -9947,43 +10046,43 @@
                 </a:solidFill>
                 <a:latin typeface="Arial"/>
               </a:rPr>
-              <a:t>mitted</a:t>
-            </a:r>
-            <a:r>
-              <a:rPr sz="2460" b="0" i="0">
-                <a:solidFill>
-                  <a:srgbClr val="0B0B0B"/>
-                </a:solidFill>
-                <a:latin typeface="Arial"/>
-              </a:rPr>
-              <a:t> </a:t>
-            </a:r>
-            <a:r>
-              <a:rPr sz="2460" b="0" i="0">
-                <a:solidFill>
-                  <a:srgbClr val="0B0B0B"/>
-                </a:solidFill>
-                <a:latin typeface="Arial"/>
-              </a:rPr>
-              <a:t>14</a:t>
-            </a:r>
-            <a:r>
-              <a:rPr sz="2460" b="0" i="0">
-                <a:solidFill>
-                  <a:srgbClr val="0B0B0B"/>
-                </a:solidFill>
-                <a:latin typeface="Arial"/>
-              </a:rPr>
-              <a:t> </a:t>
-            </a:r>
-            <a:r>
-              <a:rPr sz="2460" b="0" i="0">
-                <a:solidFill>
-                  <a:srgbClr val="0B0B0B"/>
-                </a:solidFill>
-                <a:latin typeface="Arial"/>
-              </a:rPr>
-              <a:t>October,</a:t>
+              <a:t>ficial</a:t>
+            </a:r>
+            <a:r>
+              <a:rPr sz="2460" b="0" i="0">
+                <a:solidFill>
+                  <a:srgbClr val="0B0B0B"/>
+                </a:solidFill>
+                <a:latin typeface="Arial"/>
+              </a:rPr>
+              <a:t> </a:t>
+            </a:r>
+            <a:r>
+              <a:rPr sz="2460" b="0" i="0">
+                <a:solidFill>
+                  <a:srgbClr val="0B0B0B"/>
+                </a:solidFill>
+                <a:latin typeface="Arial"/>
+              </a:rPr>
+              <a:t>public</a:t>
+            </a:r>
+            <a:r>
+              <a:rPr sz="2460" b="0" i="0">
+                <a:solidFill>
+                  <a:srgbClr val="0B0B0B"/>
+                </a:solidFill>
+                <a:latin typeface="Arial"/>
+              </a:rPr>
+              <a:t> </a:t>
+            </a:r>
+            <a:r>
+              <a:rPr sz="2460" b="0" i="0">
+                <a:solidFill>
+                  <a:srgbClr val="0B0B0B"/>
+                </a:solidFill>
+                <a:latin typeface="Arial"/>
+              </a:rPr>
+              <a:t>score</a:t>
             </a:r>
             <a:r>
               <a:rPr sz="2460" b="1" i="0">
@@ -10001,106 +10100,124 @@
                 </a:solidFill>
                 <a:latin typeface="Arial"/>
               </a:rPr>
-              <a:t>score</a:t>
-            </a:r>
-            <a:r>
-              <a:rPr sz="2460" b="1" i="0">
-                <a:solidFill>
-                  <a:srgbClr val="0B0B0B"/>
-                </a:solidFill>
-                <a:latin typeface="Arial"/>
-              </a:rPr>
-              <a:t> </a:t>
-            </a:r>
-            <a:r>
-              <a:rPr sz="2460" b="1" i="0">
-                <a:solidFill>
-                  <a:srgbClr val="0B0B0B"/>
-                </a:solidFill>
-                <a:latin typeface="Arial"/>
-              </a:rPr>
-              <a:t>pending</a:t>
-            </a:r>
-            <a:r>
-              <a:rPr sz="2460" b="0" i="0">
-                <a:solidFill>
-                  <a:srgbClr val="0B0B0B"/>
-                </a:solidFill>
-                <a:latin typeface="Arial"/>
-              </a:rPr>
-              <a:t>.</a:t>
-            </a:r>
-            <a:r>
-              <a:rPr sz="2460" b="0" i="0">
-                <a:solidFill>
-                  <a:srgbClr val="0B0B0B"/>
-                </a:solidFill>
-                <a:latin typeface="Arial"/>
-              </a:rPr>
-              <a:t> </a:t>
-            </a:r>
-            <a:r>
-              <a:rPr sz="2460" b="0" i="0">
-                <a:solidFill>
-                  <a:srgbClr val="0B0B0B"/>
-                </a:solidFill>
-                <a:latin typeface="Arial"/>
-              </a:rPr>
-              <a:t>On</a:t>
-            </a:r>
-            <a:r>
-              <a:rPr sz="2460" b="0" i="0">
-                <a:solidFill>
-                  <a:srgbClr val="0B0B0B"/>
-                </a:solidFill>
-                <a:latin typeface="Arial"/>
-              </a:rPr>
-              <a:t> </a:t>
-            </a:r>
-            <a:r>
-              <a:rPr sz="2460" b="0" i="0">
-                <a:solidFill>
-                  <a:srgbClr val="0B0B0B"/>
-                </a:solidFill>
-                <a:latin typeface="Arial"/>
-              </a:rPr>
-              <a:t>the</a:t>
-            </a:r>
-            <a:r>
-              <a:rPr sz="2460" b="0" i="0">
-                <a:solidFill>
-                  <a:srgbClr val="0B0B0B"/>
-                </a:solidFill>
-                <a:latin typeface="Arial"/>
-              </a:rPr>
-              <a:t> </a:t>
-            </a:r>
-            <a:r>
-              <a:rPr sz="2460" b="0" i="0">
-                <a:solidFill>
-                  <a:srgbClr val="0B0B0B"/>
-                </a:solidFill>
-                <a:latin typeface="Arial"/>
-              </a:rPr>
-              <a:t>240-task</a:t>
-            </a:r>
-            <a:r>
-              <a:rPr sz="2460" b="0" i="0">
-                <a:solidFill>
-                  <a:srgbClr val="0B0B0B"/>
-                </a:solidFill>
-                <a:latin typeface="Arial"/>
-              </a:rPr>
-              <a:t> </a:t>
-            </a:r>
-            <a:r>
-              <a:rPr sz="2460" b="0" i="0">
-                <a:solidFill>
-                  <a:srgbClr val="0B0B0B"/>
-                </a:solidFill>
-                <a:latin typeface="Arial"/>
-              </a:rPr>
-              <a:t>stand-in</a:t>
+              <a:t>27.64</a:t>
+            </a:r>
+            <a:r>
+              <a:rPr sz="2460" b="0" i="0">
+                <a:solidFill>
+                  <a:srgbClr val="0B0B0B"/>
+                </a:solidFill>
+                <a:latin typeface="Arial"/>
+              </a:rPr>
+              <a:t>,</a:t>
+            </a:r>
+            <a:r>
+              <a:rPr sz="2460" b="0" i="0">
+                <a:solidFill>
+                  <a:srgbClr val="0B0B0B"/>
+                </a:solidFill>
+                <a:latin typeface="Arial"/>
+              </a:rPr>
+              <a:t> </a:t>
+            </a:r>
+            <a:r>
+              <a:rPr sz="2460" b="0" i="0">
+                <a:solidFill>
+                  <a:srgbClr val="0B0B0B"/>
+                </a:solidFill>
+                <a:latin typeface="Arial"/>
+              </a:rPr>
+              <a:t>equal</a:t>
+            </a:r>
+            <a:r>
+              <a:rPr sz="2460" b="0" i="0">
+                <a:solidFill>
+                  <a:srgbClr val="0B0B0B"/>
+                </a:solidFill>
+                <a:latin typeface="Arial"/>
+              </a:rPr>
+              <a:t> </a:t>
+            </a:r>
+            <a:r>
+              <a:rPr sz="2460" b="0" i="0">
+                <a:solidFill>
+                  <a:srgbClr val="0B0B0B"/>
+                </a:solidFill>
+                <a:latin typeface="Arial"/>
+              </a:rPr>
+              <a:t>to</a:t>
+            </a:r>
+            <a:r>
+              <a:rPr sz="2460" b="0" i="0">
+                <a:solidFill>
+                  <a:srgbClr val="0B0B0B"/>
+                </a:solidFill>
+                <a:latin typeface="Arial"/>
+              </a:rPr>
+              <a:t> </a:t>
+            </a:r>
+            <a:r>
+              <a:rPr sz="2460" b="0" i="0">
+                <a:solidFill>
+                  <a:srgbClr val="0B0B0B"/>
+                </a:solidFill>
+                <a:latin typeface="Arial"/>
+              </a:rPr>
+              <a:t>NVARC’s</a:t>
+            </a:r>
+            <a:r>
+              <a:rPr sz="2460" b="0" i="0">
+                <a:solidFill>
+                  <a:srgbClr val="0B0B0B"/>
+                </a:solidFill>
+                <a:latin typeface="Arial"/>
+              </a:rPr>
+              <a:t> </a:t>
+            </a:r>
+            <a:r>
+              <a:rPr sz="2460" b="0" i="0">
+                <a:solidFill>
+                  <a:srgbClr val="0B0B0B"/>
+                </a:solidFill>
+                <a:latin typeface="Arial"/>
+              </a:rPr>
+              <a:t>own</a:t>
+            </a:r>
+            <a:r>
+              <a:rPr sz="2460" b="0" i="0">
+                <a:solidFill>
+                  <a:srgbClr val="0B0B0B"/>
+                </a:solidFill>
+                <a:latin typeface="Arial"/>
+              </a:rPr>
+              <a:t> </a:t>
+            </a:r>
+            <a:r>
+              <a:rPr sz="2460" b="0" i="0">
+                <a:solidFill>
+                  <a:srgbClr val="0B0B0B"/>
+                </a:solidFill>
+                <a:latin typeface="Arial"/>
+              </a:rPr>
+              <a:t>2025</a:t>
+            </a:r>
+            <a:r>
+              <a:rPr sz="2460" b="0" i="0">
+                <a:solidFill>
+                  <a:srgbClr val="0B0B0B"/>
+                </a:solidFill>
+                <a:latin typeface="Arial"/>
+              </a:rPr>
+              <a:t> </a:t>
+            </a:r>
+            <a:r>
+              <a:rPr sz="2460" b="0" i="0">
+                <a:solidFill>
+                  <a:srgbClr val="0B0B0B"/>
+                </a:solidFill>
+                <a:latin typeface="Arial"/>
+              </a:rPr>
+              <a:t>public</a:t>
             </a:r>
           </a:p>
         </p:txBody>
@@ -10134,6 +10251,96 @@
                 </a:solidFill>
                 <a:latin typeface="Arial"/>
               </a:rPr>
+              <a:t>score.</a:t>
+            </a:r>
+            <a:r>
+              <a:rPr sz="2460" b="0" i="0">
+                <a:solidFill>
+                  <a:srgbClr val="0B0B0B"/>
+                </a:solidFill>
+                <a:latin typeface="Arial"/>
+              </a:rPr>
+              <a:t> </a:t>
+            </a:r>
+            <a:r>
+              <a:rPr sz="2460" b="0" i="0">
+                <a:solidFill>
+                  <a:srgbClr val="0B0B0B"/>
+                </a:solidFill>
+                <a:latin typeface="Arial"/>
+              </a:rPr>
+              <a:t>On</a:t>
+            </a:r>
+            <a:r>
+              <a:rPr sz="2460" b="0" i="0">
+                <a:solidFill>
+                  <a:srgbClr val="0B0B0B"/>
+                </a:solidFill>
+                <a:latin typeface="Arial"/>
+              </a:rPr>
+              <a:t> </a:t>
+            </a:r>
+            <a:r>
+              <a:rPr sz="2460" b="0" i="0">
+                <a:solidFill>
+                  <a:srgbClr val="0B0B0B"/>
+                </a:solidFill>
+                <a:latin typeface="Arial"/>
+              </a:rPr>
+              <a:t>the</a:t>
+            </a:r>
+            <a:r>
+              <a:rPr sz="2460" b="0" i="0">
+                <a:solidFill>
+                  <a:srgbClr val="0B0B0B"/>
+                </a:solidFill>
+                <a:latin typeface="Arial"/>
+              </a:rPr>
+              <a:t> </a:t>
+            </a:r>
+            <a:r>
+              <a:rPr sz="2460" b="0" i="0">
+                <a:solidFill>
+                  <a:srgbClr val="0B0B0B"/>
+                </a:solidFill>
+                <a:latin typeface="Arial"/>
+              </a:rPr>
+              <a:t>240-task</a:t>
+            </a:r>
+            <a:r>
+              <a:rPr sz="2460" b="0" i="0">
+                <a:solidFill>
+                  <a:srgbClr val="0B0B0B"/>
+                </a:solidFill>
+                <a:latin typeface="Arial"/>
+              </a:rPr>
+              <a:t> </a:t>
+            </a:r>
+            <a:r>
+              <a:rPr sz="2460" b="0" i="0">
+                <a:solidFill>
+                  <a:srgbClr val="0B0B0B"/>
+                </a:solidFill>
+                <a:latin typeface="Arial"/>
+              </a:rPr>
+              <a:t>stand-in</a:t>
+            </a:r>
+            <a:r>
+              <a:rPr sz="2460" b="0" i="0">
+                <a:solidFill>
+                  <a:srgbClr val="0B0B0B"/>
+                </a:solidFill>
+                <a:latin typeface="Arial"/>
+              </a:rPr>
+              <a:t> </a:t>
+            </a:r>
+            <a:r>
+              <a:rPr sz="2460" b="0" i="0">
+                <a:solidFill>
+                  <a:srgbClr val="0B0B0B"/>
+                </a:solidFill>
+                <a:latin typeface="Arial"/>
+              </a:rPr>
               <a:t>it</a:t>
             </a:r>
             <a:r>
@@ -10225,96 +10432,6 @@
                 <a:latin typeface="Arial"/>
               </a:rPr>
               <a:t>of</a:t>
-            </a:r>
-            <a:r>
-              <a:rPr sz="2460" b="0" i="0">
-                <a:solidFill>
-                  <a:srgbClr val="0B0B0B"/>
-                </a:solidFill>
-                <a:latin typeface="Arial"/>
-              </a:rPr>
-              <a:t> </a:t>
-            </a:r>
-            <a:r>
-              <a:rPr sz="2460" b="0" i="0">
-                <a:solidFill>
-                  <a:srgbClr val="0B0B0B"/>
-                </a:solidFill>
-                <a:latin typeface="Arial"/>
-              </a:rPr>
-              <a:t>259</a:t>
-            </a:r>
-            <a:r>
-              <a:rPr sz="2460" b="0" i="0">
-                <a:solidFill>
-                  <a:srgbClr val="0B0B0B"/>
-                </a:solidFill>
-                <a:latin typeface="Arial"/>
-              </a:rPr>
-              <a:t> </a:t>
-            </a:r>
-            <a:r>
-              <a:rPr sz="2460" b="0" i="0">
-                <a:solidFill>
-                  <a:srgbClr val="0B0B0B"/>
-                </a:solidFill>
-                <a:latin typeface="Arial"/>
-              </a:rPr>
-              <a:t>genuine</a:t>
-            </a:r>
-            <a:r>
-              <a:rPr sz="2460" b="0" i="0">
-                <a:solidFill>
-                  <a:srgbClr val="0B0B0B"/>
-                </a:solidFill>
-                <a:latin typeface="Arial"/>
-              </a:rPr>
-              <a:t> </a:t>
-            </a:r>
-            <a:r>
-              <a:rPr sz="2460" b="0" i="0">
-                <a:solidFill>
-                  <a:srgbClr val="0B0B0B"/>
-                </a:solidFill>
-                <a:latin typeface="Arial"/>
-              </a:rPr>
-              <a:t>predictions,</a:t>
-            </a:r>
-            <a:r>
-              <a:rPr sz="2460" b="0" i="0">
-                <a:solidFill>
-                  <a:srgbClr val="0B0B0B"/>
-                </a:solidFill>
-                <a:latin typeface="Arial"/>
-              </a:rPr>
-              <a:t> </a:t>
-            </a:r>
-            <a:r>
-              <a:rPr sz="2460" b="0" i="0">
-                <a:solidFill>
-                  <a:srgbClr val="0B0B0B"/>
-                </a:solidFill>
-                <a:latin typeface="Arial"/>
-              </a:rPr>
-              <a:t>0</a:t>
-            </a:r>
-            <a:r>
-              <a:rPr sz="2460" b="0" i="0">
-                <a:solidFill>
-                  <a:srgbClr val="0B0B0B"/>
-                </a:solidFill>
-                <a:latin typeface="Arial"/>
-              </a:rPr>
-              <a:t> </a:t>
-            </a:r>
-            <a:r>
-              <a:rPr sz="2460" b="0" i="0">
-                <a:solidFill>
-                  <a:srgbClr val="0B0B0B"/>
-                </a:solidFill>
-                <a:latin typeface="Arial"/>
-              </a:rPr>
-              <a:t>fall-</a:t>
             </a:r>
           </a:p>
         </p:txBody>
@@ -10328,7 +10445,7 @@
         <p:spPr>
           <a:xfrm>
             <a:off x="20775742" y="10549138"/>
-            <a:ext cx="2163731" cy="312516"/>
+            <a:ext cx="6298331" cy="312516"/>
           </a:xfrm>
           <a:prstGeom prst="rect">
             <a:avLst/>
@@ -10348,7 +10465,7 @@
                 </a:solidFill>
                 <a:latin typeface="Arial"/>
               </a:rPr>
-              <a:t>backs) in 4.3 h.</a:t>
+              <a:t>259 genuine predictions, 0 fallbacks) in 4.3 h.</a:t>
             </a:r>
           </a:p>
         </p:txBody>

</xml_diff>

<commit_message>
D3 semantic-degeneracy audit: planted union collapses to ring(8)[part_minority] on all D3 objects; witness claim corrected to single-step everywhere; family audit (S collapses, final families aliases only)
</commit_message>
<xml_diff>
--- a/docs/summit_poster/poster.pptx
+++ b/docs/summit_poster/poster.pptx
@@ -3136,7 +3136,7 @@
         </p:blipFill>
         <p:spPr>
           <a:xfrm>
-            <a:off x="21104034" y="32071115"/>
+            <a:off x="21104034" y="33285754"/>
             <a:ext cx="7913295" cy="1448420"/>
           </a:xfrm>
           <a:prstGeom prst="rect">
@@ -3539,7 +3539,7 @@
         </p:nvSpPr>
         <p:spPr>
           <a:xfrm>
-            <a:off x="20413274" y="30907723"/>
+            <a:off x="20413274" y="32122384"/>
             <a:ext cx="9295048" cy="71999"/>
           </a:xfrm>
           <a:prstGeom prst="rect">
@@ -3582,7 +3582,7 @@
         </p:nvSpPr>
         <p:spPr>
           <a:xfrm>
-            <a:off x="20413274" y="36815214"/>
+            <a:off x="20413274" y="38029875"/>
             <a:ext cx="9295048" cy="71999"/>
           </a:xfrm>
           <a:prstGeom prst="rect">
@@ -3705,7 +3705,7 @@
         </p:blipFill>
         <p:spPr>
           <a:xfrm>
-            <a:off x="20775739" y="16252947"/>
+            <a:off x="20775739" y="16252949"/>
             <a:ext cx="8569876" cy="5412553"/>
           </a:xfrm>
           <a:prstGeom prst="rect">
@@ -12094,7 +12094,7 @@
         <p:spPr>
           <a:xfrm>
             <a:off x="21119515" y="24074525"/>
-            <a:ext cx="8276876" cy="312515"/>
+            <a:ext cx="8276879" cy="312515"/>
           </a:xfrm>
           <a:prstGeom prst="rect">
             <a:avLst/>
@@ -12114,151 +12114,7 @@
                 </a:solidFill>
                 <a:latin typeface="Arial"/>
               </a:rPr>
-              <a:t>structed</a:t>
-            </a:r>
-            <a:r>
-              <a:rPr sz="2460" b="0" i="0">
-                <a:solidFill>
-                  <a:srgbClr val="0B0B0B"/>
-                </a:solidFill>
-                <a:latin typeface="Arial"/>
-              </a:rPr>
-              <a:t> </a:t>
-            </a:r>
-            <a:r>
-              <a:rPr sz="2460" b="0" i="0">
-                <a:solidFill>
-                  <a:srgbClr val="0B0B0B"/>
-                </a:solidFill>
-                <a:latin typeface="Arial"/>
-              </a:rPr>
-              <a:t>operator</a:t>
-            </a:r>
-            <a:r>
-              <a:rPr sz="2460" b="0" i="0">
-                <a:solidFill>
-                  <a:srgbClr val="0B0B0B"/>
-                </a:solidFill>
-                <a:latin typeface="Arial"/>
-              </a:rPr>
-              <a:t> </a:t>
-            </a:r>
-            <a:r>
-              <a:rPr sz="2460" b="0" i="0">
-                <a:solidFill>
-                  <a:srgbClr val="0B0B0B"/>
-                </a:solidFill>
-                <a:latin typeface="Arial"/>
-              </a:rPr>
-              <a:t>is</a:t>
-            </a:r>
-            <a:r>
-              <a:rPr sz="2460" b="0" i="0">
-                <a:solidFill>
-                  <a:srgbClr val="0B0B0B"/>
-                </a:solidFill>
-                <a:latin typeface="Arial"/>
-              </a:rPr>
-              <a:t> </a:t>
-            </a:r>
-            <a:r>
-              <a:rPr sz="2460" b="0" i="0">
-                <a:solidFill>
-                  <a:srgbClr val="0B0B0B"/>
-                </a:solidFill>
-                <a:latin typeface="Arial"/>
-              </a:rPr>
-              <a:t>new</a:t>
-            </a:r>
-            <a:r>
-              <a:rPr sz="2460" b="0" i="0">
-                <a:solidFill>
-                  <a:srgbClr val="0B0B0B"/>
-                </a:solidFill>
-                <a:latin typeface="Arial"/>
-              </a:rPr>
-              <a:t> </a:t>
-            </a:r>
-            <a:r>
-              <a:rPr sz="2460" b="0" i="0">
-                <a:solidFill>
-                  <a:srgbClr val="0B0B0B"/>
-                </a:solidFill>
-                <a:latin typeface="Arial"/>
-              </a:rPr>
-              <a:t>(on</a:t>
-            </a:r>
-            <a:r>
-              <a:rPr sz="2460" b="0" i="0">
-                <a:solidFill>
-                  <a:srgbClr val="0B0B0B"/>
-                </a:solidFill>
-                <a:latin typeface="Arial"/>
-              </a:rPr>
-              <a:t> </a:t>
-            </a:r>
-            <a:r>
-              <a:rPr sz="2460" b="0" i="0">
-                <a:solidFill>
-                  <a:srgbClr val="0B0B0B"/>
-                </a:solidFill>
-                <a:latin typeface="Arial"/>
-              </a:rPr>
-              <a:t>300</a:t>
-            </a:r>
-            <a:r>
-              <a:rPr sz="2460" b="0" i="0">
-                <a:solidFill>
-                  <a:srgbClr val="0B0B0B"/>
-                </a:solidFill>
-                <a:latin typeface="Arial"/>
-              </a:rPr>
-              <a:t> </a:t>
-            </a:r>
-            <a:r>
-              <a:rPr sz="2460" b="0" i="0">
-                <a:solidFill>
-                  <a:srgbClr val="0B0B0B"/>
-                </a:solidFill>
-                <a:latin typeface="Arial"/>
-              </a:rPr>
-              <a:t>perturbed</a:t>
-            </a:r>
-            <a:r>
-              <a:rPr sz="2460" b="0" i="0">
-                <a:solidFill>
-                  <a:srgbClr val="0B0B0B"/>
-                </a:solidFill>
-                <a:latin typeface="Arial"/>
-              </a:rPr>
-              <a:t> </a:t>
-            </a:r>
-            <a:r>
-              <a:rPr sz="2460" b="0" i="0">
-                <a:solidFill>
-                  <a:srgbClr val="0B0B0B"/>
-                </a:solidFill>
-                <a:latin typeface="Arial"/>
-              </a:rPr>
-              <a:t>shapes</a:t>
-            </a:r>
-            <a:r>
-              <a:rPr sz="2460" b="0" i="0">
-                <a:solidFill>
-                  <a:srgbClr val="0B0B0B"/>
-                </a:solidFill>
-                <a:latin typeface="Arial"/>
-              </a:rPr>
-              <a:t> </a:t>
-            </a:r>
-            <a:r>
-              <a:rPr sz="2460" b="0" i="0">
-                <a:solidFill>
-                  <a:srgbClr val="0B0B0B"/>
-                </a:solidFill>
-                <a:latin typeface="Arial"/>
-              </a:rPr>
-              <a:t>native</a:t>
+              <a:t>structed one-step operator (a ring around the minority-colour</a:t>
             </a:r>
           </a:p>
         </p:txBody>
@@ -12272,7 +12128,7 @@
         <p:spPr>
           <a:xfrm>
             <a:off x="21119515" y="24479401"/>
-            <a:ext cx="8276879" cy="312515"/>
+            <a:ext cx="8276869" cy="312515"/>
           </a:xfrm>
           <a:prstGeom prst="rect">
             <a:avLst/>
@@ -12292,6 +12148,150 @@
                 </a:solidFill>
                 <a:latin typeface="Arial"/>
               </a:rPr>
+              <a:t>cell)</a:t>
+            </a:r>
+            <a:r>
+              <a:rPr sz="2460" b="0" i="0">
+                <a:solidFill>
+                  <a:srgbClr val="0B0B0B"/>
+                </a:solidFill>
+                <a:latin typeface="Arial"/>
+              </a:rPr>
+              <a:t> </a:t>
+            </a:r>
+            <a:r>
+              <a:rPr sz="2460" b="0" i="0">
+                <a:solidFill>
+                  <a:srgbClr val="0B0B0B"/>
+                </a:solidFill>
+                <a:latin typeface="Arial"/>
+              </a:rPr>
+              <a:t>is</a:t>
+            </a:r>
+            <a:r>
+              <a:rPr sz="2460" b="0" i="0">
+                <a:solidFill>
+                  <a:srgbClr val="0B0B0B"/>
+                </a:solidFill>
+                <a:latin typeface="Arial"/>
+              </a:rPr>
+              <a:t> </a:t>
+            </a:r>
+            <a:r>
+              <a:rPr sz="2460" b="0" i="0">
+                <a:solidFill>
+                  <a:srgbClr val="0B0B0B"/>
+                </a:solidFill>
+                <a:latin typeface="Arial"/>
+              </a:rPr>
+              <a:t>new:</a:t>
+            </a:r>
+            <a:r>
+              <a:rPr sz="2460" b="0" i="0">
+                <a:solidFill>
+                  <a:srgbClr val="0B0B0B"/>
+                </a:solidFill>
+                <a:latin typeface="Arial"/>
+              </a:rPr>
+              <a:t> </a:t>
+            </a:r>
+            <a:r>
+              <a:rPr sz="2460" b="0" i="0">
+                <a:solidFill>
+                  <a:srgbClr val="0B0B0B"/>
+                </a:solidFill>
+                <a:latin typeface="Arial"/>
+              </a:rPr>
+              <a:t>on</a:t>
+            </a:r>
+            <a:r>
+              <a:rPr sz="2460" b="0" i="0">
+                <a:solidFill>
+                  <a:srgbClr val="0B0B0B"/>
+                </a:solidFill>
+                <a:latin typeface="Arial"/>
+              </a:rPr>
+              <a:t> </a:t>
+            </a:r>
+            <a:r>
+              <a:rPr sz="2460" b="0" i="0">
+                <a:solidFill>
+                  <a:srgbClr val="0B0B0B"/>
+                </a:solidFill>
+                <a:latin typeface="Arial"/>
+              </a:rPr>
+              <a:t>300</a:t>
+            </a:r>
+            <a:r>
+              <a:rPr sz="2460" b="0" i="0">
+                <a:solidFill>
+                  <a:srgbClr val="0B0B0B"/>
+                </a:solidFill>
+                <a:latin typeface="Arial"/>
+              </a:rPr>
+              <a:t> </a:t>
+            </a:r>
+            <a:r>
+              <a:rPr sz="2460" b="0" i="0">
+                <a:solidFill>
+                  <a:srgbClr val="0B0B0B"/>
+                </a:solidFill>
+                <a:latin typeface="Arial"/>
+              </a:rPr>
+              <a:t>perturbed</a:t>
+            </a:r>
+            <a:r>
+              <a:rPr sz="2460" b="0" i="0">
+                <a:solidFill>
+                  <a:srgbClr val="0B0B0B"/>
+                </a:solidFill>
+                <a:latin typeface="Arial"/>
+              </a:rPr>
+              <a:t> </a:t>
+            </a:r>
+            <a:r>
+              <a:rPr sz="2460" b="0" i="0">
+                <a:solidFill>
+                  <a:srgbClr val="0B0B0B"/>
+                </a:solidFill>
+                <a:latin typeface="Arial"/>
+              </a:rPr>
+              <a:t>shapes</a:t>
+            </a:r>
+            <a:r>
+              <a:rPr sz="2460" b="0" i="0">
+                <a:solidFill>
+                  <a:srgbClr val="0B0B0B"/>
+                </a:solidFill>
+                <a:latin typeface="Arial"/>
+              </a:rPr>
+              <a:t> </a:t>
+            </a:r>
+            <a:r>
+              <a:rPr sz="2460" b="0" i="0">
+                <a:solidFill>
+                  <a:srgbClr val="0B0B0B"/>
+                </a:solidFill>
+                <a:latin typeface="Arial"/>
+              </a:rPr>
+              <a:t>native</a:t>
+            </a:r>
+            <a:r>
+              <a:rPr sz="2460" b="0" i="0">
+                <a:solidFill>
+                  <a:srgbClr val="0B0B0B"/>
+                </a:solidFill>
+                <a:latin typeface="Arial"/>
+              </a:rPr>
+              <a:t> </a:t>
+            </a:r>
+            <a:r>
+              <a:rPr sz="2460" b="0" i="0">
+                <a:solidFill>
+                  <a:srgbClr val="0B0B0B"/>
+                </a:solidFill>
+                <a:latin typeface="Arial"/>
+              </a:rPr>
               <a:t>reproduces</a:t>
             </a:r>
             <a:r>
@@ -12311,168 +12311,6 @@
                 <a:latin typeface="Arial"/>
               </a:rPr>
               <a:t>it</a:t>
-            </a:r>
-            <a:r>
-              <a:rPr sz="2460" b="0" i="0">
-                <a:solidFill>
-                  <a:srgbClr val="0B0B0B"/>
-                </a:solidFill>
-                <a:latin typeface="Arial"/>
-              </a:rPr>
-              <a:t> </a:t>
-            </a:r>
-            <a:r>
-              <a:rPr sz="2460" b="0" i="0">
-                <a:solidFill>
-                  <a:srgbClr val="0B0B0B"/>
-                </a:solidFill>
-                <a:latin typeface="Arial"/>
-              </a:rPr>
-              <a:t>7</a:t>
-            </a:r>
-            <a:r>
-              <a:rPr sz="2460" b="0" i="0">
-                <a:solidFill>
-                  <a:srgbClr val="0B0B0B"/>
-                </a:solidFill>
-                <a:latin typeface="Arial"/>
-              </a:rPr>
-              <a:t> </a:t>
-            </a:r>
-            <a:r>
-              <a:rPr sz="2460" b="0" i="0">
-                <a:solidFill>
-                  <a:srgbClr val="0B0B0B"/>
-                </a:solidFill>
-                <a:latin typeface="Arial"/>
-              </a:rPr>
-              <a:t>times,</a:t>
-            </a:r>
-            <a:r>
-              <a:rPr sz="2460" b="0" i="0">
-                <a:solidFill>
-                  <a:srgbClr val="0B0B0B"/>
-                </a:solidFill>
-                <a:latin typeface="Arial"/>
-              </a:rPr>
-              <a:t> </a:t>
-            </a:r>
-            <a:r>
-              <a:rPr sz="2460" b="0" i="0">
-                <a:solidFill>
-                  <a:srgbClr val="0B0B0B"/>
-                </a:solidFill>
-                <a:latin typeface="Arial"/>
-              </a:rPr>
-              <a:t>the</a:t>
-            </a:r>
-            <a:r>
-              <a:rPr sz="2460" b="0" i="0">
-                <a:solidFill>
-                  <a:srgbClr val="0B0B0B"/>
-                </a:solidFill>
-                <a:latin typeface="Arial"/>
-              </a:rPr>
-              <a:t> </a:t>
-            </a:r>
-            <a:r>
-              <a:rPr sz="2460" b="0" i="0">
-                <a:solidFill>
-                  <a:srgbClr val="0B0B0B"/>
-                </a:solidFill>
-                <a:latin typeface="Arial"/>
-              </a:rPr>
-              <a:t>best</a:t>
-            </a:r>
-            <a:r>
-              <a:rPr sz="2460" b="0" i="0">
-                <a:solidFill>
-                  <a:srgbClr val="0B0B0B"/>
-                </a:solidFill>
-                <a:latin typeface="Arial"/>
-              </a:rPr>
-              <a:t> </a:t>
-            </a:r>
-            <a:r>
-              <a:rPr sz="2460" b="0" i="0">
-                <a:solidFill>
-                  <a:srgbClr val="0B0B0B"/>
-                </a:solidFill>
-                <a:latin typeface="Arial"/>
-              </a:rPr>
-              <a:t>existing</a:t>
-            </a:r>
-            <a:r>
-              <a:rPr sz="2460" b="0" i="0">
-                <a:solidFill>
-                  <a:srgbClr val="0B0B0B"/>
-                </a:solidFill>
-                <a:latin typeface="Arial"/>
-              </a:rPr>
-              <a:t> </a:t>
-            </a:r>
-            <a:r>
-              <a:rPr sz="2460" b="0" i="0">
-                <a:solidFill>
-                  <a:srgbClr val="0B0B0B"/>
-                </a:solidFill>
-                <a:latin typeface="Arial"/>
-              </a:rPr>
-              <a:t>constructor</a:t>
-            </a:r>
-            <a:r>
-              <a:rPr sz="2460" b="0" i="0">
-                <a:solidFill>
-                  <a:srgbClr val="0B0B0B"/>
-                </a:solidFill>
-                <a:latin typeface="Arial"/>
-              </a:rPr>
-              <a:t> </a:t>
-            </a:r>
-            <a:r>
-              <a:rPr sz="2460" b="0" i="0">
-                <a:solidFill>
-                  <a:srgbClr val="0B0B0B"/>
-                </a:solidFill>
-                <a:latin typeface="Arial"/>
-              </a:rPr>
-              <a:t>8).</a:t>
-            </a:r>
-            <a:r>
-              <a:rPr sz="2460" b="0" i="0">
-                <a:solidFill>
-                  <a:srgbClr val="0B0B0B"/>
-                </a:solidFill>
-                <a:latin typeface="Arial"/>
-              </a:rPr>
-              <a:t> </a:t>
-            </a:r>
-            <a:r>
-              <a:rPr sz="2460" b="0" i="0">
-                <a:solidFill>
-                  <a:srgbClr val="0B0B0B"/>
-                </a:solidFill>
-                <a:latin typeface="Arial"/>
-              </a:rPr>
-              <a:t>All</a:t>
-            </a:r>
-            <a:r>
-              <a:rPr sz="2460" b="0" i="0">
-                <a:solidFill>
-                  <a:srgbClr val="0B0B0B"/>
-                </a:solidFill>
-                <a:latin typeface="Arial"/>
-              </a:rPr>
-              <a:t> </a:t>
-            </a:r>
-            <a:r>
-              <a:rPr sz="2460" b="0" i="0">
-                <a:solidFill>
-                  <a:srgbClr val="0B0B0B"/>
-                </a:solidFill>
-                <a:latin typeface="Arial"/>
-              </a:rPr>
-              <a:t>3</a:t>
             </a:r>
           </a:p>
         </p:txBody>
@@ -12486,7 +12324,7 @@
         <p:spPr>
           <a:xfrm>
             <a:off x="21119515" y="24884290"/>
-            <a:ext cx="8276869" cy="312515"/>
+            <a:ext cx="8276866" cy="312515"/>
           </a:xfrm>
           <a:prstGeom prst="rect">
             <a:avLst/>
@@ -12506,25 +12344,169 @@
                 </a:solidFill>
                 <a:latin typeface="Arial"/>
               </a:rPr>
-              <a:t>folds rebuild it and predict exactly.</a:t>
-            </a:r>
-            <a:r>
-              <a:rPr sz="2460" b="0" i="0">
-                <a:solidFill>
-                  <a:srgbClr val="0B0B0B"/>
-                </a:solidFill>
-                <a:latin typeface="Arial"/>
-              </a:rPr>
-              <a:t> </a:t>
-            </a:r>
-            <a:r>
-              <a:rPr sz="2460" b="0" i="0">
-                <a:solidFill>
-                  <a:srgbClr val="0B0B0B"/>
-                </a:solidFill>
-                <a:latin typeface="Arial"/>
-              </a:rPr>
-              <a:t>The committed answer is</a:t>
+              <a:t>7</a:t>
+            </a:r>
+            <a:r>
+              <a:rPr sz="2460" b="0" i="0">
+                <a:solidFill>
+                  <a:srgbClr val="0B0B0B"/>
+                </a:solidFill>
+                <a:latin typeface="Arial"/>
+              </a:rPr>
+              <a:t> </a:t>
+            </a:r>
+            <a:r>
+              <a:rPr sz="2460" b="0" i="0">
+                <a:solidFill>
+                  <a:srgbClr val="0B0B0B"/>
+                </a:solidFill>
+                <a:latin typeface="Arial"/>
+              </a:rPr>
+              <a:t>times,</a:t>
+            </a:r>
+            <a:r>
+              <a:rPr sz="2460" b="0" i="0">
+                <a:solidFill>
+                  <a:srgbClr val="0B0B0B"/>
+                </a:solidFill>
+                <a:latin typeface="Arial"/>
+              </a:rPr>
+              <a:t> </a:t>
+            </a:r>
+            <a:r>
+              <a:rPr sz="2460" b="0" i="0">
+                <a:solidFill>
+                  <a:srgbClr val="0B0B0B"/>
+                </a:solidFill>
+                <a:latin typeface="Arial"/>
+              </a:rPr>
+              <a:t>the</a:t>
+            </a:r>
+            <a:r>
+              <a:rPr sz="2460" b="0" i="0">
+                <a:solidFill>
+                  <a:srgbClr val="0B0B0B"/>
+                </a:solidFill>
+                <a:latin typeface="Arial"/>
+              </a:rPr>
+              <a:t> </a:t>
+            </a:r>
+            <a:r>
+              <a:rPr sz="2460" b="0" i="0">
+                <a:solidFill>
+                  <a:srgbClr val="0B0B0B"/>
+                </a:solidFill>
+                <a:latin typeface="Arial"/>
+              </a:rPr>
+              <a:t>best</a:t>
+            </a:r>
+            <a:r>
+              <a:rPr sz="2460" b="0" i="0">
+                <a:solidFill>
+                  <a:srgbClr val="0B0B0B"/>
+                </a:solidFill>
+                <a:latin typeface="Arial"/>
+              </a:rPr>
+              <a:t> </a:t>
+            </a:r>
+            <a:r>
+              <a:rPr sz="2460" b="0" i="0">
+                <a:solidFill>
+                  <a:srgbClr val="0B0B0B"/>
+                </a:solidFill>
+                <a:latin typeface="Arial"/>
+              </a:rPr>
+              <a:t>existing</a:t>
+            </a:r>
+            <a:r>
+              <a:rPr sz="2460" b="0" i="0">
+                <a:solidFill>
+                  <a:srgbClr val="0B0B0B"/>
+                </a:solidFill>
+                <a:latin typeface="Arial"/>
+              </a:rPr>
+              <a:t> </a:t>
+            </a:r>
+            <a:r>
+              <a:rPr sz="2460" b="0" i="0">
+                <a:solidFill>
+                  <a:srgbClr val="0B0B0B"/>
+                </a:solidFill>
+                <a:latin typeface="Arial"/>
+              </a:rPr>
+              <a:t>constructor</a:t>
+            </a:r>
+            <a:r>
+              <a:rPr sz="2460" b="0" i="0">
+                <a:solidFill>
+                  <a:srgbClr val="0B0B0B"/>
+                </a:solidFill>
+                <a:latin typeface="Arial"/>
+              </a:rPr>
+              <a:t> </a:t>
+            </a:r>
+            <a:r>
+              <a:rPr sz="2460" b="0" i="0">
+                <a:solidFill>
+                  <a:srgbClr val="0B0B0B"/>
+                </a:solidFill>
+                <a:latin typeface="Arial"/>
+              </a:rPr>
+              <a:t>8.</a:t>
+            </a:r>
+            <a:r>
+              <a:rPr sz="2460" b="0" i="0">
+                <a:solidFill>
+                  <a:srgbClr val="0B0B0B"/>
+                </a:solidFill>
+                <a:latin typeface="Arial"/>
+              </a:rPr>
+              <a:t> </a:t>
+            </a:r>
+            <a:r>
+              <a:rPr sz="2460" b="0" i="0">
+                <a:solidFill>
+                  <a:srgbClr val="0B0B0B"/>
+                </a:solidFill>
+                <a:latin typeface="Arial"/>
+              </a:rPr>
+              <a:t>The</a:t>
+            </a:r>
+            <a:r>
+              <a:rPr sz="2460" b="0" i="0">
+                <a:solidFill>
+                  <a:srgbClr val="0B0B0B"/>
+                </a:solidFill>
+                <a:latin typeface="Arial"/>
+              </a:rPr>
+              <a:t> </a:t>
+            </a:r>
+            <a:r>
+              <a:rPr sz="2460" b="0" i="0">
+                <a:solidFill>
+                  <a:srgbClr val="0B0B0B"/>
+                </a:solidFill>
+                <a:latin typeface="Arial"/>
+              </a:rPr>
+              <a:t>task’s</a:t>
+            </a:r>
+            <a:r>
+              <a:rPr sz="2460" b="0" i="0">
+                <a:solidFill>
+                  <a:srgbClr val="0B0B0B"/>
+                </a:solidFill>
+                <a:latin typeface="Arial"/>
+              </a:rPr>
+              <a:t> </a:t>
+            </a:r>
+            <a:r>
+              <a:rPr sz="2460" b="0" i="0">
+                <a:solidFill>
+                  <a:srgbClr val="0B0B0B"/>
+                </a:solidFill>
+                <a:latin typeface="Arial"/>
+              </a:rPr>
+              <a:t>planted</a:t>
             </a:r>
           </a:p>
         </p:txBody>
@@ -12538,7 +12520,7 @@
         <p:spPr>
           <a:xfrm>
             <a:off x="21119515" y="25289166"/>
-            <a:ext cx="7395264" cy="312515"/>
+            <a:ext cx="8276879" cy="312515"/>
           </a:xfrm>
           <a:prstGeom prst="rect">
             <a:avLst/>
@@ -12558,7 +12540,205 @@
                 </a:solidFill>
                 <a:latin typeface="Arial"/>
               </a:rPr>
-              <a:t>correct, and removing the operator removes the gain.</a:t>
+              <a:t>second</a:t>
+            </a:r>
+            <a:r>
+              <a:rPr sz="2460" b="0" i="0">
+                <a:solidFill>
+                  <a:srgbClr val="0B0B0B"/>
+                </a:solidFill>
+                <a:latin typeface="Arial"/>
+              </a:rPr>
+              <a:t> </a:t>
+            </a:r>
+            <a:r>
+              <a:rPr sz="2460" b="0" i="0">
+                <a:solidFill>
+                  <a:srgbClr val="0B0B0B"/>
+                </a:solidFill>
+                <a:latin typeface="Arial"/>
+              </a:rPr>
+              <a:t>step</a:t>
+            </a:r>
+            <a:r>
+              <a:rPr sz="2460" b="0" i="0">
+                <a:solidFill>
+                  <a:srgbClr val="0B0B0B"/>
+                </a:solidFill>
+                <a:latin typeface="Arial"/>
+              </a:rPr>
+              <a:t> </a:t>
+            </a:r>
+            <a:r>
+              <a:rPr sz="2460" b="0" i="0">
+                <a:solidFill>
+                  <a:srgbClr val="0B0B0B"/>
+                </a:solidFill>
+                <a:latin typeface="Arial"/>
+              </a:rPr>
+              <a:t>adds</a:t>
+            </a:r>
+            <a:r>
+              <a:rPr sz="2460" b="0" i="0">
+                <a:solidFill>
+                  <a:srgbClr val="0B0B0B"/>
+                </a:solidFill>
+                <a:latin typeface="Arial"/>
+              </a:rPr>
+              <a:t> </a:t>
+            </a:r>
+            <a:r>
+              <a:rPr sz="2460" b="0" i="0">
+                <a:solidFill>
+                  <a:srgbClr val="0B0B0B"/>
+                </a:solidFill>
+                <a:latin typeface="Arial"/>
+              </a:rPr>
+              <a:t>nothing</a:t>
+            </a:r>
+            <a:r>
+              <a:rPr sz="2460" b="0" i="0">
+                <a:solidFill>
+                  <a:srgbClr val="0B0B0B"/>
+                </a:solidFill>
+                <a:latin typeface="Arial"/>
+              </a:rPr>
+              <a:t> </a:t>
+            </a:r>
+            <a:r>
+              <a:rPr sz="2460" b="0" i="0">
+                <a:solidFill>
+                  <a:srgbClr val="0B0B0B"/>
+                </a:solidFill>
+                <a:latin typeface="Arial"/>
+              </a:rPr>
+              <a:t>on</a:t>
+            </a:r>
+            <a:r>
+              <a:rPr sz="2460" b="0" i="0">
+                <a:solidFill>
+                  <a:srgbClr val="0B0B0B"/>
+                </a:solidFill>
+                <a:latin typeface="Arial"/>
+              </a:rPr>
+              <a:t> </a:t>
+            </a:r>
+            <a:r>
+              <a:rPr sz="2460" b="0" i="0">
+                <a:solidFill>
+                  <a:srgbClr val="0B0B0B"/>
+                </a:solidFill>
+                <a:latin typeface="Arial"/>
+              </a:rPr>
+              <a:t>its</a:t>
+            </a:r>
+            <a:r>
+              <a:rPr sz="2460" b="0" i="0">
+                <a:solidFill>
+                  <a:srgbClr val="0B0B0B"/>
+                </a:solidFill>
+                <a:latin typeface="Arial"/>
+              </a:rPr>
+              <a:t> </a:t>
+            </a:r>
+            <a:r>
+              <a:rPr sz="2460" b="0" i="0">
+                <a:solidFill>
+                  <a:srgbClr val="0B0B0B"/>
+                </a:solidFill>
+                <a:latin typeface="Arial"/>
+              </a:rPr>
+              <a:t>shapes,</a:t>
+            </a:r>
+            <a:r>
+              <a:rPr sz="2460" b="0" i="0">
+                <a:solidFill>
+                  <a:srgbClr val="0B0B0B"/>
+                </a:solidFill>
+                <a:latin typeface="Arial"/>
+              </a:rPr>
+              <a:t> </a:t>
+            </a:r>
+            <a:r>
+              <a:rPr sz="2460" b="0" i="0">
+                <a:solidFill>
+                  <a:srgbClr val="0B0B0B"/>
+                </a:solidFill>
+                <a:latin typeface="Arial"/>
+              </a:rPr>
+              <a:t>so</a:t>
+            </a:r>
+            <a:r>
+              <a:rPr sz="2460" b="0" i="0">
+                <a:solidFill>
+                  <a:srgbClr val="0B0B0B"/>
+                </a:solidFill>
+                <a:latin typeface="Arial"/>
+              </a:rPr>
+              <a:t> </a:t>
+            </a:r>
+            <a:r>
+              <a:rPr sz="2460" b="0" i="0">
+                <a:solidFill>
+                  <a:srgbClr val="0B0B0B"/>
+                </a:solidFill>
+                <a:latin typeface="Arial"/>
+              </a:rPr>
+              <a:t>this</a:t>
+            </a:r>
+            <a:r>
+              <a:rPr sz="2460" b="0" i="0">
+                <a:solidFill>
+                  <a:srgbClr val="0B0B0B"/>
+                </a:solidFill>
+                <a:latin typeface="Arial"/>
+              </a:rPr>
+              <a:t> </a:t>
+            </a:r>
+            <a:r>
+              <a:rPr sz="2460" b="0" i="0">
+                <a:solidFill>
+                  <a:srgbClr val="0B0B0B"/>
+                </a:solidFill>
+                <a:latin typeface="Arial"/>
+              </a:rPr>
+              <a:t>is</a:t>
+            </a:r>
+            <a:r>
+              <a:rPr sz="2460" b="0" i="0">
+                <a:solidFill>
+                  <a:srgbClr val="0B0B0B"/>
+                </a:solidFill>
+                <a:latin typeface="Arial"/>
+              </a:rPr>
+              <a:t> </a:t>
+            </a:r>
+            <a:r>
+              <a:rPr sz="2460" b="0" i="0">
+                <a:solidFill>
+                  <a:srgbClr val="0B0B0B"/>
+                </a:solidFill>
+                <a:latin typeface="Arial"/>
+              </a:rPr>
+              <a:t>not</a:t>
+            </a:r>
+            <a:r>
+              <a:rPr sz="2460" b="0" i="0">
+                <a:solidFill>
+                  <a:srgbClr val="0B0B0B"/>
+                </a:solidFill>
+                <a:latin typeface="Arial"/>
+              </a:rPr>
+              <a:t> </a:t>
+            </a:r>
+            <a:r>
+              <a:rPr sz="2460" b="0" i="0">
+                <a:solidFill>
+                  <a:srgbClr val="0B0B0B"/>
+                </a:solidFill>
+                <a:latin typeface="Arial"/>
+              </a:rPr>
+              <a:t>a</a:t>
             </a:r>
           </a:p>
         </p:txBody>
@@ -12571,8 +12751,8 @@
         </p:nvSpPr>
         <p:spPr>
           <a:xfrm>
-            <a:off x="20946884" y="25772172"/>
-            <a:ext cx="8449684" cy="312517"/>
+            <a:off x="21119515" y="25694042"/>
+            <a:ext cx="8276873" cy="312515"/>
           </a:xfrm>
           <a:prstGeom prst="rect">
             <a:avLst/>
@@ -12592,151 +12772,187 @@
                 </a:solidFill>
                 <a:latin typeface="Arial"/>
               </a:rPr>
-              <a:t>• 27</a:t>
-            </a:r>
-            <a:r>
-              <a:rPr sz="2460" b="0" i="0">
-                <a:solidFill>
-                  <a:srgbClr val="0B0B0B"/>
-                </a:solidFill>
-                <a:latin typeface="Arial"/>
-              </a:rPr>
-              <a:t> </a:t>
-            </a:r>
-            <a:r>
-              <a:rPr sz="2460" b="0" i="0">
-                <a:solidFill>
-                  <a:srgbClr val="0B0B0B"/>
-                </a:solidFill>
-                <a:latin typeface="Arial"/>
-              </a:rPr>
-              <a:t>development</a:t>
-            </a:r>
-            <a:r>
-              <a:rPr sz="2460" b="0" i="0">
-                <a:solidFill>
-                  <a:srgbClr val="0B0B0B"/>
-                </a:solidFill>
-                <a:latin typeface="Arial"/>
-              </a:rPr>
-              <a:t> </a:t>
-            </a:r>
-            <a:r>
-              <a:rPr sz="2460" b="0" i="0">
-                <a:solidFill>
-                  <a:srgbClr val="0B0B0B"/>
-                </a:solidFill>
-                <a:latin typeface="Arial"/>
-              </a:rPr>
-              <a:t>tasks:</a:t>
-            </a:r>
-            <a:r>
-              <a:rPr sz="2460" b="0" i="0">
-                <a:solidFill>
-                  <a:srgbClr val="0B0B0B"/>
-                </a:solidFill>
-                <a:latin typeface="Arial"/>
-              </a:rPr>
-              <a:t> </a:t>
-            </a:r>
-            <a:r>
-              <a:rPr sz="2460" b="0" i="0">
-                <a:solidFill>
-                  <a:srgbClr val="0B0B0B"/>
-                </a:solidFill>
-                <a:latin typeface="Arial"/>
-              </a:rPr>
-              <a:t>0</a:t>
-            </a:r>
-            <a:r>
-              <a:rPr sz="2460" b="0" i="0">
-                <a:solidFill>
-                  <a:srgbClr val="0B0B0B"/>
-                </a:solidFill>
-                <a:latin typeface="Arial"/>
-              </a:rPr>
-              <a:t> </a:t>
-            </a:r>
-            <a:r>
-              <a:rPr sz="2460" b="0" i="0">
-                <a:solidFill>
-                  <a:srgbClr val="0B0B0B"/>
-                </a:solidFill>
-                <a:latin typeface="Arial"/>
-              </a:rPr>
-              <a:t>wrong</a:t>
-            </a:r>
-            <a:r>
-              <a:rPr sz="2460" b="0" i="0">
-                <a:solidFill>
-                  <a:srgbClr val="0B0B0B"/>
-                </a:solidFill>
-                <a:latin typeface="Arial"/>
-              </a:rPr>
-              <a:t> </a:t>
-            </a:r>
-            <a:r>
-              <a:rPr sz="2460" b="0" i="0">
-                <a:solidFill>
-                  <a:srgbClr val="0B0B0B"/>
-                </a:solidFill>
-                <a:latin typeface="Arial"/>
-              </a:rPr>
-              <a:t>certificates,</a:t>
-            </a:r>
-            <a:r>
-              <a:rPr sz="2460" b="0" i="0">
-                <a:solidFill>
-                  <a:srgbClr val="0B0B0B"/>
-                </a:solidFill>
-                <a:latin typeface="Arial"/>
-              </a:rPr>
-              <a:t> </a:t>
-            </a:r>
-            <a:r>
-              <a:rPr sz="2460" b="0" i="0">
-                <a:solidFill>
-                  <a:srgbClr val="0B0B0B"/>
-                </a:solidFill>
-                <a:latin typeface="Arial"/>
-              </a:rPr>
-              <a:t>0</a:t>
-            </a:r>
-            <a:r>
-              <a:rPr sz="2460" b="0" i="0">
-                <a:solidFill>
-                  <a:srgbClr val="0B0B0B"/>
-                </a:solidFill>
-                <a:latin typeface="Arial"/>
-              </a:rPr>
-              <a:t> </a:t>
-            </a:r>
-            <a:r>
-              <a:rPr sz="2460" b="0" i="0">
-                <a:solidFill>
-                  <a:srgbClr val="0B0B0B"/>
-                </a:solidFill>
-                <a:latin typeface="Arial"/>
-              </a:rPr>
-              <a:t>lost</a:t>
-            </a:r>
-            <a:r>
-              <a:rPr sz="2460" b="0" i="0">
-                <a:solidFill>
-                  <a:srgbClr val="0B0B0B"/>
-                </a:solidFill>
-                <a:latin typeface="Arial"/>
-              </a:rPr>
-              <a:t> </a:t>
-            </a:r>
-            <a:r>
-              <a:rPr sz="2460" b="0" i="0">
-                <a:solidFill>
-                  <a:srgbClr val="0B0B0B"/>
-                </a:solidFill>
-                <a:latin typeface="Arial"/>
-              </a:rPr>
-              <a:t>answers.</a:t>
+              <a:t>two-step</a:t>
+            </a:r>
+            <a:r>
+              <a:rPr sz="2460" b="0" i="0">
+                <a:solidFill>
+                  <a:srgbClr val="0B0B0B"/>
+                </a:solidFill>
+                <a:latin typeface="Arial"/>
+              </a:rPr>
+              <a:t> </a:t>
+            </a:r>
+            <a:r>
+              <a:rPr sz="2460" b="0" i="0">
+                <a:solidFill>
+                  <a:srgbClr val="0B0B0B"/>
+                </a:solidFill>
+                <a:latin typeface="Arial"/>
+              </a:rPr>
+              <a:t>rule.</a:t>
+            </a:r>
+            <a:r>
+              <a:rPr sz="2460" b="0" i="0">
+                <a:solidFill>
+                  <a:srgbClr val="0B0B0B"/>
+                </a:solidFill>
+                <a:latin typeface="Arial"/>
+              </a:rPr>
+              <a:t> </a:t>
+            </a:r>
+            <a:r>
+              <a:rPr sz="2460" b="0" i="0">
+                <a:solidFill>
+                  <a:srgbClr val="0B0B0B"/>
+                </a:solidFill>
+                <a:latin typeface="Arial"/>
+              </a:rPr>
+              <a:t>All</a:t>
+            </a:r>
+            <a:r>
+              <a:rPr sz="2460" b="0" i="0">
+                <a:solidFill>
+                  <a:srgbClr val="0B0B0B"/>
+                </a:solidFill>
+                <a:latin typeface="Arial"/>
+              </a:rPr>
+              <a:t> </a:t>
+            </a:r>
+            <a:r>
+              <a:rPr sz="2460" b="0" i="0">
+                <a:solidFill>
+                  <a:srgbClr val="0B0B0B"/>
+                </a:solidFill>
+                <a:latin typeface="Arial"/>
+              </a:rPr>
+              <a:t>3</a:t>
+            </a:r>
+            <a:r>
+              <a:rPr sz="2460" b="0" i="0">
+                <a:solidFill>
+                  <a:srgbClr val="0B0B0B"/>
+                </a:solidFill>
+                <a:latin typeface="Arial"/>
+              </a:rPr>
+              <a:t> </a:t>
+            </a:r>
+            <a:r>
+              <a:rPr sz="2460" b="0" i="0">
+                <a:solidFill>
+                  <a:srgbClr val="0B0B0B"/>
+                </a:solidFill>
+                <a:latin typeface="Arial"/>
+              </a:rPr>
+              <a:t>folds</a:t>
+            </a:r>
+            <a:r>
+              <a:rPr sz="2460" b="0" i="0">
+                <a:solidFill>
+                  <a:srgbClr val="0B0B0B"/>
+                </a:solidFill>
+                <a:latin typeface="Arial"/>
+              </a:rPr>
+              <a:t> </a:t>
+            </a:r>
+            <a:r>
+              <a:rPr sz="2460" b="0" i="0">
+                <a:solidFill>
+                  <a:srgbClr val="0B0B0B"/>
+                </a:solidFill>
+                <a:latin typeface="Arial"/>
+              </a:rPr>
+              <a:t>rebuild</a:t>
+            </a:r>
+            <a:r>
+              <a:rPr sz="2460" b="0" i="0">
+                <a:solidFill>
+                  <a:srgbClr val="0B0B0B"/>
+                </a:solidFill>
+                <a:latin typeface="Arial"/>
+              </a:rPr>
+              <a:t> </a:t>
+            </a:r>
+            <a:r>
+              <a:rPr sz="2460" b="0" i="0">
+                <a:solidFill>
+                  <a:srgbClr val="0B0B0B"/>
+                </a:solidFill>
+                <a:latin typeface="Arial"/>
+              </a:rPr>
+              <a:t>it</a:t>
+            </a:r>
+            <a:r>
+              <a:rPr sz="2460" b="0" i="0">
+                <a:solidFill>
+                  <a:srgbClr val="0B0B0B"/>
+                </a:solidFill>
+                <a:latin typeface="Arial"/>
+              </a:rPr>
+              <a:t> </a:t>
+            </a:r>
+            <a:r>
+              <a:rPr sz="2460" b="0" i="0">
+                <a:solidFill>
+                  <a:srgbClr val="0B0B0B"/>
+                </a:solidFill>
+                <a:latin typeface="Arial"/>
+              </a:rPr>
+              <a:t>and</a:t>
+            </a:r>
+            <a:r>
+              <a:rPr sz="2460" b="0" i="0">
+                <a:solidFill>
+                  <a:srgbClr val="0B0B0B"/>
+                </a:solidFill>
+                <a:latin typeface="Arial"/>
+              </a:rPr>
+              <a:t> </a:t>
+            </a:r>
+            <a:r>
+              <a:rPr sz="2460" b="0" i="0">
+                <a:solidFill>
+                  <a:srgbClr val="0B0B0B"/>
+                </a:solidFill>
+                <a:latin typeface="Arial"/>
+              </a:rPr>
+              <a:t>predict</a:t>
+            </a:r>
+            <a:r>
+              <a:rPr sz="2460" b="0" i="0">
+                <a:solidFill>
+                  <a:srgbClr val="0B0B0B"/>
+                </a:solidFill>
+                <a:latin typeface="Arial"/>
+              </a:rPr>
+              <a:t> </a:t>
+            </a:r>
+            <a:r>
+              <a:rPr sz="2460" b="0" i="0">
+                <a:solidFill>
+                  <a:srgbClr val="0B0B0B"/>
+                </a:solidFill>
+                <a:latin typeface="Arial"/>
+              </a:rPr>
+              <a:t>exactly.</a:t>
+            </a:r>
+            <a:r>
+              <a:rPr sz="2460" b="0" i="0">
+                <a:solidFill>
+                  <a:srgbClr val="0B0B0B"/>
+                </a:solidFill>
+                <a:latin typeface="Arial"/>
+              </a:rPr>
+              <a:t> </a:t>
+            </a:r>
+            <a:r>
+              <a:rPr sz="2460" b="0" i="0">
+                <a:solidFill>
+                  <a:srgbClr val="0B0B0B"/>
+                </a:solidFill>
+                <a:latin typeface="Arial"/>
+              </a:rPr>
+              <a:t>The</a:t>
             </a:r>
           </a:p>
         </p:txBody>
@@ -12749,8 +12965,8 @@
         </p:nvSpPr>
         <p:spPr>
           <a:xfrm>
-            <a:off x="21119515" y="26177059"/>
-            <a:ext cx="4280099" cy="312517"/>
+            <a:off x="21119515" y="26098930"/>
+            <a:ext cx="8276873" cy="312517"/>
           </a:xfrm>
           <a:prstGeom prst="rect">
             <a:avLst/>
@@ -12770,25 +12986,25 @@
                 </a:solidFill>
                 <a:latin typeface="Arial"/>
               </a:rPr>
-              <a:t>Matched extra search:</a:t>
-            </a:r>
-            <a:r>
-              <a:rPr sz="2460" b="0" i="0">
-                <a:solidFill>
-                  <a:srgbClr val="0B0B0B"/>
-                </a:solidFill>
-                <a:latin typeface="Arial"/>
-              </a:rPr>
-              <a:t> </a:t>
-            </a:r>
-            <a:r>
-              <a:rPr sz="2460" b="0" i="0">
-                <a:solidFill>
-                  <a:srgbClr val="0B0B0B"/>
-                </a:solidFill>
-                <a:latin typeface="Arial"/>
-              </a:rPr>
-              <a:t>0 of 15.</a:t>
+              <a:t>committed answer is correct,</a:t>
+            </a:r>
+            <a:r>
+              <a:rPr sz="2460" b="0" i="0">
+                <a:solidFill>
+                  <a:srgbClr val="0B0B0B"/>
+                </a:solidFill>
+                <a:latin typeface="Arial"/>
+              </a:rPr>
+              <a:t> </a:t>
+            </a:r>
+            <a:r>
+              <a:rPr sz="2460" b="0" i="0">
+                <a:solidFill>
+                  <a:srgbClr val="0B0B0B"/>
+                </a:solidFill>
+                <a:latin typeface="Arial"/>
+              </a:rPr>
+              <a:t>and removing the operator re-</a:t>
             </a:r>
           </a:p>
         </p:txBody>
@@ -12801,8 +13017,8 @@
         </p:nvSpPr>
         <p:spPr>
           <a:xfrm>
-            <a:off x="20946884" y="26660068"/>
-            <a:ext cx="8449532" cy="312774"/>
+            <a:off x="21119515" y="26503805"/>
+            <a:ext cx="2244360" cy="312517"/>
           </a:xfrm>
           <a:prstGeom prst="rect">
             <a:avLst/>
@@ -12822,196 +13038,7 @@
                 </a:solidFill>
                 <a:latin typeface="Arial"/>
               </a:rPr>
-              <a:t>•</a:t>
-            </a:r>
-            <a:r>
-              <a:rPr sz="2460" b="1" i="0">
-                <a:solidFill>
-                  <a:srgbClr val="0B0B0B"/>
-                </a:solidFill>
-                <a:latin typeface="Arial"/>
-              </a:rPr>
-              <a:t> Not</a:t>
-            </a:r>
-            <a:r>
-              <a:rPr sz="2460" b="1" i="0">
-                <a:solidFill>
-                  <a:srgbClr val="0B0B0B"/>
-                </a:solidFill>
-                <a:latin typeface="Arial"/>
-              </a:rPr>
-              <a:t> </a:t>
-            </a:r>
-            <a:r>
-              <a:rPr sz="2460" b="1" i="0">
-                <a:solidFill>
-                  <a:srgbClr val="0B0B0B"/>
-                </a:solidFill>
-                <a:latin typeface="Arial"/>
-              </a:rPr>
-              <a:t>yet</a:t>
-            </a:r>
-            <a:r>
-              <a:rPr sz="2460" b="1" i="0">
-                <a:solidFill>
-                  <a:srgbClr val="0B0B0B"/>
-                </a:solidFill>
-                <a:latin typeface="Arial"/>
-              </a:rPr>
-              <a:t> </a:t>
-            </a:r>
-            <a:r>
-              <a:rPr sz="2460" b="1" i="0">
-                <a:solidFill>
-                  <a:srgbClr val="0B0B0B"/>
-                </a:solidFill>
-                <a:latin typeface="Arial"/>
-              </a:rPr>
-              <a:t>shown:</a:t>
-            </a:r>
-            <a:r>
-              <a:rPr sz="2460" b="0" i="0">
-                <a:solidFill>
-                  <a:srgbClr val="0B0B0B"/>
-                </a:solidFill>
-                <a:latin typeface="Arial"/>
-              </a:rPr>
-              <a:t> </a:t>
-            </a:r>
-            <a:r>
-              <a:rPr sz="2460" b="0" i="0">
-                <a:solidFill>
-                  <a:srgbClr val="0B0B0B"/>
-                </a:solidFill>
-                <a:latin typeface="Arial"/>
-              </a:rPr>
-              <a:t>that</a:t>
-            </a:r>
-            <a:r>
-              <a:rPr sz="2460" b="0" i="0">
-                <a:solidFill>
-                  <a:srgbClr val="0B0B0B"/>
-                </a:solidFill>
-                <a:latin typeface="Arial"/>
-              </a:rPr>
-              <a:t> </a:t>
-            </a:r>
-            <a:r>
-              <a:rPr sz="2460" b="0" i="0">
-                <a:solidFill>
-                  <a:srgbClr val="0B0B0B"/>
-                </a:solidFill>
-                <a:latin typeface="Arial"/>
-              </a:rPr>
-              <a:t>the</a:t>
-            </a:r>
-            <a:r>
-              <a:rPr sz="2460" b="0" i="0">
-                <a:solidFill>
-                  <a:srgbClr val="0B0B0B"/>
-                </a:solidFill>
-                <a:latin typeface="Arial"/>
-              </a:rPr>
-              <a:t> </a:t>
-            </a:r>
-            <a:r>
-              <a:rPr sz="2460" b="0" i="0">
-                <a:solidFill>
-                  <a:srgbClr val="0B0B0B"/>
-                </a:solidFill>
-                <a:latin typeface="Arial"/>
-              </a:rPr>
-              <a:t>failure</a:t>
-            </a:r>
-            <a:r>
-              <a:rPr sz="2460" b="0" i="0">
-                <a:solidFill>
-                  <a:srgbClr val="0B0B0B"/>
-                </a:solidFill>
-                <a:latin typeface="Arial"/>
-              </a:rPr>
-              <a:t> </a:t>
-            </a:r>
-            <a:r>
-              <a:rPr sz="2460" b="0" i="0">
-                <a:solidFill>
-                  <a:srgbClr val="0B0B0B"/>
-                </a:solidFill>
-                <a:latin typeface="Arial"/>
-              </a:rPr>
-              <a:t>record</a:t>
-            </a:r>
-            <a:r>
-              <a:rPr sz="2460" b="0" i="0">
-                <a:solidFill>
-                  <a:srgbClr val="0B0B0B"/>
-                </a:solidFill>
-                <a:latin typeface="Arial"/>
-              </a:rPr>
-              <a:t> </a:t>
-            </a:r>
-            <a:r>
-              <a:rPr sz="2460" b="0" i="0">
-                <a:solidFill>
-                  <a:srgbClr val="0B0B0B"/>
-                </a:solidFill>
-                <a:latin typeface="Arial"/>
-              </a:rPr>
-              <a:t>is</a:t>
-            </a:r>
-            <a:r>
-              <a:rPr sz="2460" b="0" i="0">
-                <a:solidFill>
-                  <a:srgbClr val="0B0B0B"/>
-                </a:solidFill>
-                <a:latin typeface="Arial"/>
-              </a:rPr>
-              <a:t> </a:t>
-            </a:r>
-            <a:r>
-              <a:rPr sz="2460" b="0" i="0">
-                <a:solidFill>
-                  <a:srgbClr val="0B0B0B"/>
-                </a:solidFill>
-                <a:latin typeface="Arial"/>
-              </a:rPr>
-              <a:t>what</a:t>
-            </a:r>
-            <a:r>
-              <a:rPr sz="2460" b="0" i="0">
-                <a:solidFill>
-                  <a:srgbClr val="0B0B0B"/>
-                </a:solidFill>
-                <a:latin typeface="Arial"/>
-              </a:rPr>
-              <a:t> </a:t>
-            </a:r>
-            <a:r>
-              <a:rPr sz="2460" b="0" i="0">
-                <a:solidFill>
-                  <a:srgbClr val="0B0B0B"/>
-                </a:solidFill>
-                <a:latin typeface="Arial"/>
-              </a:rPr>
-              <a:t>matters.</a:t>
-            </a:r>
-            <a:r>
-              <a:rPr sz="2460" b="0" i="0">
-                <a:solidFill>
-                  <a:srgbClr val="0B0B0B"/>
-                </a:solidFill>
-                <a:latin typeface="Arial"/>
-              </a:rPr>
-              <a:t> </a:t>
-            </a:r>
-            <a:r>
-              <a:rPr sz="2460" b="0" i="0">
-                <a:solidFill>
-                  <a:srgbClr val="0B0B0B"/>
-                </a:solidFill>
-                <a:latin typeface="Arial"/>
-              </a:rPr>
-              <a:t>A</a:t>
+              <a:t>moves the gain.</a:t>
             </a:r>
           </a:p>
         </p:txBody>
@@ -13024,8 +13051,8 @@
         </p:nvSpPr>
         <p:spPr>
           <a:xfrm>
-            <a:off x="21119515" y="27064955"/>
-            <a:ext cx="8276876" cy="312517"/>
+            <a:off x="20946884" y="26986827"/>
+            <a:ext cx="8449684" cy="312517"/>
           </a:xfrm>
           <a:prstGeom prst="rect">
             <a:avLst/>
@@ -13045,133 +13072,151 @@
                 </a:solidFill>
                 <a:latin typeface="Arial"/>
               </a:rPr>
-              <a:t>failure-blind</a:t>
-            </a:r>
-            <a:r>
-              <a:rPr sz="2460" b="0" i="0">
-                <a:solidFill>
-                  <a:srgbClr val="0B0B0B"/>
-                </a:solidFill>
-                <a:latin typeface="Arial"/>
-              </a:rPr>
-              <a:t> </a:t>
-            </a:r>
-            <a:r>
-              <a:rPr sz="2460" b="0" i="0">
-                <a:solidFill>
-                  <a:srgbClr val="0B0B0B"/>
-                </a:solidFill>
-                <a:latin typeface="Arial"/>
-              </a:rPr>
-              <a:t>constructor</a:t>
-            </a:r>
-            <a:r>
-              <a:rPr sz="2460" b="0" i="0">
-                <a:solidFill>
-                  <a:srgbClr val="0B0B0B"/>
-                </a:solidFill>
-                <a:latin typeface="Arial"/>
-              </a:rPr>
-              <a:t> </a:t>
-            </a:r>
-            <a:r>
-              <a:rPr sz="2460" b="0" i="0">
-                <a:solidFill>
-                  <a:srgbClr val="0B0B0B"/>
-                </a:solidFill>
-                <a:latin typeface="Arial"/>
-              </a:rPr>
-              <a:t>found</a:t>
-            </a:r>
-            <a:r>
-              <a:rPr sz="2460" b="0" i="0">
-                <a:solidFill>
-                  <a:srgbClr val="0B0B0B"/>
-                </a:solidFill>
-                <a:latin typeface="Arial"/>
-              </a:rPr>
-              <a:t> </a:t>
-            </a:r>
-            <a:r>
-              <a:rPr sz="2460" b="0" i="0">
-                <a:solidFill>
-                  <a:srgbClr val="0B0B0B"/>
-                </a:solidFill>
-                <a:latin typeface="Arial"/>
-              </a:rPr>
-              <a:t>the</a:t>
-            </a:r>
-            <a:r>
-              <a:rPr sz="2460" b="0" i="0">
-                <a:solidFill>
-                  <a:srgbClr val="0B0B0B"/>
-                </a:solidFill>
-                <a:latin typeface="Arial"/>
-              </a:rPr>
-              <a:t> </a:t>
-            </a:r>
-            <a:r>
-              <a:rPr sz="2460" b="0" i="0">
-                <a:solidFill>
-                  <a:srgbClr val="0B0B0B"/>
-                </a:solidFill>
-                <a:latin typeface="Arial"/>
-              </a:rPr>
-              <a:t>same</a:t>
-            </a:r>
-            <a:r>
-              <a:rPr sz="2460" b="0" i="0">
-                <a:solidFill>
-                  <a:srgbClr val="0B0B0B"/>
-                </a:solidFill>
-                <a:latin typeface="Arial"/>
-              </a:rPr>
-              <a:t> </a:t>
-            </a:r>
-            <a:r>
-              <a:rPr sz="2460" b="0" i="0">
-                <a:solidFill>
-                  <a:srgbClr val="0B0B0B"/>
-                </a:solidFill>
-                <a:latin typeface="Arial"/>
-              </a:rPr>
-              <a:t>operator,</a:t>
-            </a:r>
-            <a:r>
-              <a:rPr sz="2460" b="0" i="0">
-                <a:solidFill>
-                  <a:srgbClr val="0B0B0B"/>
-                </a:solidFill>
-                <a:latin typeface="Arial"/>
-              </a:rPr>
-              <a:t> </a:t>
-            </a:r>
-            <a:r>
-              <a:rPr sz="2460" b="0" i="0">
-                <a:solidFill>
-                  <a:srgbClr val="0B0B0B"/>
-                </a:solidFill>
-                <a:latin typeface="Arial"/>
-              </a:rPr>
-              <a:t>and</a:t>
-            </a:r>
-            <a:r>
-              <a:rPr sz="2460" b="0" i="0">
-                <a:solidFill>
-                  <a:srgbClr val="0B0B0B"/>
-                </a:solidFill>
-                <a:latin typeface="Arial"/>
-              </a:rPr>
-              <a:t> </a:t>
-            </a:r>
-            <a:r>
-              <a:rPr sz="2460" b="0" i="0">
-                <a:solidFill>
-                  <a:srgbClr val="0B0B0B"/>
-                </a:solidFill>
-                <a:latin typeface="Arial"/>
-              </a:rPr>
-              <a:t>on</a:t>
+              <a:t>• 27</a:t>
+            </a:r>
+            <a:r>
+              <a:rPr sz="2460" b="0" i="0">
+                <a:solidFill>
+                  <a:srgbClr val="0B0B0B"/>
+                </a:solidFill>
+                <a:latin typeface="Arial"/>
+              </a:rPr>
+              <a:t> </a:t>
+            </a:r>
+            <a:r>
+              <a:rPr sz="2460" b="0" i="0">
+                <a:solidFill>
+                  <a:srgbClr val="0B0B0B"/>
+                </a:solidFill>
+                <a:latin typeface="Arial"/>
+              </a:rPr>
+              <a:t>development</a:t>
+            </a:r>
+            <a:r>
+              <a:rPr sz="2460" b="0" i="0">
+                <a:solidFill>
+                  <a:srgbClr val="0B0B0B"/>
+                </a:solidFill>
+                <a:latin typeface="Arial"/>
+              </a:rPr>
+              <a:t> </a:t>
+            </a:r>
+            <a:r>
+              <a:rPr sz="2460" b="0" i="0">
+                <a:solidFill>
+                  <a:srgbClr val="0B0B0B"/>
+                </a:solidFill>
+                <a:latin typeface="Arial"/>
+              </a:rPr>
+              <a:t>tasks:</a:t>
+            </a:r>
+            <a:r>
+              <a:rPr sz="2460" b="0" i="0">
+                <a:solidFill>
+                  <a:srgbClr val="0B0B0B"/>
+                </a:solidFill>
+                <a:latin typeface="Arial"/>
+              </a:rPr>
+              <a:t> </a:t>
+            </a:r>
+            <a:r>
+              <a:rPr sz="2460" b="0" i="0">
+                <a:solidFill>
+                  <a:srgbClr val="0B0B0B"/>
+                </a:solidFill>
+                <a:latin typeface="Arial"/>
+              </a:rPr>
+              <a:t>0</a:t>
+            </a:r>
+            <a:r>
+              <a:rPr sz="2460" b="0" i="0">
+                <a:solidFill>
+                  <a:srgbClr val="0B0B0B"/>
+                </a:solidFill>
+                <a:latin typeface="Arial"/>
+              </a:rPr>
+              <a:t> </a:t>
+            </a:r>
+            <a:r>
+              <a:rPr sz="2460" b="0" i="0">
+                <a:solidFill>
+                  <a:srgbClr val="0B0B0B"/>
+                </a:solidFill>
+                <a:latin typeface="Arial"/>
+              </a:rPr>
+              <a:t>wrong</a:t>
+            </a:r>
+            <a:r>
+              <a:rPr sz="2460" b="0" i="0">
+                <a:solidFill>
+                  <a:srgbClr val="0B0B0B"/>
+                </a:solidFill>
+                <a:latin typeface="Arial"/>
+              </a:rPr>
+              <a:t> </a:t>
+            </a:r>
+            <a:r>
+              <a:rPr sz="2460" b="0" i="0">
+                <a:solidFill>
+                  <a:srgbClr val="0B0B0B"/>
+                </a:solidFill>
+                <a:latin typeface="Arial"/>
+              </a:rPr>
+              <a:t>certificates,</a:t>
+            </a:r>
+            <a:r>
+              <a:rPr sz="2460" b="0" i="0">
+                <a:solidFill>
+                  <a:srgbClr val="0B0B0B"/>
+                </a:solidFill>
+                <a:latin typeface="Arial"/>
+              </a:rPr>
+              <a:t> </a:t>
+            </a:r>
+            <a:r>
+              <a:rPr sz="2460" b="0" i="0">
+                <a:solidFill>
+                  <a:srgbClr val="0B0B0B"/>
+                </a:solidFill>
+                <a:latin typeface="Arial"/>
+              </a:rPr>
+              <a:t>0</a:t>
+            </a:r>
+            <a:r>
+              <a:rPr sz="2460" b="0" i="0">
+                <a:solidFill>
+                  <a:srgbClr val="0B0B0B"/>
+                </a:solidFill>
+                <a:latin typeface="Arial"/>
+              </a:rPr>
+              <a:t> </a:t>
+            </a:r>
+            <a:r>
+              <a:rPr sz="2460" b="0" i="0">
+                <a:solidFill>
+                  <a:srgbClr val="0B0B0B"/>
+                </a:solidFill>
+                <a:latin typeface="Arial"/>
+              </a:rPr>
+              <a:t>lost</a:t>
+            </a:r>
+            <a:r>
+              <a:rPr sz="2460" b="0" i="0">
+                <a:solidFill>
+                  <a:srgbClr val="0B0B0B"/>
+                </a:solidFill>
+                <a:latin typeface="Arial"/>
+              </a:rPr>
+              <a:t> </a:t>
+            </a:r>
+            <a:r>
+              <a:rPr sz="2460" b="0" i="0">
+                <a:solidFill>
+                  <a:srgbClr val="0B0B0B"/>
+                </a:solidFill>
+                <a:latin typeface="Arial"/>
+              </a:rPr>
+              <a:t>answers.</a:t>
             </a:r>
           </a:p>
         </p:txBody>
@@ -13184,8 +13229,8 @@
         </p:nvSpPr>
         <p:spPr>
           <a:xfrm>
-            <a:off x="21119515" y="27469830"/>
-            <a:ext cx="8276869" cy="312517"/>
+            <a:off x="21119515" y="27391701"/>
+            <a:ext cx="4280099" cy="312517"/>
           </a:xfrm>
           <a:prstGeom prst="rect">
             <a:avLst/>
@@ -13205,169 +13250,25 @@
                 </a:solidFill>
                 <a:latin typeface="Arial"/>
               </a:rPr>
-              <a:t>this</a:t>
-            </a:r>
-            <a:r>
-              <a:rPr sz="2460" b="0" i="0">
-                <a:solidFill>
-                  <a:srgbClr val="0B0B0B"/>
-                </a:solidFill>
-                <a:latin typeface="Arial"/>
-              </a:rPr>
-              <a:t> </a:t>
-            </a:r>
-            <a:r>
-              <a:rPr sz="2460" b="0" i="0">
-                <a:solidFill>
-                  <a:srgbClr val="0B0B0B"/>
-                </a:solidFill>
-                <a:latin typeface="Arial"/>
-              </a:rPr>
-              <a:t>corpus</a:t>
-            </a:r>
-            <a:r>
-              <a:rPr sz="2460" b="0" i="0">
-                <a:solidFill>
-                  <a:srgbClr val="0B0B0B"/>
-                </a:solidFill>
-                <a:latin typeface="Arial"/>
-              </a:rPr>
-              <a:t> </a:t>
-            </a:r>
-            <a:r>
-              <a:rPr sz="2460" b="0" i="0">
-                <a:solidFill>
-                  <a:srgbClr val="0B0B0B"/>
-                </a:solidFill>
-                <a:latin typeface="Arial"/>
-              </a:rPr>
-              <a:t>its</a:t>
-            </a:r>
-            <a:r>
-              <a:rPr sz="2460" b="0" i="0">
-                <a:solidFill>
-                  <a:srgbClr val="0B0B0B"/>
-                </a:solidFill>
-                <a:latin typeface="Arial"/>
-              </a:rPr>
-              <a:t> </a:t>
-            </a:r>
-            <a:r>
-              <a:rPr sz="2460" b="0" i="0">
-                <a:solidFill>
-                  <a:srgbClr val="0B0B0B"/>
-                </a:solidFill>
-                <a:latin typeface="Arial"/>
-              </a:rPr>
-              <a:t>evidence</a:t>
-            </a:r>
-            <a:r>
-              <a:rPr sz="2460" b="0" i="0">
-                <a:solidFill>
-                  <a:srgbClr val="0B0B0B"/>
-                </a:solidFill>
-                <a:latin typeface="Arial"/>
-              </a:rPr>
-              <a:t> </a:t>
-            </a:r>
-            <a:r>
-              <a:rPr sz="2460" b="0" i="0">
-                <a:solidFill>
-                  <a:srgbClr val="0B0B0B"/>
-                </a:solidFill>
-                <a:latin typeface="Arial"/>
-              </a:rPr>
-              <a:t>equals</a:t>
-            </a:r>
-            <a:r>
-              <a:rPr sz="2460" b="0" i="0">
-                <a:solidFill>
-                  <a:srgbClr val="0B0B0B"/>
-                </a:solidFill>
-                <a:latin typeface="Arial"/>
-              </a:rPr>
-              <a:t> </a:t>
-            </a:r>
-            <a:r>
-              <a:rPr sz="2460" b="0" i="0">
-                <a:solidFill>
-                  <a:srgbClr val="0B0B0B"/>
-                </a:solidFill>
-                <a:latin typeface="Arial"/>
-              </a:rPr>
-              <a:t>the</a:t>
-            </a:r>
-            <a:r>
-              <a:rPr sz="2460" b="0" i="0">
-                <a:solidFill>
-                  <a:srgbClr val="0B0B0B"/>
-                </a:solidFill>
-                <a:latin typeface="Arial"/>
-              </a:rPr>
-              <a:t> </a:t>
-            </a:r>
-            <a:r>
-              <a:rPr sz="2460" b="0" i="0">
-                <a:solidFill>
-                  <a:srgbClr val="0B0B0B"/>
-                </a:solidFill>
-                <a:latin typeface="Arial"/>
-              </a:rPr>
-              <a:t>authentic</a:t>
-            </a:r>
-            <a:r>
-              <a:rPr sz="2460" b="0" i="0">
-                <a:solidFill>
-                  <a:srgbClr val="0B0B0B"/>
-                </a:solidFill>
-                <a:latin typeface="Arial"/>
-              </a:rPr>
-              <a:t> </a:t>
-            </a:r>
-            <a:r>
-              <a:rPr sz="2460" b="0" i="0">
-                <a:solidFill>
-                  <a:srgbClr val="0B0B0B"/>
-                </a:solidFill>
-                <a:latin typeface="Arial"/>
-              </a:rPr>
-              <a:t>arm’s</a:t>
-            </a:r>
-            <a:r>
-              <a:rPr sz="2460" b="0" i="0">
-                <a:solidFill>
-                  <a:srgbClr val="0B0B0B"/>
-                </a:solidFill>
-                <a:latin typeface="Arial"/>
-              </a:rPr>
-              <a:t> </a:t>
-            </a:r>
-            <a:r>
-              <a:rPr sz="2460" b="0" i="0">
-                <a:solidFill>
-                  <a:srgbClr val="0B0B0B"/>
-                </a:solidFill>
-                <a:latin typeface="Arial"/>
-              </a:rPr>
-              <a:t>by</a:t>
-            </a:r>
-            <a:r>
-              <a:rPr sz="2460" b="0" i="0">
-                <a:solidFill>
-                  <a:srgbClr val="0B0B0B"/>
-                </a:solidFill>
-                <a:latin typeface="Arial"/>
-              </a:rPr>
-              <a:t> </a:t>
-            </a:r>
-            <a:r>
-              <a:rPr sz="2460" b="0" i="0">
-                <a:solidFill>
-                  <a:srgbClr val="0B0B0B"/>
-                </a:solidFill>
-                <a:latin typeface="Arial"/>
-              </a:rPr>
-              <a:t>de-</a:t>
+              <a:t>Matched extra search:</a:t>
+            </a:r>
+            <a:r>
+              <a:rPr sz="2460" b="0" i="0">
+                <a:solidFill>
+                  <a:srgbClr val="0B0B0B"/>
+                </a:solidFill>
+                <a:latin typeface="Arial"/>
+              </a:rPr>
+              <a:t> </a:t>
+            </a:r>
+            <a:r>
+              <a:rPr sz="2460" b="0" i="0">
+                <a:solidFill>
+                  <a:srgbClr val="0B0B0B"/>
+                </a:solidFill>
+                <a:latin typeface="Arial"/>
+              </a:rPr>
+              <a:t>0 of 15.</a:t>
             </a:r>
           </a:p>
         </p:txBody>
@@ -13380,8 +13281,8 @@
         </p:nvSpPr>
         <p:spPr>
           <a:xfrm>
-            <a:off x="21119515" y="27874707"/>
-            <a:ext cx="5031390" cy="312517"/>
+            <a:off x="20946884" y="27874707"/>
+            <a:ext cx="8449532" cy="312774"/>
           </a:xfrm>
           <a:prstGeom prst="rect">
             <a:avLst/>
@@ -13401,25 +13302,196 @@
                 </a:solidFill>
                 <a:latin typeface="Arial"/>
               </a:rPr>
-              <a:t>sign.</a:t>
-            </a:r>
-            <a:r>
-              <a:rPr sz="2460" b="0" i="0">
-                <a:solidFill>
-                  <a:srgbClr val="0B0B0B"/>
-                </a:solidFill>
-                <a:latin typeface="Arial"/>
-              </a:rPr>
-              <a:t> </a:t>
-            </a:r>
-            <a:r>
-              <a:rPr sz="2460" b="0" i="0">
-                <a:solidFill>
-                  <a:srgbClr val="0B0B0B"/>
-                </a:solidFill>
-                <a:latin typeface="Arial"/>
-              </a:rPr>
-              <a:t>The prospective test is sealed.</a:t>
+              <a:t>•</a:t>
+            </a:r>
+            <a:r>
+              <a:rPr sz="2460" b="1" i="0">
+                <a:solidFill>
+                  <a:srgbClr val="0B0B0B"/>
+                </a:solidFill>
+                <a:latin typeface="Arial"/>
+              </a:rPr>
+              <a:t> Not</a:t>
+            </a:r>
+            <a:r>
+              <a:rPr sz="2460" b="1" i="0">
+                <a:solidFill>
+                  <a:srgbClr val="0B0B0B"/>
+                </a:solidFill>
+                <a:latin typeface="Arial"/>
+              </a:rPr>
+              <a:t> </a:t>
+            </a:r>
+            <a:r>
+              <a:rPr sz="2460" b="1" i="0">
+                <a:solidFill>
+                  <a:srgbClr val="0B0B0B"/>
+                </a:solidFill>
+                <a:latin typeface="Arial"/>
+              </a:rPr>
+              <a:t>yet</a:t>
+            </a:r>
+            <a:r>
+              <a:rPr sz="2460" b="1" i="0">
+                <a:solidFill>
+                  <a:srgbClr val="0B0B0B"/>
+                </a:solidFill>
+                <a:latin typeface="Arial"/>
+              </a:rPr>
+              <a:t> </a:t>
+            </a:r>
+            <a:r>
+              <a:rPr sz="2460" b="1" i="0">
+                <a:solidFill>
+                  <a:srgbClr val="0B0B0B"/>
+                </a:solidFill>
+                <a:latin typeface="Arial"/>
+              </a:rPr>
+              <a:t>shown:</a:t>
+            </a:r>
+            <a:r>
+              <a:rPr sz="2460" b="0" i="0">
+                <a:solidFill>
+                  <a:srgbClr val="0B0B0B"/>
+                </a:solidFill>
+                <a:latin typeface="Arial"/>
+              </a:rPr>
+              <a:t> </a:t>
+            </a:r>
+            <a:r>
+              <a:rPr sz="2460" b="0" i="0">
+                <a:solidFill>
+                  <a:srgbClr val="0B0B0B"/>
+                </a:solidFill>
+                <a:latin typeface="Arial"/>
+              </a:rPr>
+              <a:t>that</a:t>
+            </a:r>
+            <a:r>
+              <a:rPr sz="2460" b="0" i="0">
+                <a:solidFill>
+                  <a:srgbClr val="0B0B0B"/>
+                </a:solidFill>
+                <a:latin typeface="Arial"/>
+              </a:rPr>
+              <a:t> </a:t>
+            </a:r>
+            <a:r>
+              <a:rPr sz="2460" b="0" i="0">
+                <a:solidFill>
+                  <a:srgbClr val="0B0B0B"/>
+                </a:solidFill>
+                <a:latin typeface="Arial"/>
+              </a:rPr>
+              <a:t>the</a:t>
+            </a:r>
+            <a:r>
+              <a:rPr sz="2460" b="0" i="0">
+                <a:solidFill>
+                  <a:srgbClr val="0B0B0B"/>
+                </a:solidFill>
+                <a:latin typeface="Arial"/>
+              </a:rPr>
+              <a:t> </a:t>
+            </a:r>
+            <a:r>
+              <a:rPr sz="2460" b="0" i="0">
+                <a:solidFill>
+                  <a:srgbClr val="0B0B0B"/>
+                </a:solidFill>
+                <a:latin typeface="Arial"/>
+              </a:rPr>
+              <a:t>failure</a:t>
+            </a:r>
+            <a:r>
+              <a:rPr sz="2460" b="0" i="0">
+                <a:solidFill>
+                  <a:srgbClr val="0B0B0B"/>
+                </a:solidFill>
+                <a:latin typeface="Arial"/>
+              </a:rPr>
+              <a:t> </a:t>
+            </a:r>
+            <a:r>
+              <a:rPr sz="2460" b="0" i="0">
+                <a:solidFill>
+                  <a:srgbClr val="0B0B0B"/>
+                </a:solidFill>
+                <a:latin typeface="Arial"/>
+              </a:rPr>
+              <a:t>record</a:t>
+            </a:r>
+            <a:r>
+              <a:rPr sz="2460" b="0" i="0">
+                <a:solidFill>
+                  <a:srgbClr val="0B0B0B"/>
+                </a:solidFill>
+                <a:latin typeface="Arial"/>
+              </a:rPr>
+              <a:t> </a:t>
+            </a:r>
+            <a:r>
+              <a:rPr sz="2460" b="0" i="0">
+                <a:solidFill>
+                  <a:srgbClr val="0B0B0B"/>
+                </a:solidFill>
+                <a:latin typeface="Arial"/>
+              </a:rPr>
+              <a:t>is</a:t>
+            </a:r>
+            <a:r>
+              <a:rPr sz="2460" b="0" i="0">
+                <a:solidFill>
+                  <a:srgbClr val="0B0B0B"/>
+                </a:solidFill>
+                <a:latin typeface="Arial"/>
+              </a:rPr>
+              <a:t> </a:t>
+            </a:r>
+            <a:r>
+              <a:rPr sz="2460" b="0" i="0">
+                <a:solidFill>
+                  <a:srgbClr val="0B0B0B"/>
+                </a:solidFill>
+                <a:latin typeface="Arial"/>
+              </a:rPr>
+              <a:t>what</a:t>
+            </a:r>
+            <a:r>
+              <a:rPr sz="2460" b="0" i="0">
+                <a:solidFill>
+                  <a:srgbClr val="0B0B0B"/>
+                </a:solidFill>
+                <a:latin typeface="Arial"/>
+              </a:rPr>
+              <a:t> </a:t>
+            </a:r>
+            <a:r>
+              <a:rPr sz="2460" b="0" i="0">
+                <a:solidFill>
+                  <a:srgbClr val="0B0B0B"/>
+                </a:solidFill>
+                <a:latin typeface="Arial"/>
+              </a:rPr>
+              <a:t>matters.</a:t>
+            </a:r>
+            <a:r>
+              <a:rPr sz="2460" b="0" i="0">
+                <a:solidFill>
+                  <a:srgbClr val="0B0B0B"/>
+                </a:solidFill>
+                <a:latin typeface="Arial"/>
+              </a:rPr>
+              <a:t> </a:t>
+            </a:r>
+            <a:r>
+              <a:rPr sz="2460" b="0" i="0">
+                <a:solidFill>
+                  <a:srgbClr val="0B0B0B"/>
+                </a:solidFill>
+                <a:latin typeface="Arial"/>
+              </a:rPr>
+              <a:t>A</a:t>
             </a:r>
           </a:p>
         </p:txBody>
@@ -13432,8 +13504,8 @@
         </p:nvSpPr>
         <p:spPr>
           <a:xfrm>
-            <a:off x="20775739" y="29522139"/>
-            <a:ext cx="8385869" cy="480795"/>
+            <a:off x="21119515" y="28279597"/>
+            <a:ext cx="8276876" cy="312517"/>
           </a:xfrm>
           <a:prstGeom prst="rect">
             <a:avLst/>
@@ -13447,31 +13519,139 @@
           <a:lstStyle/>
           <a:p>
             <a:r>
-              <a:rPr sz="3790" b="1" i="0">
-                <a:solidFill>
-                  <a:srgbClr val="2A78D6"/>
-                </a:solidFill>
-                <a:latin typeface="Arial"/>
-              </a:rPr>
-              <a:t>A portable controller?</a:t>
-            </a:r>
-            <a:r>
-              <a:rPr sz="3790" b="1" i="0">
-                <a:solidFill>
-                  <a:srgbClr val="D03B3B"/>
-                </a:solidFill>
-                <a:latin typeface="Arial"/>
-              </a:rPr>
-              <a:t> </a:t>
-            </a:r>
-            <a:r>
-              <a:rPr sz="3790" b="1" i="0">
-                <a:solidFill>
-                  <a:srgbClr val="D03B3B"/>
-                </a:solidFill>
-                <a:latin typeface="Arial"/>
-              </a:rPr>
-              <a:t>BIOLOGICAL</a:t>
+              <a:rPr sz="2460" b="0" i="0">
+                <a:solidFill>
+                  <a:srgbClr val="0B0B0B"/>
+                </a:solidFill>
+                <a:latin typeface="Arial"/>
+              </a:rPr>
+              <a:t>failure-blind</a:t>
+            </a:r>
+            <a:r>
+              <a:rPr sz="2460" b="0" i="0">
+                <a:solidFill>
+                  <a:srgbClr val="0B0B0B"/>
+                </a:solidFill>
+                <a:latin typeface="Arial"/>
+              </a:rPr>
+              <a:t> </a:t>
+            </a:r>
+            <a:r>
+              <a:rPr sz="2460" b="0" i="0">
+                <a:solidFill>
+                  <a:srgbClr val="0B0B0B"/>
+                </a:solidFill>
+                <a:latin typeface="Arial"/>
+              </a:rPr>
+              <a:t>constructor</a:t>
+            </a:r>
+            <a:r>
+              <a:rPr sz="2460" b="0" i="0">
+                <a:solidFill>
+                  <a:srgbClr val="0B0B0B"/>
+                </a:solidFill>
+                <a:latin typeface="Arial"/>
+              </a:rPr>
+              <a:t> </a:t>
+            </a:r>
+            <a:r>
+              <a:rPr sz="2460" b="0" i="0">
+                <a:solidFill>
+                  <a:srgbClr val="0B0B0B"/>
+                </a:solidFill>
+                <a:latin typeface="Arial"/>
+              </a:rPr>
+              <a:t>found</a:t>
+            </a:r>
+            <a:r>
+              <a:rPr sz="2460" b="0" i="0">
+                <a:solidFill>
+                  <a:srgbClr val="0B0B0B"/>
+                </a:solidFill>
+                <a:latin typeface="Arial"/>
+              </a:rPr>
+              <a:t> </a:t>
+            </a:r>
+            <a:r>
+              <a:rPr sz="2460" b="0" i="0">
+                <a:solidFill>
+                  <a:srgbClr val="0B0B0B"/>
+                </a:solidFill>
+                <a:latin typeface="Arial"/>
+              </a:rPr>
+              <a:t>the</a:t>
+            </a:r>
+            <a:r>
+              <a:rPr sz="2460" b="0" i="0">
+                <a:solidFill>
+                  <a:srgbClr val="0B0B0B"/>
+                </a:solidFill>
+                <a:latin typeface="Arial"/>
+              </a:rPr>
+              <a:t> </a:t>
+            </a:r>
+            <a:r>
+              <a:rPr sz="2460" b="0" i="0">
+                <a:solidFill>
+                  <a:srgbClr val="0B0B0B"/>
+                </a:solidFill>
+                <a:latin typeface="Arial"/>
+              </a:rPr>
+              <a:t>same</a:t>
+            </a:r>
+            <a:r>
+              <a:rPr sz="2460" b="0" i="0">
+                <a:solidFill>
+                  <a:srgbClr val="0B0B0B"/>
+                </a:solidFill>
+                <a:latin typeface="Arial"/>
+              </a:rPr>
+              <a:t> </a:t>
+            </a:r>
+            <a:r>
+              <a:rPr sz="2460" b="0" i="0">
+                <a:solidFill>
+                  <a:srgbClr val="0B0B0B"/>
+                </a:solidFill>
+                <a:latin typeface="Arial"/>
+              </a:rPr>
+              <a:t>operator,</a:t>
+            </a:r>
+            <a:r>
+              <a:rPr sz="2460" b="0" i="0">
+                <a:solidFill>
+                  <a:srgbClr val="0B0B0B"/>
+                </a:solidFill>
+                <a:latin typeface="Arial"/>
+              </a:rPr>
+              <a:t> </a:t>
+            </a:r>
+            <a:r>
+              <a:rPr sz="2460" b="0" i="0">
+                <a:solidFill>
+                  <a:srgbClr val="0B0B0B"/>
+                </a:solidFill>
+                <a:latin typeface="Arial"/>
+              </a:rPr>
+              <a:t>and</a:t>
+            </a:r>
+            <a:r>
+              <a:rPr sz="2460" b="0" i="0">
+                <a:solidFill>
+                  <a:srgbClr val="0B0B0B"/>
+                </a:solidFill>
+                <a:latin typeface="Arial"/>
+              </a:rPr>
+              <a:t> </a:t>
+            </a:r>
+            <a:r>
+              <a:rPr sz="2460" b="0" i="0">
+                <a:solidFill>
+                  <a:srgbClr val="0B0B0B"/>
+                </a:solidFill>
+                <a:latin typeface="Arial"/>
+              </a:rPr>
+              <a:t>on</a:t>
             </a:r>
           </a:p>
         </p:txBody>
@@ -13484,8 +13664,8 @@
         </p:nvSpPr>
         <p:spPr>
           <a:xfrm>
-            <a:off x="20775739" y="30205374"/>
-            <a:ext cx="6151134" cy="480795"/>
+            <a:off x="21119515" y="28684472"/>
+            <a:ext cx="8276869" cy="312517"/>
           </a:xfrm>
           <a:prstGeom prst="rect">
             <a:avLst/>
@@ -13499,13 +13679,175 @@
           <a:lstStyle/>
           <a:p>
             <a:r>
-              <a:rPr sz="3790" b="1" i="0">
-                <a:solidFill>
-                  <a:srgbClr val="D03B3B"/>
-                </a:solidFill>
-                <a:latin typeface="Arial"/>
-              </a:rPr>
-              <a:t>APPLICATION: UNTESTED</a:t>
+              <a:rPr sz="2460" b="0" i="0">
+                <a:solidFill>
+                  <a:srgbClr val="0B0B0B"/>
+                </a:solidFill>
+                <a:latin typeface="Arial"/>
+              </a:rPr>
+              <a:t>this</a:t>
+            </a:r>
+            <a:r>
+              <a:rPr sz="2460" b="0" i="0">
+                <a:solidFill>
+                  <a:srgbClr val="0B0B0B"/>
+                </a:solidFill>
+                <a:latin typeface="Arial"/>
+              </a:rPr>
+              <a:t> </a:t>
+            </a:r>
+            <a:r>
+              <a:rPr sz="2460" b="0" i="0">
+                <a:solidFill>
+                  <a:srgbClr val="0B0B0B"/>
+                </a:solidFill>
+                <a:latin typeface="Arial"/>
+              </a:rPr>
+              <a:t>corpus</a:t>
+            </a:r>
+            <a:r>
+              <a:rPr sz="2460" b="0" i="0">
+                <a:solidFill>
+                  <a:srgbClr val="0B0B0B"/>
+                </a:solidFill>
+                <a:latin typeface="Arial"/>
+              </a:rPr>
+              <a:t> </a:t>
+            </a:r>
+            <a:r>
+              <a:rPr sz="2460" b="0" i="0">
+                <a:solidFill>
+                  <a:srgbClr val="0B0B0B"/>
+                </a:solidFill>
+                <a:latin typeface="Arial"/>
+              </a:rPr>
+              <a:t>its</a:t>
+            </a:r>
+            <a:r>
+              <a:rPr sz="2460" b="0" i="0">
+                <a:solidFill>
+                  <a:srgbClr val="0B0B0B"/>
+                </a:solidFill>
+                <a:latin typeface="Arial"/>
+              </a:rPr>
+              <a:t> </a:t>
+            </a:r>
+            <a:r>
+              <a:rPr sz="2460" b="0" i="0">
+                <a:solidFill>
+                  <a:srgbClr val="0B0B0B"/>
+                </a:solidFill>
+                <a:latin typeface="Arial"/>
+              </a:rPr>
+              <a:t>evidence</a:t>
+            </a:r>
+            <a:r>
+              <a:rPr sz="2460" b="0" i="0">
+                <a:solidFill>
+                  <a:srgbClr val="0B0B0B"/>
+                </a:solidFill>
+                <a:latin typeface="Arial"/>
+              </a:rPr>
+              <a:t> </a:t>
+            </a:r>
+            <a:r>
+              <a:rPr sz="2460" b="0" i="0">
+                <a:solidFill>
+                  <a:srgbClr val="0B0B0B"/>
+                </a:solidFill>
+                <a:latin typeface="Arial"/>
+              </a:rPr>
+              <a:t>equals</a:t>
+            </a:r>
+            <a:r>
+              <a:rPr sz="2460" b="0" i="0">
+                <a:solidFill>
+                  <a:srgbClr val="0B0B0B"/>
+                </a:solidFill>
+                <a:latin typeface="Arial"/>
+              </a:rPr>
+              <a:t> </a:t>
+            </a:r>
+            <a:r>
+              <a:rPr sz="2460" b="0" i="0">
+                <a:solidFill>
+                  <a:srgbClr val="0B0B0B"/>
+                </a:solidFill>
+                <a:latin typeface="Arial"/>
+              </a:rPr>
+              <a:t>the</a:t>
+            </a:r>
+            <a:r>
+              <a:rPr sz="2460" b="0" i="0">
+                <a:solidFill>
+                  <a:srgbClr val="0B0B0B"/>
+                </a:solidFill>
+                <a:latin typeface="Arial"/>
+              </a:rPr>
+              <a:t> </a:t>
+            </a:r>
+            <a:r>
+              <a:rPr sz="2460" b="0" i="0">
+                <a:solidFill>
+                  <a:srgbClr val="0B0B0B"/>
+                </a:solidFill>
+                <a:latin typeface="Arial"/>
+              </a:rPr>
+              <a:t>authentic</a:t>
+            </a:r>
+            <a:r>
+              <a:rPr sz="2460" b="0" i="0">
+                <a:solidFill>
+                  <a:srgbClr val="0B0B0B"/>
+                </a:solidFill>
+                <a:latin typeface="Arial"/>
+              </a:rPr>
+              <a:t> </a:t>
+            </a:r>
+            <a:r>
+              <a:rPr sz="2460" b="0" i="0">
+                <a:solidFill>
+                  <a:srgbClr val="0B0B0B"/>
+                </a:solidFill>
+                <a:latin typeface="Arial"/>
+              </a:rPr>
+              <a:t>arm’s</a:t>
+            </a:r>
+            <a:r>
+              <a:rPr sz="2460" b="0" i="0">
+                <a:solidFill>
+                  <a:srgbClr val="0B0B0B"/>
+                </a:solidFill>
+                <a:latin typeface="Arial"/>
+              </a:rPr>
+              <a:t> </a:t>
+            </a:r>
+            <a:r>
+              <a:rPr sz="2460" b="0" i="0">
+                <a:solidFill>
+                  <a:srgbClr val="0B0B0B"/>
+                </a:solidFill>
+                <a:latin typeface="Arial"/>
+              </a:rPr>
+              <a:t>by</a:t>
+            </a:r>
+            <a:r>
+              <a:rPr sz="2460" b="0" i="0">
+                <a:solidFill>
+                  <a:srgbClr val="0B0B0B"/>
+                </a:solidFill>
+                <a:latin typeface="Arial"/>
+              </a:rPr>
+              <a:t> </a:t>
+            </a:r>
+            <a:r>
+              <a:rPr sz="2460" b="0" i="0">
+                <a:solidFill>
+                  <a:srgbClr val="0B0B0B"/>
+                </a:solidFill>
+                <a:latin typeface="Arial"/>
+              </a:rPr>
+              <a:t>de-</a:t>
             </a:r>
           </a:p>
         </p:txBody>
@@ -13518,8 +13860,8 @@
         </p:nvSpPr>
         <p:spPr>
           <a:xfrm>
-            <a:off x="21438945" y="31663893"/>
-            <a:ext cx="1681853" cy="264436"/>
+            <a:off x="21119515" y="29089359"/>
+            <a:ext cx="5031390" cy="312517"/>
           </a:xfrm>
           <a:prstGeom prst="rect">
             <a:avLst/>
@@ -13533,13 +13875,31 @@
           <a:lstStyle/>
           <a:p>
             <a:r>
-              <a:rPr sz="2080" b="1" i="0">
-                <a:solidFill>
-                  <a:srgbClr val="2A78D6"/>
-                </a:solidFill>
-                <a:latin typeface="Arial"/>
-              </a:rPr>
-              <a:t>implemented</a:t>
+              <a:rPr sz="2460" b="0" i="0">
+                <a:solidFill>
+                  <a:srgbClr val="0B0B0B"/>
+                </a:solidFill>
+                <a:latin typeface="Arial"/>
+              </a:rPr>
+              <a:t>sign.</a:t>
+            </a:r>
+            <a:r>
+              <a:rPr sz="2460" b="0" i="0">
+                <a:solidFill>
+                  <a:srgbClr val="0B0B0B"/>
+                </a:solidFill>
+                <a:latin typeface="Arial"/>
+              </a:rPr>
+              <a:t> </a:t>
+            </a:r>
+            <a:r>
+              <a:rPr sz="2460" b="0" i="0">
+                <a:solidFill>
+                  <a:srgbClr val="0B0B0B"/>
+                </a:solidFill>
+                <a:latin typeface="Arial"/>
+              </a:rPr>
+              <a:t>The prospective test is sealed.</a:t>
             </a:r>
           </a:p>
         </p:txBody>
@@ -13552,8 +13912,8 @@
         </p:nvSpPr>
         <p:spPr>
           <a:xfrm>
-            <a:off x="27315935" y="31715316"/>
-            <a:ext cx="1152707" cy="264436"/>
+            <a:off x="20775739" y="30736781"/>
+            <a:ext cx="8385869" cy="480795"/>
           </a:xfrm>
           <a:prstGeom prst="rect">
             <a:avLst/>
@@ -13567,13 +13927,31 @@
           <a:lstStyle/>
           <a:p>
             <a:r>
-              <a:rPr sz="2080" b="1" i="0">
+              <a:rPr sz="3790" b="1" i="0">
+                <a:solidFill>
+                  <a:srgbClr val="2A78D6"/>
+                </a:solidFill>
+                <a:latin typeface="Arial"/>
+              </a:rPr>
+              <a:t>A portable controller?</a:t>
+            </a:r>
+            <a:r>
+              <a:rPr sz="3790" b="1" i="0">
                 <a:solidFill>
                   <a:srgbClr val="D03B3B"/>
                 </a:solidFill>
                 <a:latin typeface="Arial"/>
               </a:rPr>
-              <a:t>untested</a:t>
+              <a:t> </a:t>
+            </a:r>
+            <a:r>
+              <a:rPr sz="3790" b="1" i="0">
+                <a:solidFill>
+                  <a:srgbClr val="D03B3B"/>
+                </a:solidFill>
+                <a:latin typeface="Arial"/>
+              </a:rPr>
+              <a:t>BIOLOGICAL</a:t>
             </a:r>
           </a:p>
         </p:txBody>
@@ -13586,8 +13964,8 @@
         </p:nvSpPr>
         <p:spPr>
           <a:xfrm>
-            <a:off x="20775739" y="33749360"/>
-            <a:ext cx="8620642" cy="312517"/>
+            <a:off x="20775739" y="31420026"/>
+            <a:ext cx="6151134" cy="480795"/>
           </a:xfrm>
           <a:prstGeom prst="rect">
             <a:avLst/>
@@ -13601,139 +13979,13 @@
           <a:lstStyle/>
           <a:p>
             <a:r>
-              <a:rPr sz="2460" b="0" i="0">
-                <a:solidFill>
-                  <a:srgbClr val="0B0B0B"/>
-                </a:solidFill>
-                <a:latin typeface="Arial"/>
-              </a:rPr>
-              <a:t>Portable:</a:t>
-            </a:r>
-            <a:r>
-              <a:rPr sz="2460" b="0" i="0">
-                <a:solidFill>
-                  <a:srgbClr val="0B0B0B"/>
-                </a:solidFill>
-                <a:latin typeface="Arial"/>
-              </a:rPr>
-              <a:t> </a:t>
-            </a:r>
-            <a:r>
-              <a:rPr sz="2460" b="0" i="0">
-                <a:solidFill>
-                  <a:srgbClr val="0B0B0B"/>
-                </a:solidFill>
-                <a:latin typeface="Arial"/>
-              </a:rPr>
-              <a:t>the</a:t>
-            </a:r>
-            <a:r>
-              <a:rPr sz="2460" b="0" i="0">
-                <a:solidFill>
-                  <a:srgbClr val="0B0B0B"/>
-                </a:solidFill>
-                <a:latin typeface="Arial"/>
-              </a:rPr>
-              <a:t> </a:t>
-            </a:r>
-            <a:r>
-              <a:rPr sz="2460" b="0" i="0">
-                <a:solidFill>
-                  <a:srgbClr val="0B0B0B"/>
-                </a:solidFill>
-                <a:latin typeface="Arial"/>
-              </a:rPr>
-              <a:t>repair-and-verification</a:t>
-            </a:r>
-            <a:r>
-              <a:rPr sz="2460" b="0" i="0">
-                <a:solidFill>
-                  <a:srgbClr val="0B0B0B"/>
-                </a:solidFill>
-                <a:latin typeface="Arial"/>
-              </a:rPr>
-              <a:t> </a:t>
-            </a:r>
-            <a:r>
-              <a:rPr sz="2460" b="0" i="0">
-                <a:solidFill>
-                  <a:srgbClr val="0B0B0B"/>
-                </a:solidFill>
-                <a:latin typeface="Arial"/>
-              </a:rPr>
-              <a:t>contract,</a:t>
-            </a:r>
-            <a:r>
-              <a:rPr sz="2460" b="0" i="0">
-                <a:solidFill>
-                  <a:srgbClr val="0B0B0B"/>
-                </a:solidFill>
-                <a:latin typeface="Arial"/>
-              </a:rPr>
-              <a:t> </a:t>
-            </a:r>
-            <a:r>
-              <a:rPr sz="2460" b="0" i="0">
-                <a:solidFill>
-                  <a:srgbClr val="0B0B0B"/>
-                </a:solidFill>
-                <a:latin typeface="Arial"/>
-              </a:rPr>
-              <a:t>not</a:t>
-            </a:r>
-            <a:r>
-              <a:rPr sz="2460" b="0" i="0">
-                <a:solidFill>
-                  <a:srgbClr val="0B0B0B"/>
-                </a:solidFill>
-                <a:latin typeface="Arial"/>
-              </a:rPr>
-              <a:t> </a:t>
-            </a:r>
-            <a:r>
-              <a:rPr sz="2460" b="0" i="0">
-                <a:solidFill>
-                  <a:srgbClr val="0B0B0B"/>
-                </a:solidFill>
-                <a:latin typeface="Arial"/>
-              </a:rPr>
-              <a:t>the</a:t>
-            </a:r>
-            <a:r>
-              <a:rPr sz="2460" b="0" i="0">
-                <a:solidFill>
-                  <a:srgbClr val="0B0B0B"/>
-                </a:solidFill>
-                <a:latin typeface="Arial"/>
-              </a:rPr>
-              <a:t> </a:t>
-            </a:r>
-            <a:r>
-              <a:rPr sz="2460" b="0" i="0">
-                <a:solidFill>
-                  <a:srgbClr val="0B0B0B"/>
-                </a:solidFill>
-                <a:latin typeface="Arial"/>
-              </a:rPr>
-              <a:t>ARC</a:t>
-            </a:r>
-            <a:r>
-              <a:rPr sz="2460" b="0" i="0">
-                <a:solidFill>
-                  <a:srgbClr val="0B0B0B"/>
-                </a:solidFill>
-                <a:latin typeface="Arial"/>
-              </a:rPr>
-              <a:t> </a:t>
-            </a:r>
-            <a:r>
-              <a:rPr sz="2460" b="0" i="0">
-                <a:solidFill>
-                  <a:srgbClr val="0B0B0B"/>
-                </a:solidFill>
-                <a:latin typeface="Arial"/>
-              </a:rPr>
-              <a:t>op-</a:t>
+              <a:rPr sz="3790" b="1" i="0">
+                <a:solidFill>
+                  <a:srgbClr val="D03B3B"/>
+                </a:solidFill>
+                <a:latin typeface="Arial"/>
+              </a:rPr>
+              <a:t>APPLICATION: UNTESTED</a:t>
             </a:r>
           </a:p>
         </p:txBody>
@@ -13746,8 +13998,8 @@
         </p:nvSpPr>
         <p:spPr>
           <a:xfrm>
-            <a:off x="20775739" y="34154247"/>
-            <a:ext cx="8620639" cy="312517"/>
+            <a:off x="21438945" y="32878532"/>
+            <a:ext cx="1681853" cy="264436"/>
           </a:xfrm>
           <a:prstGeom prst="rect">
             <a:avLst/>
@@ -13761,157 +14013,13 @@
           <a:lstStyle/>
           <a:p>
             <a:r>
-              <a:rPr sz="2460" b="0" i="0">
-                <a:solidFill>
-                  <a:srgbClr val="0B0B0B"/>
-                </a:solidFill>
-                <a:latin typeface="Arial"/>
-              </a:rPr>
-              <a:t>erators.</a:t>
-            </a:r>
-            <a:r>
-              <a:rPr sz="2460" b="0" i="0">
-                <a:solidFill>
-                  <a:srgbClr val="0B0B0B"/>
-                </a:solidFill>
-                <a:latin typeface="Arial"/>
-              </a:rPr>
-              <a:t> </a:t>
-            </a:r>
-            <a:r>
-              <a:rPr sz="2460" b="0" i="0">
-                <a:solidFill>
-                  <a:srgbClr val="0B0B0B"/>
-                </a:solidFill>
-                <a:latin typeface="Arial"/>
-              </a:rPr>
-              <a:t>A</a:t>
-            </a:r>
-            <a:r>
-              <a:rPr sz="2460" b="0" i="0">
-                <a:solidFill>
-                  <a:srgbClr val="0B0B0B"/>
-                </a:solidFill>
-                <a:latin typeface="Arial"/>
-              </a:rPr>
-              <a:t> </a:t>
-            </a:r>
-            <a:r>
-              <a:rPr sz="2460" b="0" i="0">
-                <a:solidFill>
-                  <a:srgbClr val="0B0B0B"/>
-                </a:solidFill>
-                <a:latin typeface="Arial"/>
-              </a:rPr>
-              <a:t>test</a:t>
-            </a:r>
-            <a:r>
-              <a:rPr sz="2460" b="0" i="0">
-                <a:solidFill>
-                  <a:srgbClr val="0B0B0B"/>
-                </a:solidFill>
-                <a:latin typeface="Arial"/>
-              </a:rPr>
-              <a:t> </a:t>
-            </a:r>
-            <a:r>
-              <a:rPr sz="2460" b="0" i="0">
-                <a:solidFill>
-                  <a:srgbClr val="0B0B0B"/>
-                </a:solidFill>
-                <a:latin typeface="Arial"/>
-              </a:rPr>
-              <a:t>needs</a:t>
-            </a:r>
-            <a:r>
-              <a:rPr sz="2460" b="0" i="0">
-                <a:solidFill>
-                  <a:srgbClr val="0B0B0B"/>
-                </a:solidFill>
-                <a:latin typeface="Arial"/>
-              </a:rPr>
-              <a:t> </a:t>
-            </a:r>
-            <a:r>
-              <a:rPr sz="2460" b="0" i="0">
-                <a:solidFill>
-                  <a:srgbClr val="0B0B0B"/>
-                </a:solidFill>
-                <a:latin typeface="Arial"/>
-              </a:rPr>
-              <a:t>held-out</a:t>
-            </a:r>
-            <a:r>
-              <a:rPr sz="2460" b="0" i="0">
-                <a:solidFill>
-                  <a:srgbClr val="0B0B0B"/>
-                </a:solidFill>
-                <a:latin typeface="Arial"/>
-              </a:rPr>
-              <a:t> </a:t>
-            </a:r>
-            <a:r>
-              <a:rPr sz="2460" b="0" i="0">
-                <a:solidFill>
-                  <a:srgbClr val="0B0B0B"/>
-                </a:solidFill>
-                <a:latin typeface="Arial"/>
-              </a:rPr>
-              <a:t>perturbations</a:t>
-            </a:r>
-            <a:r>
-              <a:rPr sz="2460" b="0" i="0">
-                <a:solidFill>
-                  <a:srgbClr val="0B0B0B"/>
-                </a:solidFill>
-                <a:latin typeface="Arial"/>
-              </a:rPr>
-              <a:t> </a:t>
-            </a:r>
-            <a:r>
-              <a:rPr sz="2460" b="0" i="0">
-                <a:solidFill>
-                  <a:srgbClr val="0B0B0B"/>
-                </a:solidFill>
-                <a:latin typeface="Arial"/>
-              </a:rPr>
-              <a:t>and</a:t>
-            </a:r>
-            <a:r>
-              <a:rPr sz="2460" b="0" i="0">
-                <a:solidFill>
-                  <a:srgbClr val="0B0B0B"/>
-                </a:solidFill>
-                <a:latin typeface="Arial"/>
-              </a:rPr>
-              <a:t> </a:t>
-            </a:r>
-            <a:r>
-              <a:rPr sz="2460" b="0" i="0">
-                <a:solidFill>
-                  <a:srgbClr val="0B0B0B"/>
-                </a:solidFill>
-                <a:latin typeface="Arial"/>
-              </a:rPr>
-              <a:t>cell</a:t>
-            </a:r>
-            <a:r>
-              <a:rPr sz="2460" b="0" i="0">
-                <a:solidFill>
-                  <a:srgbClr val="0B0B0B"/>
-                </a:solidFill>
-                <a:latin typeface="Arial"/>
-              </a:rPr>
-              <a:t> </a:t>
-            </a:r>
-            <a:r>
-              <a:rPr sz="2460" b="0" i="0">
-                <a:solidFill>
-                  <a:srgbClr val="0B0B0B"/>
-                </a:solidFill>
-                <a:latin typeface="Arial"/>
-              </a:rPr>
-              <a:t>states,</a:t>
+              <a:rPr sz="2080" b="1" i="0">
+                <a:solidFill>
+                  <a:srgbClr val="2A78D6"/>
+                </a:solidFill>
+                <a:latin typeface="Arial"/>
+              </a:rPr>
+              <a:t>implemented</a:t>
             </a:r>
           </a:p>
         </p:txBody>
@@ -13924,8 +14032,8 @@
         </p:nvSpPr>
         <p:spPr>
           <a:xfrm>
-            <a:off x="20775739" y="34559124"/>
-            <a:ext cx="7313069" cy="312517"/>
+            <a:off x="27315935" y="32929968"/>
+            <a:ext cx="1152707" cy="264436"/>
           </a:xfrm>
           <a:prstGeom prst="rect">
             <a:avLst/>
@@ -13939,31 +14047,13 @@
           <a:lstStyle/>
           <a:p>
             <a:r>
-              <a:rPr sz="2460" b="0" i="0">
-                <a:solidFill>
-                  <a:srgbClr val="0B0B0B"/>
-                </a:solidFill>
-                <a:latin typeface="Arial"/>
-              </a:rPr>
-              <a:t>and controls.</a:t>
-            </a:r>
-            <a:r>
-              <a:rPr sz="2460" b="0" i="0">
-                <a:solidFill>
-                  <a:srgbClr val="0B0B0B"/>
-                </a:solidFill>
-                <a:latin typeface="Arial"/>
-              </a:rPr>
-              <a:t> </a:t>
-            </a:r>
-            <a:r>
-              <a:rPr sz="2460" b="0" i="0">
-                <a:solidFill>
-                  <a:srgbClr val="0B0B0B"/>
-                </a:solidFill>
-                <a:latin typeface="Arial"/>
-              </a:rPr>
-              <a:t>No biological data or result exists here.</a:t>
+              <a:rPr sz="2080" b="1" i="0">
+                <a:solidFill>
+                  <a:srgbClr val="D03B3B"/>
+                </a:solidFill>
+                <a:latin typeface="Arial"/>
+              </a:rPr>
+              <a:t>untested</a:t>
             </a:r>
           </a:p>
         </p:txBody>
@@ -13976,8 +14066,8 @@
         </p:nvSpPr>
         <p:spPr>
           <a:xfrm>
-            <a:off x="20775739" y="36050224"/>
-            <a:ext cx="5395605" cy="544062"/>
+            <a:off x="20775739" y="34963999"/>
+            <a:ext cx="8620642" cy="312517"/>
           </a:xfrm>
           <a:prstGeom prst="rect">
             <a:avLst/>
@@ -13991,49 +14081,139 @@
           <a:lstStyle/>
           <a:p>
             <a:r>
-              <a:rPr sz="3790" b="1" i="0">
-                <a:solidFill>
-                  <a:srgbClr val="2A78D6"/>
-                </a:solidFill>
-                <a:latin typeface="Arial"/>
-              </a:rPr>
-              <a:t>Not claimed</a:t>
-            </a:r>
-            <a:r>
-              <a:rPr sz="4280" b="0" i="1">
-                <a:solidFill>
-                  <a:srgbClr val="2A78D6"/>
-                </a:solidFill>
-                <a:latin typeface="Arial"/>
-              </a:rPr>
-              <a:t> </a:t>
-            </a:r>
-            <a:r>
-              <a:rPr sz="4280" b="0" i="1">
-                <a:solidFill>
-                  <a:srgbClr val="2A78D6"/>
-                </a:solidFill>
-                <a:latin typeface="Arial"/>
-              </a:rPr>
-              <a:t>·</a:t>
-            </a:r>
-            <a:r>
-              <a:rPr sz="3790" b="1" i="0">
-                <a:solidFill>
-                  <a:srgbClr val="2A78D6"/>
-                </a:solidFill>
-                <a:latin typeface="Arial"/>
-              </a:rPr>
-              <a:t> </a:t>
-            </a:r>
-            <a:r>
-              <a:rPr sz="3790" b="1" i="0">
-                <a:solidFill>
-                  <a:srgbClr val="2A78D6"/>
-                </a:solidFill>
-                <a:latin typeface="Arial"/>
-              </a:rPr>
-              <a:t>evidence</a:t>
+              <a:rPr sz="2460" b="0" i="0">
+                <a:solidFill>
+                  <a:srgbClr val="0B0B0B"/>
+                </a:solidFill>
+                <a:latin typeface="Arial"/>
+              </a:rPr>
+              <a:t>Portable:</a:t>
+            </a:r>
+            <a:r>
+              <a:rPr sz="2460" b="0" i="0">
+                <a:solidFill>
+                  <a:srgbClr val="0B0B0B"/>
+                </a:solidFill>
+                <a:latin typeface="Arial"/>
+              </a:rPr>
+              <a:t> </a:t>
+            </a:r>
+            <a:r>
+              <a:rPr sz="2460" b="0" i="0">
+                <a:solidFill>
+                  <a:srgbClr val="0B0B0B"/>
+                </a:solidFill>
+                <a:latin typeface="Arial"/>
+              </a:rPr>
+              <a:t>the</a:t>
+            </a:r>
+            <a:r>
+              <a:rPr sz="2460" b="0" i="0">
+                <a:solidFill>
+                  <a:srgbClr val="0B0B0B"/>
+                </a:solidFill>
+                <a:latin typeface="Arial"/>
+              </a:rPr>
+              <a:t> </a:t>
+            </a:r>
+            <a:r>
+              <a:rPr sz="2460" b="0" i="0">
+                <a:solidFill>
+                  <a:srgbClr val="0B0B0B"/>
+                </a:solidFill>
+                <a:latin typeface="Arial"/>
+              </a:rPr>
+              <a:t>repair-and-verification</a:t>
+            </a:r>
+            <a:r>
+              <a:rPr sz="2460" b="0" i="0">
+                <a:solidFill>
+                  <a:srgbClr val="0B0B0B"/>
+                </a:solidFill>
+                <a:latin typeface="Arial"/>
+              </a:rPr>
+              <a:t> </a:t>
+            </a:r>
+            <a:r>
+              <a:rPr sz="2460" b="0" i="0">
+                <a:solidFill>
+                  <a:srgbClr val="0B0B0B"/>
+                </a:solidFill>
+                <a:latin typeface="Arial"/>
+              </a:rPr>
+              <a:t>contract,</a:t>
+            </a:r>
+            <a:r>
+              <a:rPr sz="2460" b="0" i="0">
+                <a:solidFill>
+                  <a:srgbClr val="0B0B0B"/>
+                </a:solidFill>
+                <a:latin typeface="Arial"/>
+              </a:rPr>
+              <a:t> </a:t>
+            </a:r>
+            <a:r>
+              <a:rPr sz="2460" b="0" i="0">
+                <a:solidFill>
+                  <a:srgbClr val="0B0B0B"/>
+                </a:solidFill>
+                <a:latin typeface="Arial"/>
+              </a:rPr>
+              <a:t>not</a:t>
+            </a:r>
+            <a:r>
+              <a:rPr sz="2460" b="0" i="0">
+                <a:solidFill>
+                  <a:srgbClr val="0B0B0B"/>
+                </a:solidFill>
+                <a:latin typeface="Arial"/>
+              </a:rPr>
+              <a:t> </a:t>
+            </a:r>
+            <a:r>
+              <a:rPr sz="2460" b="0" i="0">
+                <a:solidFill>
+                  <a:srgbClr val="0B0B0B"/>
+                </a:solidFill>
+                <a:latin typeface="Arial"/>
+              </a:rPr>
+              <a:t>the</a:t>
+            </a:r>
+            <a:r>
+              <a:rPr sz="2460" b="0" i="0">
+                <a:solidFill>
+                  <a:srgbClr val="0B0B0B"/>
+                </a:solidFill>
+                <a:latin typeface="Arial"/>
+              </a:rPr>
+              <a:t> </a:t>
+            </a:r>
+            <a:r>
+              <a:rPr sz="2460" b="0" i="0">
+                <a:solidFill>
+                  <a:srgbClr val="0B0B0B"/>
+                </a:solidFill>
+                <a:latin typeface="Arial"/>
+              </a:rPr>
+              <a:t>ARC</a:t>
+            </a:r>
+            <a:r>
+              <a:rPr sz="2460" b="0" i="0">
+                <a:solidFill>
+                  <a:srgbClr val="0B0B0B"/>
+                </a:solidFill>
+                <a:latin typeface="Arial"/>
+              </a:rPr>
+              <a:t> </a:t>
+            </a:r>
+            <a:r>
+              <a:rPr sz="2460" b="0" i="0">
+                <a:solidFill>
+                  <a:srgbClr val="0B0B0B"/>
+                </a:solidFill>
+                <a:latin typeface="Arial"/>
+              </a:rPr>
+              <a:t>op-</a:t>
             </a:r>
           </a:p>
         </p:txBody>
@@ -14046,8 +14226,8 @@
         </p:nvSpPr>
         <p:spPr>
           <a:xfrm>
-            <a:off x="20775739" y="37197788"/>
-            <a:ext cx="8092172" cy="312517"/>
+            <a:off x="20775739" y="35368889"/>
+            <a:ext cx="8620639" cy="312517"/>
           </a:xfrm>
           <a:prstGeom prst="rect">
             <a:avLst/>
@@ -14067,7 +14247,151 @@
                 </a:solidFill>
                 <a:latin typeface="Arial"/>
               </a:rPr>
-              <a:t>No CORA solve or score gain on ARC-AGI-2; no semantic</a:t>
+              <a:t>erators.</a:t>
+            </a:r>
+            <a:r>
+              <a:rPr sz="2460" b="0" i="0">
+                <a:solidFill>
+                  <a:srgbClr val="0B0B0B"/>
+                </a:solidFill>
+                <a:latin typeface="Arial"/>
+              </a:rPr>
+              <a:t> </a:t>
+            </a:r>
+            <a:r>
+              <a:rPr sz="2460" b="0" i="0">
+                <a:solidFill>
+                  <a:srgbClr val="0B0B0B"/>
+                </a:solidFill>
+                <a:latin typeface="Arial"/>
+              </a:rPr>
+              <a:t>A</a:t>
+            </a:r>
+            <a:r>
+              <a:rPr sz="2460" b="0" i="0">
+                <a:solidFill>
+                  <a:srgbClr val="0B0B0B"/>
+                </a:solidFill>
+                <a:latin typeface="Arial"/>
+              </a:rPr>
+              <a:t> </a:t>
+            </a:r>
+            <a:r>
+              <a:rPr sz="2460" b="0" i="0">
+                <a:solidFill>
+                  <a:srgbClr val="0B0B0B"/>
+                </a:solidFill>
+                <a:latin typeface="Arial"/>
+              </a:rPr>
+              <a:t>test</a:t>
+            </a:r>
+            <a:r>
+              <a:rPr sz="2460" b="0" i="0">
+                <a:solidFill>
+                  <a:srgbClr val="0B0B0B"/>
+                </a:solidFill>
+                <a:latin typeface="Arial"/>
+              </a:rPr>
+              <a:t> </a:t>
+            </a:r>
+            <a:r>
+              <a:rPr sz="2460" b="0" i="0">
+                <a:solidFill>
+                  <a:srgbClr val="0B0B0B"/>
+                </a:solidFill>
+                <a:latin typeface="Arial"/>
+              </a:rPr>
+              <a:t>needs</a:t>
+            </a:r>
+            <a:r>
+              <a:rPr sz="2460" b="0" i="0">
+                <a:solidFill>
+                  <a:srgbClr val="0B0B0B"/>
+                </a:solidFill>
+                <a:latin typeface="Arial"/>
+              </a:rPr>
+              <a:t> </a:t>
+            </a:r>
+            <a:r>
+              <a:rPr sz="2460" b="0" i="0">
+                <a:solidFill>
+                  <a:srgbClr val="0B0B0B"/>
+                </a:solidFill>
+                <a:latin typeface="Arial"/>
+              </a:rPr>
+              <a:t>held-out</a:t>
+            </a:r>
+            <a:r>
+              <a:rPr sz="2460" b="0" i="0">
+                <a:solidFill>
+                  <a:srgbClr val="0B0B0B"/>
+                </a:solidFill>
+                <a:latin typeface="Arial"/>
+              </a:rPr>
+              <a:t> </a:t>
+            </a:r>
+            <a:r>
+              <a:rPr sz="2460" b="0" i="0">
+                <a:solidFill>
+                  <a:srgbClr val="0B0B0B"/>
+                </a:solidFill>
+                <a:latin typeface="Arial"/>
+              </a:rPr>
+              <a:t>perturbations</a:t>
+            </a:r>
+            <a:r>
+              <a:rPr sz="2460" b="0" i="0">
+                <a:solidFill>
+                  <a:srgbClr val="0B0B0B"/>
+                </a:solidFill>
+                <a:latin typeface="Arial"/>
+              </a:rPr>
+              <a:t> </a:t>
+            </a:r>
+            <a:r>
+              <a:rPr sz="2460" b="0" i="0">
+                <a:solidFill>
+                  <a:srgbClr val="0B0B0B"/>
+                </a:solidFill>
+                <a:latin typeface="Arial"/>
+              </a:rPr>
+              <a:t>and</a:t>
+            </a:r>
+            <a:r>
+              <a:rPr sz="2460" b="0" i="0">
+                <a:solidFill>
+                  <a:srgbClr val="0B0B0B"/>
+                </a:solidFill>
+                <a:latin typeface="Arial"/>
+              </a:rPr>
+              <a:t> </a:t>
+            </a:r>
+            <a:r>
+              <a:rPr sz="2460" b="0" i="0">
+                <a:solidFill>
+                  <a:srgbClr val="0B0B0B"/>
+                </a:solidFill>
+                <a:latin typeface="Arial"/>
+              </a:rPr>
+              <a:t>cell</a:t>
+            </a:r>
+            <a:r>
+              <a:rPr sz="2460" b="0" i="0">
+                <a:solidFill>
+                  <a:srgbClr val="0B0B0B"/>
+                </a:solidFill>
+                <a:latin typeface="Arial"/>
+              </a:rPr>
+              <a:t> </a:t>
+            </a:r>
+            <a:r>
+              <a:rPr sz="2460" b="0" i="0">
+                <a:solidFill>
+                  <a:srgbClr val="0B0B0B"/>
+                </a:solidFill>
+                <a:latin typeface="Arial"/>
+              </a:rPr>
+              <a:t>states,</a:t>
             </a:r>
           </a:p>
         </p:txBody>
@@ -14080,8 +14404,8 @@
         </p:nvSpPr>
         <p:spPr>
           <a:xfrm>
-            <a:off x="20775739" y="37602662"/>
-            <a:ext cx="8601890" cy="312517"/>
+            <a:off x="20775739" y="35773763"/>
+            <a:ext cx="7313069" cy="312517"/>
           </a:xfrm>
           <a:prstGeom prst="rect">
             <a:avLst/>
@@ -14101,7 +14425,25 @@
                 </a:solidFill>
                 <a:latin typeface="Arial"/>
               </a:rPr>
-              <a:t>invention; no automatic failure-type controller; no evidence yet</a:t>
+              <a:t>and controls.</a:t>
+            </a:r>
+            <a:r>
+              <a:rPr sz="2460" b="0" i="0">
+                <a:solidFill>
+                  <a:srgbClr val="0B0B0B"/>
+                </a:solidFill>
+                <a:latin typeface="Arial"/>
+              </a:rPr>
+              <a:t> </a:t>
+            </a:r>
+            <a:r>
+              <a:rPr sz="2460" b="0" i="0">
+                <a:solidFill>
+                  <a:srgbClr val="0B0B0B"/>
+                </a:solidFill>
+                <a:latin typeface="Arial"/>
+              </a:rPr>
+              <a:t>No biological data or result exists here.</a:t>
             </a:r>
           </a:p>
         </p:txBody>
@@ -14114,8 +14456,8 @@
         </p:nvSpPr>
         <p:spPr>
           <a:xfrm>
-            <a:off x="20775739" y="38007552"/>
-            <a:ext cx="7994048" cy="312517"/>
+            <a:off x="20775739" y="37264863"/>
+            <a:ext cx="5395605" cy="544062"/>
           </a:xfrm>
           <a:prstGeom prst="rect">
             <a:avLst/>
@@ -14129,13 +14471,49 @@
           <a:lstStyle/>
           <a:p>
             <a:r>
-              <a:rPr sz="2460" b="0" i="0">
-                <a:solidFill>
-                  <a:srgbClr val="0B0B0B"/>
-                </a:solidFill>
-                <a:latin typeface="Arial"/>
-              </a:rPr>
-              <a:t>that failure records cause a gain; the neural score is not a</a:t>
+              <a:rPr sz="3790" b="1" i="0">
+                <a:solidFill>
+                  <a:srgbClr val="2A78D6"/>
+                </a:solidFill>
+                <a:latin typeface="Arial"/>
+              </a:rPr>
+              <a:t>Not claimed</a:t>
+            </a:r>
+            <a:r>
+              <a:rPr sz="4280" b="0" i="1">
+                <a:solidFill>
+                  <a:srgbClr val="2A78D6"/>
+                </a:solidFill>
+                <a:latin typeface="Arial"/>
+              </a:rPr>
+              <a:t> </a:t>
+            </a:r>
+            <a:r>
+              <a:rPr sz="4280" b="0" i="1">
+                <a:solidFill>
+                  <a:srgbClr val="2A78D6"/>
+                </a:solidFill>
+                <a:latin typeface="Arial"/>
+              </a:rPr>
+              <a:t>·</a:t>
+            </a:r>
+            <a:r>
+              <a:rPr sz="3790" b="1" i="0">
+                <a:solidFill>
+                  <a:srgbClr val="2A78D6"/>
+                </a:solidFill>
+                <a:latin typeface="Arial"/>
+              </a:rPr>
+              <a:t> </a:t>
+            </a:r>
+            <a:r>
+              <a:rPr sz="3790" b="1" i="0">
+                <a:solidFill>
+                  <a:srgbClr val="2A78D6"/>
+                </a:solidFill>
+                <a:latin typeface="Arial"/>
+              </a:rPr>
+              <a:t>evidence</a:t>
             </a:r>
           </a:p>
         </p:txBody>
@@ -14148,8 +14526,8 @@
         </p:nvSpPr>
         <p:spPr>
           <a:xfrm>
-            <a:off x="20775739" y="38412427"/>
-            <a:ext cx="7637772" cy="312517"/>
+            <a:off x="20775739" y="38412430"/>
+            <a:ext cx="8092172" cy="312517"/>
           </a:xfrm>
           <a:prstGeom prst="rect">
             <a:avLst/>
@@ -14169,7 +14547,7 @@
                 </a:solidFill>
                 <a:latin typeface="Arial"/>
               </a:rPr>
-              <a:t>CORA result; no domain generality; no results from the</a:t>
+              <a:t>No CORA solve or score gain on ARC-AGI-2; no semantic</a:t>
             </a:r>
           </a:p>
         </p:txBody>
@@ -14182,8 +14560,8 @@
         </p:nvSpPr>
         <p:spPr>
           <a:xfrm>
-            <a:off x="20775739" y="38817317"/>
-            <a:ext cx="8453031" cy="312774"/>
+            <a:off x="20775739" y="38817320"/>
+            <a:ext cx="8601890" cy="312517"/>
           </a:xfrm>
           <a:prstGeom prst="rect">
             <a:avLst/>
@@ -14203,34 +14581,7 @@
                 </a:solidFill>
                 <a:latin typeface="Arial"/>
               </a:rPr>
-              <a:t>separate VDCG project.</a:t>
-            </a:r>
-            <a:r>
-              <a:rPr sz="2460" b="0" i="0">
-                <a:solidFill>
-                  <a:srgbClr val="0B0B0B"/>
-                </a:solidFill>
-                <a:latin typeface="Arial"/>
-              </a:rPr>
-              <a:t> </a:t>
-            </a:r>
-            <a:r>
-              <a:rPr sz="2460" b="0" i="0">
-                <a:solidFill>
-                  <a:srgbClr val="0B0B0B"/>
-                </a:solidFill>
-                <a:latin typeface="Arial"/>
-              </a:rPr>
-              <a:t>The 120-task pilot is frozen and</a:t>
-            </a:r>
-            <a:r>
-              <a:rPr sz="2460" b="1" i="0">
-                <a:solidFill>
-                  <a:srgbClr val="0B0B0B"/>
-                </a:solidFill>
-                <a:latin typeface="Arial"/>
-              </a:rPr>
-              <a:t> has</a:t>
+              <a:t>invention; no automatic failure-type controller; no evidence yet</a:t>
             </a:r>
           </a:p>
         </p:txBody>
@@ -14243,8 +14594,8 @@
         </p:nvSpPr>
         <p:spPr>
           <a:xfrm>
-            <a:off x="20775741" y="39222191"/>
-            <a:ext cx="2030271" cy="312774"/>
+            <a:off x="20775739" y="39222195"/>
+            <a:ext cx="7994048" cy="312517"/>
           </a:xfrm>
           <a:prstGeom prst="rect">
             <a:avLst/>
@@ -14258,22 +14609,13 @@
           <a:lstStyle/>
           <a:p>
             <a:r>
-              <a:rPr sz="2460" b="1" i="0">
-                <a:solidFill>
-                  <a:srgbClr val="0B0B0B"/>
-                </a:solidFill>
-                <a:latin typeface="Arial"/>
-              </a:rPr>
-              <a:t>not been run</a:t>
-            </a:r>
-            <a:r>
-              <a:rPr sz="2460" b="0" i="0">
-                <a:solidFill>
-                  <a:srgbClr val="0B0B0B"/>
-                </a:solidFill>
-                <a:latin typeface="Arial"/>
-              </a:rPr>
-              <a:t>.</a:t>
+              <a:rPr sz="2460" b="0" i="0">
+                <a:solidFill>
+                  <a:srgbClr val="0B0B0B"/>
+                </a:solidFill>
+                <a:latin typeface="Arial"/>
+              </a:rPr>
+              <a:t>that failure records cause a gain; the neural score is not a</a:t>
             </a:r>
           </a:p>
         </p:txBody>
@@ -14286,8 +14628,8 @@
         </p:nvSpPr>
         <p:spPr>
           <a:xfrm>
-            <a:off x="20775741" y="39694578"/>
-            <a:ext cx="4459778" cy="264439"/>
+            <a:off x="20775739" y="39627085"/>
+            <a:ext cx="7637772" cy="312517"/>
           </a:xfrm>
           <a:prstGeom prst="rect">
             <a:avLst/>
@@ -14301,13 +14643,13 @@
           <a:lstStyle/>
           <a:p>
             <a:r>
-              <a:rPr sz="2080" b="0" i="0">
-                <a:solidFill>
-                  <a:srgbClr val="0B0B0B"/>
-                </a:solidFill>
-                <a:latin typeface="Arial"/>
-              </a:rPr>
-              <a:t>Every number, with commit and hash:</a:t>
+              <a:rPr sz="2460" b="0" i="0">
+                <a:solidFill>
+                  <a:srgbClr val="0B0B0B"/>
+                </a:solidFill>
+                <a:latin typeface="Arial"/>
+              </a:rPr>
+              <a:t>CORA result; no domain generality; no results from the</a:t>
             </a:r>
           </a:p>
         </p:txBody>
@@ -14320,8 +14662,8 @@
         </p:nvSpPr>
         <p:spPr>
           <a:xfrm>
-            <a:off x="20775741" y="40035571"/>
-            <a:ext cx="7289872" cy="278358"/>
+            <a:off x="20775739" y="40031959"/>
+            <a:ext cx="8453031" cy="312774"/>
           </a:xfrm>
           <a:prstGeom prst="rect">
             <a:avLst/>
@@ -14335,22 +14677,40 @@
           <a:lstStyle/>
           <a:p>
             <a:r>
-              <a:rPr sz="2190" b="0" i="0">
-                <a:solidFill>
-                  <a:srgbClr val="0B0B0B"/>
-                </a:solidFill>
-                <a:latin typeface="Courier New"/>
-              </a:rPr>
-              <a:t>records/CORA_SUMMIT_POSTER_EVIDENCE_20261012.md</a:t>
-            </a:r>
-            <a:r>
-              <a:rPr sz="2080" b="0" i="0">
-                <a:solidFill>
-                  <a:srgbClr val="0B0B0B"/>
-                </a:solidFill>
-                <a:latin typeface="Arial"/>
-              </a:rPr>
-              <a:t> and</a:t>
+              <a:rPr sz="2460" b="0" i="0">
+                <a:solidFill>
+                  <a:srgbClr val="0B0B0B"/>
+                </a:solidFill>
+                <a:latin typeface="Arial"/>
+              </a:rPr>
+              <a:t>separate VDCG project.</a:t>
+            </a:r>
+            <a:r>
+              <a:rPr sz="2460" b="0" i="0">
+                <a:solidFill>
+                  <a:srgbClr val="0B0B0B"/>
+                </a:solidFill>
+                <a:latin typeface="Arial"/>
+              </a:rPr>
+              <a:t> </a:t>
+            </a:r>
+            <a:r>
+              <a:rPr sz="2460" b="0" i="0">
+                <a:solidFill>
+                  <a:srgbClr val="0B0B0B"/>
+                </a:solidFill>
+                <a:latin typeface="Arial"/>
+              </a:rPr>
+              <a:t>The 120-task pilot is frozen and</a:t>
+            </a:r>
+            <a:r>
+              <a:rPr sz="2460" b="1" i="0">
+                <a:solidFill>
+                  <a:srgbClr val="0B0B0B"/>
+                </a:solidFill>
+                <a:latin typeface="Arial"/>
+              </a:rPr>
+              <a:t> has</a:t>
             </a:r>
           </a:p>
         </p:txBody>
@@ -14363,8 +14723,8 @@
         </p:nvSpPr>
         <p:spPr>
           <a:xfrm>
-            <a:off x="20775741" y="40377188"/>
-            <a:ext cx="7438654" cy="278358"/>
+            <a:off x="20775741" y="40436837"/>
+            <a:ext cx="2030271" cy="312774"/>
           </a:xfrm>
           <a:prstGeom prst="rect">
             <a:avLst/>
@@ -14378,22 +14738,22 @@
           <a:lstStyle/>
           <a:p>
             <a:r>
-              <a:rPr sz="2190" b="0" i="0">
-                <a:solidFill>
-                  <a:srgbClr val="0B0B0B"/>
-                </a:solidFill>
-                <a:latin typeface="Courier New"/>
-              </a:rPr>
-              <a:t>records/CORA_FAILURE_FUNNEL_20261014.md</a:t>
-            </a:r>
-            <a:r>
-              <a:rPr sz="2080" b="0" i="0">
-                <a:solidFill>
-                  <a:srgbClr val="0B0B0B"/>
-                </a:solidFill>
-                <a:latin typeface="Arial"/>
-              </a:rPr>
-              <a:t>; figure hashes:</a:t>
+              <a:rPr sz="2460" b="1" i="0">
+                <a:solidFill>
+                  <a:srgbClr val="0B0B0B"/>
+                </a:solidFill>
+                <a:latin typeface="Arial"/>
+              </a:rPr>
+              <a:t>not been run</a:t>
+            </a:r>
+            <a:r>
+              <a:rPr sz="2460" b="0" i="0">
+                <a:solidFill>
+                  <a:srgbClr val="0B0B0B"/>
+                </a:solidFill>
+                <a:latin typeface="Arial"/>
+              </a:rPr>
+              <a:t>.</a:t>
             </a:r>
           </a:p>
         </p:txBody>
@@ -14406,7 +14766,127 @@
         </p:nvSpPr>
         <p:spPr>
           <a:xfrm>
-            <a:off x="20775739" y="40718804"/>
+            <a:off x="20775741" y="40909223"/>
+            <a:ext cx="4459778" cy="264439"/>
+          </a:xfrm>
+          <a:prstGeom prst="rect">
+            <a:avLst/>
+          </a:prstGeom>
+          <a:noFill/>
+        </p:spPr>
+        <p:txBody>
+          <a:bodyPr wrap="none" lIns="0" rIns="0" tIns="0" bIns="0">
+            <a:spAutoFit/>
+          </a:bodyPr>
+          <a:lstStyle/>
+          <a:p>
+            <a:r>
+              <a:rPr sz="2080" b="0" i="0">
+                <a:solidFill>
+                  <a:srgbClr val="0B0B0B"/>
+                </a:solidFill>
+                <a:latin typeface="Arial"/>
+              </a:rPr>
+              <a:t>Every number, with commit and hash:</a:t>
+            </a:r>
+          </a:p>
+        </p:txBody>
+      </p:sp>
+      <p:sp>
+        <p:nvSpPr>
+          <p:cNvPr id="154" name="TextBox 153"/>
+          <p:cNvSpPr txBox="1"/>
+          <p:nvPr/>
+        </p:nvSpPr>
+        <p:spPr>
+          <a:xfrm>
+            <a:off x="20775741" y="41250213"/>
+            <a:ext cx="7289872" cy="278358"/>
+          </a:xfrm>
+          <a:prstGeom prst="rect">
+            <a:avLst/>
+          </a:prstGeom>
+          <a:noFill/>
+        </p:spPr>
+        <p:txBody>
+          <a:bodyPr wrap="none" lIns="0" rIns="0" tIns="0" bIns="0">
+            <a:spAutoFit/>
+          </a:bodyPr>
+          <a:lstStyle/>
+          <a:p>
+            <a:r>
+              <a:rPr sz="2190" b="0" i="0">
+                <a:solidFill>
+                  <a:srgbClr val="0B0B0B"/>
+                </a:solidFill>
+                <a:latin typeface="Courier New"/>
+              </a:rPr>
+              <a:t>records/CORA_SUMMIT_POSTER_EVIDENCE_20261012.md</a:t>
+            </a:r>
+            <a:r>
+              <a:rPr sz="2080" b="0" i="0">
+                <a:solidFill>
+                  <a:srgbClr val="0B0B0B"/>
+                </a:solidFill>
+                <a:latin typeface="Arial"/>
+              </a:rPr>
+              <a:t> and</a:t>
+            </a:r>
+          </a:p>
+        </p:txBody>
+      </p:sp>
+      <p:sp>
+        <p:nvSpPr>
+          <p:cNvPr id="155" name="TextBox 154"/>
+          <p:cNvSpPr txBox="1"/>
+          <p:nvPr/>
+        </p:nvSpPr>
+        <p:spPr>
+          <a:xfrm>
+            <a:off x="20775741" y="41591833"/>
+            <a:ext cx="7438654" cy="278358"/>
+          </a:xfrm>
+          <a:prstGeom prst="rect">
+            <a:avLst/>
+          </a:prstGeom>
+          <a:noFill/>
+        </p:spPr>
+        <p:txBody>
+          <a:bodyPr wrap="none" lIns="0" rIns="0" tIns="0" bIns="0">
+            <a:spAutoFit/>
+          </a:bodyPr>
+          <a:lstStyle/>
+          <a:p>
+            <a:r>
+              <a:rPr sz="2190" b="0" i="0">
+                <a:solidFill>
+                  <a:srgbClr val="0B0B0B"/>
+                </a:solidFill>
+                <a:latin typeface="Courier New"/>
+              </a:rPr>
+              <a:t>records/CORA_FAILURE_FUNNEL_20261014.md</a:t>
+            </a:r>
+            <a:r>
+              <a:rPr sz="2080" b="0" i="0">
+                <a:solidFill>
+                  <a:srgbClr val="0B0B0B"/>
+                </a:solidFill>
+                <a:latin typeface="Arial"/>
+              </a:rPr>
+              <a:t>; figure hashes:</a:t>
+            </a:r>
+          </a:p>
+        </p:txBody>
+      </p:sp>
+      <p:sp>
+        <p:nvSpPr>
+          <p:cNvPr id="156" name="TextBox 155"/>
+          <p:cNvSpPr txBox="1"/>
+          <p:nvPr/>
+        </p:nvSpPr>
+        <p:spPr>
+          <a:xfrm>
+            <a:off x="20775739" y="41933449"/>
             <a:ext cx="3415022" cy="278358"/>
           </a:xfrm>
           <a:prstGeom prst="rect">

</xml_diff>